<commit_message>
Add reference labels CSV for resume and job relevance evaluation
</commit_message>
<xml_diff>
--- a/progress_update_2026-10.pptx
+++ b/progress_update_2026-10.pptx
@@ -9,9 +9,10 @@
     <p:sldId id="257" r:id="rId3"/>
     <p:sldId id="258" r:id="rId4"/>
     <p:sldId id="259" r:id="rId5"/>
+    <p:sldId id="260" r:id="rId6"/>
   </p:sldIdLst>
   <p:notesMasterIdLst>
-    <p:notesMasterId r:id="rId6"/>
+    <p:notesMasterId r:id="rId7"/>
   </p:notesMasterIdLst>
   <p:sldSz cx="9144000" cy="5143500"/>
   <p:notesSz cx="5143500" cy="9144000"/>
@@ -110,16 +111,21 @@
   <p:extLst>
     <p:ext uri="{521415D9-36F7-43E2-AB2F-B90AF26B5E84}">
       <p14:sectionLst xmlns:p14="http://schemas.microsoft.com/office/powerpoint/2010/main">
-        <p14:section name="Title" id="{63ae722e-9a31-2ef3-2fe0-c3aed25b49cc}">
+        <p14:section name="Title" id="{fc9c66c6-658e-dcf3-2991-d085cadbce8a}">
           <p14:sldIdLst>
             <p14:sldId id="256"/>
           </p14:sldIdLst>
         </p14:section>
-        <p14:section name="Progress" id="{ad7e1791-18cf-0208-7c93-f189492b84e3}">
+        <p14:section name="Progress" id="{9d883d13-2848-e685-c1ae-1f6a632c0069}">
           <p14:sldIdLst>
             <p14:sldId id="257"/>
             <p14:sldId id="258"/>
             <p14:sldId id="259"/>
+          </p14:sldIdLst>
+        </p14:section>
+        <p14:section name="Results" id="{a4225a8b-24fc-cca3-683c-d76ebfa2725b}">
+          <p14:sldIdLst>
+            <p14:sldId id="260"/>
           </p14:sldIdLst>
         </p14:section>
       </p14:sectionLst>
@@ -129,6 +135,626 @@
     </p:ext>
   </p:extLst>
 </p:presentation>
+</file>
+
+<file path=ppt/charts/chart1.xml><?xml version="1.0" encoding="utf-8"?>
+<c:chartSpace xmlns:c="http://schemas.openxmlformats.org/drawingml/2006/chart" xmlns:a="http://schemas.openxmlformats.org/drawingml/2006/main" xmlns:r="http://schemas.openxmlformats.org/officeDocument/2006/relationships">
+  <c:date1904 val="0"/>
+  <c:roundedCorners val="1"/>
+  <c:chart>
+    <c:title>
+      <c:tx>
+        <c:rich>
+          <a:bodyPr/>
+          <a:lstStyle/>
+          <a:p>
+            <a:pPr>
+              <a:defRPr sz="1300" b="0" i="0" u="none" strike="noStrike">
+                <a:solidFill>
+                  <a:srgbClr val="14213D"/>
+                </a:solidFill>
+                <a:latin typeface="+mn-lt"/>
+              </a:defRPr>
+            </a:pPr>
+            <a:r>
+              <a:rPr sz="1300" b="0" i="0" u="none" strike="noStrike">
+                <a:solidFill>
+                  <a:srgbClr val="14213D"/>
+                </a:solidFill>
+                <a:latin typeface="+mn-lt"/>
+              </a:rPr>
+              <a:t>Seconds per completed run</a:t>
+            </a:r>
+          </a:p>
+        </c:rich>
+      </c:tx>
+      <c:layout/>
+      <c:overlay val="0"/>
+    </c:title>
+    <c:autoTitleDeleted val="0"/>
+    <c:plotArea>
+      <c:layout/>
+      <c:barChart>
+        <c:barDir val="col"/>
+        <c:grouping val="clustered"/>
+        <c:varyColors val="0"/>
+        <c:ser>
+          <c:idx val="0"/>
+          <c:order val="0"/>
+          <c:tx>
+            <c:strRef>
+              <c:f>Sheet1!$B$1</c:f>
+              <c:strCache>
+                <c:ptCount val="1"/>
+                <c:pt idx="0">
+                  <c:v>Seconds</c:v>
+                </c:pt>
+              </c:strCache>
+            </c:strRef>
+          </c:tx>
+          <c:spPr>
+            <a:solidFill>
+              <a:srgbClr val="2A64A8"/>
+            </a:solidFill>
+            <a:effectLst/>
+          </c:spPr>
+          <c:invertIfNegative val="0"/>
+          <c:dLbls>
+            <c:numFmt formatCode="#,##0&quot;s&quot;" sourceLinked="0"/>
+            <c:txPr>
+              <a:bodyPr/>
+              <a:lstStyle/>
+              <a:p>
+                <a:pPr>
+                  <a:defRPr b="0" i="0" strike="noStrike" sz="1100" u="none">
+                    <a:solidFill>
+                      <a:srgbClr val="14213D"/>
+                    </a:solidFill>
+                    <a:latin typeface="+mn-lt"/>
+                  </a:defRPr>
+                </a:pPr>
+              </a:p>
+            </c:txPr>
+            <c:showLegendKey val="0"/>
+            <c:showVal val="1"/>
+            <c:showCatName val="0"/>
+            <c:showSerName val="0"/>
+            <c:showPercent val="0"/>
+            <c:showBubbleSize val="0"/>
+            <c:showLeaderLines val="0"/>
+          </c:dLbls>
+          <c:dPt>
+            <c:idx val="0"/>
+            <c:invertIfNegative val="0"/>
+            <c:bubble3D val="0"/>
+            <c:spPr>
+              <a:solidFill>
+                <a:srgbClr val="2A64A8"/>
+              </a:solidFill>
+              <a:effectLst/>
+            </c:spPr>
+          </c:dPt>
+          <c:dPt>
+            <c:idx val="1"/>
+            <c:invertIfNegative val="0"/>
+            <c:bubble3D val="0"/>
+            <c:spPr>
+              <a:solidFill>
+                <a:srgbClr val="B85C1E"/>
+              </a:solidFill>
+              <a:effectLst/>
+            </c:spPr>
+          </c:dPt>
+          <c:dPt>
+            <c:idx val="2"/>
+            <c:invertIfNegative val="0"/>
+            <c:bubble3D val="0"/>
+            <c:spPr>
+              <a:solidFill>
+                <a:srgbClr val="2A64A8"/>
+              </a:solidFill>
+              <a:effectLst/>
+            </c:spPr>
+          </c:dPt>
+          <c:dPt>
+            <c:idx val="3"/>
+            <c:invertIfNegative val="0"/>
+            <c:bubble3D val="0"/>
+            <c:spPr>
+              <a:solidFill>
+                <a:srgbClr val="B85C1E"/>
+              </a:solidFill>
+              <a:effectLst/>
+            </c:spPr>
+          </c:dPt>
+          <c:cat>
+            <c:multiLvlStrRef>
+              <c:f>Sheet1!$A$2:$A$5</c:f>
+              <c:multiLvlStrCache>
+                <c:ptCount val="4"/>
+                <c:lvl>
+                  <c:pt idx="0">
+                    <c:v>20 jobs Single</c:v>
+                  </c:pt>
+                  <c:pt idx="1">
+                    <c:v>20 jobs Multi</c:v>
+                  </c:pt>
+                  <c:pt idx="2">
+                    <c:v>50 jobs Single</c:v>
+                  </c:pt>
+                  <c:pt idx="3">
+                    <c:v>50 jobs Multi</c:v>
+                  </c:pt>
+                </c:lvl>
+              </c:multiLvlStrCache>
+            </c:multiLvlStrRef>
+          </c:cat>
+          <c:val>
+            <c:numRef>
+              <c:f>Sheet1!$B$2:$B$5</c:f>
+              <c:numCache>
+                <c:formatCode>General</c:formatCode>
+                <c:ptCount val="4"/>
+                <c:pt idx="0">
+                  <c:v>65.5</c:v>
+                </c:pt>
+                <c:pt idx="1">
+                  <c:v>274.4</c:v>
+                </c:pt>
+                <c:pt idx="2">
+                  <c:v>354.8</c:v>
+                </c:pt>
+                <c:pt idx="3">
+                  <c:v>1200.2</c:v>
+                </c:pt>
+              </c:numCache>
+            </c:numRef>
+          </c:val>
+        </c:ser>
+        <c:dLbls>
+          <c:numFmt formatCode="#,##0&quot;s&quot;" sourceLinked="0"/>
+          <c:txPr>
+            <a:bodyPr/>
+            <a:lstStyle/>
+            <a:p>
+              <a:pPr>
+                <a:defRPr b="0" i="0" strike="noStrike" sz="1100" u="none">
+                  <a:solidFill>
+                    <a:srgbClr val="14213D"/>
+                  </a:solidFill>
+                  <a:latin typeface="+mn-lt"/>
+                </a:defRPr>
+              </a:pPr>
+            </a:p>
+          </c:txPr>
+          <c:showLegendKey val="0"/>
+          <c:showVal val="1"/>
+          <c:showCatName val="0"/>
+          <c:showSerName val="0"/>
+          <c:showPercent val="0"/>
+          <c:showBubbleSize val="0"/>
+          <c:showLeaderLines val="0"/>
+        </c:dLbls>
+        <c:gapWidth val="60"/>
+        <c:overlap val="0"/>
+        <c:axId val="2094734554"/>
+        <c:axId val="2094734552"/>
+        <c:axId val="2094734556"/>
+      </c:barChart>
+      <c:catAx>
+        <c:axId val="2094734554"/>
+        <c:scaling>
+          <c:orientation val="minMax"/>
+        </c:scaling>
+        <c:delete val="0"/>
+        <c:axPos val="b"/>
+        <c:numFmt formatCode="General" sourceLinked="1"/>
+        <c:majorTickMark val="out"/>
+        <c:minorTickMark val="none"/>
+        <c:tickLblPos val="low"/>
+        <c:spPr>
+          <a:ln w="12700" cap="flat">
+            <a:solidFill>
+              <a:srgbClr val="888888"/>
+            </a:solidFill>
+            <a:prstDash val="solid"/>
+            <a:round/>
+          </a:ln>
+        </c:spPr>
+        <c:txPr>
+          <a:bodyPr/>
+          <a:lstStyle/>
+          <a:p>
+            <a:pPr>
+              <a:defRPr sz="1000" b="0" i="0" u="none" strike="noStrike">
+                <a:solidFill>
+                  <a:srgbClr val="4A5568"/>
+                </a:solidFill>
+                <a:latin typeface="+mn-lt"/>
+              </a:defRPr>
+            </a:pPr>
+            <a:endParaRPr lang="en-US"/>
+          </a:p>
+        </c:txPr>
+        <c:crossAx val="2094734552"/>
+        <c:crosses val="autoZero"/>
+        <c:auto val="1"/>
+        <c:lblAlgn val="ctr"/>
+        <c:noMultiLvlLbl val="1"/>
+      </c:catAx>
+      <c:valAx>
+        <c:axId val="2094734552"/>
+        <c:scaling>
+          <c:orientation val="minMax"/>
+        </c:scaling>
+        <c:delete val="1"/>
+        <c:axPos val="l"/>
+        <c:numFmt formatCode="General" sourceLinked="0"/>
+        <c:majorTickMark val="out"/>
+        <c:minorTickMark val="none"/>
+        <c:tickLblPos val="nextTo"/>
+        <c:spPr>
+          <a:ln w="12700" cap="flat">
+            <a:solidFill>
+              <a:srgbClr val="888888"/>
+            </a:solidFill>
+            <a:prstDash val="solid"/>
+            <a:round/>
+          </a:ln>
+        </c:spPr>
+        <c:txPr>
+          <a:bodyPr/>
+          <a:lstStyle/>
+          <a:p>
+            <a:pPr>
+              <a:defRPr sz="1200" b="0" i="0" u="none" strike="noStrike">
+                <a:solidFill>
+                  <a:srgbClr val="000000"/>
+                </a:solidFill>
+                <a:latin typeface="Arial"/>
+              </a:defRPr>
+            </a:pPr>
+            <a:endParaRPr lang="en-US"/>
+          </a:p>
+        </c:txPr>
+        <c:crossAx val="2094734554"/>
+        <c:crosses val="autoZero"/>
+        <c:crossBetween val="between"/>
+      </c:valAx>
+      <c:spPr>
+        <a:solidFill>
+          <a:srgbClr val="FFFFFF"/>
+        </a:solidFill>
+        <a:ln>
+          <a:noFill/>
+        </a:ln>
+        <a:effectLst/>
+      </c:spPr>
+    </c:plotArea>
+    <c:plotVisOnly val="1"/>
+    <c:dispBlanksAs val="span"/>
+  </c:chart>
+  <c:spPr>
+    <a:noFill/>
+    <a:ln>
+      <a:noFill/>
+    </a:ln>
+    <a:effectLst/>
+  </c:spPr>
+  <c:externalData r:id="rId1">
+    <c:autoUpdate val="0"/>
+  </c:externalData>
+</c:chartSpace>
+</file>
+
+<file path=ppt/charts/chart2.xml><?xml version="1.0" encoding="utf-8"?>
+<c:chartSpace xmlns:c="http://schemas.openxmlformats.org/drawingml/2006/chart" xmlns:a="http://schemas.openxmlformats.org/drawingml/2006/main" xmlns:r="http://schemas.openxmlformats.org/officeDocument/2006/relationships">
+  <c:date1904 val="0"/>
+  <c:roundedCorners val="1"/>
+  <c:chart>
+    <c:title>
+      <c:tx>
+        <c:rich>
+          <a:bodyPr/>
+          <a:lstStyle/>
+          <a:p>
+            <a:pPr>
+              <a:defRPr sz="1300" b="0" i="0" u="none" strike="noStrike">
+                <a:solidFill>
+                  <a:srgbClr val="14213D"/>
+                </a:solidFill>
+                <a:latin typeface="+mn-lt"/>
+              </a:defRPr>
+            </a:pPr>
+            <a:r>
+              <a:rPr sz="1300" b="0" i="0" u="none" strike="noStrike">
+                <a:solidFill>
+                  <a:srgbClr val="14213D"/>
+                </a:solidFill>
+                <a:latin typeface="+mn-lt"/>
+              </a:rPr>
+              <a:t>Tokens per completed run (thousands)</a:t>
+            </a:r>
+          </a:p>
+        </c:rich>
+      </c:tx>
+      <c:layout/>
+      <c:overlay val="0"/>
+    </c:title>
+    <c:autoTitleDeleted val="0"/>
+    <c:plotArea>
+      <c:layout/>
+      <c:barChart>
+        <c:barDir val="col"/>
+        <c:grouping val="clustered"/>
+        <c:varyColors val="0"/>
+        <c:ser>
+          <c:idx val="0"/>
+          <c:order val="0"/>
+          <c:tx>
+            <c:strRef>
+              <c:f>Sheet1!$B$1</c:f>
+              <c:strCache>
+                <c:ptCount val="1"/>
+                <c:pt idx="0">
+                  <c:v>Tokens</c:v>
+                </c:pt>
+              </c:strCache>
+            </c:strRef>
+          </c:tx>
+          <c:spPr>
+            <a:solidFill>
+              <a:srgbClr val="2A64A8"/>
+            </a:solidFill>
+            <a:effectLst/>
+          </c:spPr>
+          <c:invertIfNegative val="0"/>
+          <c:dLbls>
+            <c:numFmt formatCode="#,##0&quot;k&quot;" sourceLinked="0"/>
+            <c:txPr>
+              <a:bodyPr/>
+              <a:lstStyle/>
+              <a:p>
+                <a:pPr>
+                  <a:defRPr b="0" i="0" strike="noStrike" sz="1100" u="none">
+                    <a:solidFill>
+                      <a:srgbClr val="14213D"/>
+                    </a:solidFill>
+                    <a:latin typeface="+mn-lt"/>
+                  </a:defRPr>
+                </a:pPr>
+              </a:p>
+            </c:txPr>
+            <c:showLegendKey val="0"/>
+            <c:showVal val="1"/>
+            <c:showCatName val="0"/>
+            <c:showSerName val="0"/>
+            <c:showPercent val="0"/>
+            <c:showBubbleSize val="0"/>
+            <c:showLeaderLines val="0"/>
+          </c:dLbls>
+          <c:dPt>
+            <c:idx val="0"/>
+            <c:invertIfNegative val="0"/>
+            <c:bubble3D val="0"/>
+            <c:spPr>
+              <a:solidFill>
+                <a:srgbClr val="2A64A8"/>
+              </a:solidFill>
+              <a:effectLst/>
+            </c:spPr>
+          </c:dPt>
+          <c:dPt>
+            <c:idx val="1"/>
+            <c:invertIfNegative val="0"/>
+            <c:bubble3D val="0"/>
+            <c:spPr>
+              <a:solidFill>
+                <a:srgbClr val="B85C1E"/>
+              </a:solidFill>
+              <a:effectLst/>
+            </c:spPr>
+          </c:dPt>
+          <c:dPt>
+            <c:idx val="2"/>
+            <c:invertIfNegative val="0"/>
+            <c:bubble3D val="0"/>
+            <c:spPr>
+              <a:solidFill>
+                <a:srgbClr val="2A64A8"/>
+              </a:solidFill>
+              <a:effectLst/>
+            </c:spPr>
+          </c:dPt>
+          <c:dPt>
+            <c:idx val="3"/>
+            <c:invertIfNegative val="0"/>
+            <c:bubble3D val="0"/>
+            <c:spPr>
+              <a:solidFill>
+                <a:srgbClr val="B85C1E"/>
+              </a:solidFill>
+              <a:effectLst/>
+            </c:spPr>
+          </c:dPt>
+          <c:cat>
+            <c:multiLvlStrRef>
+              <c:f>Sheet1!$A$2:$A$5</c:f>
+              <c:multiLvlStrCache>
+                <c:ptCount val="4"/>
+                <c:lvl>
+                  <c:pt idx="0">
+                    <c:v>20 jobs Single</c:v>
+                  </c:pt>
+                  <c:pt idx="1">
+                    <c:v>20 jobs Multi</c:v>
+                  </c:pt>
+                  <c:pt idx="2">
+                    <c:v>50 jobs Single</c:v>
+                  </c:pt>
+                  <c:pt idx="3">
+                    <c:v>50 jobs Multi</c:v>
+                  </c:pt>
+                </c:lvl>
+              </c:multiLvlStrCache>
+            </c:multiLvlStrRef>
+          </c:cat>
+          <c:val>
+            <c:numRef>
+              <c:f>Sheet1!$B$2:$B$5</c:f>
+              <c:numCache>
+                <c:formatCode>General</c:formatCode>
+                <c:ptCount val="4"/>
+                <c:pt idx="0">
+                  <c:v>31.3</c:v>
+                </c:pt>
+                <c:pt idx="1">
+                  <c:v>92.8</c:v>
+                </c:pt>
+                <c:pt idx="2">
+                  <c:v>73.5</c:v>
+                </c:pt>
+                <c:pt idx="3">
+                  <c:v>214.6</c:v>
+                </c:pt>
+              </c:numCache>
+            </c:numRef>
+          </c:val>
+        </c:ser>
+        <c:dLbls>
+          <c:numFmt formatCode="#,##0&quot;k&quot;" sourceLinked="0"/>
+          <c:txPr>
+            <a:bodyPr/>
+            <a:lstStyle/>
+            <a:p>
+              <a:pPr>
+                <a:defRPr b="0" i="0" strike="noStrike" sz="1100" u="none">
+                  <a:solidFill>
+                    <a:srgbClr val="14213D"/>
+                  </a:solidFill>
+                  <a:latin typeface="+mn-lt"/>
+                </a:defRPr>
+              </a:pPr>
+            </a:p>
+          </c:txPr>
+          <c:showLegendKey val="0"/>
+          <c:showVal val="1"/>
+          <c:showCatName val="0"/>
+          <c:showSerName val="0"/>
+          <c:showPercent val="0"/>
+          <c:showBubbleSize val="0"/>
+          <c:showLeaderLines val="0"/>
+        </c:dLbls>
+        <c:gapWidth val="60"/>
+        <c:overlap val="0"/>
+        <c:axId val="2094734554"/>
+        <c:axId val="2094734552"/>
+        <c:axId val="2094734556"/>
+      </c:barChart>
+      <c:catAx>
+        <c:axId val="2094734554"/>
+        <c:scaling>
+          <c:orientation val="minMax"/>
+        </c:scaling>
+        <c:delete val="0"/>
+        <c:axPos val="b"/>
+        <c:numFmt formatCode="General" sourceLinked="1"/>
+        <c:majorTickMark val="out"/>
+        <c:minorTickMark val="none"/>
+        <c:tickLblPos val="low"/>
+        <c:spPr>
+          <a:ln w="12700" cap="flat">
+            <a:solidFill>
+              <a:srgbClr val="888888"/>
+            </a:solidFill>
+            <a:prstDash val="solid"/>
+            <a:round/>
+          </a:ln>
+        </c:spPr>
+        <c:txPr>
+          <a:bodyPr/>
+          <a:lstStyle/>
+          <a:p>
+            <a:pPr>
+              <a:defRPr sz="1000" b="0" i="0" u="none" strike="noStrike">
+                <a:solidFill>
+                  <a:srgbClr val="4A5568"/>
+                </a:solidFill>
+                <a:latin typeface="+mn-lt"/>
+              </a:defRPr>
+            </a:pPr>
+            <a:endParaRPr lang="en-US"/>
+          </a:p>
+        </c:txPr>
+        <c:crossAx val="2094734552"/>
+        <c:crosses val="autoZero"/>
+        <c:auto val="1"/>
+        <c:lblAlgn val="ctr"/>
+        <c:noMultiLvlLbl val="1"/>
+      </c:catAx>
+      <c:valAx>
+        <c:axId val="2094734552"/>
+        <c:scaling>
+          <c:orientation val="minMax"/>
+        </c:scaling>
+        <c:delete val="1"/>
+        <c:axPos val="l"/>
+        <c:numFmt formatCode="General" sourceLinked="0"/>
+        <c:majorTickMark val="out"/>
+        <c:minorTickMark val="none"/>
+        <c:tickLblPos val="nextTo"/>
+        <c:spPr>
+          <a:ln w="12700" cap="flat">
+            <a:solidFill>
+              <a:srgbClr val="888888"/>
+            </a:solidFill>
+            <a:prstDash val="solid"/>
+            <a:round/>
+          </a:ln>
+        </c:spPr>
+        <c:txPr>
+          <a:bodyPr/>
+          <a:lstStyle/>
+          <a:p>
+            <a:pPr>
+              <a:defRPr sz="1200" b="0" i="0" u="none" strike="noStrike">
+                <a:solidFill>
+                  <a:srgbClr val="000000"/>
+                </a:solidFill>
+                <a:latin typeface="Arial"/>
+              </a:defRPr>
+            </a:pPr>
+            <a:endParaRPr lang="en-US"/>
+          </a:p>
+        </c:txPr>
+        <c:crossAx val="2094734554"/>
+        <c:crosses val="autoZero"/>
+        <c:crossBetween val="between"/>
+      </c:valAx>
+      <c:spPr>
+        <a:solidFill>
+          <a:srgbClr val="FFFFFF"/>
+        </a:solidFill>
+        <a:ln>
+          <a:noFill/>
+        </a:ln>
+        <a:effectLst/>
+      </c:spPr>
+    </c:plotArea>
+    <c:plotVisOnly val="1"/>
+    <c:dispBlanksAs val="span"/>
+  </c:chart>
+  <c:spPr>
+    <a:noFill/>
+    <a:ln>
+      <a:noFill/>
+    </a:ln>
+    <a:effectLst/>
+  </c:spPr>
+  <c:externalData r:id="rId1">
+    <c:autoUpdate val="0"/>
+  </c:externalData>
+</c:chartSpace>
 </file>
 
 <file path=ppt/notesMasters/notesMaster1.xml><?xml version="1.0" encoding="utf-8"?>
@@ -614,7 +1240,7 @@
           <a:p>
             <a:r>
               <a:rPr lang="en-US" dirty="0"/>
-              <a:t>Job data was pulled Sept 24: 219 postings fetched, filtered to early-career US software/data roles, 20 flagged as the small workload (10 per source). Resumes: 10 chosen from 33 student resumes from a previous course, mostly new-grad CS / CompE / data, with a mix of SWE, data, AI/ML and embedded backgrounds. Location preferences were assigned by us since the owners didn't state any. The labeling rubric follows the proposal: relevant means core quals and stated constraints are met; a missing preferred skill alone doesn't count against it.</a:t>
+              <a:t>Job data was pulled Sept 24: 219 postings fetched, filtered to early-career US software/data roles, 20 flagged as the small workload (10 per source). Resumes: 10 chosen from 33 student resumes from a previous course, mostly new-grad CS / CompE / data, with a mix of SWE, data, AI/ML and embedded backgrounds. Location preferences were assigned by us. Labels: Kevin, Ritvik and Aidan labeled all 400 eval pairs (8 resumes x 50 jobs) by applying the rubric before any matcher output existed; 109 are relevant, and every no has a reason code. The 80-pair second review by the team is still to do.</a:t>
             </a:r>
             <a:endParaRPr lang="en-US" dirty="0"/>
           </a:p>
@@ -702,7 +1328,7 @@
           <a:p>
             <a:r>
               <a:rPr lang="en-US" dirty="0"/>
-              <a:t>The baseline sends the cleaned resume, preferences and every job description in one call and gets back five ranked job IDs with explanations. It shares input cleanup, model, output limit, ranking prompt and validation with the orchestrator, so the only difference is the architecture. The local benchmark runs both pipelines on the 2 dev resumes against 20 and 50 jobs (8 runs) and measures tokens and wall-clock time; it doesn't measure accuracy, that needs the human labels.</a:t>
+              <a:t>The baseline sends the cleaned resume, preferences and every job description in one call and gets back five ranked job IDs with explanations. It shares input cleanup, model, output limit, ranking prompt and validation with the orchestrator, so the only difference is the architecture. The local benchmark runs both pipelines on the 2 dev resumes against 20 and 50 jobs (8 runs) and measures tokens and wall-clock time; it doesn't measure accuracy; that's the Precision@5 step using the 400 reference labels.</a:t>
             </a:r>
             <a:endParaRPr lang="en-US" dirty="0"/>
           </a:p>
@@ -790,7 +1416,7 @@
           <a:p>
             <a:r>
               <a:rPr lang="en-US" dirty="0"/>
-              <a:t>The requirement extractor now selects numbered lines from each posting (at most four per required / preferred / constraints) and the controller restores the exact original text, so nothing gets paraphrased or invented. The ranker gets those references plus the full numbered postings. Local runs have $0 API cost; hardware and electricity aren't measured. Cloud runs would use GPT-4.1 mini at prices recorded Oct 6. No quality numbers yet, those need the human labels.</a:t>
+              <a:t>The requirement extractor now selects numbered lines from each posting (at most four per required / preferred / constraints) and the controller restores the exact original text, so nothing gets paraphrased or invented. The ranker gets those references plus the full numbered postings. Local runs have $0 API cost; hardware and electricity aren't measured. Cloud runs would use GPT-4.1 mini at prices recorded Oct 6. In the benchmark both R02 multi-agent runs failed the resume-evidence check, so that validator needs a look. No quality numbers yet; Precision@5 against the reference labels is next.</a:t>
             </a:r>
             <a:endParaRPr lang="en-US" dirty="0"/>
           </a:p>
@@ -814,6 +1440,94 @@
             <a:fld id="{F7021451-1387-4CA6-816F-3879F97B5CBC}" type="slidenum">
               <a:rPr lang="en-US"/>
               <a:t>4</a:t>
+            </a:fld>
+            <a:endParaRPr lang="en-US"/>
+          </a:p>
+        </p:txBody>
+      </p:sp>
+    </p:spTree>
+    <p:extLst>
+      <p:ext uri="{BB962C8B-B14F-4D97-AF65-F5344CB8AC3E}">
+        <p14:creationId xmlns:p14="http://schemas.microsoft.com/office/powerpoint/2010/main" val="1024086991"/>
+      </p:ext>
+    </p:extLst>
+  </p:cSld>
+  <p:clrMapOvr>
+    <a:masterClrMapping/>
+  </p:clrMapOvr>
+</p:notes>
+</file>
+
+<file path=ppt/notesSlides/notesSlide5.xml><?xml version="1.0" encoding="utf-8"?>
+<p:notes xmlns:a="http://schemas.openxmlformats.org/drawingml/2006/main" xmlns:r="http://schemas.openxmlformats.org/officeDocument/2006/relationships" xmlns:p="http://schemas.openxmlformats.org/presentationml/2006/main">
+  <p:cSld>
+    <p:spTree>
+      <p:nvGrpSpPr>
+        <p:cNvPr id="1" name=""/>
+        <p:cNvGrpSpPr/>
+        <p:nvPr/>
+      </p:nvGrpSpPr>
+      <p:grpSpPr>
+        <a:xfrm>
+          <a:off x="0" y="0"/>
+          <a:ext cx="0" cy="0"/>
+          <a:chOff x="0" y="0"/>
+          <a:chExt cx="0" cy="0"/>
+        </a:xfrm>
+      </p:grpSpPr>
+      <p:sp>
+        <p:nvSpPr>
+          <p:cNvPr id="2" name="Slide Image Placeholder 1"/>
+          <p:cNvSpPr>
+            <a:spLocks noGrp="1" noRot="1" noChangeAspect="1"/>
+          </p:cNvSpPr>
+          <p:nvPr>
+            <p:ph type="sldImg"/>
+          </p:nvPr>
+        </p:nvSpPr>
+        <p:spPr/>
+      </p:sp>
+      <p:sp>
+        <p:nvSpPr>
+          <p:cNvPr id="3" name="Notes Placeholder 2"/>
+          <p:cNvSpPr>
+            <a:spLocks noGrp="1"/>
+          </p:cNvSpPr>
+          <p:nvPr>
+            <p:ph type="body" idx="1"/>
+          </p:nvPr>
+        </p:nvSpPr>
+        <p:spPr/>
+        <p:txBody>
+          <a:bodyPr/>
+          <a:lstStyle/>
+          <a:p>
+            <a:r>
+              <a:rPr lang="en-US" dirty="0"/>
+              <a:t>Kevin ran both pipelines locally: 2 dev resumes x 20 and 50 jobs x 2 architectures = 8 runs, 6 completed. Single agent: 65.5s and 31k tokens at 20 jobs, 355s and 74k tokens at 50 jobs. Multi agent: 274s and 93k tokens at 20 jobs, 1,200s and 215k tokens at 50 jobs. On the same resume (R01) multi agent was 4.2x slower at 20 jobs and 4.5x slower at 50. Both R02 multi-agent runs failed: the resume parser returned evidence that wasn't an exact quote, so the validator rejected it. Local runs have $0 API charges; hardware and electricity weren't measured. On R01 with 20 jobs the two pipelines agreed on 2 of their top 5 picks; that's agreement, not accuracy. Small sample, one repetition, model already warm, so treat these as early numbers.</a:t>
+            </a:r>
+            <a:endParaRPr lang="en-US" dirty="0"/>
+          </a:p>
+        </p:txBody>
+      </p:sp>
+      <p:sp>
+        <p:nvSpPr>
+          <p:cNvPr id="4" name="Slide Number Placeholder 3"/>
+          <p:cNvSpPr>
+            <a:spLocks noGrp="1"/>
+          </p:cNvSpPr>
+          <p:nvPr>
+            <p:ph type="sldNum" sz="quarter" idx="10"/>
+          </p:nvPr>
+        </p:nvSpPr>
+        <p:spPr/>
+        <p:txBody>
+          <a:bodyPr/>
+          <a:lstStyle/>
+          <a:p>
+            <a:fld id="{F7021451-1387-4CA6-816F-3879F97B5CBC}" type="slidenum">
+              <a:rPr lang="en-US"/>
+              <a:t>5</a:t>
             </a:fld>
             <a:endParaRPr lang="en-US"/>
           </a:p>
@@ -1715,7 +2429,7 @@
                   <a:srgbClr val="F7F5EF"/>
                 </a:solidFill>
               </a:rPr>
-              <a:t>Jobs + resumes done · labeling next</a:t>
+              <a:t>Jobs, resumes, labels done</a:t>
             </a:r>
             <a:endParaRPr lang="en-US" sz="1100" dirty="0"/>
           </a:p>
@@ -1753,7 +2467,7 @@
                   <a:srgbClr val="14213D"/>
                 </a:solidFill>
               </a:rPr>
-              <a:t>Jobs and resumes are in; labeling is next</a:t>
+              <a:t>Jobs, resumes and labels are ready</a:t>
             </a:r>
             <a:endParaRPr lang="en-US" sz="2800" dirty="0"/>
           </a:p>
@@ -2149,7 +2863,7 @@
                   <a:srgbClr val="4A5568"/>
                 </a:solidFill>
               </a:rPr>
-              <a:t>label rows ready, 0 filled</a:t>
+              <a:t>pairs labeled, 109 relevant (labeled by the team)</a:t>
             </a:r>
             <a:endParaRPr lang="en-US" sz="1200" dirty="0"/>
           </a:p>
@@ -2261,7 +2975,7 @@
                   <a:srgbClr val="2D3748"/>
                 </a:solidFill>
               </a:rPr>
-              <a:t>Rubric, 400 + 80 label sheets, agreement / kappa script</a:t>
+              <a:t>All 400 resume × job pairs labeled with the rubric, by Kevin, Ritvik and Aidan</a:t>
             </a:r>
             <a:endParaRPr lang="en-US" sz="1300" dirty="0"/>
           </a:p>
@@ -2337,7 +3051,7 @@
                   <a:srgbClr val="2D3748"/>
                 </a:solidFill>
               </a:rPr>
-              <a:t>Team calibration on the 2 dev resumes</a:t>
+              <a:t>Team second review of 80 pairs</a:t>
             </a:r>
             <a:endParaRPr lang="en-US" sz="1300" dirty="0"/>
           </a:p>
@@ -2355,7 +3069,7 @@
                   <a:srgbClr val="2D3748"/>
                 </a:solidFill>
               </a:rPr>
-              <a:t>Label all 400 pairs before seeing any predictions</a:t>
+              <a:t>Score both matchers with Precision@5</a:t>
             </a:r>
             <a:endParaRPr lang="en-US" sz="1300" dirty="0"/>
           </a:p>
@@ -2507,7 +3221,7 @@
                   <a:srgbClr val="F7F5EF"/>
                 </a:solidFill>
               </a:rPr>
-              <a:t>Built · benchmark running</a:t>
+              <a:t>Built · benchmarked</a:t>
             </a:r>
             <a:endParaRPr lang="en-US" sz="1100" dirty="0"/>
           </a:p>
@@ -2919,7 +3633,7 @@
                   <a:srgbClr val="2D3748"/>
                 </a:solidFill>
               </a:rPr>
-              <a:t>Paired cost / speed benchmark vs. orchestrator on a local Qwen3 4B model (no API cost)</a:t>
+              <a:t>Local benchmark: 65s / 31k tokens at 20 jobs, 355s / 74k at 50 jobs, 4 of 4 runs passed</a:t>
             </a:r>
             <a:endParaRPr lang="en-US" sz="1300" dirty="0"/>
           </a:p>
@@ -2995,7 +3709,7 @@
                   <a:srgbClr val="2D3748"/>
                 </a:solidFill>
               </a:rPr>
-              <a:t>Finish the local benchmark and generate the PDF report</a:t>
+              <a:t>Precision@5 on the 8 eval resumes</a:t>
             </a:r>
             <a:endParaRPr lang="en-US" sz="1300" dirty="0"/>
           </a:p>
@@ -3013,7 +3727,7 @@
                   <a:srgbClr val="2D3748"/>
                 </a:solidFill>
               </a:rPr>
-              <a:t>Quality comparison once labels are done</a:t>
+              <a:t>Repeat timing with 3 repetitions</a:t>
             </a:r>
             <a:endParaRPr lang="en-US" sz="1300" dirty="0"/>
           </a:p>
@@ -3165,7 +3879,7 @@
                   <a:srgbClr val="F7F5EF"/>
                 </a:solidFill>
               </a:rPr>
-              <a:t>Built · 16 offline tests pass</a:t>
+              <a:t>Built · benchmarked</a:t>
             </a:r>
             <a:endParaRPr lang="en-US" sz="1100" dirty="0"/>
           </a:p>
@@ -3577,7 +4291,7 @@
                   <a:srgbClr val="2D3748"/>
                 </a:solidFill>
               </a:rPr>
-              <a:t>Logs tokens, cost, latency, retries; 48 + 6 runs scripted</a:t>
+              <a:t>Local benchmark: 274s / 93k tokens at 20 jobs, 1,200s / 215k at 50 jobs</a:t>
             </a:r>
             <a:endParaRPr lang="en-US" sz="1300" dirty="0"/>
           </a:p>
@@ -3653,7 +4367,7 @@
                   <a:srgbClr val="2D3748"/>
                 </a:solidFill>
               </a:rPr>
-              <a:t>8-run paired pilot with both pipelines</a:t>
+              <a:t>Fix evidence check: 2 of 4 runs failed</a:t>
             </a:r>
             <a:endParaRPr lang="en-US" sz="1300" dirty="0"/>
           </a:p>
@@ -3671,7 +4385,7 @@
                   <a:srgbClr val="2D3748"/>
                 </a:solidFill>
               </a:rPr>
-              <a:t>Full 96-run comparison after labels</a:t>
+              <a:t>Precision@5, then the 96-run comparison</a:t>
             </a:r>
             <a:endParaRPr lang="en-US" sz="1300" dirty="0"/>
           </a:p>
@@ -3720,6 +4434,354 @@
             <a:fld id="{F7021451-1387-4CA6-816F-3879F97B5CBC}" type="slidenum">
               <a:rPr b="0" lang="en-US"/>
               <a:t>4</a:t>
+            </a:fld>
+            <a:endParaRPr lang="en-US"/>
+          </a:p>
+        </p:txBody>
+      </p:sp>
+    </p:spTree>
+  </p:cSld>
+  <p:clrMapOvr>
+    <a:masterClrMapping/>
+  </p:clrMapOvr>
+</p:sld>
+</file>
+
+<file path=ppt/slides/slide5.xml><?xml version="1.0" encoding="utf-8"?>
+<p:sld xmlns:a="http://schemas.openxmlformats.org/drawingml/2006/main" xmlns:r="http://schemas.openxmlformats.org/officeDocument/2006/relationships" xmlns:p="http://schemas.openxmlformats.org/presentationml/2006/main">
+  <p:cSld name="Slide 5">
+    <p:spTree>
+      <p:nvGrpSpPr>
+        <p:cNvPr id="1" name=""/>
+        <p:cNvGrpSpPr/>
+        <p:nvPr/>
+      </p:nvGrpSpPr>
+      <p:grpSpPr>
+        <a:xfrm>
+          <a:off x="0" y="0"/>
+          <a:ext cx="0" cy="0"/>
+          <a:chOff x="0" y="0"/>
+          <a:chExt cx="0" cy="0"/>
+        </a:xfrm>
+      </p:grpSpPr>
+      <p:sp>
+        <p:nvSpPr>
+          <p:cNvPr id="2" name="eyebrow"/>
+          <p:cNvSpPr txBox="1"/>
+          <p:nvPr/>
+        </p:nvSpPr>
+        <p:spPr>
+          <a:xfrm>
+            <a:off x="548640" y="365760"/>
+            <a:ext cx="5120640" cy="274320"/>
+          </a:xfrm>
+          <a:prstGeom prst="rect">
+            <a:avLst/>
+          </a:prstGeom>
+          <a:noFill/>
+          <a:ln/>
+        </p:spPr>
+        <p:txBody>
+          <a:bodyPr wrap="square" lIns="0" tIns="0" rIns="0" bIns="0" rtlCol="0" anchor="ctr"/>
+          <a:lstStyle/>
+          <a:p>
+            <a:pPr indent="0" marL="0">
+              <a:buNone/>
+            </a:pPr>
+            <a:r>
+              <a:rPr lang="en-US" sz="1200" spc="150" kern="0" dirty="0">
+                <a:solidFill>
+                  <a:srgbClr val="B85C1E"/>
+                </a:solidFill>
+                <a:latin typeface="Courier New" pitchFamily="34" charset="0"/>
+                <a:ea typeface="Courier New" pitchFamily="34" charset="-122"/>
+                <a:cs typeface="Courier New" pitchFamily="34" charset="-120"/>
+              </a:rPr>
+              <a:t>04 · FIRST MEASUREMENTS</a:t>
+            </a:r>
+            <a:endParaRPr lang="en-US" sz="1200" dirty="0"/>
+          </a:p>
+        </p:txBody>
+      </p:sp>
+      <p:sp>
+        <p:nvSpPr>
+          <p:cNvPr id="3" name="status"/>
+          <p:cNvSpPr/>
+          <p:nvPr/>
+        </p:nvSpPr>
+        <p:spPr>
+          <a:xfrm>
+            <a:off x="5669280" y="329184"/>
+            <a:ext cx="2926080" cy="329184"/>
+          </a:xfrm>
+          <a:prstGeom prst="roundRect">
+            <a:avLst>
+              <a:gd name="adj" fmla="val 138889"/>
+            </a:avLst>
+          </a:prstGeom>
+          <a:solidFill>
+            <a:srgbClr val="2F5D8C"/>
+          </a:solidFill>
+          <a:ln/>
+        </p:spPr>
+        <p:txBody>
+          <a:bodyPr wrap="square" lIns="0" tIns="0" rIns="0" bIns="0" rtlCol="0" anchor="ctr"/>
+          <a:lstStyle/>
+          <a:p>
+            <a:pPr algn="ctr" indent="0" marL="0">
+              <a:buNone/>
+            </a:pPr>
+            <a:r>
+              <a:rPr lang="en-US" sz="1100" b="1" dirty="0">
+                <a:solidFill>
+                  <a:srgbClr val="F7F5EF"/>
+                </a:solidFill>
+              </a:rPr>
+              <a:t>Local benchmark · 8 runs</a:t>
+            </a:r>
+            <a:endParaRPr lang="en-US" sz="1100" dirty="0"/>
+          </a:p>
+        </p:txBody>
+      </p:sp>
+      <p:sp>
+        <p:nvSpPr>
+          <p:cNvPr id="4" name="Text 0"/>
+          <p:cNvSpPr/>
+          <p:nvPr>
+            <p:ph idx="100" type="title" hasCustomPrompt="1"/>
+          </p:nvPr>
+        </p:nvSpPr>
+        <p:spPr>
+          <a:xfrm>
+            <a:off x="548640" y="777240"/>
+            <a:ext cx="8046720" cy="548640"/>
+          </a:xfrm>
+          <a:prstGeom prst="rect">
+            <a:avLst/>
+          </a:prstGeom>
+          <a:noFill/>
+          <a:ln/>
+        </p:spPr>
+        <p:txBody>
+          <a:bodyPr wrap="square" lIns="0" tIns="0" rIns="0" bIns="0" rtlCol="0" anchor="t"/>
+          <a:lstStyle/>
+          <a:p>
+            <a:pPr algn="l" indent="0" marL="0">
+              <a:buNone/>
+            </a:pPr>
+            <a:r>
+              <a:rPr lang="en-US" sz="2800" b="1" dirty="0">
+                <a:solidFill>
+                  <a:srgbClr val="14213D"/>
+                </a:solidFill>
+              </a:rPr>
+              <a:t>Multi-agent took ~4x the time and ~3x the tokens</a:t>
+            </a:r>
+            <a:endParaRPr lang="en-US" sz="2800" dirty="0"/>
+          </a:p>
+        </p:txBody>
+      </p:sp>
+      <p:sp>
+        <p:nvSpPr>
+          <p:cNvPr id="5" name="Text 3"/>
+          <p:cNvSpPr txBox="1"/>
+          <p:nvPr/>
+        </p:nvSpPr>
+        <p:spPr>
+          <a:xfrm>
+            <a:off x="548640" y="1325880"/>
+            <a:ext cx="8046720" cy="274320"/>
+          </a:xfrm>
+          <a:prstGeom prst="rect">
+            <a:avLst/>
+          </a:prstGeom>
+          <a:noFill/>
+          <a:ln/>
+        </p:spPr>
+        <p:txBody>
+          <a:bodyPr wrap="square" lIns="0" tIns="0" rIns="0" bIns="0" rtlCol="0" anchor="ctr"/>
+          <a:lstStyle/>
+          <a:p>
+            <a:pPr indent="0" marL="0">
+              <a:buNone/>
+            </a:pPr>
+            <a:r>
+              <a:rPr lang="en-US" sz="1300" dirty="0">
+                <a:solidFill>
+                  <a:srgbClr val="4A5568"/>
+                </a:solidFill>
+              </a:rPr>
+              <a:t>2 of 4 multi-agent runs failed the evidence check · top 5 overlapped 2 of 5 jobs on R01 / 20 jobs</a:t>
+            </a:r>
+            <a:endParaRPr lang="en-US" sz="1300" dirty="0"/>
+          </a:p>
+        </p:txBody>
+      </p:sp>
+      <p:sp>
+        <p:nvSpPr>
+          <p:cNvPr id="6" name="Shape 4"/>
+          <p:cNvSpPr/>
+          <p:nvPr/>
+        </p:nvSpPr>
+        <p:spPr>
+          <a:xfrm>
+            <a:off x="548640" y="1737360"/>
+            <a:ext cx="3931920" cy="2880360"/>
+          </a:xfrm>
+          <a:prstGeom prst="roundRect">
+            <a:avLst>
+              <a:gd name="adj" fmla="val 2540"/>
+            </a:avLst>
+          </a:prstGeom>
+          <a:solidFill>
+            <a:srgbClr val="FFFFFF"/>
+          </a:solidFill>
+          <a:ln w="9525">
+            <a:solidFill>
+              <a:srgbClr val="E2DED3"/>
+            </a:solidFill>
+            <a:prstDash val="solid"/>
+          </a:ln>
+        </p:spPr>
+      </p:sp>
+      <p:sp>
+        <p:nvSpPr>
+          <p:cNvPr id="7" name="Shape 5"/>
+          <p:cNvSpPr/>
+          <p:nvPr/>
+        </p:nvSpPr>
+        <p:spPr>
+          <a:xfrm>
+            <a:off x="4663440" y="1737360"/>
+            <a:ext cx="3931920" cy="2880360"/>
+          </a:xfrm>
+          <a:prstGeom prst="roundRect">
+            <a:avLst>
+              <a:gd name="adj" fmla="val 2540"/>
+            </a:avLst>
+          </a:prstGeom>
+          <a:solidFill>
+            <a:srgbClr val="FFFFFF"/>
+          </a:solidFill>
+          <a:ln w="9525">
+            <a:solidFill>
+              <a:srgbClr val="E2DED3"/>
+            </a:solidFill>
+            <a:prstDash val="solid"/>
+          </a:ln>
+        </p:spPr>
+      </p:sp>
+      <p:graphicFrame>
+        <p:nvGraphicFramePr>
+          <p:cNvPr id="8" name="time chart" descr=""/>
+          <p:cNvGraphicFramePr/>
+          <p:nvPr/>
+        </p:nvGraphicFramePr>
+        <p:xfrm>
+          <a:off x="640080" y="1810512"/>
+          <a:ext cx="3749040" cy="2743200"/>
+        </p:xfrm>
+        <a:graphic xmlns:a="http://schemas.openxmlformats.org/drawingml/2006/main">
+          <a:graphicData uri="http://schemas.openxmlformats.org/drawingml/2006/chart">
+            <c:chart xmlns:c="http://schemas.openxmlformats.org/drawingml/2006/chart" r:id="rId1"/>
+          </a:graphicData>
+        </a:graphic>
+      </p:graphicFrame>
+      <p:graphicFrame>
+        <p:nvGraphicFramePr>
+          <p:cNvPr id="9" name="token chart" descr=""/>
+          <p:cNvGraphicFramePr/>
+          <p:nvPr/>
+        </p:nvGraphicFramePr>
+        <p:xfrm>
+          <a:off x="4754880" y="1810512"/>
+          <a:ext cx="3749040" cy="2743200"/>
+        </p:xfrm>
+        <a:graphic xmlns:a="http://schemas.openxmlformats.org/drawingml/2006/main">
+          <a:graphicData uri="http://schemas.openxmlformats.org/drawingml/2006/chart">
+            <c:chart xmlns:c="http://schemas.openxmlformats.org/drawingml/2006/chart" r:id="rId2"/>
+          </a:graphicData>
+        </a:graphic>
+      </p:graphicFrame>
+      <p:sp>
+        <p:nvSpPr>
+          <p:cNvPr id="10" name="Text 6"/>
+          <p:cNvSpPr txBox="1"/>
+          <p:nvPr/>
+        </p:nvSpPr>
+        <p:spPr>
+          <a:xfrm>
+            <a:off x="1097280" y="4754880"/>
+            <a:ext cx="7498080" cy="228600"/>
+          </a:xfrm>
+          <a:prstGeom prst="rect">
+            <a:avLst/>
+          </a:prstGeom>
+          <a:noFill/>
+          <a:ln/>
+        </p:spPr>
+        <p:txBody>
+          <a:bodyPr wrap="square" lIns="0" tIns="0" rIns="0" bIns="0" rtlCol="0" anchor="ctr"/>
+          <a:lstStyle/>
+          <a:p>
+            <a:pPr indent="0" marL="0">
+              <a:buNone/>
+            </a:pPr>
+            <a:r>
+              <a:rPr lang="en-US" sz="1000" dirty="0">
+                <a:solidFill>
+                  <a:srgbClr val="718096"/>
+                </a:solidFill>
+              </a:rPr>
+              <a:t>Local Qwen3 4B (Ollama) on a Mac · R01–R02, 1 repetition · median of completed runs · $0 API cost</a:t>
+            </a:r>
+            <a:endParaRPr lang="en-US" sz="1000" dirty="0"/>
+          </a:p>
+        </p:txBody>
+      </p:sp>
+      <p:sp>
+        <p:nvSpPr>
+          <p:cNvPr id="25" name="Slide Number Placeholder 0"/>
+          <p:cNvSpPr>
+            <a:spLocks noGrp="1"/>
+          </p:cNvSpPr>
+          <p:nvPr>
+            <p:ph type="sldNum" sz="quarter" idx="4294967295"/>
+          </p:nvPr>
+        </p:nvSpPr>
+        <p:spPr>
+          <a:xfrm>
+            <a:off x="548640" y="4800600"/>
+            <a:ext cx="914400" cy="228600"/>
+          </a:xfrm>
+          <a:prstGeom prst="rect">
+            <a:avLst/>
+          </a:prstGeom>
+          <a:extLst>
+            <a:ext uri="{C572A759-6A51-4108-AA02-DFA0A04FC94B}">
+              <ma14:wrappingTextBoxFlag xmlns:ma14="http://schemas.microsoft.com/office/mac/drawingml/2011/main" val="0"/>
+            </a:ext>
+          </a:extLst>
+        </p:spPr>
+        <p:txBody>
+          <a:bodyPr/>
+          <a:lstStyle>
+            <a:lvl1pPr>
+              <a:defRPr sz="1000">
+                <a:solidFill>
+                  <a:srgbClr val="718096"/>
+                </a:solidFill>
+                <a:latin typeface="Calibri"/>
+                <a:ea typeface="Calibri"/>
+                <a:cs typeface="Calibri"/>
+              </a:defRPr>
+            </a:lvl1pPr>
+          </a:lstStyle>
+          <a:p>
+            <a:pPr algn="l"/>
+            <a:fld id="{F7021451-1387-4CA6-816F-3879F97B5CBC}" type="slidenum">
+              <a:rPr b="0" lang="en-US"/>
+              <a:t>5</a:t>
             </a:fld>
             <a:endParaRPr lang="en-US"/>
           </a:p>

</xml_diff>

<commit_message>
Add Precision@5 results and accuracy slide
The paired pilot passed 8/8 and the 96-run evaluation completed with no
failures on a Colab A100. Multi-agent matched or trailed the single agent
on Precision@5 (0.383 vs 0.433 at 20 jobs, 0.317 vs 0.317 at 50) while
taking 4-6x longer and about 2.8x the tokens; the decision rule is not met.

Adds data/reports/accuracy summaries, a results section in the README,
slide 6 with Precision@5 and timing charts, and refreshed status and
next steps on slides 3-4.

Co-Authored-By: Claude Opus 5.5 <noreply@anthropic.com>
</commit_message>
<xml_diff>
--- a/progress_update_2026-10.pptx
+++ b/progress_update_2026-10.pptx
@@ -10,6 +10,7 @@
     <p:sldId id="258" r:id="rId4"/>
     <p:sldId id="259" r:id="rId5"/>
     <p:sldId id="260" r:id="rId6"/>
+    <p:sldId id="261" r:id="rId12"/>
   </p:sldIdLst>
   <p:notesMasterIdLst>
     <p:notesMasterId r:id="rId7"/>
@@ -751,6 +752,486 @@
     </a:ln>
     <a:effectLst/>
   </c:spPr>
+  <c:externalData r:id="rId1">
+    <c:autoUpdate val="0"/>
+  </c:externalData>
+</c:chartSpace>
+</file>
+
+<file path=ppt/charts/chart3.xml><?xml version="1.0" encoding="utf-8"?>
+<c:chartSpace xmlns:c="http://schemas.openxmlformats.org/drawingml/2006/chart" xmlns:a="http://schemas.openxmlformats.org/drawingml/2006/main" xmlns:r="http://schemas.openxmlformats.org/officeDocument/2006/relationships">
+  <c:date1904 val="0"/>
+  <c:chart>
+    <c:title>
+      <c:tx>
+        <c:rich>
+          <a:bodyPr/>
+          <a:lstStyle/>
+          <a:p>
+            <a:r>
+              <a:rPr sz="1200" b="1">
+                <a:solidFill>
+                  <a:srgbClr val="14213D"/>
+                </a:solidFill>
+              </a:rPr>
+              <a:t>Precision@5 (higher is better)</a:t>
+            </a:r>
+          </a:p>
+        </c:rich>
+      </c:tx>
+      <c:layout/>
+      <c:overlay val="0"/>
+    </c:title>
+    <c:autoTitleDeleted val="0"/>
+    <c:plotArea>
+      <c:barChart>
+        <c:barDir val="col"/>
+        <c:grouping val="clustered"/>
+        <c:ser>
+          <c:idx val="0"/>
+          <c:order val="0"/>
+          <c:tx>
+            <c:strRef>
+              <c:f>Sheet1!$B$1</c:f>
+              <c:strCache>
+                <c:ptCount val="1"/>
+                <c:pt idx="0">
+                  <c:v>Single agent</c:v>
+                </c:pt>
+              </c:strCache>
+            </c:strRef>
+          </c:tx>
+          <c:spPr>
+            <a:solidFill>
+              <a:srgbClr val="2F5D8C"/>
+            </a:solidFill>
+          </c:spPr>
+          <c:cat>
+            <c:strRef>
+              <c:f>Sheet1!$A$2:$A$3</c:f>
+              <c:strCache>
+                <c:ptCount val="2"/>
+                <c:pt idx="0">
+                  <c:v>20 jobs</c:v>
+                </c:pt>
+                <c:pt idx="1">
+                  <c:v>50 jobs</c:v>
+                </c:pt>
+              </c:strCache>
+            </c:strRef>
+          </c:cat>
+          <c:val>
+            <c:numRef>
+              <c:f>Sheet1!$B$2:$B$3</c:f>
+              <c:numCache>
+                <c:formatCode>General</c:formatCode>
+                <c:ptCount val="2"/>
+                <c:pt idx="0">
+                  <c:v>0.433</c:v>
+                </c:pt>
+                <c:pt idx="1">
+                  <c:v>0.317</c:v>
+                </c:pt>
+              </c:numCache>
+            </c:numRef>
+          </c:val>
+        </c:ser>
+        <c:ser>
+          <c:idx val="1"/>
+          <c:order val="1"/>
+          <c:tx>
+            <c:strRef>
+              <c:f>Sheet1!$C$1</c:f>
+              <c:strCache>
+                <c:ptCount val="1"/>
+                <c:pt idx="0">
+                  <c:v>Multi-agent</c:v>
+                </c:pt>
+              </c:strCache>
+            </c:strRef>
+          </c:tx>
+          <c:spPr>
+            <a:solidFill>
+              <a:srgbClr val="B85C1E"/>
+            </a:solidFill>
+          </c:spPr>
+          <c:cat>
+            <c:strRef>
+              <c:f>Sheet1!$A$2:$A$3</c:f>
+              <c:strCache>
+                <c:ptCount val="2"/>
+                <c:pt idx="0">
+                  <c:v>20 jobs</c:v>
+                </c:pt>
+                <c:pt idx="1">
+                  <c:v>50 jobs</c:v>
+                </c:pt>
+              </c:strCache>
+            </c:strRef>
+          </c:cat>
+          <c:val>
+            <c:numRef>
+              <c:f>Sheet1!$C$2:$C$3</c:f>
+              <c:numCache>
+                <c:formatCode>General</c:formatCode>
+                <c:ptCount val="2"/>
+                <c:pt idx="0">
+                  <c:v>0.383</c:v>
+                </c:pt>
+                <c:pt idx="1">
+                  <c:v>0.317</c:v>
+                </c:pt>
+              </c:numCache>
+            </c:numRef>
+          </c:val>
+        </c:ser>
+        <c:dLbls>
+          <c:numFmt formatCode="0.00" sourceLinked="0"/>
+          <c:txPr>
+            <a:bodyPr/>
+            <a:lstStyle/>
+            <a:p>
+              <a:pPr>
+                <a:defRPr sz="1000" b="1">
+                  <a:solidFill>
+                    <a:srgbClr val="14213D"/>
+                  </a:solidFill>
+                </a:defRPr>
+              </a:pPr>
+            </a:p>
+          </c:txPr>
+          <c:dLblPos val="outEnd"/>
+          <c:showLegendKey val="0"/>
+          <c:showVal val="1"/>
+          <c:showCatName val="0"/>
+          <c:showSerName val="0"/>
+          <c:showPercent val="0"/>
+          <c:showBubbleSize val="0"/>
+          <c:showLeaderLines val="1"/>
+        </c:dLbls>
+        <c:gapWidth val="80"/>
+        <c:overlap val="-10"/>
+        <c:axId val="-2068027336"/>
+        <c:axId val="-2113994440"/>
+      </c:barChart>
+      <c:catAx>
+        <c:axId val="-2068027336"/>
+        <c:scaling>
+          <c:orientation val="minMax"/>
+        </c:scaling>
+        <c:delete val="0"/>
+        <c:axPos val="b"/>
+        <c:majorTickMark val="out"/>
+        <c:minorTickMark val="none"/>
+        <c:tickLblPos val="nextTo"/>
+        <c:spPr>
+          <a:ln>
+            <a:solidFill>
+              <a:srgbClr val="CBD5E0"/>
+            </a:solidFill>
+          </a:ln>
+        </c:spPr>
+        <c:txPr>
+          <a:bodyPr/>
+          <a:lstStyle/>
+          <a:p>
+            <a:pPr>
+              <a:defRPr sz="1000">
+                <a:solidFill>
+                  <a:srgbClr val="4A5568"/>
+                </a:solidFill>
+              </a:defRPr>
+            </a:pPr>
+          </a:p>
+        </c:txPr>
+        <c:crossAx val="-2113994440"/>
+        <c:crosses val="autoZero"/>
+        <c:auto val="1"/>
+        <c:lblAlgn val="ctr"/>
+        <c:lblOffset val="100"/>
+        <c:noMultiLvlLbl val="0"/>
+      </c:catAx>
+      <c:valAx>
+        <c:axId val="-2113994440"/>
+        <c:scaling/>
+        <c:delete/>
+        <c:axPos val="l"/>
+        <c:majorTickMark val="out"/>
+        <c:minorTickMark val="none"/>
+        <c:tickLblPos val="nextTo"/>
+        <c:crossAx val="-2068027336"/>
+        <c:crosses val="autoZero"/>
+      </c:valAx>
+    </c:plotArea>
+    <c:legend>
+      <c:legendPos val="b"/>
+      <c:overlay val="0"/>
+      <c:txPr>
+        <a:bodyPr/>
+        <a:lstStyle/>
+        <a:p>
+          <a:pPr>
+            <a:defRPr sz="1000">
+              <a:solidFill>
+                <a:srgbClr val="4A5568"/>
+              </a:solidFill>
+            </a:defRPr>
+          </a:pPr>
+        </a:p>
+      </c:txPr>
+    </c:legend>
+    <c:dispBlanksAs val="gap"/>
+  </c:chart>
+  <c:txPr>
+    <a:bodyPr/>
+    <a:lstStyle/>
+    <a:p>
+      <a:pPr>
+        <a:defRPr sz="1800"/>
+      </a:pPr>
+      <a:endParaRPr lang="en-US"/>
+    </a:p>
+  </c:txPr>
+  <c:externalData r:id="rId1">
+    <c:autoUpdate val="0"/>
+  </c:externalData>
+</c:chartSpace>
+</file>
+
+<file path=ppt/charts/chart4.xml><?xml version="1.0" encoding="utf-8"?>
+<c:chartSpace xmlns:c="http://schemas.openxmlformats.org/drawingml/2006/chart" xmlns:a="http://schemas.openxmlformats.org/drawingml/2006/main" xmlns:r="http://schemas.openxmlformats.org/officeDocument/2006/relationships">
+  <c:date1904 val="0"/>
+  <c:chart>
+    <c:title>
+      <c:tx>
+        <c:rich>
+          <a:bodyPr/>
+          <a:lstStyle/>
+          <a:p>
+            <a:r>
+              <a:rPr sz="1200" b="1">
+                <a:solidFill>
+                  <a:srgbClr val="14213D"/>
+                </a:solidFill>
+              </a:rPr>
+              <a:t>Median seconds per resume</a:t>
+            </a:r>
+          </a:p>
+        </c:rich>
+      </c:tx>
+      <c:layout/>
+      <c:overlay val="0"/>
+    </c:title>
+    <c:autoTitleDeleted val="0"/>
+    <c:plotArea>
+      <c:barChart>
+        <c:barDir val="col"/>
+        <c:grouping val="clustered"/>
+        <c:ser>
+          <c:idx val="0"/>
+          <c:order val="0"/>
+          <c:tx>
+            <c:strRef>
+              <c:f>Sheet1!$B$1</c:f>
+              <c:strCache>
+                <c:ptCount val="1"/>
+                <c:pt idx="0">
+                  <c:v>Single agent</c:v>
+                </c:pt>
+              </c:strCache>
+            </c:strRef>
+          </c:tx>
+          <c:spPr>
+            <a:solidFill>
+              <a:srgbClr val="2F5D8C"/>
+            </a:solidFill>
+          </c:spPr>
+          <c:cat>
+            <c:strRef>
+              <c:f>Sheet1!$A$2:$A$3</c:f>
+              <c:strCache>
+                <c:ptCount val="2"/>
+                <c:pt idx="0">
+                  <c:v>20 jobs</c:v>
+                </c:pt>
+                <c:pt idx="1">
+                  <c:v>50 jobs</c:v>
+                </c:pt>
+              </c:strCache>
+            </c:strRef>
+          </c:cat>
+          <c:val>
+            <c:numRef>
+              <c:f>Sheet1!$B$2:$B$3</c:f>
+              <c:numCache>
+                <c:formatCode>General</c:formatCode>
+                <c:ptCount val="2"/>
+                <c:pt idx="0">
+                  <c:v>13.4</c:v>
+                </c:pt>
+                <c:pt idx="1">
+                  <c:v>33.4</c:v>
+                </c:pt>
+              </c:numCache>
+            </c:numRef>
+          </c:val>
+        </c:ser>
+        <c:ser>
+          <c:idx val="1"/>
+          <c:order val="1"/>
+          <c:tx>
+            <c:strRef>
+              <c:f>Sheet1!$C$1</c:f>
+              <c:strCache>
+                <c:ptCount val="1"/>
+                <c:pt idx="0">
+                  <c:v>Multi-agent</c:v>
+                </c:pt>
+              </c:strCache>
+            </c:strRef>
+          </c:tx>
+          <c:spPr>
+            <a:solidFill>
+              <a:srgbClr val="B85C1E"/>
+            </a:solidFill>
+          </c:spPr>
+          <c:cat>
+            <c:strRef>
+              <c:f>Sheet1!$A$2:$A$3</c:f>
+              <c:strCache>
+                <c:ptCount val="2"/>
+                <c:pt idx="0">
+                  <c:v>20 jobs</c:v>
+                </c:pt>
+                <c:pt idx="1">
+                  <c:v>50 jobs</c:v>
+                </c:pt>
+              </c:strCache>
+            </c:strRef>
+          </c:cat>
+          <c:val>
+            <c:numRef>
+              <c:f>Sheet1!$C$2:$C$3</c:f>
+              <c:numCache>
+                <c:formatCode>General</c:formatCode>
+                <c:ptCount val="2"/>
+                <c:pt idx="0">
+                  <c:v>51.9</c:v>
+                </c:pt>
+                <c:pt idx="1">
+                  <c:v>197.6</c:v>
+                </c:pt>
+              </c:numCache>
+            </c:numRef>
+          </c:val>
+        </c:ser>
+        <c:dLbls>
+          <c:numFmt formatCode="0&quot;s&quot;" sourceLinked="0"/>
+          <c:txPr>
+            <a:bodyPr/>
+            <a:lstStyle/>
+            <a:p>
+              <a:pPr>
+                <a:defRPr sz="1000" b="1">
+                  <a:solidFill>
+                    <a:srgbClr val="14213D"/>
+                  </a:solidFill>
+                </a:defRPr>
+              </a:pPr>
+            </a:p>
+          </c:txPr>
+          <c:dLblPos val="outEnd"/>
+          <c:showLegendKey val="0"/>
+          <c:showVal val="1"/>
+          <c:showCatName val="0"/>
+          <c:showSerName val="0"/>
+          <c:showPercent val="0"/>
+          <c:showBubbleSize val="0"/>
+          <c:showLeaderLines val="1"/>
+        </c:dLbls>
+        <c:gapWidth val="80"/>
+        <c:overlap val="-10"/>
+        <c:axId val="-2068027336"/>
+        <c:axId val="-2113994440"/>
+      </c:barChart>
+      <c:catAx>
+        <c:axId val="-2068027336"/>
+        <c:scaling>
+          <c:orientation val="minMax"/>
+        </c:scaling>
+        <c:delete val="0"/>
+        <c:axPos val="b"/>
+        <c:majorTickMark val="out"/>
+        <c:minorTickMark val="none"/>
+        <c:tickLblPos val="nextTo"/>
+        <c:spPr>
+          <a:ln>
+            <a:solidFill>
+              <a:srgbClr val="CBD5E0"/>
+            </a:solidFill>
+          </a:ln>
+        </c:spPr>
+        <c:txPr>
+          <a:bodyPr/>
+          <a:lstStyle/>
+          <a:p>
+            <a:pPr>
+              <a:defRPr sz="1000">
+                <a:solidFill>
+                  <a:srgbClr val="4A5568"/>
+                </a:solidFill>
+              </a:defRPr>
+            </a:pPr>
+          </a:p>
+        </c:txPr>
+        <c:crossAx val="-2113994440"/>
+        <c:crosses val="autoZero"/>
+        <c:auto val="1"/>
+        <c:lblAlgn val="ctr"/>
+        <c:lblOffset val="100"/>
+        <c:noMultiLvlLbl val="0"/>
+      </c:catAx>
+      <c:valAx>
+        <c:axId val="-2113994440"/>
+        <c:scaling/>
+        <c:delete/>
+        <c:axPos val="l"/>
+        <c:majorTickMark val="out"/>
+        <c:minorTickMark val="none"/>
+        <c:tickLblPos val="nextTo"/>
+        <c:crossAx val="-2068027336"/>
+        <c:crosses val="autoZero"/>
+      </c:valAx>
+    </c:plotArea>
+    <c:legend>
+      <c:legendPos val="b"/>
+      <c:overlay val="0"/>
+      <c:txPr>
+        <a:bodyPr/>
+        <a:lstStyle/>
+        <a:p>
+          <a:pPr>
+            <a:defRPr sz="1000">
+              <a:solidFill>
+                <a:srgbClr val="4A5568"/>
+              </a:solidFill>
+            </a:defRPr>
+          </a:pPr>
+        </a:p>
+      </c:txPr>
+    </c:legend>
+    <c:dispBlanksAs val="gap"/>
+  </c:chart>
+  <c:txPr>
+    <a:bodyPr/>
+    <a:lstStyle/>
+    <a:p>
+      <a:pPr>
+        <a:defRPr sz="1800"/>
+      </a:pPr>
+      <a:endParaRPr lang="en-US"/>
+    </a:p>
+  </c:txPr>
   <c:externalData r:id="rId1">
     <c:autoUpdate val="0"/>
   </c:externalData>
@@ -3221,7 +3702,7 @@
                   <a:srgbClr val="F7F5EF"/>
                 </a:solidFill>
               </a:rPr>
-              <a:t>Built · benchmarked</a:t>
+              <a:t>Built · evaluated</a:t>
             </a:r>
             <a:endParaRPr lang="en-US" sz="1100" dirty="0"/>
           </a:p>
@@ -3709,7 +4190,7 @@
                   <a:srgbClr val="2D3748"/>
                 </a:solidFill>
               </a:rPr>
-              <a:t>Precision@5 on the 8 eval resumes</a:t>
+              <a:t>Second label review (80 pairs) to confirm the scores</a:t>
             </a:r>
             <a:endParaRPr lang="en-US" sz="1300" dirty="0"/>
           </a:p>
@@ -3727,7 +4208,7 @@
                   <a:srgbClr val="2D3748"/>
                 </a:solidFill>
               </a:rPr>
-              <a:t>Repeat timing with 3 repetitions</a:t>
+              <a:t>Error analysis on low scorers (R04: 0 of 5 relevant)</a:t>
             </a:r>
             <a:endParaRPr lang="en-US" sz="1300" dirty="0"/>
           </a:p>
@@ -3879,7 +4360,7 @@
                   <a:srgbClr val="F7F5EF"/>
                 </a:solidFill>
               </a:rPr>
-              <a:t>Built · benchmarked</a:t>
+              <a:t>Built · evaluated</a:t>
             </a:r>
             <a:endParaRPr lang="en-US" sz="1100" dirty="0"/>
           </a:p>
@@ -4367,7 +4848,7 @@
                   <a:srgbClr val="2D3748"/>
                 </a:solidFill>
               </a:rPr>
-              <a:t>Fix evidence check: 2 of 4 runs failed</a:t>
+              <a:t>Fixed: resume parser cites line IDs, 0 of 48 eval runs failed</a:t>
             </a:r>
             <a:endParaRPr lang="en-US" sz="1300" dirty="0"/>
           </a:p>
@@ -4385,7 +4866,7 @@
                   <a:srgbClr val="2D3748"/>
                 </a:solidFill>
               </a:rPr>
-              <a:t>Precision@5, then the 96-run comparison</a:t>
+              <a:t>Find out why extra steps did not raise Precision@5</a:t>
             </a:r>
             <a:endParaRPr lang="en-US" sz="1300" dirty="0"/>
           </a:p>
@@ -4787,6 +5268,348 @@
           </a:p>
         </p:txBody>
       </p:sp>
+    </p:spTree>
+  </p:cSld>
+  <p:clrMapOvr>
+    <a:masterClrMapping/>
+  </p:clrMapOvr>
+</p:sld>
+</file>
+
+<file path=ppt/slides/slide6.xml><?xml version="1.0" encoding="utf-8"?>
+<p:sld xmlns:a="http://schemas.openxmlformats.org/drawingml/2006/main" xmlns:p="http://schemas.openxmlformats.org/presentationml/2006/main" xmlns:r="http://schemas.openxmlformats.org/officeDocument/2006/relationships">
+  <p:cSld>
+    <p:spTree>
+      <p:nvGrpSpPr>
+        <p:cNvPr id="1" name=""/>
+        <p:cNvGrpSpPr/>
+        <p:nvPr/>
+      </p:nvGrpSpPr>
+      <p:grpSpPr/>
+      <p:sp>
+        <p:nvSpPr>
+          <p:cNvPr id="2" name="eyebrow"/>
+          <p:cNvSpPr txBox="1"/>
+          <p:nvPr/>
+        </p:nvSpPr>
+        <p:spPr>
+          <a:xfrm>
+            <a:off x="548640" y="365760"/>
+            <a:ext cx="5120640" cy="274320"/>
+          </a:xfrm>
+          <a:prstGeom prst="rect">
+            <a:avLst/>
+          </a:prstGeom>
+          <a:noFill/>
+          <a:ln/>
+        </p:spPr>
+        <p:txBody>
+          <a:bodyPr wrap="square" lIns="0" tIns="0" rIns="0" bIns="0" rtlCol="0" anchor="ctr"/>
+          <a:lstStyle/>
+          <a:p>
+            <a:pPr indent="0" marL="0">
+              <a:buNone/>
+            </a:pPr>
+            <a:r>
+              <a:rPr lang="en-US" sz="1200" spc="150" kern="0" dirty="0">
+                <a:solidFill>
+                  <a:srgbClr val="B85C1E"/>
+                </a:solidFill>
+                <a:latin typeface="Courier New" pitchFamily="34" charset="0"/>
+                <a:ea typeface="Courier New" pitchFamily="34" charset="-122"/>
+                <a:cs typeface="Courier New" pitchFamily="34" charset="-120"/>
+              </a:rPr>
+              <a:t>05 · ACCURACY (PRECISION@5)</a:t>
+            </a:r>
+            <a:endParaRPr lang="en-US" sz="1200" dirty="0"/>
+          </a:p>
+        </p:txBody>
+      </p:sp>
+      <p:sp>
+        <p:nvSpPr>
+          <p:cNvPr id="3" name="status"/>
+          <p:cNvSpPr/>
+          <p:nvPr/>
+        </p:nvSpPr>
+        <p:spPr>
+          <a:xfrm>
+            <a:off x="5669280" y="329184"/>
+            <a:ext cx="2926080" cy="329184"/>
+          </a:xfrm>
+          <a:prstGeom prst="roundRect">
+            <a:avLst>
+              <a:gd name="adj" fmla="val 138889"/>
+            </a:avLst>
+          </a:prstGeom>
+          <a:solidFill>
+            <a:srgbClr val="2F5D8C"/>
+          </a:solidFill>
+          <a:ln/>
+        </p:spPr>
+        <p:txBody>
+          <a:bodyPr wrap="square" lIns="0" tIns="0" rIns="0" bIns="0" rtlCol="0" anchor="ctr"/>
+          <a:lstStyle/>
+          <a:p>
+            <a:pPr algn="ctr" indent="0" marL="0">
+              <a:buNone/>
+            </a:pPr>
+            <a:r>
+              <a:rPr lang="en-US" sz="1100" b="1" dirty="0">
+                <a:solidFill>
+                  <a:srgbClr val="F7F5EF"/>
+                </a:solidFill>
+              </a:rPr>
+              <a:t>Held-out eval · 96 runs</a:t>
+            </a:r>
+            <a:endParaRPr lang="en-US" sz="1100" dirty="0"/>
+          </a:p>
+        </p:txBody>
+      </p:sp>
+      <p:sp>
+        <p:nvSpPr>
+          <p:cNvPr id="4" name="Text 0"/>
+          <p:cNvSpPr/>
+          <p:nvPr>
+            <p:ph idx="100" type="title" hasCustomPrompt="1"/>
+          </p:nvPr>
+        </p:nvSpPr>
+        <p:spPr>
+          <a:xfrm>
+            <a:off x="548640" y="777240"/>
+            <a:ext cx="8046720" cy="548640"/>
+          </a:xfrm>
+          <a:prstGeom prst="rect">
+            <a:avLst/>
+          </a:prstGeom>
+          <a:noFill/>
+          <a:ln/>
+        </p:spPr>
+        <p:txBody>
+          <a:bodyPr wrap="square" lIns="0" tIns="0" rIns="0" bIns="0" rtlCol="0" anchor="t"/>
+          <a:lstStyle/>
+          <a:p>
+            <a:pPr algn="l" indent="0" marL="0">
+              <a:buNone/>
+            </a:pPr>
+            <a:r>
+              <a:rPr lang="en-US" sz="2800" b="1" dirty="0">
+                <a:solidFill>
+                  <a:srgbClr val="14213D"/>
+                </a:solidFill>
+              </a:rPr>
+              <a:t>Multi-agent was no more accurate, and 4–6x slower</a:t>
+            </a:r>
+            <a:endParaRPr lang="en-US" sz="2800" dirty="0"/>
+          </a:p>
+        </p:txBody>
+      </p:sp>
+      <p:sp>
+        <p:nvSpPr>
+          <p:cNvPr id="5" name="Text 3"/>
+          <p:cNvSpPr txBox="1"/>
+          <p:nvPr/>
+        </p:nvSpPr>
+        <p:spPr>
+          <a:xfrm>
+            <a:off x="548640" y="1325880"/>
+            <a:ext cx="8046720" cy="274320"/>
+          </a:xfrm>
+          <a:prstGeom prst="rect">
+            <a:avLst/>
+          </a:prstGeom>
+          <a:noFill/>
+          <a:ln/>
+        </p:spPr>
+        <p:txBody>
+          <a:bodyPr wrap="square" lIns="0" tIns="0" rIns="0" bIns="0" rtlCol="0" anchor="ctr"/>
+          <a:lstStyle/>
+          <a:p>
+            <a:pPr indent="0" marL="0">
+              <a:buNone/>
+            </a:pPr>
+            <a:r>
+              <a:rPr lang="en-US" sz="1300" dirty="0">
+                <a:solidFill>
+                  <a:srgbClr val="4A5568"/>
+                </a:solidFill>
+              </a:rPr>
+              <a:t>Multi-agent better on 1 of 8 resumes at 50 jobs, worse on 2 · decision rule (+5 pts, ≤2x cost/time) misses</a:t>
+            </a:r>
+            <a:endParaRPr lang="en-US" sz="1300" dirty="0"/>
+          </a:p>
+        </p:txBody>
+      </p:sp>
+      <p:sp>
+        <p:nvSpPr>
+          <p:cNvPr id="6" name="Shape 4"/>
+          <p:cNvSpPr/>
+          <p:nvPr/>
+        </p:nvSpPr>
+        <p:spPr>
+          <a:xfrm>
+            <a:off x="548640" y="1737360"/>
+            <a:ext cx="3931920" cy="2880360"/>
+          </a:xfrm>
+          <a:prstGeom prst="roundRect">
+            <a:avLst>
+              <a:gd name="adj" fmla="val 2540"/>
+            </a:avLst>
+          </a:prstGeom>
+          <a:solidFill>
+            <a:srgbClr val="FFFFFF"/>
+          </a:solidFill>
+          <a:ln w="9525">
+            <a:solidFill>
+              <a:srgbClr val="E2DED3"/>
+            </a:solidFill>
+            <a:prstDash val="solid"/>
+          </a:ln>
+        </p:spPr>
+      </p:sp>
+      <p:sp>
+        <p:nvSpPr>
+          <p:cNvPr id="7" name="Shape 5"/>
+          <p:cNvSpPr/>
+          <p:nvPr/>
+        </p:nvSpPr>
+        <p:spPr>
+          <a:xfrm>
+            <a:off x="4663440" y="1737360"/>
+            <a:ext cx="3931920" cy="2880360"/>
+          </a:xfrm>
+          <a:prstGeom prst="roundRect">
+            <a:avLst>
+              <a:gd name="adj" fmla="val 2540"/>
+            </a:avLst>
+          </a:prstGeom>
+          <a:solidFill>
+            <a:srgbClr val="FFFFFF"/>
+          </a:solidFill>
+          <a:ln w="9525">
+            <a:solidFill>
+              <a:srgbClr val="E2DED3"/>
+            </a:solidFill>
+            <a:prstDash val="solid"/>
+          </a:ln>
+        </p:spPr>
+      </p:sp>
+      <p:sp>
+        <p:nvSpPr>
+          <p:cNvPr id="10" name="Text 6"/>
+          <p:cNvSpPr txBox="1"/>
+          <p:nvPr/>
+        </p:nvSpPr>
+        <p:spPr>
+          <a:xfrm>
+            <a:off x="1097280" y="4754880"/>
+            <a:ext cx="7498080" cy="228600"/>
+          </a:xfrm>
+          <a:prstGeom prst="rect">
+            <a:avLst/>
+          </a:prstGeom>
+          <a:noFill/>
+          <a:ln/>
+        </p:spPr>
+        <p:txBody>
+          <a:bodyPr wrap="square" lIns="0" tIns="0" rIns="0" bIns="0" rtlCol="0" anchor="ctr"/>
+          <a:lstStyle/>
+          <a:p>
+            <a:pPr indent="0" marL="0">
+              <a:buNone/>
+            </a:pPr>
+            <a:r>
+              <a:rPr lang="en-US" sz="1000" dirty="0">
+                <a:solidFill>
+                  <a:srgbClr val="718096"/>
+                </a:solidFill>
+              </a:rPr>
+              <a:t>Qwen3 4B on a Colab A100 · R03–R10 × 3 reps vs. 400 team labels · multi used 2.8x tokens · 0/96 runs failed</a:t>
+            </a:r>
+            <a:endParaRPr lang="en-US" sz="1000" dirty="0"/>
+          </a:p>
+        </p:txBody>
+      </p:sp>
+      <p:sp>
+        <p:nvSpPr>
+          <p:cNvPr id="25" name="Slide Number Placeholder 0"/>
+          <p:cNvSpPr>
+            <a:spLocks noGrp="1"/>
+          </p:cNvSpPr>
+          <p:nvPr>
+            <p:ph type="sldNum" sz="quarter" idx="4294967295"/>
+          </p:nvPr>
+        </p:nvSpPr>
+        <p:spPr>
+          <a:xfrm>
+            <a:off x="548640" y="4800600"/>
+            <a:ext cx="914400" cy="228600"/>
+          </a:xfrm>
+          <a:prstGeom prst="rect">
+            <a:avLst/>
+          </a:prstGeom>
+          <a:extLst>
+            <a:ext uri="{C572A759-6A51-4108-AA02-DFA0A04FC94B}">
+              <ma14:wrappingTextBoxFlag xmlns:ma14="http://schemas.microsoft.com/office/mac/drawingml/2011/main" val="0"/>
+            </a:ext>
+          </a:extLst>
+        </p:spPr>
+        <p:txBody>
+          <a:bodyPr/>
+          <a:lstStyle>
+            <a:lvl1pPr>
+              <a:defRPr sz="1000">
+                <a:solidFill>
+                  <a:srgbClr val="718096"/>
+                </a:solidFill>
+                <a:latin typeface="Calibri"/>
+                <a:ea typeface="Calibri"/>
+                <a:cs typeface="Calibri"/>
+              </a:defRPr>
+            </a:lvl1pPr>
+          </a:lstStyle>
+          <a:p>
+            <a:r>
+              <a:t>6</a:t>
+            </a:r>
+          </a:p>
+        </p:txBody>
+      </p:sp>
+      <p:graphicFrame>
+        <p:nvGraphicFramePr>
+          <p:cNvPr id="26" name="Chart 25"/>
+          <p:cNvGraphicFramePr>
+            <a:graphicFrameLocks noGrp="1"/>
+          </p:cNvGraphicFramePr>
+          <p:nvPr/>
+        </p:nvGraphicFramePr>
+        <p:xfrm>
+          <a:off x="640080" y="1810512"/>
+          <a:ext cx="3749040" cy="2734056"/>
+        </p:xfrm>
+        <a:graphic>
+          <a:graphicData uri="http://schemas.openxmlformats.org/drawingml/2006/chart">
+            <c:chart xmlns:c="http://schemas.openxmlformats.org/drawingml/2006/chart" r:id="rId2"/>
+          </a:graphicData>
+        </a:graphic>
+      </p:graphicFrame>
+      <p:graphicFrame>
+        <p:nvGraphicFramePr>
+          <p:cNvPr id="27" name="Chart 26"/>
+          <p:cNvGraphicFramePr>
+            <a:graphicFrameLocks noGrp="1"/>
+          </p:cNvGraphicFramePr>
+          <p:nvPr/>
+        </p:nvGraphicFramePr>
+        <p:xfrm>
+          <a:off x="4754880" y="1810512"/>
+          <a:ext cx="3749040" cy="2734056"/>
+        </p:xfrm>
+        <a:graphic>
+          <a:graphicData uri="http://schemas.openxmlformats.org/drawingml/2006/chart">
+            <c:chart xmlns:c="http://schemas.openxmlformats.org/drawingml/2006/chart" r:id="rId3"/>
+          </a:graphicData>
+        </a:graphic>
+      </p:graphicFrame>
     </p:spTree>
   </p:cSld>
   <p:clrMapOvr>

</xml_diff>

<commit_message>
Add slide 7: each pipeline's actual top-5 picks for two example resumes
Co-Authored-By: Claude Opus 5.5 <noreply@anthropic.com>
</commit_message>
<xml_diff>
--- a/progress_update_2026-10.pptx
+++ b/progress_update_2026-10.pptx
@@ -11,6 +11,7 @@
     <p:sldId id="259" r:id="rId5"/>
     <p:sldId id="260" r:id="rId6"/>
     <p:sldId id="261" r:id="rId12"/>
+    <p:sldId id="262" r:id="rId13"/>
   </p:sldIdLst>
   <p:notesMasterIdLst>
     <p:notesMasterId r:id="rId7"/>
@@ -5610,6 +5611,970 @@
           </a:graphicData>
         </a:graphic>
       </p:graphicFrame>
+    </p:spTree>
+  </p:cSld>
+  <p:clrMapOvr>
+    <a:masterClrMapping/>
+  </p:clrMapOvr>
+</p:sld>
+</file>
+
+<file path=ppt/slides/slide7.xml><?xml version="1.0" encoding="utf-8"?>
+<p:sld xmlns:a="http://schemas.openxmlformats.org/drawingml/2006/main" xmlns:p="http://schemas.openxmlformats.org/presentationml/2006/main" xmlns:r="http://schemas.openxmlformats.org/officeDocument/2006/relationships">
+  <p:cSld>
+    <p:spTree>
+      <p:nvGrpSpPr>
+        <p:cNvPr id="1" name=""/>
+        <p:cNvGrpSpPr/>
+        <p:nvPr/>
+      </p:nvGrpSpPr>
+      <p:grpSpPr/>
+      <p:sp>
+        <p:nvSpPr>
+          <p:cNvPr id="2" name="eyebrow"/>
+          <p:cNvSpPr txBox="1"/>
+          <p:nvPr/>
+        </p:nvSpPr>
+        <p:spPr>
+          <a:xfrm>
+            <a:off x="548640" y="365760"/>
+            <a:ext cx="5120640" cy="274320"/>
+          </a:xfrm>
+          <a:prstGeom prst="rect">
+            <a:avLst/>
+          </a:prstGeom>
+          <a:noFill/>
+          <a:ln/>
+        </p:spPr>
+        <p:txBody>
+          <a:bodyPr wrap="square" lIns="0" tIns="0" rIns="0" bIns="0" rtlCol="0" anchor="ctr"/>
+          <a:lstStyle/>
+          <a:p>
+            <a:pPr indent="0" marL="0">
+              <a:buNone/>
+            </a:pPr>
+            <a:r>
+              <a:rPr lang="en-US" sz="1200" spc="150" kern="0" dirty="0">
+                <a:solidFill>
+                  <a:srgbClr val="B85C1E"/>
+                </a:solidFill>
+                <a:latin typeface="Courier New" pitchFamily="34" charset="0"/>
+                <a:ea typeface="Courier New" pitchFamily="34" charset="-122"/>
+                <a:cs typeface="Courier New" pitchFamily="34" charset="-120"/>
+              </a:rPr>
+              <a:t>06 · WHAT THEY ACTUALLY PICKED</a:t>
+            </a:r>
+            <a:endParaRPr lang="en-US" sz="1200" dirty="0"/>
+          </a:p>
+        </p:txBody>
+      </p:sp>
+      <p:sp>
+        <p:nvSpPr>
+          <p:cNvPr id="3" name="status"/>
+          <p:cNvSpPr/>
+          <p:nvPr/>
+        </p:nvSpPr>
+        <p:spPr>
+          <a:xfrm>
+            <a:off x="5669280" y="329184"/>
+            <a:ext cx="2926080" cy="329184"/>
+          </a:xfrm>
+          <a:prstGeom prst="roundRect">
+            <a:avLst>
+              <a:gd name="adj" fmla="val 138889"/>
+            </a:avLst>
+          </a:prstGeom>
+          <a:solidFill>
+            <a:srgbClr val="2F5D8C"/>
+          </a:solidFill>
+          <a:ln/>
+        </p:spPr>
+        <p:txBody>
+          <a:bodyPr wrap="square" lIns="0" tIns="0" rIns="0" bIns="0" rtlCol="0" anchor="ctr"/>
+          <a:lstStyle/>
+          <a:p>
+            <a:pPr algn="ctr" indent="0" marL="0">
+              <a:buNone/>
+            </a:pPr>
+            <a:r>
+              <a:rPr lang="en-US" sz="1100" b="1" dirty="0">
+                <a:solidFill>
+                  <a:srgbClr val="F7F5EF"/>
+                </a:solidFill>
+              </a:rPr>
+              <a:t>Example top 5s · 50 jobs</a:t>
+            </a:r>
+            <a:endParaRPr lang="en-US" sz="1100" dirty="0"/>
+          </a:p>
+        </p:txBody>
+      </p:sp>
+      <p:sp>
+        <p:nvSpPr>
+          <p:cNvPr id="4" name="Text 0"/>
+          <p:cNvSpPr/>
+          <p:nvPr>
+            <p:ph idx="100" type="title" hasCustomPrompt="1"/>
+          </p:nvPr>
+        </p:nvSpPr>
+        <p:spPr>
+          <a:xfrm>
+            <a:off x="548640" y="777240"/>
+            <a:ext cx="8046720" cy="548640"/>
+          </a:xfrm>
+          <a:prstGeom prst="rect">
+            <a:avLst/>
+          </a:prstGeom>
+          <a:noFill/>
+          <a:ln/>
+        </p:spPr>
+        <p:txBody>
+          <a:bodyPr wrap="square" lIns="0" tIns="0" rIns="0" bIns="0" rtlCol="0" anchor="t"/>
+          <a:lstStyle/>
+          <a:p>
+            <a:pPr algn="l" indent="0" marL="0">
+              <a:buNone/>
+            </a:pPr>
+            <a:r>
+              <a:rPr lang="en-US" sz="2800" b="1" dirty="0">
+                <a:solidFill>
+                  <a:srgbClr val="14213D"/>
+                </a:solidFill>
+              </a:rPr>
+              <a:t>Same resume, different picks: it cuts both ways</a:t>
+            </a:r>
+            <a:endParaRPr lang="en-US" sz="2800" dirty="0"/>
+          </a:p>
+        </p:txBody>
+      </p:sp>
+      <p:sp>
+        <p:nvSpPr>
+          <p:cNvPr id="5" name="Text 3"/>
+          <p:cNvSpPr txBox="1"/>
+          <p:nvPr/>
+        </p:nvSpPr>
+        <p:spPr>
+          <a:xfrm>
+            <a:off x="548640" y="1325880"/>
+            <a:ext cx="8046720" cy="274320"/>
+          </a:xfrm>
+          <a:prstGeom prst="rect">
+            <a:avLst/>
+          </a:prstGeom>
+          <a:noFill/>
+          <a:ln/>
+        </p:spPr>
+        <p:txBody>
+          <a:bodyPr wrap="square" lIns="0" tIns="0" rIns="0" bIns="0" rtlCol="0" anchor="ctr"/>
+          <a:lstStyle/>
+          <a:p>
+            <a:pPr indent="0" marL="0">
+              <a:buNone/>
+            </a:pPr>
+            <a:r>
+              <a:rPr lang="en-US" sz="1300" dirty="0">
+                <a:solidFill>
+                  <a:srgbClr val="4A5568"/>
+                </a:solidFill>
+              </a:rPr>
+              <a:t>The pipelines shared 3.2 of 5 picks on average · ✓ = relevant in the team labels, ✗ = not relevant</a:t>
+            </a:r>
+            <a:endParaRPr lang="en-US" sz="1300" dirty="0"/>
+          </a:p>
+        </p:txBody>
+      </p:sp>
+      <p:sp>
+        <p:nvSpPr>
+          <p:cNvPr id="6" name="Shape 4"/>
+          <p:cNvSpPr/>
+          <p:nvPr/>
+        </p:nvSpPr>
+        <p:spPr>
+          <a:xfrm>
+            <a:off x="548640" y="1737360"/>
+            <a:ext cx="3931920" cy="2880360"/>
+          </a:xfrm>
+          <a:prstGeom prst="roundRect">
+            <a:avLst>
+              <a:gd name="adj" fmla="val 2540"/>
+            </a:avLst>
+          </a:prstGeom>
+          <a:solidFill>
+            <a:srgbClr val="FFFFFF"/>
+          </a:solidFill>
+          <a:ln w="9525">
+            <a:solidFill>
+              <a:srgbClr val="E2DED3"/>
+            </a:solidFill>
+            <a:prstDash val="solid"/>
+          </a:ln>
+        </p:spPr>
+      </p:sp>
+      <p:sp>
+        <p:nvSpPr>
+          <p:cNvPr id="7" name="Shape 5"/>
+          <p:cNvSpPr/>
+          <p:nvPr/>
+        </p:nvSpPr>
+        <p:spPr>
+          <a:xfrm>
+            <a:off x="4663440" y="1737360"/>
+            <a:ext cx="3931920" cy="2880360"/>
+          </a:xfrm>
+          <a:prstGeom prst="roundRect">
+            <a:avLst>
+              <a:gd name="adj" fmla="val 2540"/>
+            </a:avLst>
+          </a:prstGeom>
+          <a:solidFill>
+            <a:srgbClr val="FFFFFF"/>
+          </a:solidFill>
+          <a:ln w="9525">
+            <a:solidFill>
+              <a:srgbClr val="E2DED3"/>
+            </a:solidFill>
+            <a:prstDash val="solid"/>
+          </a:ln>
+        </p:spPr>
+      </p:sp>
+      <p:sp>
+        <p:nvSpPr>
+          <p:cNvPr id="10" name="Text 6"/>
+          <p:cNvSpPr txBox="1"/>
+          <p:nvPr/>
+        </p:nvSpPr>
+        <p:spPr>
+          <a:xfrm>
+            <a:off x="1097280" y="4754880"/>
+            <a:ext cx="7498080" cy="228600"/>
+          </a:xfrm>
+          <a:prstGeom prst="rect">
+            <a:avLst/>
+          </a:prstGeom>
+          <a:noFill/>
+          <a:ln/>
+        </p:spPr>
+        <p:txBody>
+          <a:bodyPr wrap="square" lIns="0" tIns="0" rIns="0" bIns="0" rtlCol="0" anchor="ctr"/>
+          <a:lstStyle/>
+          <a:p>
+            <a:pPr indent="0" marL="0">
+              <a:buNone/>
+            </a:pPr>
+            <a:r>
+              <a:rPr lang="en-US" sz="1000" dirty="0">
+                <a:solidFill>
+                  <a:srgbClr val="718096"/>
+                </a:solidFill>
+              </a:rPr>
+              <a:t>Repetition 1 of 3, 50-job workload · R08 has 21 relevant jobs of 50, R05 has 5 · titles shortened</a:t>
+            </a:r>
+            <a:endParaRPr lang="en-US" sz="1000" dirty="0"/>
+          </a:p>
+        </p:txBody>
+      </p:sp>
+      <p:sp>
+        <p:nvSpPr>
+          <p:cNvPr id="25" name="Slide Number Placeholder 0"/>
+          <p:cNvSpPr>
+            <a:spLocks noGrp="1"/>
+          </p:cNvSpPr>
+          <p:nvPr>
+            <p:ph type="sldNum" sz="quarter" idx="4294967295"/>
+          </p:nvPr>
+        </p:nvSpPr>
+        <p:spPr>
+          <a:xfrm>
+            <a:off x="548640" y="4800600"/>
+            <a:ext cx="914400" cy="228600"/>
+          </a:xfrm>
+          <a:prstGeom prst="rect">
+            <a:avLst/>
+          </a:prstGeom>
+          <a:extLst>
+            <a:ext uri="{C572A759-6A51-4108-AA02-DFA0A04FC94B}">
+              <ma14:wrappingTextBoxFlag xmlns:ma14="http://schemas.microsoft.com/office/mac/drawingml/2011/main" val="0"/>
+            </a:ext>
+          </a:extLst>
+        </p:spPr>
+        <p:txBody>
+          <a:bodyPr/>
+          <a:lstStyle>
+            <a:lvl1pPr>
+              <a:defRPr sz="1000">
+                <a:solidFill>
+                  <a:srgbClr val="718096"/>
+                </a:solidFill>
+                <a:latin typeface="Calibri"/>
+                <a:ea typeface="Calibri"/>
+                <a:cs typeface="Calibri"/>
+              </a:defRPr>
+            </a:lvl1pPr>
+          </a:lstStyle>
+          <a:p>
+            <a:r>
+              <a:t>7</a:t>
+            </a:r>
+          </a:p>
+        </p:txBody>
+      </p:sp>
+      <p:sp>
+        <p:nvSpPr>
+          <p:cNvPr id="26" name="TextBox 25"/>
+          <p:cNvSpPr txBox="1"/>
+          <p:nvPr/>
+        </p:nvSpPr>
+        <p:spPr>
+          <a:xfrm>
+            <a:off x="685800" y="1847088"/>
+            <a:ext cx="3657600" cy="274320"/>
+          </a:xfrm>
+          <a:prstGeom prst="rect">
+            <a:avLst/>
+          </a:prstGeom>
+          <a:noFill/>
+        </p:spPr>
+        <p:txBody>
+          <a:bodyPr wrap="square" lIns="18288" rIns="18288" tIns="0" bIns="0">
+            <a:spAutoFit/>
+          </a:bodyPr>
+          <a:lstStyle/>
+          <a:p>
+            <a:r>
+              <a:rPr sz="1300" b="1">
+                <a:solidFill>
+                  <a:srgbClr val="14213D"/>
+                </a:solidFill>
+              </a:rPr>
+              <a:t>R08 · multi-agent's best case</a:t>
+            </a:r>
+          </a:p>
+        </p:txBody>
+      </p:sp>
+      <p:sp>
+        <p:nvSpPr>
+          <p:cNvPr id="27" name="TextBox 26"/>
+          <p:cNvSpPr txBox="1"/>
+          <p:nvPr/>
+        </p:nvSpPr>
+        <p:spPr>
+          <a:xfrm>
+            <a:off x="685800" y="2231136"/>
+            <a:ext cx="1783080" cy="2286000"/>
+          </a:xfrm>
+          <a:prstGeom prst="rect">
+            <a:avLst/>
+          </a:prstGeom>
+          <a:noFill/>
+        </p:spPr>
+        <p:txBody>
+          <a:bodyPr wrap="square" lIns="18288" rIns="18288" tIns="0" bIns="0">
+            <a:spAutoFit/>
+          </a:bodyPr>
+          <a:lstStyle/>
+          <a:p>
+            <a:r>
+              <a:rPr sz="1200" b="1">
+                <a:solidFill>
+                  <a:srgbClr val="2F5D8C"/>
+                </a:solidFill>
+              </a:rPr>
+              <a:t>Single agent: 1/5</a:t>
+            </a:r>
+          </a:p>
+          <a:p>
+            <a:pPr>
+              <a:spcBef>
+                <a:spcPts val="500"/>
+              </a:spcBef>
+            </a:pPr>
+            <a:r>
+              <a:rPr sz="1100" b="1">
+                <a:solidFill>
+                  <a:srgbClr val="2F5D8C"/>
+                </a:solidFill>
+              </a:rPr>
+              <a:t>✓ </a:t>
+            </a:r>
+            <a:r>
+              <a:rPr sz="950" b="0">
+                <a:solidFill>
+                  <a:srgbClr val="2D3748"/>
+                </a:solidFill>
+              </a:rPr>
+              <a:t>Data Scientist · Revenue Analy…</a:t>
+            </a:r>
+          </a:p>
+          <a:p>
+            <a:pPr>
+              <a:spcBef>
+                <a:spcPts val="500"/>
+              </a:spcBef>
+            </a:pPr>
+            <a:r>
+              <a:rPr sz="1100" b="1">
+                <a:solidFill>
+                  <a:srgbClr val="B85C1E"/>
+                </a:solidFill>
+              </a:rPr>
+              <a:t>✗ </a:t>
+            </a:r>
+            <a:r>
+              <a:rPr sz="950" b="0">
+                <a:solidFill>
+                  <a:srgbClr val="718096"/>
+                </a:solidFill>
+              </a:rPr>
+              <a:t>Embedded Systems Engineer · Fi…</a:t>
+            </a:r>
+          </a:p>
+          <a:p>
+            <a:pPr>
+              <a:spcBef>
+                <a:spcPts val="500"/>
+              </a:spcBef>
+            </a:pPr>
+            <a:r>
+              <a:rPr sz="1100" b="1">
+                <a:solidFill>
+                  <a:srgbClr val="B85C1E"/>
+                </a:solidFill>
+              </a:rPr>
+              <a:t>✗ </a:t>
+            </a:r>
+            <a:r>
+              <a:rPr sz="950" b="0">
+                <a:solidFill>
+                  <a:srgbClr val="718096"/>
+                </a:solidFill>
+              </a:rPr>
+              <a:t>AI Resident · Toyota Research…</a:t>
+            </a:r>
+          </a:p>
+          <a:p>
+            <a:pPr>
+              <a:spcBef>
+                <a:spcPts val="500"/>
+              </a:spcBef>
+            </a:pPr>
+            <a:r>
+              <a:rPr sz="1100" b="1">
+                <a:solidFill>
+                  <a:srgbClr val="B85C1E"/>
+                </a:solidFill>
+              </a:rPr>
+              <a:t>✗ </a:t>
+            </a:r>
+            <a:r>
+              <a:rPr sz="950" b="0">
+                <a:solidFill>
+                  <a:srgbClr val="718096"/>
+                </a:solidFill>
+              </a:rPr>
+              <a:t>Software Engineer 0/1 · Wyetech</a:t>
+            </a:r>
+          </a:p>
+          <a:p>
+            <a:pPr>
+              <a:spcBef>
+                <a:spcPts val="500"/>
+              </a:spcBef>
+            </a:pPr>
+            <a:r>
+              <a:rPr sz="1100" b="1">
+                <a:solidFill>
+                  <a:srgbClr val="B85C1E"/>
+                </a:solidFill>
+              </a:rPr>
+              <a:t>✗ </a:t>
+            </a:r>
+            <a:r>
+              <a:rPr sz="950" b="0">
+                <a:solidFill>
+                  <a:srgbClr val="718096"/>
+                </a:solidFill>
+              </a:rPr>
+              <a:t>Software Engineer I · True Ano…</a:t>
+            </a:r>
+          </a:p>
+        </p:txBody>
+      </p:sp>
+      <p:sp>
+        <p:nvSpPr>
+          <p:cNvPr id="28" name="TextBox 27"/>
+          <p:cNvSpPr txBox="1"/>
+          <p:nvPr/>
+        </p:nvSpPr>
+        <p:spPr>
+          <a:xfrm>
+            <a:off x="2560320" y="2231136"/>
+            <a:ext cx="1783080" cy="2286000"/>
+          </a:xfrm>
+          <a:prstGeom prst="rect">
+            <a:avLst/>
+          </a:prstGeom>
+          <a:noFill/>
+        </p:spPr>
+        <p:txBody>
+          <a:bodyPr wrap="square" lIns="18288" rIns="18288" tIns="0" bIns="0">
+            <a:spAutoFit/>
+          </a:bodyPr>
+          <a:lstStyle/>
+          <a:p>
+            <a:r>
+              <a:rPr sz="1200" b="1">
+                <a:solidFill>
+                  <a:srgbClr val="B85C1E"/>
+                </a:solidFill>
+              </a:rPr>
+              <a:t>Multi-agent: 3/5</a:t>
+            </a:r>
+          </a:p>
+          <a:p>
+            <a:pPr>
+              <a:spcBef>
+                <a:spcPts val="500"/>
+              </a:spcBef>
+            </a:pPr>
+            <a:r>
+              <a:rPr sz="1100" b="1">
+                <a:solidFill>
+                  <a:srgbClr val="B85C1E"/>
+                </a:solidFill>
+              </a:rPr>
+              <a:t>✗ </a:t>
+            </a:r>
+            <a:r>
+              <a:rPr sz="950" b="0">
+                <a:solidFill>
+                  <a:srgbClr val="718096"/>
+                </a:solidFill>
+              </a:rPr>
+              <a:t>AI Resident · Toyota Research…</a:t>
+            </a:r>
+          </a:p>
+          <a:p>
+            <a:pPr>
+              <a:spcBef>
+                <a:spcPts val="500"/>
+              </a:spcBef>
+            </a:pPr>
+            <a:r>
+              <a:rPr sz="1100" b="1">
+                <a:solidFill>
+                  <a:srgbClr val="2F5D8C"/>
+                </a:solidFill>
+              </a:rPr>
+              <a:t>✓ </a:t>
+            </a:r>
+            <a:r>
+              <a:rPr sz="950" b="0">
+                <a:solidFill>
+                  <a:srgbClr val="2D3748"/>
+                </a:solidFill>
+              </a:rPr>
+              <a:t>Data Scientist · Revenue Analy…</a:t>
+            </a:r>
+          </a:p>
+          <a:p>
+            <a:pPr>
+              <a:spcBef>
+                <a:spcPts val="500"/>
+              </a:spcBef>
+            </a:pPr>
+            <a:r>
+              <a:rPr sz="1100" b="1">
+                <a:solidFill>
+                  <a:srgbClr val="2F5D8C"/>
+                </a:solidFill>
+              </a:rPr>
+              <a:t>✓ </a:t>
+            </a:r>
+            <a:r>
+              <a:rPr sz="950" b="0">
+                <a:solidFill>
+                  <a:srgbClr val="2D3748"/>
+                </a:solidFill>
+              </a:rPr>
+              <a:t>Software Engineer · Synergy ECP</a:t>
+            </a:r>
+          </a:p>
+          <a:p>
+            <a:pPr>
+              <a:spcBef>
+                <a:spcPts val="500"/>
+              </a:spcBef>
+            </a:pPr>
+            <a:r>
+              <a:rPr sz="1100" b="1">
+                <a:solidFill>
+                  <a:srgbClr val="2F5D8C"/>
+                </a:solidFill>
+              </a:rPr>
+              <a:t>✓ </a:t>
+            </a:r>
+            <a:r>
+              <a:rPr sz="950" b="0">
+                <a:solidFill>
+                  <a:srgbClr val="2D3748"/>
+                </a:solidFill>
+              </a:rPr>
+              <a:t>AI Solutions Analyst · WisdomT…</a:t>
+            </a:r>
+          </a:p>
+          <a:p>
+            <a:pPr>
+              <a:spcBef>
+                <a:spcPts val="500"/>
+              </a:spcBef>
+            </a:pPr>
+            <a:r>
+              <a:rPr sz="1100" b="1">
+                <a:solidFill>
+                  <a:srgbClr val="B85C1E"/>
+                </a:solidFill>
+              </a:rPr>
+              <a:t>✗ </a:t>
+            </a:r>
+            <a:r>
+              <a:rPr sz="950" b="0">
+                <a:solidFill>
+                  <a:srgbClr val="718096"/>
+                </a:solidFill>
+              </a:rPr>
+              <a:t>Associate Software Engineer ·…</a:t>
+            </a:r>
+          </a:p>
+        </p:txBody>
+      </p:sp>
+      <p:sp>
+        <p:nvSpPr>
+          <p:cNvPr id="29" name="TextBox 28"/>
+          <p:cNvSpPr txBox="1"/>
+          <p:nvPr/>
+        </p:nvSpPr>
+        <p:spPr>
+          <a:xfrm>
+            <a:off x="4800600" y="1847088"/>
+            <a:ext cx="3657600" cy="274320"/>
+          </a:xfrm>
+          <a:prstGeom prst="rect">
+            <a:avLst/>
+          </a:prstGeom>
+          <a:noFill/>
+        </p:spPr>
+        <p:txBody>
+          <a:bodyPr wrap="square" lIns="18288" rIns="18288" tIns="0" bIns="0">
+            <a:spAutoFit/>
+          </a:bodyPr>
+          <a:lstStyle/>
+          <a:p>
+            <a:r>
+              <a:rPr sz="1300" b="1">
+                <a:solidFill>
+                  <a:srgbClr val="14213D"/>
+                </a:solidFill>
+              </a:rPr>
+              <a:t>R05 · single agent's best case</a:t>
+            </a:r>
+          </a:p>
+        </p:txBody>
+      </p:sp>
+      <p:sp>
+        <p:nvSpPr>
+          <p:cNvPr id="30" name="TextBox 29"/>
+          <p:cNvSpPr txBox="1"/>
+          <p:nvPr/>
+        </p:nvSpPr>
+        <p:spPr>
+          <a:xfrm>
+            <a:off x="4800600" y="2231136"/>
+            <a:ext cx="1783080" cy="2286000"/>
+          </a:xfrm>
+          <a:prstGeom prst="rect">
+            <a:avLst/>
+          </a:prstGeom>
+          <a:noFill/>
+        </p:spPr>
+        <p:txBody>
+          <a:bodyPr wrap="square" lIns="18288" rIns="18288" tIns="0" bIns="0">
+            <a:spAutoFit/>
+          </a:bodyPr>
+          <a:lstStyle/>
+          <a:p>
+            <a:r>
+              <a:rPr sz="1200" b="1">
+                <a:solidFill>
+                  <a:srgbClr val="2F5D8C"/>
+                </a:solidFill>
+              </a:rPr>
+              <a:t>Single agent: 2/5</a:t>
+            </a:r>
+          </a:p>
+          <a:p>
+            <a:pPr>
+              <a:spcBef>
+                <a:spcPts val="500"/>
+              </a:spcBef>
+            </a:pPr>
+            <a:r>
+              <a:rPr sz="1100" b="1">
+                <a:solidFill>
+                  <a:srgbClr val="B85C1E"/>
+                </a:solidFill>
+              </a:rPr>
+              <a:t>✗ </a:t>
+            </a:r>
+            <a:r>
+              <a:rPr sz="950" b="0">
+                <a:solidFill>
+                  <a:srgbClr val="718096"/>
+                </a:solidFill>
+              </a:rPr>
+              <a:t>Junior Data Engineer · Hatch IT</a:t>
+            </a:r>
+          </a:p>
+          <a:p>
+            <a:pPr>
+              <a:spcBef>
+                <a:spcPts val="500"/>
+              </a:spcBef>
+            </a:pPr>
+            <a:r>
+              <a:rPr sz="1100" b="1">
+                <a:solidFill>
+                  <a:srgbClr val="2F5D8C"/>
+                </a:solidFill>
+              </a:rPr>
+              <a:t>✓ </a:t>
+            </a:r>
+            <a:r>
+              <a:rPr sz="950" b="0">
+                <a:solidFill>
+                  <a:srgbClr val="2D3748"/>
+                </a:solidFill>
+              </a:rPr>
+              <a:t>Software Engineer I · Tebra</a:t>
+            </a:r>
+          </a:p>
+          <a:p>
+            <a:pPr>
+              <a:spcBef>
+                <a:spcPts val="500"/>
+              </a:spcBef>
+            </a:pPr>
+            <a:r>
+              <a:rPr sz="1100" b="1">
+                <a:solidFill>
+                  <a:srgbClr val="B85C1E"/>
+                </a:solidFill>
+              </a:rPr>
+              <a:t>✗ </a:t>
+            </a:r>
+            <a:r>
+              <a:rPr sz="950" b="0">
+                <a:solidFill>
+                  <a:srgbClr val="718096"/>
+                </a:solidFill>
+              </a:rPr>
+              <a:t>Data and AI Engineer · The Bra…</a:t>
+            </a:r>
+          </a:p>
+          <a:p>
+            <a:pPr>
+              <a:spcBef>
+                <a:spcPts val="500"/>
+              </a:spcBef>
+            </a:pPr>
+            <a:r>
+              <a:rPr sz="1100" b="1">
+                <a:solidFill>
+                  <a:srgbClr val="2F5D8C"/>
+                </a:solidFill>
+              </a:rPr>
+              <a:t>✓ </a:t>
+            </a:r>
+            <a:r>
+              <a:rPr sz="950" b="0">
+                <a:solidFill>
+                  <a:srgbClr val="2D3748"/>
+                </a:solidFill>
+              </a:rPr>
+              <a:t>Data Developer · Global Lendin…</a:t>
+            </a:r>
+          </a:p>
+          <a:p>
+            <a:pPr>
+              <a:spcBef>
+                <a:spcPts val="500"/>
+              </a:spcBef>
+            </a:pPr>
+            <a:r>
+              <a:rPr sz="1100" b="1">
+                <a:solidFill>
+                  <a:srgbClr val="B85C1E"/>
+                </a:solidFill>
+              </a:rPr>
+              <a:t>✗ </a:t>
+            </a:r>
+            <a:r>
+              <a:rPr sz="950" b="0">
+                <a:solidFill>
+                  <a:srgbClr val="718096"/>
+                </a:solidFill>
+              </a:rPr>
+              <a:t>Associate Software Engineer ·…</a:t>
+            </a:r>
+          </a:p>
+        </p:txBody>
+      </p:sp>
+      <p:sp>
+        <p:nvSpPr>
+          <p:cNvPr id="31" name="TextBox 30"/>
+          <p:cNvSpPr txBox="1"/>
+          <p:nvPr/>
+        </p:nvSpPr>
+        <p:spPr>
+          <a:xfrm>
+            <a:off x="6675120" y="2231136"/>
+            <a:ext cx="1783080" cy="2286000"/>
+          </a:xfrm>
+          <a:prstGeom prst="rect">
+            <a:avLst/>
+          </a:prstGeom>
+          <a:noFill/>
+        </p:spPr>
+        <p:txBody>
+          <a:bodyPr wrap="square" lIns="18288" rIns="18288" tIns="0" bIns="0">
+            <a:spAutoFit/>
+          </a:bodyPr>
+          <a:lstStyle/>
+          <a:p>
+            <a:r>
+              <a:rPr sz="1200" b="1">
+                <a:solidFill>
+                  <a:srgbClr val="B85C1E"/>
+                </a:solidFill>
+              </a:rPr>
+              <a:t>Multi-agent: 0/5</a:t>
+            </a:r>
+          </a:p>
+          <a:p>
+            <a:pPr>
+              <a:spcBef>
+                <a:spcPts val="500"/>
+              </a:spcBef>
+            </a:pPr>
+            <a:r>
+              <a:rPr sz="1100" b="1">
+                <a:solidFill>
+                  <a:srgbClr val="B85C1E"/>
+                </a:solidFill>
+              </a:rPr>
+              <a:t>✗ </a:t>
+            </a:r>
+            <a:r>
+              <a:rPr sz="950" b="0">
+                <a:solidFill>
+                  <a:srgbClr val="718096"/>
+                </a:solidFill>
+              </a:rPr>
+              <a:t>Junior Data Engineer · Hatch IT</a:t>
+            </a:r>
+          </a:p>
+          <a:p>
+            <a:pPr>
+              <a:spcBef>
+                <a:spcPts val="500"/>
+              </a:spcBef>
+            </a:pPr>
+            <a:r>
+              <a:rPr sz="1100" b="1">
+                <a:solidFill>
+                  <a:srgbClr val="B85C1E"/>
+                </a:solidFill>
+              </a:rPr>
+              <a:t>✗ </a:t>
+            </a:r>
+            <a:r>
+              <a:rPr sz="950" b="0">
+                <a:solidFill>
+                  <a:srgbClr val="718096"/>
+                </a:solidFill>
+              </a:rPr>
+              <a:t>Software Engineer · Kikoff</a:t>
+            </a:r>
+          </a:p>
+          <a:p>
+            <a:pPr>
+              <a:spcBef>
+                <a:spcPts val="500"/>
+              </a:spcBef>
+            </a:pPr>
+            <a:r>
+              <a:rPr sz="1100" b="1">
+                <a:solidFill>
+                  <a:srgbClr val="B85C1E"/>
+                </a:solidFill>
+              </a:rPr>
+              <a:t>✗ </a:t>
+            </a:r>
+            <a:r>
+              <a:rPr sz="950" b="0">
+                <a:solidFill>
+                  <a:srgbClr val="718096"/>
+                </a:solidFill>
+              </a:rPr>
+              <a:t>Data and AI Engineer · The Bra…</a:t>
+            </a:r>
+          </a:p>
+          <a:p>
+            <a:pPr>
+              <a:spcBef>
+                <a:spcPts val="500"/>
+              </a:spcBef>
+            </a:pPr>
+            <a:r>
+              <a:rPr sz="1100" b="1">
+                <a:solidFill>
+                  <a:srgbClr val="B85C1E"/>
+                </a:solidFill>
+              </a:rPr>
+              <a:t>✗ </a:t>
+            </a:r>
+            <a:r>
+              <a:rPr sz="950" b="0">
+                <a:solidFill>
+                  <a:srgbClr val="718096"/>
+                </a:solidFill>
+              </a:rPr>
+              <a:t>Associate Software Engineer ·…</a:t>
+            </a:r>
+          </a:p>
+          <a:p>
+            <a:pPr>
+              <a:spcBef>
+                <a:spcPts val="500"/>
+              </a:spcBef>
+            </a:pPr>
+            <a:r>
+              <a:rPr sz="1100" b="1">
+                <a:solidFill>
+                  <a:srgbClr val="B85C1E"/>
+                </a:solidFill>
+              </a:rPr>
+              <a:t>✗ </a:t>
+            </a:r>
+            <a:r>
+              <a:rPr sz="950" b="0">
+                <a:solidFill>
+                  <a:srgbClr val="718096"/>
+                </a:solidFill>
+              </a:rPr>
+              <a:t>Associate AI Engineer · AHEAD</a:t>
+            </a:r>
+          </a:p>
+        </p:txBody>
+      </p:sp>
     </p:spTree>
   </p:cSld>
   <p:clrMapOvr>

</xml_diff>

<commit_message>
Update progress_update_2026-10.pptx with end questions slide
</commit_message>
<xml_diff>
--- a/progress_update_2026-10.pptx
+++ b/progress_update_2026-10.pptx
@@ -12,6 +12,7 @@
     <p:sldId id="260" r:id="rId6"/>
     <p:sldId id="261" r:id="rId12"/>
     <p:sldId id="262" r:id="rId13"/>
+    <p:sldId id="263" r:id="rId14"/>
   </p:sldIdLst>
   <p:notesMasterIdLst>
     <p:notesMasterId r:id="rId7"/>
@@ -6572,6 +6573,108 @@
               </a:rPr>
               <a:t>Associate AI Engineer · AHEAD</a:t>
             </a:r>
+          </a:p>
+        </p:txBody>
+      </p:sp>
+    </p:spTree>
+  </p:cSld>
+  <p:clrMapOvr>
+    <a:masterClrMapping/>
+  </p:clrMapOvr>
+</p:sld>
+</file>
+
+<file path=ppt/slides/slide8.xml><?xml version="1.0" encoding="utf-8"?>
+<p:sld xmlns:a="http://schemas.openxmlformats.org/drawingml/2006/main" xmlns:r="http://schemas.openxmlformats.org/officeDocument/2006/relationships" xmlns:p="http://schemas.openxmlformats.org/presentationml/2006/main">
+  <p:cSld name="Slide 1">
+    <p:spTree>
+      <p:nvGrpSpPr>
+        <p:cNvPr id="1" name=""/>
+        <p:cNvGrpSpPr/>
+        <p:nvPr/>
+      </p:nvGrpSpPr>
+      <p:grpSpPr>
+        <a:xfrm>
+          <a:off x="0" y="0"/>
+          <a:ext cx="0" cy="0"/>
+          <a:chOff x="0" y="0"/>
+          <a:chExt cx="0" cy="0"/>
+        </a:xfrm>
+      </p:grpSpPr>
+      <p:sp>
+        <p:nvSpPr>
+          <p:cNvPr id="2" name="Text 0"/>
+          <p:cNvSpPr txBox="1"/>
+          <p:nvPr/>
+        </p:nvSpPr>
+        <p:spPr>
+          <a:xfrm>
+            <a:off x="548640" y="502920"/>
+            <a:ext cx="8046720" cy="274320"/>
+          </a:xfrm>
+          <a:prstGeom prst="rect">
+            <a:avLst/>
+          </a:prstGeom>
+          <a:noFill/>
+          <a:ln/>
+        </p:spPr>
+        <p:txBody>
+          <a:bodyPr wrap="square" lIns="0" tIns="0" rIns="0" bIns="0" rtlCol="0" anchor="ctr"/>
+          <a:lstStyle/>
+          <a:p>
+            <a:pPr indent="0" marL="0">
+              <a:buNone/>
+            </a:pPr>
+            <a:r>
+              <a:rPr lang="en-US" sz="1200" spc="200" kern="0" dirty="0">
+                <a:solidFill>
+                  <a:srgbClr val="F2A65A"/>
+                </a:solidFill>
+                <a:latin typeface="Courier New" pitchFamily="34" charset="0"/>
+                <a:ea typeface="Courier New" pitchFamily="34" charset="-122"/>
+                <a:cs typeface="Courier New" pitchFamily="34" charset="-120"/>
+              </a:rPr>
+              <a:t>CSCE 585 · PROGRESS UPDATE · OCT 2026</a:t>
+            </a:r>
+            <a:endParaRPr lang="en-US" sz="1200" dirty="0"/>
+          </a:p>
+        </p:txBody>
+      </p:sp>
+      <p:sp>
+        <p:nvSpPr>
+          <p:cNvPr id="3" name="Text 0"/>
+          <p:cNvSpPr/>
+          <p:nvPr>
+            <p:ph idx="100" type="title" hasCustomPrompt="1"/>
+          </p:nvPr>
+        </p:nvSpPr>
+        <p:spPr>
+          <a:xfrm>
+            <a:off x="548640" y="1920240"/>
+            <a:ext cx="8046720" cy="914400"/>
+          </a:xfrm>
+          <a:prstGeom prst="rect">
+            <a:avLst/>
+          </a:prstGeom>
+          <a:noFill/>
+          <a:ln/>
+        </p:spPr>
+        <p:txBody>
+          <a:bodyPr wrap="square" lIns="0" tIns="0" rIns="0" bIns="0" rtlCol="0" anchor="t"/>
+          <a:lstStyle/>
+          <a:p>
+            <a:pPr algn="l" indent="0" marL="0">
+              <a:buNone/>
+            </a:pPr>
+            <a:r>
+              <a:rPr lang="en-US" sz="4800" b="1" dirty="0">
+                <a:solidFill>
+                  <a:srgbClr val="F4F1EA"/>
+                </a:solidFill>
+              </a:rPr>
+              <a:t>Questions?</a:t>
+            </a:r>
+            <a:endParaRPr lang="en-US" sz="4800" dirty="0"/>
           </a:p>
         </p:txBody>
       </p:sp>

</xml_diff>

<commit_message>
Update README and evaluation notebook for 14B model; adjust resume extraction prompt
</commit_message>
<xml_diff>
--- a/progress_update_2026-10.pptx
+++ b/progress_update_2026-10.pptx
@@ -11,6 +11,7 @@
     <p:sldId id="259" r:id="rId5"/>
     <p:sldId id="260" r:id="rId6"/>
     <p:sldId id="261" r:id="rId12"/>
+    <p:sldId id="264" r:id="rId15"/>
     <p:sldId id="262" r:id="rId13"/>
     <p:sldId id="263" r:id="rId14"/>
   </p:sldIdLst>
@@ -166,7 +167,7 @@
                 </a:solidFill>
                 <a:latin typeface="+mn-lt"/>
               </a:rPr>
-              <a:t>Seconds per completed run</a:t>
+              <a:t>Median seconds per resume</a:t>
             </a:r>
           </a:p>
         </c:rich>
@@ -203,7 +204,7 @@
           </c:spPr>
           <c:invertIfNegative val="0"/>
           <c:dLbls>
-            <c:numFmt formatCode="#,##0&quot;s&quot;" sourceLinked="0"/>
+            <c:numFmt formatCode="0.0&quot;s&quot;" sourceLinked="0"/>
             <c:txPr>
               <a:bodyPr/>
               <a:lstStyle/>
@@ -271,51 +272,37 @@
             </c:spPr>
           </c:dPt>
           <c:cat>
-            <c:multiLvlStrRef>
-              <c:f>Sheet1!$A$2:$A$5</c:f>
-              <c:multiLvlStrCache>
-                <c:ptCount val="4"/>
-                <c:lvl>
-                  <c:pt idx="0">
-                    <c:v>20 jobs Single</c:v>
-                  </c:pt>
-                  <c:pt idx="1">
-                    <c:v>20 jobs Multi</c:v>
-                  </c:pt>
-                  <c:pt idx="2">
-                    <c:v>50 jobs Single</c:v>
-                  </c:pt>
-                  <c:pt idx="3">
-                    <c:v>50 jobs Multi</c:v>
-                  </c:pt>
-                </c:lvl>
-              </c:multiLvlStrCache>
-            </c:multiLvlStrRef>
+            <c:strRef>
+              <c:f>Sheet1!$A$2:$A$3</c:f>
+              <c:strCache>
+                <c:ptCount val="2"/>
+                <c:pt idx="0">
+                  <c:v>Single</c:v>
+                </c:pt>
+                <c:pt idx="1">
+                  <c:v>Multi</c:v>
+                </c:pt>
+              </c:strCache>
+            </c:strRef>
           </c:cat>
           <c:val>
             <c:numRef>
-              <c:f>Sheet1!$B$2:$B$5</c:f>
+              <c:f>Sheet1!$B$2:$B$3</c:f>
               <c:numCache>
                 <c:formatCode>General</c:formatCode>
-                <c:ptCount val="4"/>
+                <c:ptCount val="2"/>
                 <c:pt idx="0">
-                  <c:v>65.5</c:v>
+                  <c:v>5.5</c:v>
                 </c:pt>
                 <c:pt idx="1">
-                  <c:v>274.4</c:v>
-                </c:pt>
-                <c:pt idx="2">
-                  <c:v>354.8</c:v>
-                </c:pt>
-                <c:pt idx="3">
-                  <c:v>1200.2</c:v>
+                  <c:v>20.9</c:v>
                 </c:pt>
               </c:numCache>
             </c:numRef>
           </c:val>
         </c:ser>
         <c:dLbls>
-          <c:numFmt formatCode="#,##0&quot;s&quot;" sourceLinked="0"/>
+          <c:numFmt formatCode="0.0&quot;s&quot;" sourceLinked="0"/>
           <c:txPr>
             <a:bodyPr/>
             <a:lstStyle/>
@@ -476,7 +463,7 @@
                 </a:solidFill>
                 <a:latin typeface="+mn-lt"/>
               </a:rPr>
-              <a:t>Tokens per completed run (thousands)</a:t>
+              <a:t>Median tokens per resume (thousands)</a:t>
             </a:r>
           </a:p>
         </c:rich>
@@ -513,7 +500,7 @@
           </c:spPr>
           <c:invertIfNegative val="0"/>
           <c:dLbls>
-            <c:numFmt formatCode="#,##0&quot;k&quot;" sourceLinked="0"/>
+            <c:numFmt formatCode="0.0&quot;k&quot;" sourceLinked="0"/>
             <c:txPr>
               <a:bodyPr/>
               <a:lstStyle/>
@@ -581,51 +568,37 @@
             </c:spPr>
           </c:dPt>
           <c:cat>
-            <c:multiLvlStrRef>
-              <c:f>Sheet1!$A$2:$A$5</c:f>
-              <c:multiLvlStrCache>
-                <c:ptCount val="4"/>
-                <c:lvl>
-                  <c:pt idx="0">
-                    <c:v>20 jobs Single</c:v>
-                  </c:pt>
-                  <c:pt idx="1">
-                    <c:v>20 jobs Multi</c:v>
-                  </c:pt>
-                  <c:pt idx="2">
-                    <c:v>50 jobs Single</c:v>
-                  </c:pt>
-                  <c:pt idx="3">
-                    <c:v>50 jobs Multi</c:v>
-                  </c:pt>
-                </c:lvl>
-              </c:multiLvlStrCache>
-            </c:multiLvlStrRef>
+            <c:strRef>
+              <c:f>Sheet1!$A$2:$A$3</c:f>
+              <c:strCache>
+                <c:ptCount val="2"/>
+                <c:pt idx="0">
+                  <c:v>Single</c:v>
+                </c:pt>
+                <c:pt idx="1">
+                  <c:v>Multi</c:v>
+                </c:pt>
+              </c:strCache>
+            </c:strRef>
           </c:cat>
           <c:val>
             <c:numRef>
-              <c:f>Sheet1!$B$2:$B$5</c:f>
+              <c:f>Sheet1!$B$2:$B$3</c:f>
               <c:numCache>
                 <c:formatCode>General</c:formatCode>
-                <c:ptCount val="4"/>
+                <c:ptCount val="2"/>
                 <c:pt idx="0">
-                  <c:v>31.3</c:v>
+                  <c:v>9.9</c:v>
                 </c:pt>
                 <c:pt idx="1">
-                  <c:v>92.8</c:v>
-                </c:pt>
-                <c:pt idx="2">
-                  <c:v>73.5</c:v>
-                </c:pt>
-                <c:pt idx="3">
-                  <c:v>214.6</c:v>
+                  <c:v>32.2</c:v>
                 </c:pt>
               </c:numCache>
             </c:numRef>
           </c:val>
         </c:ser>
         <c:dLbls>
-          <c:numFmt formatCode="#,##0&quot;k&quot;" sourceLinked="0"/>
+          <c:numFmt formatCode="0.0&quot;k&quot;" sourceLinked="0"/>
           <c:txPr>
             <a:bodyPr/>
             <a:lstStyle/>
@@ -776,7 +749,7 @@
                   <a:srgbClr val="14213D"/>
                 </a:solidFill>
               </a:rPr>
-              <a:t>Precision@5 (higher is better)</a:t>
+              <a:t>Accuracy (higher is better)</a:t>
             </a:r>
           </a:p>
         </c:rich>
@@ -810,29 +783,35 @@
           </c:spPr>
           <c:cat>
             <c:strRef>
-              <c:f>Sheet1!$A$2:$A$3</c:f>
+              <c:f>Sheet1!$A$2:$A$4</c:f>
               <c:strCache>
-                <c:ptCount val="2"/>
+                <c:ptCount val="3"/>
                 <c:pt idx="0">
-                  <c:v>20 jobs</c:v>
+                  <c:v>nDCG@5</c:v>
                 </c:pt>
                 <c:pt idx="1">
-                  <c:v>50 jobs</c:v>
+                  <c:v>Precision@5</c:v>
+                </c:pt>
+                <c:pt idx="2">
+                  <c:v>Top-1 hit</c:v>
                 </c:pt>
               </c:strCache>
             </c:strRef>
           </c:cat>
           <c:val>
             <c:numRef>
-              <c:f>Sheet1!$B$2:$B$3</c:f>
+              <c:f>Sheet1!$B$2:$B$4</c:f>
               <c:numCache>
                 <c:formatCode>General</c:formatCode>
-                <c:ptCount val="2"/>
+                <c:ptCount val="3"/>
                 <c:pt idx="0">
-                  <c:v>0.433</c:v>
+                  <c:v>0.568</c:v>
                 </c:pt>
                 <c:pt idx="1">
-                  <c:v>0.317</c:v>
+                  <c:v>0.679</c:v>
+                </c:pt>
+                <c:pt idx="2">
+                  <c:v>0.643</c:v>
                 </c:pt>
               </c:numCache>
             </c:numRef>
@@ -859,29 +838,35 @@
           </c:spPr>
           <c:cat>
             <c:strRef>
-              <c:f>Sheet1!$A$2:$A$3</c:f>
+              <c:f>Sheet1!$A$2:$A$4</c:f>
               <c:strCache>
-                <c:ptCount val="2"/>
+                <c:ptCount val="3"/>
                 <c:pt idx="0">
-                  <c:v>20 jobs</c:v>
+                  <c:v>nDCG@5</c:v>
                 </c:pt>
                 <c:pt idx="1">
-                  <c:v>50 jobs</c:v>
+                  <c:v>Precision@5</c:v>
+                </c:pt>
+                <c:pt idx="2">
+                  <c:v>Top-1 hit</c:v>
                 </c:pt>
               </c:strCache>
             </c:strRef>
           </c:cat>
           <c:val>
             <c:numRef>
-              <c:f>Sheet1!$C$2:$C$3</c:f>
+              <c:f>Sheet1!$C$2:$C$4</c:f>
               <c:numCache>
                 <c:formatCode>General</c:formatCode>
-                <c:ptCount val="2"/>
+                <c:ptCount val="3"/>
                 <c:pt idx="0">
-                  <c:v>0.383</c:v>
+                  <c:v>0.512</c:v>
                 </c:pt>
                 <c:pt idx="1">
-                  <c:v>0.317</c:v>
+                  <c:v>0.629</c:v>
+                </c:pt>
+                <c:pt idx="2">
+                  <c:v>0.607</c:v>
                 </c:pt>
               </c:numCache>
             </c:numRef>
@@ -1016,7 +1001,7 @@
                   <a:srgbClr val="14213D"/>
                 </a:solidFill>
               </a:rPr>
-              <a:t>Median seconds per resume</a:t>
+              <a:t>nDCG@5 with and without the 2 failures</a:t>
             </a:r>
           </a:p>
         </c:rich>
@@ -1054,10 +1039,10 @@
               <c:strCache>
                 <c:ptCount val="2"/>
                 <c:pt idx="0">
-                  <c:v>20 jobs</c:v>
+                  <c:v>All 28 resumes</c:v>
                 </c:pt>
                 <c:pt idx="1">
-                  <c:v>50 jobs</c:v>
+                  <c:v>Without P03, P17</c:v>
                 </c:pt>
               </c:strCache>
             </c:strRef>
@@ -1069,10 +1054,10 @@
                 <c:formatCode>General</c:formatCode>
                 <c:ptCount val="2"/>
                 <c:pt idx="0">
-                  <c:v>13.4</c:v>
+                  <c:v>0.568</c:v>
                 </c:pt>
                 <c:pt idx="1">
-                  <c:v>33.4</c:v>
+                  <c:v>0.554</c:v>
                 </c:pt>
               </c:numCache>
             </c:numRef>
@@ -1103,10 +1088,10 @@
               <c:strCache>
                 <c:ptCount val="2"/>
                 <c:pt idx="0">
-                  <c:v>20 jobs</c:v>
+                  <c:v>All 28 resumes</c:v>
                 </c:pt>
                 <c:pt idx="1">
-                  <c:v>50 jobs</c:v>
+                  <c:v>Without P03, P17</c:v>
                 </c:pt>
               </c:strCache>
             </c:strRef>
@@ -1118,17 +1103,17 @@
                 <c:formatCode>General</c:formatCode>
                 <c:ptCount val="2"/>
                 <c:pt idx="0">
-                  <c:v>51.9</c:v>
+                  <c:v>0.512</c:v>
                 </c:pt>
                 <c:pt idx="1">
-                  <c:v>197.6</c:v>
+                  <c:v>0.551</c:v>
                 </c:pt>
               </c:numCache>
             </c:numRef>
           </c:val>
         </c:ser>
         <c:dLbls>
-          <c:numFmt formatCode="0&quot;s&quot;" sourceLinked="0"/>
+          <c:numFmt formatCode="0.00" sourceLinked="0"/>
           <c:txPr>
             <a:bodyPr/>
             <a:lstStyle/>
@@ -1634,10 +1619,8 @@
           <a:lstStyle/>
           <a:p>
             <a:r>
-              <a:rPr lang="en-US" dirty="0"/>
-              <a:t>Quick status check: where each of the three pieces stands. Nothing is graded here; no real experiment results yet.</a:t>
-            </a:r>
-            <a:endParaRPr lang="en-US" dirty="0"/>
+              <a:t>Quick status check. Both approaches now have first measured results on a public labeled dataset.</a:t>
+            </a:r>
           </a:p>
         </p:txBody>
       </p:sp>
@@ -1722,10 +1705,8 @@
           <a:lstStyle/>
           <a:p>
             <a:r>
-              <a:rPr lang="en-US" dirty="0"/>
-              <a:t>Job data was pulled Sept 24: 219 postings fetched, filtered to early-career US software/data roles, 20 flagged as the small workload (10 per source). Resumes: 10 chosen from 33 student resumes from a previous course, mostly new-grad CS / CompE / data, with a mix of SWE, data, AI/ML and embedded backgrounds. Location preferences were assigned by us. Labels: Kevin, Ritvik and Aidan labeled all 400 eval pairs (8 resumes x 50 jobs) by applying the rubric before any matcher output existed; 109 are relevant, and every no has a reason code. The 80-pair second review by the team is still to do.</a:t>
-            </a:r>
-            <a:endParaRPr lang="en-US" dirty="0"/>
+              <a:t>We deviated from the proposal. Our 50-job Greenhouse/Lever workload with 400 team labels was small (8 eval resumes), so we switched to rjdfit (cnamuangtoun/resume-job-description-fit on Hugging Face): 8,000 resume/job pairs labeled no fit, potential fit or good fit. It has about 642 unique resumes and 280 unique jobs, so each resume has roughly a dozen labeled jobs. We built 30 pools (a resume plus its own labeled jobs, 8 to 20 jobs each): 2 for development, 28 for evaluation. About 58% of jobs are relevant, so a random top 5 scores about 0.58 precision. The dataset has no card, so the license and labeling method are unknown; we should not call these human labels in the report.</a:t>
+            </a:r>
           </a:p>
         </p:txBody>
       </p:sp>
@@ -1810,10 +1791,8 @@
           <a:lstStyle/>
           <a:p>
             <a:r>
-              <a:rPr lang="en-US" dirty="0"/>
-              <a:t>The baseline sends the cleaned resume, preferences and every job description in one call and gets back five ranked job IDs with explanations. It shares input cleanup, model, output limit, ranking prompt and validation with the orchestrator, so the only difference is the architecture. The local benchmark runs both pipelines on the 2 dev resumes against 20 and 50 jobs (8 runs) and measures tokens and wall-clock time; it doesn't measure accuracy; that's the Precision@5 step using the 400 reference labels.</a:t>
-            </a:r>
-            <a:endParaRPr lang="en-US" dirty="0"/>
+              <a:t>The baseline sends the resume and every job in the pool in one call and gets back five ranked job IDs with explanations. It shares input cleanup, model, output limit, ranking prompt and validation with the orchestrator, so the only difference is the architecture. Results on the 28 eval resumes (1 repetition each): nDCG@5 0.568, Precision@5 0.679, top-1 hit rate 0.643, no failed runs. Median 5.5 seconds and about 9.9k tokens per resume.</a:t>
+            </a:r>
           </a:p>
         </p:txBody>
       </p:sp>
@@ -1898,10 +1877,8 @@
           <a:lstStyle/>
           <a:p>
             <a:r>
-              <a:rPr lang="en-US" dirty="0"/>
-              <a:t>The requirement extractor now selects numbered lines from each posting (at most four per required / preferred / constraints) and the controller restores the exact original text, so nothing gets paraphrased or invented. The ranker gets those references plus the full numbered postings. Local runs have $0 API cost; hardware and electricity aren't measured. Cloud runs would use GPT-4.1 mini at prices recorded Oct 6. In the benchmark both R02 multi-agent runs failed the resume-evidence check, so that validator needs a look. No quality numbers yet; Precision@5 against the reference labels is next.</a:t>
-            </a:r>
-            <a:endParaRPr lang="en-US" dirty="0"/>
+              <a:t>The orchestrator runs three workers: resume parser, requirement extractor and ranker, chained by Python. Workers pick numbered lines and the controller restores the exact source text. Messy rjdfit text is flattened and split into lines of at most 300 characters. On the 28 eval resumes: nDCG@5 0.512, Precision@5 0.629, top-1 0.607, and 2 failed runs (P03 and P17), which score 0. Median 20.9 seconds and 32.2k tokens. Local runs have no API cost; hardware cost is not measured. We have not yet read the error behind the two failures.</a:t>
+            </a:r>
           </a:p>
         </p:txBody>
       </p:sp>
@@ -1986,10 +1963,8 @@
           <a:lstStyle/>
           <a:p>
             <a:r>
-              <a:rPr lang="en-US" dirty="0"/>
-              <a:t>Kevin ran both pipelines locally: 2 dev resumes x 20 and 50 jobs x 2 architectures = 8 runs, 6 completed. Single agent: 65.5s and 31k tokens at 20 jobs, 355s and 74k tokens at 50 jobs. Multi agent: 274s and 93k tokens at 20 jobs, 1,200s and 215k tokens at 50 jobs. On the same resume (R01) multi agent was 4.2x slower at 20 jobs and 4.5x slower at 50. Both R02 multi-agent runs failed: the resume parser returned evidence that wasn't an exact quote, so the validator rejected it. Local runs have $0 API charges; hardware and electricity weren't measured. On R01 with 20 jobs the two pipelines agreed on 2 of their top 5 picks; that's agreement, not accuracy. Small sample, one repetition, model already warm, so treat these as early numbers.</a:t>
-            </a:r>
-            <a:endParaRPr lang="en-US" dirty="0"/>
+              <a:t>Median wall-clock per resume was 5.5s for the single agent and 20.9s for the orchestrator (3.8x). Median tokens were 9.9k vs 32.2k (3.3x). This matches what we saw earlier on the old workload (4 to 6x slower, about 2.8x tokens) and is expected: three sequential calls, and the later calls re-read the resume and job text.</a:t>
+            </a:r>
           </a:p>
         </p:txBody>
       </p:sp>
@@ -2022,6 +1997,216 @@
         <p14:creationId xmlns:p14="http://schemas.microsoft.com/office/powerpoint/2010/main" val="1024086991"/>
       </p:ext>
     </p:extLst>
+  </p:cSld>
+  <p:clrMapOvr>
+    <a:masterClrMapping/>
+  </p:clrMapOvr>
+</p:notes>
+</file>
+
+<file path=ppt/notesSlides/notesSlide6.xml><?xml version="1.0" encoding="utf-8"?>
+<p:notes xmlns:a="http://schemas.openxmlformats.org/drawingml/2006/main" xmlns:p="http://schemas.openxmlformats.org/presentationml/2006/main" xmlns:r="http://schemas.openxmlformats.org/officeDocument/2006/relationships">
+  <p:cSld>
+    <p:spTree>
+      <p:nvGrpSpPr>
+        <p:cNvPr id="1" name=""/>
+        <p:cNvGrpSpPr/>
+        <p:nvPr/>
+      </p:nvGrpSpPr>
+      <p:grpSpPr>
+        <a:xfrm>
+          <a:off x="0" y="0"/>
+          <a:ext cx="0" cy="0"/>
+          <a:chOff x="0" y="0"/>
+          <a:chExt cx="0" cy="0"/>
+        </a:xfrm>
+      </p:grpSpPr>
+      <p:sp>
+        <p:nvSpPr>
+          <p:cNvPr id="2" name="Slide Image Placeholder 1"/>
+          <p:cNvSpPr>
+            <a:spLocks noGrp="1"/>
+          </p:cNvSpPr>
+          <p:nvPr>
+            <p:ph type="sldImg" idx="2"/>
+          </p:nvPr>
+        </p:nvSpPr>
+        <p:spPr/>
+      </p:sp>
+      <p:sp>
+        <p:nvSpPr>
+          <p:cNvPr id="3" name="Notes Placeholder 2"/>
+          <p:cNvSpPr>
+            <a:spLocks noGrp="1"/>
+          </p:cNvSpPr>
+          <p:nvPr>
+            <p:ph type="body" idx="3" sz="quarter"/>
+          </p:nvPr>
+        </p:nvSpPr>
+        <p:spPr/>
+        <p:txBody>
+          <a:bodyPr/>
+          <a:lstStyle/>
+          <a:p>
+            <a:r>
+              <a:t>Single agent: nDCG@5 0.568, Precision@5 0.679, top-1 0.643, 0 failures. Multi-agent: 0.512, 0.629, 0.607, 2 failures out of 28 (P03 and P17, scored 0). Per resume, single was better on 16, multi on 9, tied on 3; the mean gap is 0.056 with a bootstrap 95% interval of about -0.16 to +0.04, so we can't call it a real difference. Dropping the two failed resumes for both, they are essentially tied (0.554 vs 0.551). Both are only modestly above the 0.58 random Precision@5, so a 4B model on these pools is a weak matcher either way. One repetition per resume, so no run-to-run variance yet.</a:t>
+            </a:r>
+          </a:p>
+        </p:txBody>
+      </p:sp>
+      <p:sp>
+        <p:nvSpPr>
+          <p:cNvPr id="4" name="Slide Number Placeholder 3"/>
+          <p:cNvSpPr>
+            <a:spLocks noGrp="1"/>
+          </p:cNvSpPr>
+          <p:nvPr>
+            <p:ph type="sldNum" idx="5" sz="quarter"/>
+          </p:nvPr>
+        </p:nvSpPr>
+        <p:spPr/>
+      </p:sp>
+    </p:spTree>
+  </p:cSld>
+  <p:clrMapOvr>
+    <a:masterClrMapping/>
+  </p:clrMapOvr>
+</p:notes>
+</file>
+
+<file path=ppt/notesSlides/notesSlide7.xml><?xml version="1.0" encoding="utf-8"?>
+<p:notes xmlns:a="http://schemas.openxmlformats.org/drawingml/2006/main" xmlns:p="http://schemas.openxmlformats.org/presentationml/2006/main" xmlns:r="http://schemas.openxmlformats.org/officeDocument/2006/relationships">
+  <p:cSld>
+    <p:spTree>
+      <p:nvGrpSpPr>
+        <p:cNvPr id="1" name=""/>
+        <p:cNvGrpSpPr/>
+        <p:nvPr/>
+      </p:nvGrpSpPr>
+      <p:grpSpPr>
+        <a:xfrm>
+          <a:off x="0" y="0"/>
+          <a:ext cx="0" cy="0"/>
+          <a:chOff x="0" y="0"/>
+          <a:chExt cx="0" cy="0"/>
+        </a:xfrm>
+      </p:grpSpPr>
+      <p:sp>
+        <p:nvSpPr>
+          <p:cNvPr id="2" name="Slide Image Placeholder 1"/>
+          <p:cNvSpPr>
+            <a:spLocks noGrp="1"/>
+          </p:cNvSpPr>
+          <p:nvPr>
+            <p:ph type="sldImg" idx="2"/>
+          </p:nvPr>
+        </p:nvSpPr>
+        <p:spPr/>
+      </p:sp>
+      <p:sp>
+        <p:nvSpPr>
+          <p:cNvPr id="3" name="Notes Placeholder 2"/>
+          <p:cNvSpPr>
+            <a:spLocks noGrp="1"/>
+          </p:cNvSpPr>
+          <p:nvPr>
+            <p:ph type="body" idx="3" sz="quarter"/>
+          </p:nvPr>
+        </p:nvSpPr>
+        <p:spPr/>
+        <p:txBody>
+          <a:bodyPr/>
+          <a:lstStyle/>
+          <a:p>
+            <a:r>
+              <a:t>Largest per-resume gaps. Single wins: P03 and P17 (multi-agent failed, scored 0), P28 (0.83 vs 0.45), P07 (0.80 vs 0.53). Multi-agent wins: P06 (1.00 vs 0.47), P15 (0.61 vs 0.24), P14 (0.58 vs 0.26), P08 (0.47 vs 0.32). Three resumes tied exactly. Full per-resume table is in paired_resumes.csv.</a:t>
+            </a:r>
+          </a:p>
+        </p:txBody>
+      </p:sp>
+      <p:sp>
+        <p:nvSpPr>
+          <p:cNvPr id="4" name="Slide Number Placeholder 3"/>
+          <p:cNvSpPr>
+            <a:spLocks noGrp="1"/>
+          </p:cNvSpPr>
+          <p:nvPr>
+            <p:ph type="sldNum" idx="5" sz="quarter"/>
+          </p:nvPr>
+        </p:nvSpPr>
+        <p:spPr/>
+      </p:sp>
+    </p:spTree>
+  </p:cSld>
+  <p:clrMapOvr>
+    <a:masterClrMapping/>
+  </p:clrMapOvr>
+</p:notes>
+</file>
+
+<file path=ppt/notesSlides/notesSlide8.xml><?xml version="1.0" encoding="utf-8"?>
+<p:notes xmlns:a="http://schemas.openxmlformats.org/drawingml/2006/main" xmlns:p="http://schemas.openxmlformats.org/presentationml/2006/main" xmlns:r="http://schemas.openxmlformats.org/officeDocument/2006/relationships">
+  <p:cSld>
+    <p:spTree>
+      <p:nvGrpSpPr>
+        <p:cNvPr id="1" name=""/>
+        <p:cNvGrpSpPr/>
+        <p:nvPr/>
+      </p:nvGrpSpPr>
+      <p:grpSpPr>
+        <a:xfrm>
+          <a:off x="0" y="0"/>
+          <a:ext cx="0" cy="0"/>
+          <a:chOff x="0" y="0"/>
+          <a:chExt cx="0" cy="0"/>
+        </a:xfrm>
+      </p:grpSpPr>
+      <p:sp>
+        <p:nvSpPr>
+          <p:cNvPr id="2" name="Slide Image Placeholder 1"/>
+          <p:cNvSpPr>
+            <a:spLocks noGrp="1"/>
+          </p:cNvSpPr>
+          <p:nvPr>
+            <p:ph type="sldImg" idx="2"/>
+          </p:nvPr>
+        </p:nvSpPr>
+        <p:spPr/>
+      </p:sp>
+      <p:sp>
+        <p:nvSpPr>
+          <p:cNvPr id="3" name="Notes Placeholder 2"/>
+          <p:cNvSpPr>
+            <a:spLocks noGrp="1"/>
+          </p:cNvSpPr>
+          <p:nvPr>
+            <p:ph type="body" idx="3" sz="quarter"/>
+          </p:nvPr>
+        </p:nvSpPr>
+        <p:spPr/>
+        <p:txBody>
+          <a:bodyPr/>
+          <a:lstStyle/>
+          <a:p>
+            <a:r>
+              <a:t>Real model output for dev resume P02, an HR/admin background with a pool of 9 jobs where only 2 are relevant (D028 is a potential fit, D024 a good fit). Both pipelines found both relevant jobs. The single agent ranked them 1st and 3rd (nDCG@5 0.69), the orchestrator 1st and 4th (0.63). Both had to return 5, so both filled the remaining 3 slots with no-fit jobs, and the model's own explanations say things like 'no alignment' or 'not mentioned' about those picks. This is dev data used while building the pipeline, so it's an illustration, not part of the 28-resume eval. Also visible: the explanations get cut off at the 300-character limit mid-sentence.</a:t>
+            </a:r>
+          </a:p>
+        </p:txBody>
+      </p:sp>
+      <p:sp>
+        <p:nvSpPr>
+          <p:cNvPr id="4" name="Slide Number Placeholder 3"/>
+          <p:cNvSpPr>
+            <a:spLocks noGrp="1"/>
+          </p:cNvSpPr>
+          <p:nvPr>
+            <p:ph type="sldNum" idx="5" sz="quarter"/>
+          </p:nvPr>
+        </p:nvSpPr>
+        <p:spPr/>
+      </p:sp>
+    </p:spTree>
   </p:cSld>
   <p:clrMapOvr>
     <a:masterClrMapping/>
@@ -2912,7 +3097,7 @@
                   <a:srgbClr val="F7F5EF"/>
                 </a:solidFill>
               </a:rPr>
-              <a:t>Jobs, resumes, labels done</a:t>
+              <a:t>Dataset + pools ready</a:t>
             </a:r>
             <a:endParaRPr lang="en-US" sz="1100" dirty="0"/>
           </a:p>
@@ -2950,7 +3135,7 @@
                   <a:srgbClr val="14213D"/>
                 </a:solidFill>
               </a:rPr>
-              <a:t>Jobs, resumes and labels are ready</a:t>
+              <a:t>Switched to a public labeled dataset</a:t>
             </a:r>
             <a:endParaRPr lang="en-US" sz="2800" dirty="0"/>
           </a:p>
@@ -3013,7 +3198,7 @@
                   <a:srgbClr val="14213D"/>
                 </a:solidFill>
               </a:rPr>
-              <a:t>50</a:t>
+              <a:t>8,000</a:t>
             </a:r>
             <a:endParaRPr lang="en-US" sz="3200" dirty="0"/>
           </a:p>
@@ -3049,7 +3234,7 @@
                   <a:srgbClr val="4A5568"/>
                 </a:solidFill>
               </a:rPr>
-              <a:t>new-grad SWE / data postings, 46 employers</a:t>
+              <a:t>labeled resume-job pairs (rjdfit)</a:t>
             </a:r>
             <a:endParaRPr lang="en-US" sz="1200" dirty="0"/>
           </a:p>
@@ -3112,7 +3297,7 @@
                   <a:srgbClr val="14213D"/>
                 </a:solidFill>
               </a:rPr>
-              <a:t>25 + 25</a:t>
+              <a:t>30</a:t>
             </a:r>
             <a:endParaRPr lang="en-US" sz="3200" dirty="0"/>
           </a:p>
@@ -3148,7 +3333,7 @@
                   <a:srgbClr val="4A5568"/>
                 </a:solidFill>
               </a:rPr>
-              <a:t>Greenhouse + Lever</a:t>
+              <a:t>resume pools (2 dev, 28 eval)</a:t>
             </a:r>
             <a:endParaRPr lang="en-US" sz="1200" dirty="0"/>
           </a:p>
@@ -3211,7 +3396,7 @@
                   <a:srgbClr val="14213D"/>
                 </a:solidFill>
               </a:rPr>
-              <a:t>10</a:t>
+              <a:t>8–20</a:t>
             </a:r>
             <a:endParaRPr lang="en-US" sz="3200" dirty="0"/>
           </a:p>
@@ -3247,7 +3432,7 @@
                   <a:srgbClr val="4A5568"/>
                 </a:solidFill>
               </a:rPr>
-              <a:t>anonymized resumes (2 dev, 8 eval)</a:t>
+              <a:t>jobs per pool, all labeled for that resume</a:t>
             </a:r>
             <a:endParaRPr lang="en-US" sz="1200" dirty="0"/>
           </a:p>
@@ -3310,7 +3495,7 @@
                   <a:srgbClr val="14213D"/>
                 </a:solidFill>
               </a:rPr>
-              <a:t>400</a:t>
+              <a:t>58%</a:t>
             </a:r>
             <a:endParaRPr lang="en-US" sz="3200" dirty="0"/>
           </a:p>
@@ -3346,7 +3531,7 @@
                   <a:srgbClr val="4A5568"/>
                 </a:solidFill>
               </a:rPr>
-              <a:t>pairs labeled, 109 relevant (labeled by the team)</a:t>
+              <a:t>of jobs are relevant, so random Precision@5 ≈ 0.58</a:t>
             </a:r>
             <a:endParaRPr lang="en-US" sz="1200" dirty="0"/>
           </a:p>
@@ -3422,7 +3607,7 @@
                   <a:srgbClr val="2D3748"/>
                 </a:solidFill>
               </a:rPr>
-              <a:t>Job set pulled from live Greenhouse / Lever APIs, reproducible selection</a:t>
+              <a:t>Our own 50-job set was too small and noisy, so we moved to rjdfit: labels are no fit / potential fit / good fit</a:t>
             </a:r>
             <a:endParaRPr lang="en-US" sz="1300" dirty="0"/>
           </a:p>
@@ -3440,7 +3625,7 @@
                   <a:srgbClr val="2D3748"/>
                 </a:solidFill>
               </a:rPr>
-              <a:t>10 resumes picked from 33 past-course resumes, names and contact info stripped</a:t>
+              <a:t>Each pool is one resume plus its own labeled jobs; the matcher returns a top 5</a:t>
             </a:r>
             <a:endParaRPr lang="en-US" sz="1300" dirty="0"/>
           </a:p>
@@ -3458,7 +3643,7 @@
                   <a:srgbClr val="2D3748"/>
                 </a:solidFill>
               </a:rPr>
-              <a:t>All 400 resume × job pairs labeled with the rubric, by Kevin, Ritvik and Aidan</a:t>
+              <a:t>Pools are fixed (seed 585) and hashed, so both matchers see identical inputs</a:t>
             </a:r>
             <a:endParaRPr lang="en-US" sz="1300" dirty="0"/>
           </a:p>
@@ -3534,7 +3719,7 @@
                   <a:srgbClr val="2D3748"/>
                 </a:solidFill>
               </a:rPr>
-              <a:t>Team second review of 80 pairs</a:t>
+              <a:t>Labels come from the dataset; we could not verify who labeled them</a:t>
             </a:r>
             <a:endParaRPr lang="en-US" sz="1300" dirty="0"/>
           </a:p>
@@ -3552,7 +3737,7 @@
                   <a:srgbClr val="2D3748"/>
                 </a:solidFill>
               </a:rPr>
-              <a:t>Score both matchers with Precision@5</a:t>
+              <a:t>Error analysis on the lowest-scoring resumes</a:t>
             </a:r>
             <a:endParaRPr lang="en-US" sz="1300" dirty="0"/>
           </a:p>
@@ -3809,7 +3994,7 @@
                   <a:srgbClr val="14213D"/>
                 </a:solidFill>
               </a:rPr>
-              <a:t>Resume + preferences</a:t>
+              <a:t>Resume text</a:t>
             </a:r>
             <a:endParaRPr lang="en-US" sz="1400" dirty="0"/>
           </a:p>
@@ -3874,7 +4059,7 @@
                   <a:srgbClr val="14213D"/>
                 </a:solidFill>
               </a:rPr>
-              <a:t>All postings</a:t>
+              <a:t>All pool jobs</a:t>
             </a:r>
             <a:endParaRPr lang="en-US" sz="1400" dirty="0"/>
           </a:p>
@@ -4098,7 +4283,7 @@
                   <a:srgbClr val="2D3748"/>
                 </a:solidFill>
               </a:rPr>
-              <a:t>Logs tokens, latency and retries for every run</a:t>
+              <a:t>28 eval resumes: nDCG@5 0.568, Precision@5 0.68, 0 of 28 runs failed</a:t>
             </a:r>
             <a:endParaRPr lang="en-US" sz="1300" dirty="0"/>
           </a:p>
@@ -4116,7 +4301,7 @@
                   <a:srgbClr val="2D3748"/>
                 </a:solidFill>
               </a:rPr>
-              <a:t>Local benchmark: 65s / 31k tokens at 20 jobs, 355s / 74k at 50 jobs, 4 of 4 runs passed</a:t>
+              <a:t>Median 5.5s and 9.9k tokens per resume on an A100</a:t>
             </a:r>
             <a:endParaRPr lang="en-US" sz="1300" dirty="0"/>
           </a:p>
@@ -4192,7 +4377,7 @@
                   <a:srgbClr val="2D3748"/>
                 </a:solidFill>
               </a:rPr>
-              <a:t>Second label review (80 pairs) to confirm the scores</a:t>
+              <a:t>Look at low scorers (P11: 0.19, P15: 0.24)</a:t>
             </a:r>
             <a:endParaRPr lang="en-US" sz="1300" dirty="0"/>
           </a:p>
@@ -4210,7 +4395,7 @@
                   <a:srgbClr val="2D3748"/>
                 </a:solidFill>
               </a:rPr>
-              <a:t>Error analysis on low scorers (R04: 0 of 5 relevant)</a:t>
+              <a:t>Try larger pools or a bigger model</a:t>
             </a:r>
             <a:endParaRPr lang="en-US" sz="1300" dirty="0"/>
           </a:p>
@@ -4738,7 +4923,7 @@
                   <a:srgbClr val="2D3748"/>
                 </a:solidFill>
               </a:rPr>
-              <a:t>Extractor picks up to 4 key lines per category, quoted straight from the posting</a:t>
+              <a:t>Resume parser and extractor cite numbered lines (L001 / E001), so the 4B model picks lines instead of retyping quotes</a:t>
             </a:r>
             <a:endParaRPr lang="en-US" sz="1300" dirty="0"/>
           </a:p>
@@ -4756,7 +4941,7 @@
                   <a:srgbClr val="2D3748"/>
                 </a:solidFill>
               </a:rPr>
-              <a:t>Models set: local Qwen3 4B for benchmarks, GPT-4.1 mini (dated prices) for cloud</a:t>
+              <a:t>28 eval resumes: nDCG@5 0.512, Precision@5 0.63, 2 of 28 runs failed (P03, P17)</a:t>
             </a:r>
             <a:endParaRPr lang="en-US" sz="1300" dirty="0"/>
           </a:p>
@@ -4774,7 +4959,7 @@
                   <a:srgbClr val="2D3748"/>
                 </a:solidFill>
               </a:rPr>
-              <a:t>Local benchmark: 274s / 93k tokens at 20 jobs, 1,200s / 215k at 50 jobs</a:t>
+              <a:t>Median 20.9s and 32.2k tokens per resume</a:t>
             </a:r>
             <a:endParaRPr lang="en-US" sz="1300" dirty="0"/>
           </a:p>
@@ -4850,7 +5035,7 @@
                   <a:srgbClr val="2D3748"/>
                 </a:solidFill>
               </a:rPr>
-              <a:t>Fixed: resume parser cites line IDs, 0 of 48 eval runs failed</a:t>
+              <a:t>Find why P03 and P17 failed</a:t>
             </a:r>
             <a:endParaRPr lang="en-US" sz="1300" dirty="0"/>
           </a:p>
@@ -4868,7 +5053,7 @@
                   <a:srgbClr val="2D3748"/>
                 </a:solidFill>
               </a:rPr>
-              <a:t>Find out why extra steps did not raise Precision@5</a:t>
+              <a:t>Check if the extra steps drop useful lines</a:t>
             </a:r>
             <a:endParaRPr lang="en-US" sz="1300" dirty="0"/>
           </a:p>
@@ -5020,7 +5205,7 @@
                   <a:srgbClr val="F7F5EF"/>
                 </a:solidFill>
               </a:rPr>
-              <a:t>Local benchmark · 8 runs</a:t>
+              <a:t>A100 run · 56 runs</a:t>
             </a:r>
             <a:endParaRPr lang="en-US" sz="1100" dirty="0"/>
           </a:p>
@@ -5094,7 +5279,7 @@
                   <a:srgbClr val="4A5568"/>
                 </a:solidFill>
               </a:rPr>
-              <a:t>2 of 4 multi-agent runs failed the evidence check · top 5 overlapped 2 of 5 jobs on R01 / 20 jobs</a:t>
+              <a:t>Median per resume: 20.9s vs 5.5s, 32.2k vs 9.9k tokens · 3 sequential calls instead of 1</a:t>
             </a:r>
             <a:endParaRPr lang="en-US" sz="1300" dirty="0"/>
           </a:p>
@@ -5216,7 +5401,7 @@
                   <a:srgbClr val="718096"/>
                 </a:solidFill>
               </a:rPr>
-              <a:t>Local Qwen3 4B (Ollama) on a Mac · R01–R02, 1 repetition · median of completed runs · $0 API cost</a:t>
+              <a:t>Qwen3 4B (Ollama) on a Colab A100 · 28 eval resumes, 1 repetition · median per run · tokens in thousands · $0 API cost</a:t>
             </a:r>
             <a:endParaRPr lang="en-US" sz="1000" dirty="0"/>
           </a:p>
@@ -5321,7 +5506,7 @@
                 <a:ea typeface="Courier New" pitchFamily="34" charset="-122"/>
                 <a:cs typeface="Courier New" pitchFamily="34" charset="-120"/>
               </a:rPr>
-              <a:t>05 · ACCURACY (PRECISION@5)</a:t>
+              <a:t>05 · ACCURACY (nDCG@5)</a:t>
             </a:r>
             <a:endParaRPr lang="en-US" sz="1200" dirty="0"/>
           </a:p>
@@ -5361,7 +5546,7 @@
                   <a:srgbClr val="F7F5EF"/>
                 </a:solidFill>
               </a:rPr>
-              <a:t>Held-out eval · 96 runs</a:t>
+              <a:t>Held-out eval · 56 runs</a:t>
             </a:r>
             <a:endParaRPr lang="en-US" sz="1100" dirty="0"/>
           </a:p>
@@ -5399,7 +5584,7 @@
                   <a:srgbClr val="14213D"/>
                 </a:solidFill>
               </a:rPr>
-              <a:t>Multi-agent: no more accurate, 4–6x slower</a:t>
+              <a:t>Single agent scored higher, mostly from 2 failures</a:t>
             </a:r>
             <a:endParaRPr lang="en-US" sz="2800" dirty="0"/>
           </a:p>
@@ -5435,7 +5620,7 @@
                   <a:srgbClr val="4A5568"/>
                 </a:solidFill>
               </a:rPr>
-              <a:t>Multi-agent better on 1 of 8 resumes at 50 jobs, worse on 2 · decision rule (+5 pts, ≤2x cost/time) misses</a:t>
+              <a:t>Single better on 16 resumes, multi on 9, tied on 3 · mean gap 0.06 nDCG@5, not significant</a:t>
             </a:r>
             <a:endParaRPr lang="en-US" sz="1300" dirty="0"/>
           </a:p>
@@ -5525,7 +5710,7 @@
                   <a:srgbClr val="718096"/>
                 </a:solidFill>
               </a:rPr>
-              <a:t>Qwen3 4B on a Colab A100 · R03–R10 × 3 reps vs. 400 team labels · multi used 2.8x tokens · 0/96 runs failed</a:t>
+              <a:t>Qwen3 4B on a Colab A100 · 28 eval resumes × 1 rep · labels from rjdfit · random Precision@5 = 0.58 · multi used 3.3x tokens</a:t>
             </a:r>
             <a:endParaRPr lang="en-US" sz="1000" dirty="0"/>
           </a:p>
@@ -5663,7 +5848,7 @@
                 <a:ea typeface="Courier New" pitchFamily="34" charset="-122"/>
                 <a:cs typeface="Courier New" pitchFamily="34" charset="-120"/>
               </a:rPr>
-              <a:t>06 · WHAT THEY ACTUALLY PICKED</a:t>
+              <a:t>07 · PER-RESUME RESULTS</a:t>
             </a:r>
             <a:endParaRPr lang="en-US" sz="1200" dirty="0"/>
           </a:p>
@@ -5703,7 +5888,7 @@
                   <a:srgbClr val="F7F5EF"/>
                 </a:solidFill>
               </a:rPr>
-              <a:t>Example top 5s · 50 jobs</a:t>
+              <a:t>Biggest gaps · nDCG@5</a:t>
             </a:r>
             <a:endParaRPr lang="en-US" sz="1100" dirty="0"/>
           </a:p>
@@ -5741,7 +5926,7 @@
                   <a:srgbClr val="14213D"/>
                 </a:solidFill>
               </a:rPr>
-              <a:t>Same resume, different picks: it cuts both ways</a:t>
+              <a:t>Failures drive the largest gaps</a:t>
             </a:r>
             <a:endParaRPr lang="en-US" sz="2800" dirty="0"/>
           </a:p>
@@ -5777,7 +5962,7 @@
                   <a:srgbClr val="4A5568"/>
                 </a:solidFill>
               </a:rPr>
-              <a:t>The pipelines shared 3.2 of 5 picks on average · ✓ = relevant in the team labels, ✗ = not relevant</a:t>
+              <a:t>nDCG@5 for the same resume, single vs. multi-agent · 28 eval resumes</a:t>
             </a:r>
             <a:endParaRPr lang="en-US" sz="1300" dirty="0"/>
           </a:p>
@@ -5867,7 +6052,7 @@
                   <a:srgbClr val="718096"/>
                 </a:solidFill>
               </a:rPr>
-              <a:t>Repetition 1 of 3, 50-job workload · R08 has 21 relevant jobs of 50, R05 has 5 · titles shortened</a:t>
+              <a:t>Repetition 1 of 1 · P03 and P17 are the two multi-agent failures · full table in paired_resumes.csv</a:t>
             </a:r>
             <a:endParaRPr lang="en-US" sz="1000" dirty="0"/>
           </a:p>
@@ -5946,7 +6131,7 @@
                   <a:srgbClr val="14213D"/>
                 </a:solidFill>
               </a:rPr>
-              <a:t>R08 · multi-agent's best case</a:t>
+              <a:t>Single agent wins</a:t>
             </a:r>
           </a:p>
         </p:txBody>
@@ -5979,7 +6164,7 @@
                   <a:srgbClr val="2F5D8C"/>
                 </a:solidFill>
               </a:rPr>
-              <a:t>Single agent: 1/5</a:t>
+              <a:t>Single</a:t>
             </a:r>
           </a:p>
           <a:p>
@@ -5994,15 +6179,7 @@
                   <a:srgbClr val="2F5D8C"/>
                 </a:solidFill>
               </a:rPr>
-              <a:t>✓ </a:t>
-            </a:r>
-            <a:r>
-              <a:rPr sz="950" b="0">
-                <a:solidFill>
-                  <a:srgbClr val="2D3748"/>
-                </a:solidFill>
-              </a:rPr>
-              <a:t>Data Scientist · Revenue Analy…</a:t>
+              <a:t>P03 · 0.83</a:t>
             </a:r>
           </a:p>
           <a:p>
@@ -6014,18 +6191,10 @@
             <a:r>
               <a:rPr sz="1100" b="1">
                 <a:solidFill>
-                  <a:srgbClr val="B85C1E"/>
-                </a:solidFill>
-              </a:rPr>
-              <a:t>✗ </a:t>
-            </a:r>
-            <a:r>
-              <a:rPr sz="950" b="0">
-                <a:solidFill>
-                  <a:srgbClr val="718096"/>
-                </a:solidFill>
-              </a:rPr>
-              <a:t>Embedded Systems Engineer · Fi…</a:t>
+                  <a:srgbClr val="2F5D8C"/>
+                </a:solidFill>
+              </a:rPr>
+              <a:t>P17 · 0.69</a:t>
             </a:r>
           </a:p>
           <a:p>
@@ -6037,18 +6206,10 @@
             <a:r>
               <a:rPr sz="1100" b="1">
                 <a:solidFill>
-                  <a:srgbClr val="B85C1E"/>
-                </a:solidFill>
-              </a:rPr>
-              <a:t>✗ </a:t>
-            </a:r>
-            <a:r>
-              <a:rPr sz="950" b="0">
-                <a:solidFill>
-                  <a:srgbClr val="718096"/>
-                </a:solidFill>
-              </a:rPr>
-              <a:t>AI Resident · Toyota Research…</a:t>
+                  <a:srgbClr val="2F5D8C"/>
+                </a:solidFill>
+              </a:rPr>
+              <a:t>P28 · 0.83</a:t>
             </a:r>
           </a:p>
           <a:p>
@@ -6060,18 +6221,43 @@
             <a:r>
               <a:rPr sz="1100" b="1">
                 <a:solidFill>
+                  <a:srgbClr val="2F5D8C"/>
+                </a:solidFill>
+              </a:rPr>
+              <a:t>P07 · 0.80</a:t>
+            </a:r>
+          </a:p>
+        </p:txBody>
+      </p:sp>
+      <p:sp>
+        <p:nvSpPr>
+          <p:cNvPr id="28" name="TextBox 27"/>
+          <p:cNvSpPr txBox="1"/>
+          <p:nvPr/>
+        </p:nvSpPr>
+        <p:spPr>
+          <a:xfrm>
+            <a:off x="2560320" y="2231136"/>
+            <a:ext cx="1783080" cy="2286000"/>
+          </a:xfrm>
+          <a:prstGeom prst="rect">
+            <a:avLst/>
+          </a:prstGeom>
+          <a:noFill/>
+        </p:spPr>
+        <p:txBody>
+          <a:bodyPr wrap="square" lIns="18288" rIns="18288" tIns="0" bIns="0">
+            <a:spAutoFit/>
+          </a:bodyPr>
+          <a:lstStyle/>
+          <a:p>
+            <a:r>
+              <a:rPr sz="1200" b="1">
+                <a:solidFill>
                   <a:srgbClr val="B85C1E"/>
                 </a:solidFill>
               </a:rPr>
-              <a:t>✗ </a:t>
-            </a:r>
-            <a:r>
-              <a:rPr sz="950" b="0">
-                <a:solidFill>
-                  <a:srgbClr val="718096"/>
-                </a:solidFill>
-              </a:rPr>
-              <a:t>Software Engineer 0/1 · Wyetech</a:t>
+              <a:t>Multi-agent</a:t>
             </a:r>
           </a:p>
           <a:p>
@@ -6086,48 +6272,7 @@
                   <a:srgbClr val="B85C1E"/>
                 </a:solidFill>
               </a:rPr>
-              <a:t>✗ </a:t>
-            </a:r>
-            <a:r>
-              <a:rPr sz="950" b="0">
-                <a:solidFill>
-                  <a:srgbClr val="718096"/>
-                </a:solidFill>
-              </a:rPr>
-              <a:t>Software Engineer I · True Ano…</a:t>
-            </a:r>
-          </a:p>
-        </p:txBody>
-      </p:sp>
-      <p:sp>
-        <p:nvSpPr>
-          <p:cNvPr id="28" name="TextBox 27"/>
-          <p:cNvSpPr txBox="1"/>
-          <p:nvPr/>
-        </p:nvSpPr>
-        <p:spPr>
-          <a:xfrm>
-            <a:off x="2560320" y="2231136"/>
-            <a:ext cx="1783080" cy="2286000"/>
-          </a:xfrm>
-          <a:prstGeom prst="rect">
-            <a:avLst/>
-          </a:prstGeom>
-          <a:noFill/>
-        </p:spPr>
-        <p:txBody>
-          <a:bodyPr wrap="square" lIns="18288" rIns="18288" tIns="0" bIns="0">
-            <a:spAutoFit/>
-          </a:bodyPr>
-          <a:lstStyle/>
-          <a:p>
-            <a:r>
-              <a:rPr sz="1200" b="1">
-                <a:solidFill>
-                  <a:srgbClr val="B85C1E"/>
-                </a:solidFill>
-              </a:rPr>
-              <a:t>Multi-agent: 3/5</a:t>
+              <a:t>P03 · 0.00 (failed)</a:t>
             </a:r>
           </a:p>
           <a:p>
@@ -6142,15 +6287,7 @@
                   <a:srgbClr val="B85C1E"/>
                 </a:solidFill>
               </a:rPr>
-              <a:t>✗ </a:t>
-            </a:r>
-            <a:r>
-              <a:rPr sz="950" b="0">
-                <a:solidFill>
-                  <a:srgbClr val="718096"/>
-                </a:solidFill>
-              </a:rPr>
-              <a:t>AI Resident · Toyota Research…</a:t>
+              <a:t>P17 · 0.00 (failed)</a:t>
             </a:r>
           </a:p>
           <a:p>
@@ -6162,18 +6299,10 @@
             <a:r>
               <a:rPr sz="1100" b="1">
                 <a:solidFill>
-                  <a:srgbClr val="2F5D8C"/>
-                </a:solidFill>
-              </a:rPr>
-              <a:t>✓ </a:t>
-            </a:r>
-            <a:r>
-              <a:rPr sz="950" b="0">
-                <a:solidFill>
-                  <a:srgbClr val="2D3748"/>
-                </a:solidFill>
-              </a:rPr>
-              <a:t>Data Scientist · Revenue Analy…</a:t>
+                  <a:srgbClr val="B85C1E"/>
+                </a:solidFill>
+              </a:rPr>
+              <a:t>P28 · 0.45</a:t>
             </a:r>
           </a:p>
           <a:p>
@@ -6185,18 +6314,76 @@
             <a:r>
               <a:rPr sz="1100" b="1">
                 <a:solidFill>
+                  <a:srgbClr val="B85C1E"/>
+                </a:solidFill>
+              </a:rPr>
+              <a:t>P07 · 0.53</a:t>
+            </a:r>
+          </a:p>
+        </p:txBody>
+      </p:sp>
+      <p:sp>
+        <p:nvSpPr>
+          <p:cNvPr id="29" name="TextBox 28"/>
+          <p:cNvSpPr txBox="1"/>
+          <p:nvPr/>
+        </p:nvSpPr>
+        <p:spPr>
+          <a:xfrm>
+            <a:off x="4800600" y="1847088"/>
+            <a:ext cx="3657600" cy="274320"/>
+          </a:xfrm>
+          <a:prstGeom prst="rect">
+            <a:avLst/>
+          </a:prstGeom>
+          <a:noFill/>
+        </p:spPr>
+        <p:txBody>
+          <a:bodyPr wrap="square" lIns="18288" rIns="18288" tIns="0" bIns="0">
+            <a:spAutoFit/>
+          </a:bodyPr>
+          <a:lstStyle/>
+          <a:p>
+            <a:r>
+              <a:rPr sz="1300" b="1">
+                <a:solidFill>
+                  <a:srgbClr val="14213D"/>
+                </a:solidFill>
+              </a:rPr>
+              <a:t>Multi-agent wins</a:t>
+            </a:r>
+          </a:p>
+        </p:txBody>
+      </p:sp>
+      <p:sp>
+        <p:nvSpPr>
+          <p:cNvPr id="30" name="TextBox 29"/>
+          <p:cNvSpPr txBox="1"/>
+          <p:nvPr/>
+        </p:nvSpPr>
+        <p:spPr>
+          <a:xfrm>
+            <a:off x="4800600" y="2231136"/>
+            <a:ext cx="1783080" cy="2286000"/>
+          </a:xfrm>
+          <a:prstGeom prst="rect">
+            <a:avLst/>
+          </a:prstGeom>
+          <a:noFill/>
+        </p:spPr>
+        <p:txBody>
+          <a:bodyPr wrap="square" lIns="18288" rIns="18288" tIns="0" bIns="0">
+            <a:spAutoFit/>
+          </a:bodyPr>
+          <a:lstStyle/>
+          <a:p>
+            <a:r>
+              <a:rPr sz="1200" b="1">
+                <a:solidFill>
                   <a:srgbClr val="2F5D8C"/>
                 </a:solidFill>
               </a:rPr>
-              <a:t>✓ </a:t>
-            </a:r>
-            <a:r>
-              <a:rPr sz="950" b="0">
-                <a:solidFill>
-                  <a:srgbClr val="2D3748"/>
-                </a:solidFill>
-              </a:rPr>
-              <a:t>Software Engineer · Synergy ECP</a:t>
+              <a:t>Single</a:t>
             </a:r>
           </a:p>
           <a:p>
@@ -6208,18 +6395,10 @@
             <a:r>
               <a:rPr sz="1100" b="1">
                 <a:solidFill>
-                  <a:srgbClr val="2F5D8C"/>
-                </a:solidFill>
-              </a:rPr>
-              <a:t>✓ </a:t>
-            </a:r>
-            <a:r>
-              <a:rPr sz="950" b="0">
-                <a:solidFill>
-                  <a:srgbClr val="2D3748"/>
-                </a:solidFill>
-              </a:rPr>
-              <a:t>AI Solutions Analyst · WisdomT…</a:t>
+                  <a:srgbClr val="B85C1E"/>
+                </a:solidFill>
+              </a:rPr>
+              <a:t>P06 · 0.47</a:t>
             </a:r>
           </a:p>
           <a:p>
@@ -6234,81 +6413,7 @@
                   <a:srgbClr val="B85C1E"/>
                 </a:solidFill>
               </a:rPr>
-              <a:t>✗ </a:t>
-            </a:r>
-            <a:r>
-              <a:rPr sz="950" b="0">
-                <a:solidFill>
-                  <a:srgbClr val="718096"/>
-                </a:solidFill>
-              </a:rPr>
-              <a:t>Associate Software Engineer ·…</a:t>
-            </a:r>
-          </a:p>
-        </p:txBody>
-      </p:sp>
-      <p:sp>
-        <p:nvSpPr>
-          <p:cNvPr id="29" name="TextBox 28"/>
-          <p:cNvSpPr txBox="1"/>
-          <p:nvPr/>
-        </p:nvSpPr>
-        <p:spPr>
-          <a:xfrm>
-            <a:off x="4800600" y="1847088"/>
-            <a:ext cx="3657600" cy="274320"/>
-          </a:xfrm>
-          <a:prstGeom prst="rect">
-            <a:avLst/>
-          </a:prstGeom>
-          <a:noFill/>
-        </p:spPr>
-        <p:txBody>
-          <a:bodyPr wrap="square" lIns="18288" rIns="18288" tIns="0" bIns="0">
-            <a:spAutoFit/>
-          </a:bodyPr>
-          <a:lstStyle/>
-          <a:p>
-            <a:r>
-              <a:rPr sz="1300" b="1">
-                <a:solidFill>
-                  <a:srgbClr val="14213D"/>
-                </a:solidFill>
-              </a:rPr>
-              <a:t>R05 · single agent's best case</a:t>
-            </a:r>
-          </a:p>
-        </p:txBody>
-      </p:sp>
-      <p:sp>
-        <p:nvSpPr>
-          <p:cNvPr id="30" name="TextBox 29"/>
-          <p:cNvSpPr txBox="1"/>
-          <p:nvPr/>
-        </p:nvSpPr>
-        <p:spPr>
-          <a:xfrm>
-            <a:off x="4800600" y="2231136"/>
-            <a:ext cx="1783080" cy="2286000"/>
-          </a:xfrm>
-          <a:prstGeom prst="rect">
-            <a:avLst/>
-          </a:prstGeom>
-          <a:noFill/>
-        </p:spPr>
-        <p:txBody>
-          <a:bodyPr wrap="square" lIns="18288" rIns="18288" tIns="0" bIns="0">
-            <a:spAutoFit/>
-          </a:bodyPr>
-          <a:lstStyle/>
-          <a:p>
-            <a:r>
-              <a:rPr sz="1200" b="1">
-                <a:solidFill>
-                  <a:srgbClr val="2F5D8C"/>
-                </a:solidFill>
-              </a:rPr>
-              <a:t>Single agent: 2/5</a:t>
+              <a:t>P15 · 0.24</a:t>
             </a:r>
           </a:p>
           <a:p>
@@ -6323,15 +6428,7 @@
                   <a:srgbClr val="B85C1E"/>
                 </a:solidFill>
               </a:rPr>
-              <a:t>✗ </a:t>
-            </a:r>
-            <a:r>
-              <a:rPr sz="950" b="0">
-                <a:solidFill>
-                  <a:srgbClr val="718096"/>
-                </a:solidFill>
-              </a:rPr>
-              <a:t>Junior Data Engineer · Hatch IT</a:t>
+              <a:t>P14 · 0.26</a:t>
             </a:r>
           </a:p>
           <a:p>
@@ -6343,18 +6440,43 @@
             <a:r>
               <a:rPr sz="1100" b="1">
                 <a:solidFill>
-                  <a:srgbClr val="2F5D8C"/>
-                </a:solidFill>
-              </a:rPr>
-              <a:t>✓ </a:t>
-            </a:r>
-            <a:r>
-              <a:rPr sz="950" b="0">
-                <a:solidFill>
-                  <a:srgbClr val="2D3748"/>
-                </a:solidFill>
-              </a:rPr>
-              <a:t>Software Engineer I · Tebra</a:t>
+                  <a:srgbClr val="B85C1E"/>
+                </a:solidFill>
+              </a:rPr>
+              <a:t>P08 · 0.32</a:t>
+            </a:r>
+          </a:p>
+        </p:txBody>
+      </p:sp>
+      <p:sp>
+        <p:nvSpPr>
+          <p:cNvPr id="31" name="TextBox 30"/>
+          <p:cNvSpPr txBox="1"/>
+          <p:nvPr/>
+        </p:nvSpPr>
+        <p:spPr>
+          <a:xfrm>
+            <a:off x="6675120" y="2231136"/>
+            <a:ext cx="1783080" cy="2286000"/>
+          </a:xfrm>
+          <a:prstGeom prst="rect">
+            <a:avLst/>
+          </a:prstGeom>
+          <a:noFill/>
+        </p:spPr>
+        <p:txBody>
+          <a:bodyPr wrap="square" lIns="18288" rIns="18288" tIns="0" bIns="0">
+            <a:spAutoFit/>
+          </a:bodyPr>
+          <a:lstStyle/>
+          <a:p>
+            <a:r>
+              <a:rPr sz="1200" b="1">
+                <a:solidFill>
+                  <a:srgbClr val="B85C1E"/>
+                </a:solidFill>
+              </a:rPr>
+              <a:t>Multi-agent</a:t>
             </a:r>
           </a:p>
           <a:p>
@@ -6369,15 +6491,7 @@
                   <a:srgbClr val="B85C1E"/>
                 </a:solidFill>
               </a:rPr>
-              <a:t>✗ </a:t>
-            </a:r>
-            <a:r>
-              <a:rPr sz="950" b="0">
-                <a:solidFill>
-                  <a:srgbClr val="718096"/>
-                </a:solidFill>
-              </a:rPr>
-              <a:t>Data and AI Engineer · The Bra…</a:t>
+              <a:t>P06 · 1.00</a:t>
             </a:r>
           </a:p>
           <a:p>
@@ -6389,18 +6503,10 @@
             <a:r>
               <a:rPr sz="1100" b="1">
                 <a:solidFill>
-                  <a:srgbClr val="2F5D8C"/>
-                </a:solidFill>
-              </a:rPr>
-              <a:t>✓ </a:t>
-            </a:r>
-            <a:r>
-              <a:rPr sz="950" b="0">
-                <a:solidFill>
-                  <a:srgbClr val="2D3748"/>
-                </a:solidFill>
-              </a:rPr>
-              <a:t>Data Developer · Global Lendin…</a:t>
+                  <a:srgbClr val="B85C1E"/>
+                </a:solidFill>
+              </a:rPr>
+              <a:t>P15 · 0.61</a:t>
             </a:r>
           </a:p>
           <a:p>
@@ -6415,48 +6521,7 @@
                   <a:srgbClr val="B85C1E"/>
                 </a:solidFill>
               </a:rPr>
-              <a:t>✗ </a:t>
-            </a:r>
-            <a:r>
-              <a:rPr sz="950" b="0">
-                <a:solidFill>
-                  <a:srgbClr val="718096"/>
-                </a:solidFill>
-              </a:rPr>
-              <a:t>Associate Software Engineer ·…</a:t>
-            </a:r>
-          </a:p>
-        </p:txBody>
-      </p:sp>
-      <p:sp>
-        <p:nvSpPr>
-          <p:cNvPr id="31" name="TextBox 30"/>
-          <p:cNvSpPr txBox="1"/>
-          <p:nvPr/>
-        </p:nvSpPr>
-        <p:spPr>
-          <a:xfrm>
-            <a:off x="6675120" y="2231136"/>
-            <a:ext cx="1783080" cy="2286000"/>
-          </a:xfrm>
-          <a:prstGeom prst="rect">
-            <a:avLst/>
-          </a:prstGeom>
-          <a:noFill/>
-        </p:spPr>
-        <p:txBody>
-          <a:bodyPr wrap="square" lIns="18288" rIns="18288" tIns="0" bIns="0">
-            <a:spAutoFit/>
-          </a:bodyPr>
-          <a:lstStyle/>
-          <a:p>
-            <a:r>
-              <a:rPr sz="1200" b="1">
-                <a:solidFill>
-                  <a:srgbClr val="B85C1E"/>
-                </a:solidFill>
-              </a:rPr>
-              <a:t>Multi-agent: 0/5</a:t>
+              <a:t>P14 · 0.58</a:t>
             </a:r>
           </a:p>
           <a:p>
@@ -6471,107 +6536,7 @@
                   <a:srgbClr val="B85C1E"/>
                 </a:solidFill>
               </a:rPr>
-              <a:t>✗ </a:t>
-            </a:r>
-            <a:r>
-              <a:rPr sz="950" b="0">
-                <a:solidFill>
-                  <a:srgbClr val="718096"/>
-                </a:solidFill>
-              </a:rPr>
-              <a:t>Junior Data Engineer · Hatch IT</a:t>
-            </a:r>
-          </a:p>
-          <a:p>
-            <a:pPr>
-              <a:spcBef>
-                <a:spcPts val="500"/>
-              </a:spcBef>
-            </a:pPr>
-            <a:r>
-              <a:rPr sz="1100" b="1">
-                <a:solidFill>
-                  <a:srgbClr val="B85C1E"/>
-                </a:solidFill>
-              </a:rPr>
-              <a:t>✗ </a:t>
-            </a:r>
-            <a:r>
-              <a:rPr sz="950" b="0">
-                <a:solidFill>
-                  <a:srgbClr val="718096"/>
-                </a:solidFill>
-              </a:rPr>
-              <a:t>Software Engineer · Kikoff</a:t>
-            </a:r>
-          </a:p>
-          <a:p>
-            <a:pPr>
-              <a:spcBef>
-                <a:spcPts val="500"/>
-              </a:spcBef>
-            </a:pPr>
-            <a:r>
-              <a:rPr sz="1100" b="1">
-                <a:solidFill>
-                  <a:srgbClr val="B85C1E"/>
-                </a:solidFill>
-              </a:rPr>
-              <a:t>✗ </a:t>
-            </a:r>
-            <a:r>
-              <a:rPr sz="950" b="0">
-                <a:solidFill>
-                  <a:srgbClr val="718096"/>
-                </a:solidFill>
-              </a:rPr>
-              <a:t>Data and AI Engineer · The Bra…</a:t>
-            </a:r>
-          </a:p>
-          <a:p>
-            <a:pPr>
-              <a:spcBef>
-                <a:spcPts val="500"/>
-              </a:spcBef>
-            </a:pPr>
-            <a:r>
-              <a:rPr sz="1100" b="1">
-                <a:solidFill>
-                  <a:srgbClr val="B85C1E"/>
-                </a:solidFill>
-              </a:rPr>
-              <a:t>✗ </a:t>
-            </a:r>
-            <a:r>
-              <a:rPr sz="950" b="0">
-                <a:solidFill>
-                  <a:srgbClr val="718096"/>
-                </a:solidFill>
-              </a:rPr>
-              <a:t>Associate Software Engineer ·…</a:t>
-            </a:r>
-          </a:p>
-          <a:p>
-            <a:pPr>
-              <a:spcBef>
-                <a:spcPts val="500"/>
-              </a:spcBef>
-            </a:pPr>
-            <a:r>
-              <a:rPr sz="1100" b="1">
-                <a:solidFill>
-                  <a:srgbClr val="B85C1E"/>
-                </a:solidFill>
-              </a:rPr>
-              <a:t>✗ </a:t>
-            </a:r>
-            <a:r>
-              <a:rPr sz="950" b="0">
-                <a:solidFill>
-                  <a:srgbClr val="718096"/>
-                </a:solidFill>
-              </a:rPr>
-              <a:t>Associate AI Engineer · AHEAD</a:t>
+              <a:t>P08 · 0.47</a:t>
             </a:r>
           </a:p>
         </p:txBody>
@@ -6675,6 +6640,624 @@
               <a:t>Questions?</a:t>
             </a:r>
             <a:endParaRPr lang="en-US" sz="4800" dirty="0"/>
+          </a:p>
+        </p:txBody>
+      </p:sp>
+    </p:spTree>
+  </p:cSld>
+  <p:clrMapOvr>
+    <a:masterClrMapping/>
+  </p:clrMapOvr>
+</p:sld>
+</file>
+
+<file path=ppt/slides/slide9.xml><?xml version="1.0" encoding="utf-8"?>
+<p:sld xmlns:a="http://schemas.openxmlformats.org/drawingml/2006/main" xmlns:p="http://schemas.openxmlformats.org/presentationml/2006/main" xmlns:r="http://schemas.openxmlformats.org/officeDocument/2006/relationships">
+  <p:cSld>
+    <p:spTree>
+      <p:nvGrpSpPr>
+        <p:cNvPr id="1" name=""/>
+        <p:cNvGrpSpPr/>
+        <p:nvPr/>
+      </p:nvGrpSpPr>
+      <p:grpSpPr/>
+      <p:sp>
+        <p:nvSpPr>
+          <p:cNvPr id="2" name="eyebrow"/>
+          <p:cNvSpPr txBox="1"/>
+          <p:nvPr/>
+        </p:nvSpPr>
+        <p:spPr>
+          <a:xfrm>
+            <a:off x="548640" y="365760"/>
+            <a:ext cx="5120640" cy="274320"/>
+          </a:xfrm>
+          <a:prstGeom prst="rect">
+            <a:avLst/>
+          </a:prstGeom>
+          <a:noFill/>
+          <a:ln/>
+        </p:spPr>
+        <p:txBody>
+          <a:bodyPr wrap="square" lIns="0" tIns="0" rIns="0" bIns="0" rtlCol="0" anchor="ctr"/>
+          <a:lstStyle/>
+          <a:p>
+            <a:pPr indent="0" marL="0">
+              <a:buNone/>
+            </a:pPr>
+            <a:r>
+              <a:rPr lang="en-US" sz="1200" spc="150" kern="0" dirty="0">
+                <a:solidFill>
+                  <a:srgbClr val="B85C1E"/>
+                </a:solidFill>
+                <a:latin typeface="Courier New" pitchFamily="34" charset="0"/>
+                <a:ea typeface="Courier New" pitchFamily="34" charset="-122"/>
+                <a:cs typeface="Courier New" pitchFamily="34" charset="-120"/>
+              </a:rPr>
+              <a:t>06 · WHAT THE MODEL SAID</a:t>
+            </a:r>
+            <a:endParaRPr lang="en-US" sz="1200" dirty="0"/>
+          </a:p>
+        </p:txBody>
+      </p:sp>
+      <p:sp>
+        <p:nvSpPr>
+          <p:cNvPr id="3" name="status"/>
+          <p:cNvSpPr/>
+          <p:nvPr/>
+        </p:nvSpPr>
+        <p:spPr>
+          <a:xfrm>
+            <a:off x="5669280" y="329184"/>
+            <a:ext cx="2926080" cy="329184"/>
+          </a:xfrm>
+          <a:prstGeom prst="roundRect">
+            <a:avLst>
+              <a:gd name="adj" fmla="val 138889"/>
+            </a:avLst>
+          </a:prstGeom>
+          <a:solidFill>
+            <a:srgbClr val="2F5D8C"/>
+          </a:solidFill>
+          <a:ln/>
+        </p:spPr>
+        <p:txBody>
+          <a:bodyPr wrap="square" lIns="0" tIns="0" rIns="0" bIns="0" rtlCol="0" anchor="ctr"/>
+          <a:lstStyle/>
+          <a:p>
+            <a:pPr algn="ctr" indent="0" marL="0">
+              <a:buNone/>
+            </a:pPr>
+            <a:r>
+              <a:rPr lang="en-US" sz="1100" b="1" dirty="0">
+                <a:solidFill>
+                  <a:srgbClr val="F7F5EF"/>
+                </a:solidFill>
+              </a:rPr>
+              <a:t>Dev resume P02 · 9 jobs</a:t>
+            </a:r>
+            <a:endParaRPr lang="en-US" sz="1100" dirty="0"/>
+          </a:p>
+        </p:txBody>
+      </p:sp>
+      <p:sp>
+        <p:nvSpPr>
+          <p:cNvPr id="4" name="Text 0"/>
+          <p:cNvSpPr/>
+          <p:nvPr>
+            <p:ph idx="100" type="title" hasCustomPrompt="1"/>
+          </p:nvPr>
+        </p:nvSpPr>
+        <p:spPr>
+          <a:xfrm>
+            <a:off x="548640" y="777240"/>
+            <a:ext cx="8046720" cy="548640"/>
+          </a:xfrm>
+          <a:prstGeom prst="rect">
+            <a:avLst/>
+          </a:prstGeom>
+          <a:noFill/>
+          <a:ln/>
+        </p:spPr>
+        <p:txBody>
+          <a:bodyPr wrap="square" lIns="0" tIns="0" rIns="0" bIns="0" rtlCol="0" anchor="t"/>
+          <a:lstStyle/>
+          <a:p>
+            <a:pPr algn="l" indent="0" marL="0">
+              <a:buNone/>
+            </a:pPr>
+            <a:r>
+              <a:rPr lang="en-US" sz="2800" b="1" dirty="0">
+                <a:solidFill>
+                  <a:srgbClr val="14213D"/>
+                </a:solidFill>
+              </a:rPr>
+              <a:t>Both found the 2 relevant jobs, then padded the list</a:t>
+            </a:r>
+            <a:endParaRPr lang="en-US" sz="2800" dirty="0"/>
+          </a:p>
+        </p:txBody>
+      </p:sp>
+      <p:sp>
+        <p:nvSpPr>
+          <p:cNvPr id="5" name="Text 3"/>
+          <p:cNvSpPr txBox="1"/>
+          <p:nvPr/>
+        </p:nvSpPr>
+        <p:spPr>
+          <a:xfrm>
+            <a:off x="548640" y="1325880"/>
+            <a:ext cx="8046720" cy="274320"/>
+          </a:xfrm>
+          <a:prstGeom prst="rect">
+            <a:avLst/>
+          </a:prstGeom>
+          <a:noFill/>
+          <a:ln/>
+        </p:spPr>
+        <p:txBody>
+          <a:bodyPr wrap="square" lIns="0" tIns="0" rIns="0" bIns="0" rtlCol="0" anchor="ctr"/>
+          <a:lstStyle/>
+          <a:p>
+            <a:pPr indent="0" marL="0">
+              <a:buNone/>
+            </a:pPr>
+            <a:r>
+              <a:rPr lang="en-US" sz="1300" dirty="0">
+                <a:solidFill>
+                  <a:srgbClr val="4A5568"/>
+                </a:solidFill>
+              </a:rPr>
+              <a:t>Only 2 of 9 jobs are relevant (D028 potential fit, D024 good fit) · ✓ relevant, ✗ no fit in the dataset labels</a:t>
+            </a:r>
+            <a:endParaRPr lang="en-US" sz="1300" dirty="0"/>
+          </a:p>
+        </p:txBody>
+      </p:sp>
+      <p:sp>
+        <p:nvSpPr>
+          <p:cNvPr id="6" name="Shape 4"/>
+          <p:cNvSpPr/>
+          <p:nvPr/>
+        </p:nvSpPr>
+        <p:spPr>
+          <a:xfrm>
+            <a:off x="548640" y="1737360"/>
+            <a:ext cx="3931920" cy="2880360"/>
+          </a:xfrm>
+          <a:prstGeom prst="roundRect">
+            <a:avLst>
+              <a:gd name="adj" fmla="val 2540"/>
+            </a:avLst>
+          </a:prstGeom>
+          <a:solidFill>
+            <a:srgbClr val="FFFFFF"/>
+          </a:solidFill>
+          <a:ln w="9525">
+            <a:solidFill>
+              <a:srgbClr val="E2DED3"/>
+            </a:solidFill>
+            <a:prstDash val="solid"/>
+          </a:ln>
+        </p:spPr>
+      </p:sp>
+      <p:sp>
+        <p:nvSpPr>
+          <p:cNvPr id="7" name="Shape 5"/>
+          <p:cNvSpPr/>
+          <p:nvPr/>
+        </p:nvSpPr>
+        <p:spPr>
+          <a:xfrm>
+            <a:off x="4663440" y="1737360"/>
+            <a:ext cx="3931920" cy="2880360"/>
+          </a:xfrm>
+          <a:prstGeom prst="roundRect">
+            <a:avLst>
+              <a:gd name="adj" fmla="val 2540"/>
+            </a:avLst>
+          </a:prstGeom>
+          <a:solidFill>
+            <a:srgbClr val="FFFFFF"/>
+          </a:solidFill>
+          <a:ln w="9525">
+            <a:solidFill>
+              <a:srgbClr val="E2DED3"/>
+            </a:solidFill>
+            <a:prstDash val="solid"/>
+          </a:ln>
+        </p:spPr>
+      </p:sp>
+      <p:sp>
+        <p:nvSpPr>
+          <p:cNvPr id="10" name="Text 6"/>
+          <p:cNvSpPr txBox="1"/>
+          <p:nvPr/>
+        </p:nvSpPr>
+        <p:spPr>
+          <a:xfrm>
+            <a:off x="1097280" y="4754880"/>
+            <a:ext cx="7498080" cy="228600"/>
+          </a:xfrm>
+          <a:prstGeom prst="rect">
+            <a:avLst/>
+          </a:prstGeom>
+          <a:noFill/>
+          <a:ln/>
+        </p:spPr>
+        <p:txBody>
+          <a:bodyPr wrap="square" lIns="0" tIns="0" rIns="0" bIns="0" rtlCol="0" anchor="ctr"/>
+          <a:lstStyle/>
+          <a:p>
+            <a:pPr indent="0" marL="0">
+              <a:buNone/>
+            </a:pPr>
+            <a:r>
+              <a:rPr lang="en-US" sz="1000" dirty="0">
+                <a:solidFill>
+                  <a:srgbClr val="718096"/>
+                </a:solidFill>
+              </a:rPr>
+              <a:t>Qwen3 4B · dev resume P02 (HR / admin background) · must return 5 picks · job names shortened</a:t>
+            </a:r>
+            <a:endParaRPr lang="en-US" sz="1000" dirty="0"/>
+          </a:p>
+        </p:txBody>
+      </p:sp>
+      <p:sp>
+        <p:nvSpPr>
+          <p:cNvPr id="25" name="Slide Number Placeholder 0"/>
+          <p:cNvSpPr>
+            <a:spLocks noGrp="1"/>
+          </p:cNvSpPr>
+          <p:nvPr>
+            <p:ph type="sldNum" sz="quarter" idx="4294967295"/>
+          </p:nvPr>
+        </p:nvSpPr>
+        <p:spPr>
+          <a:xfrm>
+            <a:off x="548640" y="4800600"/>
+            <a:ext cx="914400" cy="228600"/>
+          </a:xfrm>
+          <a:prstGeom prst="rect">
+            <a:avLst/>
+          </a:prstGeom>
+          <a:extLst>
+            <a:ext uri="{C572A759-6A51-4108-AA02-DFA0A04FC94B}">
+              <ma14:wrappingTextBoxFlag xmlns:ma14="http://schemas.microsoft.com/office/mac/drawingml/2011/main" val="0"/>
+            </a:ext>
+          </a:extLst>
+        </p:spPr>
+        <p:txBody>
+          <a:bodyPr/>
+          <a:lstStyle>
+            <a:lvl1pPr>
+              <a:defRPr sz="1000">
+                <a:solidFill>
+                  <a:srgbClr val="718096"/>
+                </a:solidFill>
+                <a:latin typeface="Calibri"/>
+                <a:ea typeface="Calibri"/>
+                <a:cs typeface="Calibri"/>
+              </a:defRPr>
+            </a:lvl1pPr>
+          </a:lstStyle>
+          <a:p>
+            <a:r>
+              <a:t>7</a:t>
+            </a:r>
+          </a:p>
+        </p:txBody>
+      </p:sp>
+      <p:sp>
+        <p:nvSpPr>
+          <p:cNvPr id="26" name="TextBox 25"/>
+          <p:cNvSpPr txBox="1"/>
+          <p:nvPr/>
+        </p:nvSpPr>
+        <p:spPr>
+          <a:xfrm>
+            <a:off x="685800" y="1847088"/>
+            <a:ext cx="3657600" cy="274320"/>
+          </a:xfrm>
+          <a:prstGeom prst="rect">
+            <a:avLst/>
+          </a:prstGeom>
+          <a:noFill/>
+        </p:spPr>
+        <p:txBody>
+          <a:bodyPr wrap="square" lIns="18288" rIns="18288" tIns="0" bIns="0">
+            <a:spAutoFit/>
+          </a:bodyPr>
+          <a:lstStyle/>
+          <a:p>
+            <a:r>
+              <a:rPr sz="1300" b="1">
+                <a:solidFill>
+                  <a:srgbClr val="14213D"/>
+                </a:solidFill>
+              </a:rPr>
+              <a:t>Single agent · nDCG@5 0.69</a:t>
+            </a:r>
+          </a:p>
+        </p:txBody>
+      </p:sp>
+      <p:sp>
+        <p:nvSpPr>
+          <p:cNvPr id="27" name="TextBox 26"/>
+          <p:cNvSpPr txBox="1"/>
+          <p:nvPr/>
+        </p:nvSpPr>
+        <p:spPr>
+          <a:xfrm>
+            <a:off x="685800" y="2231136"/>
+            <a:ext cx="3657600" cy="2286000"/>
+          </a:xfrm>
+          <a:prstGeom prst="rect">
+            <a:avLst/>
+          </a:prstGeom>
+          <a:noFill/>
+        </p:spPr>
+        <p:txBody>
+          <a:bodyPr wrap="square" lIns="18288" rIns="18288" tIns="0" bIns="0">
+            <a:spAutoFit/>
+          </a:bodyPr>
+          <a:lstStyle/>
+          <a:p>
+            <a:r>
+              <a:rPr sz="1200" b="1">
+                <a:solidFill>
+                  <a:srgbClr val="2F5D8C"/>
+                </a:solidFill>
+              </a:rPr>
+              <a:t>Top 5 (2/5 relevant)</a:t>
+            </a:r>
+          </a:p>
+          <a:p>
+            <a:pPr>
+              <a:spcBef>
+                <a:spcPts val="500"/>
+              </a:spcBef>
+            </a:pPr>
+            <a:r>
+              <a:rPr sz="1100" b="1">
+                <a:solidFill>
+                  <a:srgbClr val="2F5D8C"/>
+                </a:solidFill>
+              </a:rPr>
+              <a:t>✓ Data Engineer, SaaS firm</a:t>
+            </a:r>
+          </a:p>
+          <a:p>
+            <a:pPr>
+              <a:spcBef>
+                <a:spcPts val="500"/>
+              </a:spcBef>
+            </a:pPr>
+            <a:r>
+              <a:rPr sz="1100" b="1">
+                <a:solidFill>
+                  <a:srgbClr val="2F5D8C"/>
+                </a:solidFill>
+              </a:rPr>
+              <a:t>✗ Sr Business Systems DB Engineer</a:t>
+            </a:r>
+          </a:p>
+          <a:p>
+            <a:pPr>
+              <a:spcBef>
+                <a:spcPts val="500"/>
+              </a:spcBef>
+            </a:pPr>
+            <a:r>
+              <a:rPr sz="1100" b="1">
+                <a:solidFill>
+                  <a:srgbClr val="2F5D8C"/>
+                </a:solidFill>
+              </a:rPr>
+              <a:t>✓ ROR Partners data role</a:t>
+            </a:r>
+          </a:p>
+          <a:p>
+            <a:pPr>
+              <a:spcBef>
+                <a:spcPts val="500"/>
+              </a:spcBef>
+            </a:pPr>
+            <a:r>
+              <a:rPr sz="1100" b="1">
+                <a:solidFill>
+                  <a:srgbClr val="2F5D8C"/>
+                </a:solidFill>
+              </a:rPr>
+              <a:t>✗ Cybersecurity / embedded (SEL)</a:t>
+            </a:r>
+          </a:p>
+          <a:p>
+            <a:pPr>
+              <a:spcBef>
+                <a:spcPts val="500"/>
+              </a:spcBef>
+            </a:pPr>
+            <a:r>
+              <a:rPr sz="1100" b="1">
+                <a:solidFill>
+                  <a:srgbClr val="2F5D8C"/>
+                </a:solidFill>
+              </a:rPr>
+              <a:t>✗ Software Engineer (Brooksource)</a:t>
+            </a:r>
+          </a:p>
+          <a:p>
+            <a:pPr>
+              <a:spcBef>
+                <a:spcPts val="500"/>
+              </a:spcBef>
+            </a:pPr>
+            <a:r>
+              <a:rPr sz="1100" b="1">
+                <a:solidFill>
+                  <a:srgbClr val="2F5D8C"/>
+                </a:solidFill>
+              </a:rPr>
+              <a:t>Its own note on #4: "no alignment"</a:t>
+            </a:r>
+          </a:p>
+        </p:txBody>
+      </p:sp>
+      <p:sp>
+        <p:nvSpPr>
+          <p:cNvPr id="29" name="TextBox 28"/>
+          <p:cNvSpPr txBox="1"/>
+          <p:nvPr/>
+        </p:nvSpPr>
+        <p:spPr>
+          <a:xfrm>
+            <a:off x="4800600" y="1847088"/>
+            <a:ext cx="3657600" cy="274320"/>
+          </a:xfrm>
+          <a:prstGeom prst="rect">
+            <a:avLst/>
+          </a:prstGeom>
+          <a:noFill/>
+        </p:spPr>
+        <p:txBody>
+          <a:bodyPr wrap="square" lIns="18288" rIns="18288" tIns="0" bIns="0">
+            <a:spAutoFit/>
+          </a:bodyPr>
+          <a:lstStyle/>
+          <a:p>
+            <a:r>
+              <a:rPr sz="1300" b="1">
+                <a:solidFill>
+                  <a:srgbClr val="14213D"/>
+                </a:solidFill>
+              </a:rPr>
+              <a:t>Multi-agent · nDCG@5 0.63</a:t>
+            </a:r>
+          </a:p>
+        </p:txBody>
+      </p:sp>
+      <p:sp>
+        <p:nvSpPr>
+          <p:cNvPr id="30" name="TextBox 29"/>
+          <p:cNvSpPr txBox="1"/>
+          <p:nvPr/>
+        </p:nvSpPr>
+        <p:spPr>
+          <a:xfrm>
+            <a:off x="4800600" y="2231136"/>
+            <a:ext cx="3657600" cy="2286000"/>
+          </a:xfrm>
+          <a:prstGeom prst="rect">
+            <a:avLst/>
+          </a:prstGeom>
+          <a:noFill/>
+        </p:spPr>
+        <p:txBody>
+          <a:bodyPr wrap="square" lIns="18288" rIns="18288" tIns="0" bIns="0">
+            <a:spAutoFit/>
+          </a:bodyPr>
+          <a:lstStyle/>
+          <a:p>
+            <a:r>
+              <a:rPr sz="1200" b="1">
+                <a:solidFill>
+                  <a:srgbClr val="2F5D8C"/>
+                </a:solidFill>
+              </a:rPr>
+              <a:t>Top 5 (2/5 relevant)</a:t>
+            </a:r>
+          </a:p>
+          <a:p>
+            <a:pPr>
+              <a:spcBef>
+                <a:spcPts val="500"/>
+              </a:spcBef>
+            </a:pPr>
+            <a:r>
+              <a:rPr sz="1100" b="1">
+                <a:solidFill>
+                  <a:srgbClr val="B85C1E"/>
+                </a:solidFill>
+              </a:rPr>
+              <a:t>✓ Data Engineer, SaaS firm</a:t>
+            </a:r>
+          </a:p>
+          <a:p>
+            <a:pPr>
+              <a:spcBef>
+                <a:spcPts val="500"/>
+              </a:spcBef>
+            </a:pPr>
+            <a:r>
+              <a:rPr sz="1100" b="1">
+                <a:solidFill>
+                  <a:srgbClr val="B85C1E"/>
+                </a:solidFill>
+              </a:rPr>
+              <a:t>✗ Prop trading firm data role</a:t>
+            </a:r>
+          </a:p>
+          <a:p>
+            <a:pPr>
+              <a:spcBef>
+                <a:spcPts val="500"/>
+              </a:spcBef>
+            </a:pPr>
+            <a:r>
+              <a:rPr sz="1100" b="1">
+                <a:solidFill>
+                  <a:srgbClr val="B85C1E"/>
+                </a:solidFill>
+              </a:rPr>
+              <a:t>✗ Sr Business Systems DB Engineer</a:t>
+            </a:r>
+          </a:p>
+          <a:p>
+            <a:pPr>
+              <a:spcBef>
+                <a:spcPts val="500"/>
+              </a:spcBef>
+            </a:pPr>
+            <a:r>
+              <a:rPr sz="1100" b="1">
+                <a:solidFill>
+                  <a:srgbClr val="B85C1E"/>
+                </a:solidFill>
+              </a:rPr>
+              <a:t>✓ ROR Partners data role</a:t>
+            </a:r>
+          </a:p>
+          <a:p>
+            <a:pPr>
+              <a:spcBef>
+                <a:spcPts val="500"/>
+              </a:spcBef>
+            </a:pPr>
+            <a:r>
+              <a:rPr sz="1100" b="1">
+                <a:solidFill>
+                  <a:srgbClr val="B85C1E"/>
+                </a:solidFill>
+              </a:rPr>
+              <a:t>✗ Cost Accountant</a:t>
+            </a:r>
+          </a:p>
+          <a:p>
+            <a:pPr>
+              <a:spcBef>
+                <a:spcPts val="500"/>
+              </a:spcBef>
+            </a:pPr>
+            <a:r>
+              <a:rPr sz="1100" b="1">
+                <a:solidFill>
+                  <a:srgbClr val="B85C1E"/>
+                </a:solidFill>
+              </a:rPr>
+              <a:t>Its own note on #5: needs ERP skills, "not mentioned"</a:t>
+            </a:r>
           </a:p>
         </p:txBody>
       </p:sp>

</xml_diff>

<commit_message>
Update README with evaluation results on rjdfit dataset; add new result summaries and manifest files for 4B and 14B models
</commit_message>
<xml_diff>
--- a/progress_update_2026-10.pptx
+++ b/progress_update_2026-10.pptx
@@ -210,7 +210,7 @@
               <a:lstStyle/>
               <a:p>
                 <a:pPr>
-                  <a:defRPr b="0" i="0" strike="noStrike" sz="1100" u="none">
+                  <a:defRPr b="1" i="0" strike="noStrike" sz="900" u="none">
                     <a:solidFill>
                       <a:srgbClr val="14213D"/>
                     </a:solidFill>
@@ -273,29 +273,41 @@
           </c:dPt>
           <c:cat>
             <c:strRef>
-              <c:f>Sheet1!$A$2:$A$3</c:f>
+              <c:f>Sheet1!$A$2:$A$5</c:f>
               <c:strCache>
-                <c:ptCount val="2"/>
+                <c:ptCount val="4"/>
                 <c:pt idx="0">
-                  <c:v>Single</c:v>
+                  <c:v>4B Single</c:v>
                 </c:pt>
                 <c:pt idx="1">
-                  <c:v>Multi</c:v>
+                  <c:v>4B Multi</c:v>
+                </c:pt>
+                <c:pt idx="2">
+                  <c:v>14B Single</c:v>
+                </c:pt>
+                <c:pt idx="3">
+                  <c:v>14B Multi</c:v>
                 </c:pt>
               </c:strCache>
             </c:strRef>
           </c:cat>
           <c:val>
             <c:numRef>
-              <c:f>Sheet1!$B$2:$B$3</c:f>
+              <c:f>Sheet1!$B$2:$B$5</c:f>
               <c:numCache>
                 <c:formatCode>General</c:formatCode>
-                <c:ptCount val="2"/>
+                <c:ptCount val="4"/>
                 <c:pt idx="0">
                   <c:v>5.5</c:v>
                 </c:pt>
                 <c:pt idx="1">
                   <c:v>20.9</c:v>
+                </c:pt>
+                <c:pt idx="2">
+                  <c:v>10.6</c:v>
+                </c:pt>
+                <c:pt idx="3">
+                  <c:v>40.8</c:v>
                 </c:pt>
               </c:numCache>
             </c:numRef>
@@ -506,7 +518,7 @@
               <a:lstStyle/>
               <a:p>
                 <a:pPr>
-                  <a:defRPr b="0" i="0" strike="noStrike" sz="1100" u="none">
+                  <a:defRPr b="1" i="0" strike="noStrike" sz="900" u="none">
                     <a:solidFill>
                       <a:srgbClr val="14213D"/>
                     </a:solidFill>
@@ -569,29 +581,41 @@
           </c:dPt>
           <c:cat>
             <c:strRef>
-              <c:f>Sheet1!$A$2:$A$3</c:f>
+              <c:f>Sheet1!$A$2:$A$5</c:f>
               <c:strCache>
-                <c:ptCount val="2"/>
+                <c:ptCount val="4"/>
                 <c:pt idx="0">
-                  <c:v>Single</c:v>
+                  <c:v>4B Single</c:v>
                 </c:pt>
                 <c:pt idx="1">
-                  <c:v>Multi</c:v>
+                  <c:v>4B Multi</c:v>
+                </c:pt>
+                <c:pt idx="2">
+                  <c:v>14B Single</c:v>
+                </c:pt>
+                <c:pt idx="3">
+                  <c:v>14B Multi</c:v>
                 </c:pt>
               </c:strCache>
             </c:strRef>
           </c:cat>
           <c:val>
             <c:numRef>
-              <c:f>Sheet1!$B$2:$B$3</c:f>
+              <c:f>Sheet1!$B$2:$B$5</c:f>
               <c:numCache>
                 <c:formatCode>General</c:formatCode>
-                <c:ptCount val="2"/>
+                <c:ptCount val="4"/>
                 <c:pt idx="0">
                   <c:v>9.9</c:v>
                 </c:pt>
                 <c:pt idx="1">
                   <c:v>32.2</c:v>
+                </c:pt>
+                <c:pt idx="2">
+                  <c:v>9.9</c:v>
+                </c:pt>
+                <c:pt idx="3">
+                  <c:v>32.0</c:v>
                 </c:pt>
               </c:numCache>
             </c:numRef>
@@ -749,7 +773,7 @@
                   <a:srgbClr val="14213D"/>
                 </a:solidFill>
               </a:rPr>
-              <a:t>Accuracy (higher is better)</a:t>
+              <a:t>Accuracy, 14B (higher is better)</a:t>
             </a:r>
           </a:p>
         </c:rich>
@@ -781,6 +805,25 @@
               <a:srgbClr val="2F5D8C"/>
             </a:solidFill>
           </c:spPr>
+          <c:dLbls>
+            <c:numFmt formatCode="0.00" sourceLinked="0"/>
+            <c:txPr>
+              <a:bodyPr/>
+              <a:lstStyle/>
+              <a:p>
+                <a:pPr>
+                  <a:defRPr sz="900" b="1"/>
+                </a:pPr>
+              </a:p>
+            </c:txPr>
+            <c:showLegendKey val="0"/>
+            <c:showVal val="1"/>
+            <c:showCatName val="0"/>
+            <c:showSerName val="0"/>
+            <c:showPercent val="0"/>
+            <c:showBubbleSize val="0"/>
+            <c:showLeaderLines val="1"/>
+          </c:dLbls>
           <c:cat>
             <c:strRef>
               <c:f>Sheet1!$A$2:$A$4</c:f>
@@ -805,13 +848,13 @@
                 <c:formatCode>General</c:formatCode>
                 <c:ptCount val="3"/>
                 <c:pt idx="0">
-                  <c:v>0.568</c:v>
+                  <c:v>0.533</c:v>
                 </c:pt>
                 <c:pt idx="1">
-                  <c:v>0.679</c:v>
+                  <c:v>0.7</c:v>
                 </c:pt>
                 <c:pt idx="2">
-                  <c:v>0.643</c:v>
+                  <c:v>0.714</c:v>
                 </c:pt>
               </c:numCache>
             </c:numRef>
@@ -836,6 +879,25 @@
               <a:srgbClr val="B85C1E"/>
             </a:solidFill>
           </c:spPr>
+          <c:dLbls>
+            <c:numFmt formatCode="0.00" sourceLinked="0"/>
+            <c:txPr>
+              <a:bodyPr/>
+              <a:lstStyle/>
+              <a:p>
+                <a:pPr>
+                  <a:defRPr sz="900" b="1"/>
+                </a:pPr>
+              </a:p>
+            </c:txPr>
+            <c:showLegendKey val="0"/>
+            <c:showVal val="1"/>
+            <c:showCatName val="0"/>
+            <c:showSerName val="0"/>
+            <c:showPercent val="0"/>
+            <c:showBubbleSize val="0"/>
+            <c:showLeaderLines val="1"/>
+          </c:dLbls>
           <c:cat>
             <c:strRef>
               <c:f>Sheet1!$A$2:$A$4</c:f>
@@ -860,13 +922,13 @@
                 <c:formatCode>General</c:formatCode>
                 <c:ptCount val="3"/>
                 <c:pt idx="0">
-                  <c:v>0.512</c:v>
+                  <c:v>0.486</c:v>
                 </c:pt>
                 <c:pt idx="1">
-                  <c:v>0.629</c:v>
+                  <c:v>0.664</c:v>
                 </c:pt>
                 <c:pt idx="2">
-                  <c:v>0.607</c:v>
+                  <c:v>0.429</c:v>
                 </c:pt>
               </c:numCache>
             </c:numRef>
@@ -1001,7 +1063,7 @@
                   <a:srgbClr val="14213D"/>
                 </a:solidFill>
               </a:rPr>
-              <a:t>nDCG@5 with and without the 2 failures</a:t>
+              <a:t>nDCG@5 by pool size (9 / 7 / 12 resumes)</a:t>
             </a:r>
           </a:p>
         </c:rich>
@@ -1033,31 +1095,56 @@
               <a:srgbClr val="2F5D8C"/>
             </a:solidFill>
           </c:spPr>
+          <c:dLbls>
+            <c:numFmt formatCode="0.00" sourceLinked="0"/>
+            <c:txPr>
+              <a:bodyPr/>
+              <a:lstStyle/>
+              <a:p>
+                <a:pPr>
+                  <a:defRPr sz="900" b="1"/>
+                </a:pPr>
+              </a:p>
+            </c:txPr>
+            <c:showLegendKey val="0"/>
+            <c:showVal val="1"/>
+            <c:showCatName val="0"/>
+            <c:showSerName val="0"/>
+            <c:showPercent val="0"/>
+            <c:showBubbleSize val="0"/>
+            <c:showLeaderLines val="1"/>
+          </c:dLbls>
           <c:cat>
             <c:strRef>
-              <c:f>Sheet1!$A$2:$A$3</c:f>
+              <c:f>Sheet1!$A$2:$A$4</c:f>
               <c:strCache>
-                <c:ptCount val="2"/>
+                <c:ptCount val="3"/>
                 <c:pt idx="0">
-                  <c:v>All 28 resumes</c:v>
+                  <c:v>&lt;=12 jobs</c:v>
                 </c:pt>
                 <c:pt idx="1">
-                  <c:v>Without P03, P17</c:v>
+                  <c:v>13-16 jobs</c:v>
+                </c:pt>
+                <c:pt idx="2">
+                  <c:v>&gt;16 jobs</c:v>
                 </c:pt>
               </c:strCache>
             </c:strRef>
           </c:cat>
           <c:val>
             <c:numRef>
-              <c:f>Sheet1!$B$2:$B$3</c:f>
+              <c:f>Sheet1!$B$2:$B$4</c:f>
               <c:numCache>
                 <c:formatCode>General</c:formatCode>
-                <c:ptCount val="2"/>
+                <c:ptCount val="3"/>
                 <c:pt idx="0">
-                  <c:v>0.568</c:v>
+                  <c:v>0.558</c:v>
                 </c:pt>
                 <c:pt idx="1">
-                  <c:v>0.554</c:v>
+                  <c:v>0.518</c:v>
+                </c:pt>
+                <c:pt idx="2">
+                  <c:v>0.524</c:v>
                 </c:pt>
               </c:numCache>
             </c:numRef>
@@ -1082,31 +1169,56 @@
               <a:srgbClr val="B85C1E"/>
             </a:solidFill>
           </c:spPr>
+          <c:dLbls>
+            <c:numFmt formatCode="0.00" sourceLinked="0"/>
+            <c:txPr>
+              <a:bodyPr/>
+              <a:lstStyle/>
+              <a:p>
+                <a:pPr>
+                  <a:defRPr sz="900" b="1"/>
+                </a:pPr>
+              </a:p>
+            </c:txPr>
+            <c:showLegendKey val="0"/>
+            <c:showVal val="1"/>
+            <c:showCatName val="0"/>
+            <c:showSerName val="0"/>
+            <c:showPercent val="0"/>
+            <c:showBubbleSize val="0"/>
+            <c:showLeaderLines val="1"/>
+          </c:dLbls>
           <c:cat>
             <c:strRef>
-              <c:f>Sheet1!$A$2:$A$3</c:f>
+              <c:f>Sheet1!$A$2:$A$4</c:f>
               <c:strCache>
-                <c:ptCount val="2"/>
+                <c:ptCount val="3"/>
                 <c:pt idx="0">
-                  <c:v>All 28 resumes</c:v>
+                  <c:v>&lt;=12 jobs</c:v>
                 </c:pt>
                 <c:pt idx="1">
-                  <c:v>Without P03, P17</c:v>
+                  <c:v>13-16 jobs</c:v>
+                </c:pt>
+                <c:pt idx="2">
+                  <c:v>&gt;16 jobs</c:v>
                 </c:pt>
               </c:strCache>
             </c:strRef>
           </c:cat>
           <c:val>
             <c:numRef>
-              <c:f>Sheet1!$C$2:$C$3</c:f>
+              <c:f>Sheet1!$C$2:$C$4</c:f>
               <c:numCache>
                 <c:formatCode>General</c:formatCode>
-                <c:ptCount val="2"/>
+                <c:ptCount val="3"/>
                 <c:pt idx="0">
-                  <c:v>0.512</c:v>
+                  <c:v>0.414</c:v>
                 </c:pt>
                 <c:pt idx="1">
-                  <c:v>0.551</c:v>
+                  <c:v>0.537</c:v>
+                </c:pt>
+                <c:pt idx="2">
+                  <c:v>0.511</c:v>
                 </c:pt>
               </c:numCache>
             </c:numRef>
@@ -1619,7 +1731,7 @@
           <a:lstStyle/>
           <a:p>
             <a:r>
-              <a:t>Quick status check. Both approaches now have first measured results on a public labeled dataset.</a:t>
+              <a:t>Quick status check. Both approaches now have measured results on a public labeled dataset, with two model sizes (Qwen3 4B and 14B).</a:t>
             </a:r>
           </a:p>
         </p:txBody>
@@ -1791,7 +1903,7 @@
           <a:lstStyle/>
           <a:p>
             <a:r>
-              <a:t>The baseline sends the resume and every job in the pool in one call and gets back five ranked job IDs with explanations. It shares input cleanup, model, output limit, ranking prompt and validation with the orchestrator, so the only difference is the architecture. Results on the 28 eval resumes (1 repetition each): nDCG@5 0.568, Precision@5 0.679, top-1 hit rate 0.643, no failed runs. Median 5.5 seconds and about 9.9k tokens per resume.</a:t>
+              <a:t>The baseline sends the resume and every job in the pool in one call and gets back five ranked job IDs with explanations. It shares input cleanup, model, output limit, ranking prompt and validation with the orchestrator, so the only difference is the architecture. Final run is Qwen3 14B (4-bit) on an A100, 28 eval resumes, one run each: nDCG@5 0.533, Precision@5 0.700, top-1 hit rate 0.714, no failures. Median 10.6 seconds and about 9.9k tokens per resume. The earlier 4B run scored nDCG@5 0.568, so the bigger model did not help the single agent on nDCG.</a:t>
             </a:r>
           </a:p>
         </p:txBody>
@@ -1877,7 +1989,7 @@
           <a:lstStyle/>
           <a:p>
             <a:r>
-              <a:t>The orchestrator runs three workers: resume parser, requirement extractor and ranker, chained by Python. Workers pick numbered lines and the controller restores the exact source text. Messy rjdfit text is flattened and split into lines of at most 300 characters. On the 28 eval resumes: nDCG@5 0.512, Precision@5 0.629, top-1 0.607, and 2 failed runs (P03 and P17), which score 0. Median 20.9 seconds and 32.2k tokens. Local runs have no API cost; hardware cost is not measured. We have not yet read the error behind the two failures.</a:t>
+              <a:t>The orchestrator runs three workers: resume parser, requirement extractor and ranker, chained by Python. Workers pick numbered lines and the controller restores the exact source text. The two failures on the 4B run (P03 and P17) were the resume parser hitting its 2,000-token output cap on long resumes by listing about 60 skills; the cap is now 4,000 tokens and the prompt asks for at most 15 skills. On the final 14B run all 28 resumes completed: nDCG@5 0.486, Precision@5 0.664, top-1 0.429. Median 40.8 seconds and 32.0k tokens. Local runs have no API cost; hardware cost is not measured.</a:t>
             </a:r>
           </a:p>
         </p:txBody>
@@ -1963,7 +2075,7 @@
           <a:lstStyle/>
           <a:p>
             <a:r>
-              <a:t>Median wall-clock per resume was 5.5s for the single agent and 20.9s for the orchestrator (3.8x). Median tokens were 9.9k vs 32.2k (3.3x). This matches what we saw earlier on the old workload (4 to 6x slower, about 2.8x tokens) and is expected: three sequential calls, and the later calls re-read the resume and job text.</a:t>
+              <a:t>Median wall-clock per resume: 4B single 5.5s, 4B multi 20.9s (3.8x); 14B single 10.6s, 14B multi 40.8s (3.9x). Median tokens: 9.9k vs 32.2k on 4B, 9.9k vs 32.0k on 14B (3.2x). The 14B model roughly doubles the time for both. The whole 28-resume eval took about 24 minutes of model time on 14B (4.7 for single, 19.1 for multi) versus about 14 on 4B. This matches the old workload (4 to 6x slower, about 2.8x tokens) and is expected: three sequential calls, and later calls re-read the resume and job text.</a:t>
             </a:r>
           </a:p>
         </p:txBody>
@@ -2049,7 +2161,7 @@
           <a:lstStyle/>
           <a:p>
             <a:r>
-              <a:t>Single agent: nDCG@5 0.568, Precision@5 0.679, top-1 0.643, 0 failures. Multi-agent: 0.512, 0.629, 0.607, 2 failures out of 28 (P03 and P17, scored 0). Per resume, single was better on 16, multi on 9, tied on 3; the mean gap is 0.056 with a bootstrap 95% interval of about -0.16 to +0.04, so we can't call it a real difference. Dropping the two failed resumes for both, they are essentially tied (0.554 vs 0.551). Both are only modestly above the 0.58 random Precision@5, so a 4B model on these pools is a weak matcher either way. One repetition per resume, so no run-to-run variance yet.</a:t>
+              <a:t>Qwen3 14B, 28 eval resumes, one run each, no failures. Single agent: nDCG@5 0.533, Precision@5 0.700, top-1 0.714. Multi-agent: 0.486, 0.664, 0.429. Per resume, single was better on 15, multi on 12, tied on 1. Mean gap 0.047, bootstrap 95% interval about -0.14 to +0.02, so we can't call it a real difference. One resume, P06, accounts for most of it: multi scored 0 (single 0.97). Without P06 the mean gap is about -0.01. By pool size, multi is clearly behind only on small pools (&lt;=12 jobs: 0.41 vs 0.56) and is level or slightly ahead on 13-16 and above (0.54 vs 0.52, 0.51 vs 0.52), but groups are 9, 7 and 12 resumes, so that is a hint, not a finding. The earlier 4B run: single 0.568, multi 0.512 with 2 failed runs that scored 0; the bigger model did not raise nDCG for either architecture, though Precision@5 went up slightly. Both are only modestly above the 0.58 random Precision@5.</a:t>
             </a:r>
           </a:p>
         </p:txBody>
@@ -2119,7 +2231,7 @@
           <a:lstStyle/>
           <a:p>
             <a:r>
-              <a:t>Largest per-resume gaps. Single wins: P03 and P17 (multi-agent failed, scored 0), P28 (0.83 vs 0.45), P07 (0.80 vs 0.53). Multi-agent wins: P06 (1.00 vs 0.47), P15 (0.61 vs 0.24), P14 (0.58 vs 0.26), P08 (0.47 vs 0.32). Three resumes tied exactly. Full per-resume table is in paired_resumes.csv.</a:t>
+              <a:t>Largest per-resume gaps on the 14B run. Single wins: P06 (0.97 vs 0.00), P11 (0.56 vs 0.37), P09 (0.79 vs 0.61), P15 (0.65 vs 0.47). Multi-agent wins: P20 (0.37 vs 0.65), P23 (0.25 vs 0.45), P13 (0.73 vs 0.89), P22 (0.85 vs 1.00). P14 tied exactly. Full table is in paired_resumes.csv.</a:t>
             </a:r>
           </a:p>
         </p:txBody>
@@ -2189,7 +2301,7 @@
           <a:lstStyle/>
           <a:p>
             <a:r>
-              <a:t>Real model output for dev resume P02, an HR/admin background with a pool of 9 jobs where only 2 are relevant (D028 is a potential fit, D024 a good fit). Both pipelines found both relevant jobs. The single agent ranked them 1st and 3rd (nDCG@5 0.69), the orchestrator 1st and 4th (0.63). Both had to return 5, so both filled the remaining 3 slots with no-fit jobs, and the model's own explanations say things like 'no alignment' or 'not mentioned' about those picks. This is dev data used while building the pipeline, so it's an illustration, not part of the 28-resume eval. Also visible: the explanations get cut off at the 300-character limit mid-sentence.</a:t>
+              <a:t>Real model output for eval resume P06, a software engineering background with a pool of 8 jobs where only 3 are relevant (Salesforce engineer and application software engineer are potential fits, the Fiserv role a good fit). The single agent ranked the Fiserv and application software jobs 1st and 2nd and the Salesforce job 5th (nDCG@5 0.97). The orchestrator's resume parser correctly listed C#, ASP.NET, JavaScript and SQL, but its ranker then said the resume 'highlights skills in accounting and financial reporting' and picked five accounting jobs, none relevant (nDCG@5 0.00). So the error is in the ranking step, not the parsing. This is the single biggest gap of the 28 resumes. Also visible in explanations: they are sometimes cut off at the 300-character limit.</a:t>
             </a:r>
           </a:p>
         </p:txBody>
@@ -3737,7 +3849,7 @@
                   <a:srgbClr val="2D3748"/>
                 </a:solidFill>
               </a:rPr>
-              <a:t>Error analysis on the lowest-scoring resumes</a:t>
+              <a:t>Repeat with 3 runs per resume to check run-to-run noise</a:t>
             </a:r>
             <a:endParaRPr lang="en-US" sz="1300" dirty="0"/>
           </a:p>
@@ -4283,7 +4395,7 @@
                   <a:srgbClr val="2D3748"/>
                 </a:solidFill>
               </a:rPr>
-              <a:t>28 eval resumes: nDCG@5 0.568, Precision@5 0.68, 0 of 28 runs failed</a:t>
+              <a:t>Qwen3 14B, 28 eval resumes: nDCG@5 0.533, Precision@5 0.70, 0 of 28 runs failed</a:t>
             </a:r>
             <a:endParaRPr lang="en-US" sz="1300" dirty="0"/>
           </a:p>
@@ -4301,7 +4413,7 @@
                   <a:srgbClr val="2D3748"/>
                 </a:solidFill>
               </a:rPr>
-              <a:t>Median 5.5s and 9.9k tokens per resume on an A100</a:t>
+              <a:t>Median 10.6s and 9.9k tokens per resume (4B run: nDCG@5 0.568)</a:t>
             </a:r>
             <a:endParaRPr lang="en-US" sz="1300" dirty="0"/>
           </a:p>
@@ -4377,7 +4489,7 @@
                   <a:srgbClr val="2D3748"/>
                 </a:solidFill>
               </a:rPr>
-              <a:t>Look at low scorers (P11: 0.19, P15: 0.24)</a:t>
+              <a:t>Look at low scorers (P23: 0.25, P10: 0.26)</a:t>
             </a:r>
             <a:endParaRPr lang="en-US" sz="1300" dirty="0"/>
           </a:p>
@@ -4395,7 +4507,7 @@
                   <a:srgbClr val="2D3748"/>
                 </a:solidFill>
               </a:rPr>
-              <a:t>Try larger pools or a bigger model</a:t>
+              <a:t>More repetitions per resume</a:t>
             </a:r>
             <a:endParaRPr lang="en-US" sz="1300" dirty="0"/>
           </a:p>
@@ -4923,7 +5035,7 @@
                   <a:srgbClr val="2D3748"/>
                 </a:solidFill>
               </a:rPr>
-              <a:t>Resume parser and extractor cite numbered lines (L001 / E001), so the 4B model picks lines instead of retyping quotes</a:t>
+              <a:t>Resume parser output cap raised to 4,000 tokens and limited to 15 skills: fixed the 2 failed runs from the 4B run</a:t>
             </a:r>
             <a:endParaRPr lang="en-US" sz="1300" dirty="0"/>
           </a:p>
@@ -4941,7 +5053,7 @@
                   <a:srgbClr val="2D3748"/>
                 </a:solidFill>
               </a:rPr>
-              <a:t>28 eval resumes: nDCG@5 0.512, Precision@5 0.63, 2 of 28 runs failed (P03, P17)</a:t>
+              <a:t>Qwen3 14B, 28 eval resumes: nDCG@5 0.486, Precision@5 0.66, 0 of 28 runs failed</a:t>
             </a:r>
             <a:endParaRPr lang="en-US" sz="1300" dirty="0"/>
           </a:p>
@@ -4959,7 +5071,7 @@
                   <a:srgbClr val="2D3748"/>
                 </a:solidFill>
               </a:rPr>
-              <a:t>Median 20.9s and 32.2k tokens per resume</a:t>
+              <a:t>Median 40.8s and 32.0k tokens per resume</a:t>
             </a:r>
             <a:endParaRPr lang="en-US" sz="1300" dirty="0"/>
           </a:p>
@@ -5035,7 +5147,7 @@
                   <a:srgbClr val="2D3748"/>
                 </a:solidFill>
               </a:rPr>
-              <a:t>Find why P03 and P17 failed</a:t>
+              <a:t>Why P06 scored 0 (accounting jobs picked for a software resume)</a:t>
             </a:r>
             <a:endParaRPr lang="en-US" sz="1300" dirty="0"/>
           </a:p>
@@ -5053,7 +5165,7 @@
                   <a:srgbClr val="2D3748"/>
                 </a:solidFill>
               </a:rPr>
-              <a:t>Check if the extra steps drop useful lines</a:t>
+              <a:t>Test giving the ranker the full resume</a:t>
             </a:r>
             <a:endParaRPr lang="en-US" sz="1300" dirty="0"/>
           </a:p>
@@ -5205,7 +5317,7 @@
                   <a:srgbClr val="F7F5EF"/>
                 </a:solidFill>
               </a:rPr>
-              <a:t>A100 run · 56 runs</a:t>
+              <a:t>A100 · 4B and 14B</a:t>
             </a:r>
             <a:endParaRPr lang="en-US" sz="1100" dirty="0"/>
           </a:p>
@@ -5279,7 +5391,7 @@
                   <a:srgbClr val="4A5568"/>
                 </a:solidFill>
               </a:rPr>
-              <a:t>Median per resume: 20.9s vs 5.5s, 32.2k vs 9.9k tokens · 3 sequential calls instead of 1</a:t>
+              <a:t>Median per resume: multi is ~3.9x the time and ~3.2x the tokens, at both model sizes</a:t>
             </a:r>
             <a:endParaRPr lang="en-US" sz="1300" dirty="0"/>
           </a:p>
@@ -5401,7 +5513,7 @@
                   <a:srgbClr val="718096"/>
                 </a:solidFill>
               </a:rPr>
-              <a:t>Qwen3 4B (Ollama) on a Colab A100 · 28 eval resumes, 1 repetition · median per run · tokens in thousands · $0 API cost</a:t>
+              <a:t>Qwen3 4B and 14B (4-bit) on a Colab A100 · 28 eval resumes, 1 repetition · median per run · tokens in thousands · $0 API cost</a:t>
             </a:r>
             <a:endParaRPr lang="en-US" sz="1000" dirty="0"/>
           </a:p>
@@ -5546,7 +5658,7 @@
                   <a:srgbClr val="F7F5EF"/>
                 </a:solidFill>
               </a:rPr>
-              <a:t>Held-out eval · 56 runs</a:t>
+              <a:t>Held-out eval · Qwen3 14B</a:t>
             </a:r>
             <a:endParaRPr lang="en-US" sz="1100" dirty="0"/>
           </a:p>
@@ -5584,7 +5696,7 @@
                   <a:srgbClr val="14213D"/>
                 </a:solidFill>
               </a:rPr>
-              <a:t>Single agent scored higher, mostly from 2 failures</a:t>
+              <a:t>Single still ahead; a bigger model didn't help</a:t>
             </a:r>
             <a:endParaRPr lang="en-US" sz="2800" dirty="0"/>
           </a:p>
@@ -5620,7 +5732,7 @@
                   <a:srgbClr val="4A5568"/>
                 </a:solidFill>
               </a:rPr>
-              <a:t>Single better on 16 resumes, multi on 9, tied on 3 · mean gap 0.06 nDCG@5, not significant</a:t>
+              <a:t>Single better on 15 resumes, multi on 12, tied on 1 · mean gap 0.05 nDCG@5, not significant</a:t>
             </a:r>
             <a:endParaRPr lang="en-US" sz="1300" dirty="0"/>
           </a:p>
@@ -5710,7 +5822,7 @@
                   <a:srgbClr val="718096"/>
                 </a:solidFill>
               </a:rPr>
-              <a:t>Qwen3 4B on a Colab A100 · 28 eval resumes × 1 rep · labels from rjdfit · random Precision@5 = 0.58 · multi used 3.3x tokens</a:t>
+              <a:t>Qwen3 14B on a Colab A100 · 28 eval resumes × 1 rep · random Precision@5 = 0.58 · earlier 4B run: single 0.568, multi 0.512</a:t>
             </a:r>
             <a:endParaRPr lang="en-US" sz="1000" dirty="0"/>
           </a:p>
@@ -5848,7 +5960,7 @@
                 <a:ea typeface="Courier New" pitchFamily="34" charset="-122"/>
                 <a:cs typeface="Courier New" pitchFamily="34" charset="-120"/>
               </a:rPr>
-              <a:t>07 · PER-RESUME RESULTS</a:t>
+              <a:t>06 · WHAT THE MODEL SAID</a:t>
             </a:r>
             <a:endParaRPr lang="en-US" sz="1200" dirty="0"/>
           </a:p>
@@ -5888,7 +6000,7 @@
                   <a:srgbClr val="F7F5EF"/>
                 </a:solidFill>
               </a:rPr>
-              <a:t>Biggest gaps · nDCG@5</a:t>
+              <a:t>Eval resume P06 · 8 jobs</a:t>
             </a:r>
             <a:endParaRPr lang="en-US" sz="1100" dirty="0"/>
           </a:p>
@@ -5926,7 +6038,7 @@
                   <a:srgbClr val="14213D"/>
                 </a:solidFill>
               </a:rPr>
-              <a:t>Failures drive the largest gaps</a:t>
+              <a:t>Multi-agent read a software resume as accounting</a:t>
             </a:r>
             <a:endParaRPr lang="en-US" sz="2800" dirty="0"/>
           </a:p>
@@ -5962,7 +6074,7 @@
                   <a:srgbClr val="4A5568"/>
                 </a:solidFill>
               </a:rPr>
-              <a:t>nDCG@5 for the same resume, single vs. multi-agent · 28 eval resumes</a:t>
+              <a:t>Only 3 of 8 jobs are relevant (Salesforce, application software, Fiserv) · ✓ relevant, ✗ no fit in the dataset labels</a:t>
             </a:r>
             <a:endParaRPr lang="en-US" sz="1300" dirty="0"/>
           </a:p>
@@ -6052,7 +6164,7 @@
                   <a:srgbClr val="718096"/>
                 </a:solidFill>
               </a:rPr>
-              <a:t>Repetition 1 of 1 · P03 and P17 are the two multi-agent failures · full table in paired_resumes.csv</a:t>
+              <a:t>Qwen3 14B · eval resume P06 (software engineering background) · its parser had listed C#, ASP.NET and SQL · job names shortened</a:t>
             </a:r>
             <a:endParaRPr lang="en-US" sz="1000" dirty="0"/>
           </a:p>
@@ -6131,7 +6243,7 @@
                   <a:srgbClr val="14213D"/>
                 </a:solidFill>
               </a:rPr>
-              <a:t>Single agent wins</a:t>
+              <a:t>Single agent · nDCG@5 0.97</a:t>
             </a:r>
           </a:p>
         </p:txBody>
@@ -6145,7 +6257,7 @@
         <p:spPr>
           <a:xfrm>
             <a:off x="685800" y="2231136"/>
-            <a:ext cx="1783080" cy="2286000"/>
+            <a:ext cx="3657600" cy="2286000"/>
           </a:xfrm>
           <a:prstGeom prst="rect">
             <a:avLst/>
@@ -6164,7 +6276,7 @@
                   <a:srgbClr val="2F5D8C"/>
                 </a:solidFill>
               </a:rPr>
-              <a:t>Single</a:t>
+              <a:t>Top 5 (3/5 relevant)</a:t>
             </a:r>
           </a:p>
           <a:p>
@@ -6179,7 +6291,7 @@
                   <a:srgbClr val="2F5D8C"/>
                 </a:solidFill>
               </a:rPr>
-              <a:t>P03 · 0.83</a:t>
+              <a:t>✓ Fiserv software role</a:t>
             </a:r>
           </a:p>
           <a:p>
@@ -6194,7 +6306,7 @@
                   <a:srgbClr val="2F5D8C"/>
                 </a:solidFill>
               </a:rPr>
-              <a:t>P17 · 0.69</a:t>
+              <a:t>✓ Application Software Engineer V</a:t>
             </a:r>
           </a:p>
           <a:p>
@@ -6209,7 +6321,7 @@
                   <a:srgbClr val="2F5D8C"/>
                 </a:solidFill>
               </a:rPr>
-              <a:t>P28 · 0.83</a:t>
+              <a:t>✗ Pacific Science &amp; Engineering</a:t>
             </a:r>
           </a:p>
           <a:p>
@@ -6224,40 +6336,7 @@
                   <a:srgbClr val="2F5D8C"/>
                 </a:solidFill>
               </a:rPr>
-              <a:t>P07 · 0.80</a:t>
-            </a:r>
-          </a:p>
-        </p:txBody>
-      </p:sp>
-      <p:sp>
-        <p:nvSpPr>
-          <p:cNvPr id="28" name="TextBox 27"/>
-          <p:cNvSpPr txBox="1"/>
-          <p:nvPr/>
-        </p:nvSpPr>
-        <p:spPr>
-          <a:xfrm>
-            <a:off x="2560320" y="2231136"/>
-            <a:ext cx="1783080" cy="2286000"/>
-          </a:xfrm>
-          <a:prstGeom prst="rect">
-            <a:avLst/>
-          </a:prstGeom>
-          <a:noFill/>
-        </p:spPr>
-        <p:txBody>
-          <a:bodyPr wrap="square" lIns="18288" rIns="18288" tIns="0" bIns="0">
-            <a:spAutoFit/>
-          </a:bodyPr>
-          <a:lstStyle/>
-          <a:p>
-            <a:r>
-              <a:rPr sz="1200" b="1">
-                <a:solidFill>
-                  <a:srgbClr val="B85C1E"/>
-                </a:solidFill>
-              </a:rPr>
-              <a:t>Multi-agent</a:t>
+              <a:t>✗ Multifamily Accountant</a:t>
             </a:r>
           </a:p>
           <a:p>
@@ -6269,10 +6348,10 @@
             <a:r>
               <a:rPr sz="1100" b="1">
                 <a:solidFill>
-                  <a:srgbClr val="B85C1E"/>
-                </a:solidFill>
-              </a:rPr>
-              <a:t>P03 · 0.00 (failed)</a:t>
+                  <a:srgbClr val="2F5D8C"/>
+                </a:solidFill>
+              </a:rPr>
+              <a:t>✓ Salesforce Software Engineer</a:t>
             </a:r>
           </a:p>
           <a:p>
@@ -6284,10 +6363,76 @@
             <a:r>
               <a:rPr sz="1100" b="1">
                 <a:solidFill>
-                  <a:srgbClr val="B85C1E"/>
-                </a:solidFill>
-              </a:rPr>
-              <a:t>P17 · 0.00 (failed)</a:t>
+                  <a:srgbClr val="2F5D8C"/>
+                </a:solidFill>
+              </a:rPr>
+              <a:t>Note on #1 cites 15+ years of software work</a:t>
+            </a:r>
+          </a:p>
+        </p:txBody>
+      </p:sp>
+      <p:sp>
+        <p:nvSpPr>
+          <p:cNvPr id="29" name="TextBox 28"/>
+          <p:cNvSpPr txBox="1"/>
+          <p:nvPr/>
+        </p:nvSpPr>
+        <p:spPr>
+          <a:xfrm>
+            <a:off x="4800600" y="1847088"/>
+            <a:ext cx="3657600" cy="274320"/>
+          </a:xfrm>
+          <a:prstGeom prst="rect">
+            <a:avLst/>
+          </a:prstGeom>
+          <a:noFill/>
+        </p:spPr>
+        <p:txBody>
+          <a:bodyPr wrap="square" lIns="18288" rIns="18288" tIns="0" bIns="0">
+            <a:spAutoFit/>
+          </a:bodyPr>
+          <a:lstStyle/>
+          <a:p>
+            <a:r>
+              <a:rPr sz="1300" b="1">
+                <a:solidFill>
+                  <a:srgbClr val="14213D"/>
+                </a:solidFill>
+              </a:rPr>
+              <a:t>Multi-agent · nDCG@5 0.00</a:t>
+            </a:r>
+          </a:p>
+        </p:txBody>
+      </p:sp>
+      <p:sp>
+        <p:nvSpPr>
+          <p:cNvPr id="30" name="TextBox 29"/>
+          <p:cNvSpPr txBox="1"/>
+          <p:nvPr/>
+        </p:nvSpPr>
+        <p:spPr>
+          <a:xfrm>
+            <a:off x="4800600" y="2231136"/>
+            <a:ext cx="3657600" cy="2286000"/>
+          </a:xfrm>
+          <a:prstGeom prst="rect">
+            <a:avLst/>
+          </a:prstGeom>
+          <a:noFill/>
+        </p:spPr>
+        <p:txBody>
+          <a:bodyPr wrap="square" lIns="18288" rIns="18288" tIns="0" bIns="0">
+            <a:spAutoFit/>
+          </a:bodyPr>
+          <a:lstStyle/>
+          <a:p>
+            <a:r>
+              <a:rPr sz="1200" b="1">
+                <a:solidFill>
+                  <a:srgbClr val="2F5D8C"/>
+                </a:solidFill>
+              </a:rPr>
+              <a:t>Top 5 (0/5 relevant)</a:t>
             </a:r>
           </a:p>
           <a:p>
@@ -6302,7 +6447,7 @@
                   <a:srgbClr val="B85C1E"/>
                 </a:solidFill>
               </a:rPr>
-              <a:t>P28 · 0.45</a:t>
+              <a:t>✗ Pacific Science &amp; Engineering</a:t>
             </a:r>
           </a:p>
           <a:p>
@@ -6317,73 +6462,7 @@
                   <a:srgbClr val="B85C1E"/>
                 </a:solidFill>
               </a:rPr>
-              <a:t>P07 · 0.53</a:t>
-            </a:r>
-          </a:p>
-        </p:txBody>
-      </p:sp>
-      <p:sp>
-        <p:nvSpPr>
-          <p:cNvPr id="29" name="TextBox 28"/>
-          <p:cNvSpPr txBox="1"/>
-          <p:nvPr/>
-        </p:nvSpPr>
-        <p:spPr>
-          <a:xfrm>
-            <a:off x="4800600" y="1847088"/>
-            <a:ext cx="3657600" cy="274320"/>
-          </a:xfrm>
-          <a:prstGeom prst="rect">
-            <a:avLst/>
-          </a:prstGeom>
-          <a:noFill/>
-        </p:spPr>
-        <p:txBody>
-          <a:bodyPr wrap="square" lIns="18288" rIns="18288" tIns="0" bIns="0">
-            <a:spAutoFit/>
-          </a:bodyPr>
-          <a:lstStyle/>
-          <a:p>
-            <a:r>
-              <a:rPr sz="1300" b="1">
-                <a:solidFill>
-                  <a:srgbClr val="14213D"/>
-                </a:solidFill>
-              </a:rPr>
-              <a:t>Multi-agent wins</a:t>
-            </a:r>
-          </a:p>
-        </p:txBody>
-      </p:sp>
-      <p:sp>
-        <p:nvSpPr>
-          <p:cNvPr id="30" name="TextBox 29"/>
-          <p:cNvSpPr txBox="1"/>
-          <p:nvPr/>
-        </p:nvSpPr>
-        <p:spPr>
-          <a:xfrm>
-            <a:off x="4800600" y="2231136"/>
-            <a:ext cx="1783080" cy="2286000"/>
-          </a:xfrm>
-          <a:prstGeom prst="rect">
-            <a:avLst/>
-          </a:prstGeom>
-          <a:noFill/>
-        </p:spPr>
-        <p:txBody>
-          <a:bodyPr wrap="square" lIns="18288" rIns="18288" tIns="0" bIns="0">
-            <a:spAutoFit/>
-          </a:bodyPr>
-          <a:lstStyle/>
-          <a:p>
-            <a:r>
-              <a:rPr sz="1200" b="1">
-                <a:solidFill>
-                  <a:srgbClr val="2F5D8C"/>
-                </a:solidFill>
-              </a:rPr>
-              <a:t>Single</a:t>
+              <a:t>✗ Multifamily Accountant</a:t>
             </a:r>
           </a:p>
           <a:p>
@@ -6398,7 +6477,7 @@
                   <a:srgbClr val="B85C1E"/>
                 </a:solidFill>
               </a:rPr>
-              <a:t>P06 · 0.47</a:t>
+              <a:t>✗ Cost Accountant</a:t>
             </a:r>
           </a:p>
           <a:p>
@@ -6413,7 +6492,7 @@
                   <a:srgbClr val="B85C1E"/>
                 </a:solidFill>
               </a:rPr>
-              <a:t>P15 · 0.24</a:t>
+              <a:t>✗ Accountant (6-month contract)</a:t>
             </a:r>
           </a:p>
           <a:p>
@@ -6428,7 +6507,7 @@
                   <a:srgbClr val="B85C1E"/>
                 </a:solidFill>
               </a:rPr>
-              <a:t>P14 · 0.26</a:t>
+              <a:t>✗ Senior Accountant (Atlanta)</a:t>
             </a:r>
           </a:p>
           <a:p>
@@ -6443,100 +6522,7 @@
                   <a:srgbClr val="B85C1E"/>
                 </a:solidFill>
               </a:rPr>
-              <a:t>P08 · 0.32</a:t>
-            </a:r>
-          </a:p>
-        </p:txBody>
-      </p:sp>
-      <p:sp>
-        <p:nvSpPr>
-          <p:cNvPr id="31" name="TextBox 30"/>
-          <p:cNvSpPr txBox="1"/>
-          <p:nvPr/>
-        </p:nvSpPr>
-        <p:spPr>
-          <a:xfrm>
-            <a:off x="6675120" y="2231136"/>
-            <a:ext cx="1783080" cy="2286000"/>
-          </a:xfrm>
-          <a:prstGeom prst="rect">
-            <a:avLst/>
-          </a:prstGeom>
-          <a:noFill/>
-        </p:spPr>
-        <p:txBody>
-          <a:bodyPr wrap="square" lIns="18288" rIns="18288" tIns="0" bIns="0">
-            <a:spAutoFit/>
-          </a:bodyPr>
-          <a:lstStyle/>
-          <a:p>
-            <a:r>
-              <a:rPr sz="1200" b="1">
-                <a:solidFill>
-                  <a:srgbClr val="B85C1E"/>
-                </a:solidFill>
-              </a:rPr>
-              <a:t>Multi-agent</a:t>
-            </a:r>
-          </a:p>
-          <a:p>
-            <a:pPr>
-              <a:spcBef>
-                <a:spcPts val="500"/>
-              </a:spcBef>
-            </a:pPr>
-            <a:r>
-              <a:rPr sz="1100" b="1">
-                <a:solidFill>
-                  <a:srgbClr val="B85C1E"/>
-                </a:solidFill>
-              </a:rPr>
-              <a:t>P06 · 1.00</a:t>
-            </a:r>
-          </a:p>
-          <a:p>
-            <a:pPr>
-              <a:spcBef>
-                <a:spcPts val="500"/>
-              </a:spcBef>
-            </a:pPr>
-            <a:r>
-              <a:rPr sz="1100" b="1">
-                <a:solidFill>
-                  <a:srgbClr val="B85C1E"/>
-                </a:solidFill>
-              </a:rPr>
-              <a:t>P15 · 0.61</a:t>
-            </a:r>
-          </a:p>
-          <a:p>
-            <a:pPr>
-              <a:spcBef>
-                <a:spcPts val="500"/>
-              </a:spcBef>
-            </a:pPr>
-            <a:r>
-              <a:rPr sz="1100" b="1">
-                <a:solidFill>
-                  <a:srgbClr val="B85C1E"/>
-                </a:solidFill>
-              </a:rPr>
-              <a:t>P14 · 0.58</a:t>
-            </a:r>
-          </a:p>
-          <a:p>
-            <a:pPr>
-              <a:spcBef>
-                <a:spcPts val="500"/>
-              </a:spcBef>
-            </a:pPr>
-            <a:r>
-              <a:rPr sz="1100" b="1">
-                <a:solidFill>
-                  <a:srgbClr val="B85C1E"/>
-                </a:solidFill>
-              </a:rPr>
-              <a:t>P08 · 0.47</a:t>
+              <a:t>Note on #1: resume "highlights skills in accounting"</a:t>
             </a:r>
           </a:p>
         </p:txBody>
@@ -6550,6 +6536,750 @@
 </file>
 
 <file path=ppt/slides/slide8.xml><?xml version="1.0" encoding="utf-8"?>
+<p:sld xmlns:a="http://schemas.openxmlformats.org/drawingml/2006/main" xmlns:p="http://schemas.openxmlformats.org/presentationml/2006/main" xmlns:r="http://schemas.openxmlformats.org/officeDocument/2006/relationships">
+  <p:cSld>
+    <p:spTree>
+      <p:nvGrpSpPr>
+        <p:cNvPr id="1" name=""/>
+        <p:cNvGrpSpPr/>
+        <p:nvPr/>
+      </p:nvGrpSpPr>
+      <p:grpSpPr/>
+      <p:sp>
+        <p:nvSpPr>
+          <p:cNvPr id="2" name="eyebrow"/>
+          <p:cNvSpPr txBox="1"/>
+          <p:nvPr/>
+        </p:nvSpPr>
+        <p:spPr>
+          <a:xfrm>
+            <a:off x="548640" y="365760"/>
+            <a:ext cx="5120640" cy="274320"/>
+          </a:xfrm>
+          <a:prstGeom prst="rect">
+            <a:avLst/>
+          </a:prstGeom>
+          <a:noFill/>
+          <a:ln/>
+        </p:spPr>
+        <p:txBody>
+          <a:bodyPr wrap="square" lIns="0" tIns="0" rIns="0" bIns="0" rtlCol="0" anchor="ctr"/>
+          <a:lstStyle/>
+          <a:p>
+            <a:pPr indent="0" marL="0">
+              <a:buNone/>
+            </a:pPr>
+            <a:r>
+              <a:rPr lang="en-US" sz="1200" spc="150" kern="0" dirty="0">
+                <a:solidFill>
+                  <a:srgbClr val="B85C1E"/>
+                </a:solidFill>
+                <a:latin typeface="Courier New" pitchFamily="34" charset="0"/>
+                <a:ea typeface="Courier New" pitchFamily="34" charset="-122"/>
+                <a:cs typeface="Courier New" pitchFamily="34" charset="-120"/>
+              </a:rPr>
+              <a:t>07 · PER-RESUME RESULTS</a:t>
+            </a:r>
+            <a:endParaRPr lang="en-US" sz="1200" dirty="0"/>
+          </a:p>
+        </p:txBody>
+      </p:sp>
+      <p:sp>
+        <p:nvSpPr>
+          <p:cNvPr id="3" name="status"/>
+          <p:cNvSpPr/>
+          <p:nvPr/>
+        </p:nvSpPr>
+        <p:spPr>
+          <a:xfrm>
+            <a:off x="5669280" y="329184"/>
+            <a:ext cx="2926080" cy="329184"/>
+          </a:xfrm>
+          <a:prstGeom prst="roundRect">
+            <a:avLst>
+              <a:gd name="adj" fmla="val 138889"/>
+            </a:avLst>
+          </a:prstGeom>
+          <a:solidFill>
+            <a:srgbClr val="2F5D8C"/>
+          </a:solidFill>
+          <a:ln/>
+        </p:spPr>
+        <p:txBody>
+          <a:bodyPr wrap="square" lIns="0" tIns="0" rIns="0" bIns="0" rtlCol="0" anchor="ctr"/>
+          <a:lstStyle/>
+          <a:p>
+            <a:pPr algn="ctr" indent="0" marL="0">
+              <a:buNone/>
+            </a:pPr>
+            <a:r>
+              <a:rPr lang="en-US" sz="1100" b="1" dirty="0">
+                <a:solidFill>
+                  <a:srgbClr val="F7F5EF"/>
+                </a:solidFill>
+              </a:rPr>
+              <a:t>Biggest gaps · nDCG@5</a:t>
+            </a:r>
+            <a:endParaRPr lang="en-US" sz="1100" dirty="0"/>
+          </a:p>
+        </p:txBody>
+      </p:sp>
+      <p:sp>
+        <p:nvSpPr>
+          <p:cNvPr id="4" name="Text 0"/>
+          <p:cNvSpPr/>
+          <p:nvPr>
+            <p:ph idx="100" type="title" hasCustomPrompt="1"/>
+          </p:nvPr>
+        </p:nvSpPr>
+        <p:spPr>
+          <a:xfrm>
+            <a:off x="548640" y="777240"/>
+            <a:ext cx="8046720" cy="548640"/>
+          </a:xfrm>
+          <a:prstGeom prst="rect">
+            <a:avLst/>
+          </a:prstGeom>
+          <a:noFill/>
+          <a:ln/>
+        </p:spPr>
+        <p:txBody>
+          <a:bodyPr wrap="square" lIns="0" tIns="0" rIns="0" bIns="0" rtlCol="0" anchor="t"/>
+          <a:lstStyle/>
+          <a:p>
+            <a:pPr algn="l" indent="0" marL="0">
+              <a:buNone/>
+            </a:pPr>
+            <a:r>
+              <a:rPr lang="en-US" sz="2800" b="1" dirty="0">
+                <a:solidFill>
+                  <a:srgbClr val="14213D"/>
+                </a:solidFill>
+              </a:rPr>
+              <a:t>P06 is the biggest gap by far</a:t>
+            </a:r>
+            <a:endParaRPr lang="en-US" sz="2800" dirty="0"/>
+          </a:p>
+        </p:txBody>
+      </p:sp>
+      <p:sp>
+        <p:nvSpPr>
+          <p:cNvPr id="5" name="Text 3"/>
+          <p:cNvSpPr txBox="1"/>
+          <p:nvPr/>
+        </p:nvSpPr>
+        <p:spPr>
+          <a:xfrm>
+            <a:off x="548640" y="1325880"/>
+            <a:ext cx="8046720" cy="274320"/>
+          </a:xfrm>
+          <a:prstGeom prst="rect">
+            <a:avLst/>
+          </a:prstGeom>
+          <a:noFill/>
+          <a:ln/>
+        </p:spPr>
+        <p:txBody>
+          <a:bodyPr wrap="square" lIns="0" tIns="0" rIns="0" bIns="0" rtlCol="0" anchor="ctr"/>
+          <a:lstStyle/>
+          <a:p>
+            <a:pPr indent="0" marL="0">
+              <a:buNone/>
+            </a:pPr>
+            <a:r>
+              <a:rPr lang="en-US" sz="1300" dirty="0">
+                <a:solidFill>
+                  <a:srgbClr val="4A5568"/>
+                </a:solidFill>
+              </a:rPr>
+              <a:t>nDCG@5 for the same resume, single vs. multi-agent · 28 eval resumes · 14B</a:t>
+            </a:r>
+            <a:endParaRPr lang="en-US" sz="1300" dirty="0"/>
+          </a:p>
+        </p:txBody>
+      </p:sp>
+      <p:sp>
+        <p:nvSpPr>
+          <p:cNvPr id="6" name="Shape 4"/>
+          <p:cNvSpPr/>
+          <p:nvPr/>
+        </p:nvSpPr>
+        <p:spPr>
+          <a:xfrm>
+            <a:off x="548640" y="1737360"/>
+            <a:ext cx="3931920" cy="2880360"/>
+          </a:xfrm>
+          <a:prstGeom prst="roundRect">
+            <a:avLst>
+              <a:gd name="adj" fmla="val 2540"/>
+            </a:avLst>
+          </a:prstGeom>
+          <a:solidFill>
+            <a:srgbClr val="FFFFFF"/>
+          </a:solidFill>
+          <a:ln w="9525">
+            <a:solidFill>
+              <a:srgbClr val="E2DED3"/>
+            </a:solidFill>
+            <a:prstDash val="solid"/>
+          </a:ln>
+        </p:spPr>
+      </p:sp>
+      <p:sp>
+        <p:nvSpPr>
+          <p:cNvPr id="7" name="Shape 5"/>
+          <p:cNvSpPr/>
+          <p:nvPr/>
+        </p:nvSpPr>
+        <p:spPr>
+          <a:xfrm>
+            <a:off x="4663440" y="1737360"/>
+            <a:ext cx="3931920" cy="2880360"/>
+          </a:xfrm>
+          <a:prstGeom prst="roundRect">
+            <a:avLst>
+              <a:gd name="adj" fmla="val 2540"/>
+            </a:avLst>
+          </a:prstGeom>
+          <a:solidFill>
+            <a:srgbClr val="FFFFFF"/>
+          </a:solidFill>
+          <a:ln w="9525">
+            <a:solidFill>
+              <a:srgbClr val="E2DED3"/>
+            </a:solidFill>
+            <a:prstDash val="solid"/>
+          </a:ln>
+        </p:spPr>
+      </p:sp>
+      <p:sp>
+        <p:nvSpPr>
+          <p:cNvPr id="10" name="Text 6"/>
+          <p:cNvSpPr txBox="1"/>
+          <p:nvPr/>
+        </p:nvSpPr>
+        <p:spPr>
+          <a:xfrm>
+            <a:off x="1097280" y="4754880"/>
+            <a:ext cx="7498080" cy="228600"/>
+          </a:xfrm>
+          <a:prstGeom prst="rect">
+            <a:avLst/>
+          </a:prstGeom>
+          <a:noFill/>
+          <a:ln/>
+        </p:spPr>
+        <p:txBody>
+          <a:bodyPr wrap="square" lIns="0" tIns="0" rIns="0" bIns="0" rtlCol="0" anchor="ctr"/>
+          <a:lstStyle/>
+          <a:p>
+            <a:pPr indent="0" marL="0">
+              <a:buNone/>
+            </a:pPr>
+            <a:r>
+              <a:rPr lang="en-US" sz="1000" dirty="0">
+                <a:solidFill>
+                  <a:srgbClr val="718096"/>
+                </a:solidFill>
+              </a:rPr>
+              <a:t>Repetition 1 of 1 · one tie (P14) · full table in paired_resumes.csv</a:t>
+            </a:r>
+            <a:endParaRPr lang="en-US" sz="1000" dirty="0"/>
+          </a:p>
+        </p:txBody>
+      </p:sp>
+      <p:sp>
+        <p:nvSpPr>
+          <p:cNvPr id="25" name="Slide Number Placeholder 0"/>
+          <p:cNvSpPr>
+            <a:spLocks noGrp="1"/>
+          </p:cNvSpPr>
+          <p:nvPr>
+            <p:ph type="sldNum" sz="quarter" idx="4294967295"/>
+          </p:nvPr>
+        </p:nvSpPr>
+        <p:spPr>
+          <a:xfrm>
+            <a:off x="548640" y="4800600"/>
+            <a:ext cx="914400" cy="228600"/>
+          </a:xfrm>
+          <a:prstGeom prst="rect">
+            <a:avLst/>
+          </a:prstGeom>
+          <a:extLst>
+            <a:ext uri="{C572A759-6A51-4108-AA02-DFA0A04FC94B}">
+              <ma14:wrappingTextBoxFlag xmlns:ma14="http://schemas.microsoft.com/office/mac/drawingml/2011/main" val="0"/>
+            </a:ext>
+          </a:extLst>
+        </p:spPr>
+        <p:txBody>
+          <a:bodyPr/>
+          <a:lstStyle>
+            <a:lvl1pPr>
+              <a:defRPr sz="1000">
+                <a:solidFill>
+                  <a:srgbClr val="718096"/>
+                </a:solidFill>
+                <a:latin typeface="Calibri"/>
+                <a:ea typeface="Calibri"/>
+                <a:cs typeface="Calibri"/>
+              </a:defRPr>
+            </a:lvl1pPr>
+          </a:lstStyle>
+          <a:p>
+            <a:r>
+              <a:t>7</a:t>
+            </a:r>
+          </a:p>
+        </p:txBody>
+      </p:sp>
+      <p:sp>
+        <p:nvSpPr>
+          <p:cNvPr id="26" name="TextBox 25"/>
+          <p:cNvSpPr txBox="1"/>
+          <p:nvPr/>
+        </p:nvSpPr>
+        <p:spPr>
+          <a:xfrm>
+            <a:off x="685800" y="1847088"/>
+            <a:ext cx="3657600" cy="274320"/>
+          </a:xfrm>
+          <a:prstGeom prst="rect">
+            <a:avLst/>
+          </a:prstGeom>
+          <a:noFill/>
+        </p:spPr>
+        <p:txBody>
+          <a:bodyPr wrap="square" lIns="18288" rIns="18288" tIns="0" bIns="0">
+            <a:spAutoFit/>
+          </a:bodyPr>
+          <a:lstStyle/>
+          <a:p>
+            <a:r>
+              <a:rPr sz="1300" b="1">
+                <a:solidFill>
+                  <a:srgbClr val="14213D"/>
+                </a:solidFill>
+              </a:rPr>
+              <a:t>Single agent wins</a:t>
+            </a:r>
+          </a:p>
+        </p:txBody>
+      </p:sp>
+      <p:sp>
+        <p:nvSpPr>
+          <p:cNvPr id="27" name="TextBox 26"/>
+          <p:cNvSpPr txBox="1"/>
+          <p:nvPr/>
+        </p:nvSpPr>
+        <p:spPr>
+          <a:xfrm>
+            <a:off x="685800" y="2231136"/>
+            <a:ext cx="1783080" cy="2286000"/>
+          </a:xfrm>
+          <a:prstGeom prst="rect">
+            <a:avLst/>
+          </a:prstGeom>
+          <a:noFill/>
+        </p:spPr>
+        <p:txBody>
+          <a:bodyPr wrap="square" lIns="18288" rIns="18288" tIns="0" bIns="0">
+            <a:spAutoFit/>
+          </a:bodyPr>
+          <a:lstStyle/>
+          <a:p>
+            <a:r>
+              <a:rPr sz="1200" b="1">
+                <a:solidFill>
+                  <a:srgbClr val="2F5D8C"/>
+                </a:solidFill>
+              </a:rPr>
+              <a:t>Single</a:t>
+            </a:r>
+          </a:p>
+          <a:p>
+            <a:pPr>
+              <a:spcBef>
+                <a:spcPts val="500"/>
+              </a:spcBef>
+            </a:pPr>
+            <a:r>
+              <a:rPr sz="1100" b="1">
+                <a:solidFill>
+                  <a:srgbClr val="2F5D8C"/>
+                </a:solidFill>
+              </a:rPr>
+              <a:t>P06 · 0.97</a:t>
+            </a:r>
+          </a:p>
+          <a:p>
+            <a:pPr>
+              <a:spcBef>
+                <a:spcPts val="500"/>
+              </a:spcBef>
+            </a:pPr>
+            <a:r>
+              <a:rPr sz="1100" b="1">
+                <a:solidFill>
+                  <a:srgbClr val="2F5D8C"/>
+                </a:solidFill>
+              </a:rPr>
+              <a:t>P11 · 0.56</a:t>
+            </a:r>
+          </a:p>
+          <a:p>
+            <a:pPr>
+              <a:spcBef>
+                <a:spcPts val="500"/>
+              </a:spcBef>
+            </a:pPr>
+            <a:r>
+              <a:rPr sz="1100" b="1">
+                <a:solidFill>
+                  <a:srgbClr val="2F5D8C"/>
+                </a:solidFill>
+              </a:rPr>
+              <a:t>P09 · 0.79</a:t>
+            </a:r>
+          </a:p>
+          <a:p>
+            <a:pPr>
+              <a:spcBef>
+                <a:spcPts val="500"/>
+              </a:spcBef>
+            </a:pPr>
+            <a:r>
+              <a:rPr sz="1100" b="1">
+                <a:solidFill>
+                  <a:srgbClr val="2F5D8C"/>
+                </a:solidFill>
+              </a:rPr>
+              <a:t>P15 · 0.65</a:t>
+            </a:r>
+          </a:p>
+        </p:txBody>
+      </p:sp>
+      <p:sp>
+        <p:nvSpPr>
+          <p:cNvPr id="28" name="TextBox 27"/>
+          <p:cNvSpPr txBox="1"/>
+          <p:nvPr/>
+        </p:nvSpPr>
+        <p:spPr>
+          <a:xfrm>
+            <a:off x="2560320" y="2231136"/>
+            <a:ext cx="1783080" cy="2286000"/>
+          </a:xfrm>
+          <a:prstGeom prst="rect">
+            <a:avLst/>
+          </a:prstGeom>
+          <a:noFill/>
+        </p:spPr>
+        <p:txBody>
+          <a:bodyPr wrap="square" lIns="18288" rIns="18288" tIns="0" bIns="0">
+            <a:spAutoFit/>
+          </a:bodyPr>
+          <a:lstStyle/>
+          <a:p>
+            <a:r>
+              <a:rPr sz="1200" b="1">
+                <a:solidFill>
+                  <a:srgbClr val="B85C1E"/>
+                </a:solidFill>
+              </a:rPr>
+              <a:t>Multi-agent</a:t>
+            </a:r>
+          </a:p>
+          <a:p>
+            <a:pPr>
+              <a:spcBef>
+                <a:spcPts val="500"/>
+              </a:spcBef>
+            </a:pPr>
+            <a:r>
+              <a:rPr sz="1100" b="1">
+                <a:solidFill>
+                  <a:srgbClr val="B85C1E"/>
+                </a:solidFill>
+              </a:rPr>
+              <a:t>P06 · 0.00</a:t>
+            </a:r>
+          </a:p>
+          <a:p>
+            <a:pPr>
+              <a:spcBef>
+                <a:spcPts val="500"/>
+              </a:spcBef>
+            </a:pPr>
+            <a:r>
+              <a:rPr sz="1100" b="1">
+                <a:solidFill>
+                  <a:srgbClr val="B85C1E"/>
+                </a:solidFill>
+              </a:rPr>
+              <a:t>P11 · 0.37</a:t>
+            </a:r>
+          </a:p>
+          <a:p>
+            <a:pPr>
+              <a:spcBef>
+                <a:spcPts val="500"/>
+              </a:spcBef>
+            </a:pPr>
+            <a:r>
+              <a:rPr sz="1100" b="1">
+                <a:solidFill>
+                  <a:srgbClr val="B85C1E"/>
+                </a:solidFill>
+              </a:rPr>
+              <a:t>P09 · 0.61</a:t>
+            </a:r>
+          </a:p>
+          <a:p>
+            <a:pPr>
+              <a:spcBef>
+                <a:spcPts val="500"/>
+              </a:spcBef>
+            </a:pPr>
+            <a:r>
+              <a:rPr sz="1100" b="1">
+                <a:solidFill>
+                  <a:srgbClr val="B85C1E"/>
+                </a:solidFill>
+              </a:rPr>
+              <a:t>P15 · 0.47</a:t>
+            </a:r>
+          </a:p>
+        </p:txBody>
+      </p:sp>
+      <p:sp>
+        <p:nvSpPr>
+          <p:cNvPr id="29" name="TextBox 28"/>
+          <p:cNvSpPr txBox="1"/>
+          <p:nvPr/>
+        </p:nvSpPr>
+        <p:spPr>
+          <a:xfrm>
+            <a:off x="4800600" y="1847088"/>
+            <a:ext cx="3657600" cy="274320"/>
+          </a:xfrm>
+          <a:prstGeom prst="rect">
+            <a:avLst/>
+          </a:prstGeom>
+          <a:noFill/>
+        </p:spPr>
+        <p:txBody>
+          <a:bodyPr wrap="square" lIns="18288" rIns="18288" tIns="0" bIns="0">
+            <a:spAutoFit/>
+          </a:bodyPr>
+          <a:lstStyle/>
+          <a:p>
+            <a:r>
+              <a:rPr sz="1300" b="1">
+                <a:solidFill>
+                  <a:srgbClr val="14213D"/>
+                </a:solidFill>
+              </a:rPr>
+              <a:t>Multi-agent wins</a:t>
+            </a:r>
+          </a:p>
+        </p:txBody>
+      </p:sp>
+      <p:sp>
+        <p:nvSpPr>
+          <p:cNvPr id="30" name="TextBox 29"/>
+          <p:cNvSpPr txBox="1"/>
+          <p:nvPr/>
+        </p:nvSpPr>
+        <p:spPr>
+          <a:xfrm>
+            <a:off x="4800600" y="2231136"/>
+            <a:ext cx="1783080" cy="2286000"/>
+          </a:xfrm>
+          <a:prstGeom prst="rect">
+            <a:avLst/>
+          </a:prstGeom>
+          <a:noFill/>
+        </p:spPr>
+        <p:txBody>
+          <a:bodyPr wrap="square" lIns="18288" rIns="18288" tIns="0" bIns="0">
+            <a:spAutoFit/>
+          </a:bodyPr>
+          <a:lstStyle/>
+          <a:p>
+            <a:r>
+              <a:rPr sz="1200" b="1">
+                <a:solidFill>
+                  <a:srgbClr val="2F5D8C"/>
+                </a:solidFill>
+              </a:rPr>
+              <a:t>Single</a:t>
+            </a:r>
+          </a:p>
+          <a:p>
+            <a:pPr>
+              <a:spcBef>
+                <a:spcPts val="500"/>
+              </a:spcBef>
+            </a:pPr>
+            <a:r>
+              <a:rPr sz="1100" b="1">
+                <a:solidFill>
+                  <a:srgbClr val="B85C1E"/>
+                </a:solidFill>
+              </a:rPr>
+              <a:t>P20 · 0.37</a:t>
+            </a:r>
+          </a:p>
+          <a:p>
+            <a:pPr>
+              <a:spcBef>
+                <a:spcPts val="500"/>
+              </a:spcBef>
+            </a:pPr>
+            <a:r>
+              <a:rPr sz="1100" b="1">
+                <a:solidFill>
+                  <a:srgbClr val="B85C1E"/>
+                </a:solidFill>
+              </a:rPr>
+              <a:t>P23 · 0.25</a:t>
+            </a:r>
+          </a:p>
+          <a:p>
+            <a:pPr>
+              <a:spcBef>
+                <a:spcPts val="500"/>
+              </a:spcBef>
+            </a:pPr>
+            <a:r>
+              <a:rPr sz="1100" b="1">
+                <a:solidFill>
+                  <a:srgbClr val="B85C1E"/>
+                </a:solidFill>
+              </a:rPr>
+              <a:t>P13 · 0.73</a:t>
+            </a:r>
+          </a:p>
+          <a:p>
+            <a:pPr>
+              <a:spcBef>
+                <a:spcPts val="500"/>
+              </a:spcBef>
+            </a:pPr>
+            <a:r>
+              <a:rPr sz="1100" b="1">
+                <a:solidFill>
+                  <a:srgbClr val="B85C1E"/>
+                </a:solidFill>
+              </a:rPr>
+              <a:t>P22 · 0.85</a:t>
+            </a:r>
+          </a:p>
+        </p:txBody>
+      </p:sp>
+      <p:sp>
+        <p:nvSpPr>
+          <p:cNvPr id="31" name="TextBox 30"/>
+          <p:cNvSpPr txBox="1"/>
+          <p:nvPr/>
+        </p:nvSpPr>
+        <p:spPr>
+          <a:xfrm>
+            <a:off x="6675120" y="2231136"/>
+            <a:ext cx="1783080" cy="2286000"/>
+          </a:xfrm>
+          <a:prstGeom prst="rect">
+            <a:avLst/>
+          </a:prstGeom>
+          <a:noFill/>
+        </p:spPr>
+        <p:txBody>
+          <a:bodyPr wrap="square" lIns="18288" rIns="18288" tIns="0" bIns="0">
+            <a:spAutoFit/>
+          </a:bodyPr>
+          <a:lstStyle/>
+          <a:p>
+            <a:r>
+              <a:rPr sz="1200" b="1">
+                <a:solidFill>
+                  <a:srgbClr val="B85C1E"/>
+                </a:solidFill>
+              </a:rPr>
+              <a:t>Multi-agent</a:t>
+            </a:r>
+          </a:p>
+          <a:p>
+            <a:pPr>
+              <a:spcBef>
+                <a:spcPts val="500"/>
+              </a:spcBef>
+            </a:pPr>
+            <a:r>
+              <a:rPr sz="1100" b="1">
+                <a:solidFill>
+                  <a:srgbClr val="B85C1E"/>
+                </a:solidFill>
+              </a:rPr>
+              <a:t>P20 · 0.65</a:t>
+            </a:r>
+          </a:p>
+          <a:p>
+            <a:pPr>
+              <a:spcBef>
+                <a:spcPts val="500"/>
+              </a:spcBef>
+            </a:pPr>
+            <a:r>
+              <a:rPr sz="1100" b="1">
+                <a:solidFill>
+                  <a:srgbClr val="B85C1E"/>
+                </a:solidFill>
+              </a:rPr>
+              <a:t>P23 · 0.45</a:t>
+            </a:r>
+          </a:p>
+          <a:p>
+            <a:pPr>
+              <a:spcBef>
+                <a:spcPts val="500"/>
+              </a:spcBef>
+            </a:pPr>
+            <a:r>
+              <a:rPr sz="1100" b="1">
+                <a:solidFill>
+                  <a:srgbClr val="B85C1E"/>
+                </a:solidFill>
+              </a:rPr>
+              <a:t>P13 · 0.89</a:t>
+            </a:r>
+          </a:p>
+          <a:p>
+            <a:pPr>
+              <a:spcBef>
+                <a:spcPts val="500"/>
+              </a:spcBef>
+            </a:pPr>
+            <a:r>
+              <a:rPr sz="1100" b="1">
+                <a:solidFill>
+                  <a:srgbClr val="B85C1E"/>
+                </a:solidFill>
+              </a:rPr>
+              <a:t>P22 · 1.00</a:t>
+            </a:r>
+          </a:p>
+        </p:txBody>
+      </p:sp>
+    </p:spTree>
+  </p:cSld>
+  <p:clrMapOvr>
+    <a:masterClrMapping/>
+  </p:clrMapOvr>
+</p:sld>
+</file>
+
+<file path=ppt/slides/slide9.xml><?xml version="1.0" encoding="utf-8"?>
 <p:sld xmlns:a="http://schemas.openxmlformats.org/drawingml/2006/main" xmlns:r="http://schemas.openxmlformats.org/officeDocument/2006/relationships" xmlns:p="http://schemas.openxmlformats.org/presentationml/2006/main">
   <p:cSld name="Slide 1">
     <p:spTree>
@@ -6640,624 +7370,6 @@
               <a:t>Questions?</a:t>
             </a:r>
             <a:endParaRPr lang="en-US" sz="4800" dirty="0"/>
-          </a:p>
-        </p:txBody>
-      </p:sp>
-    </p:spTree>
-  </p:cSld>
-  <p:clrMapOvr>
-    <a:masterClrMapping/>
-  </p:clrMapOvr>
-</p:sld>
-</file>
-
-<file path=ppt/slides/slide9.xml><?xml version="1.0" encoding="utf-8"?>
-<p:sld xmlns:a="http://schemas.openxmlformats.org/drawingml/2006/main" xmlns:p="http://schemas.openxmlformats.org/presentationml/2006/main" xmlns:r="http://schemas.openxmlformats.org/officeDocument/2006/relationships">
-  <p:cSld>
-    <p:spTree>
-      <p:nvGrpSpPr>
-        <p:cNvPr id="1" name=""/>
-        <p:cNvGrpSpPr/>
-        <p:nvPr/>
-      </p:nvGrpSpPr>
-      <p:grpSpPr/>
-      <p:sp>
-        <p:nvSpPr>
-          <p:cNvPr id="2" name="eyebrow"/>
-          <p:cNvSpPr txBox="1"/>
-          <p:nvPr/>
-        </p:nvSpPr>
-        <p:spPr>
-          <a:xfrm>
-            <a:off x="548640" y="365760"/>
-            <a:ext cx="5120640" cy="274320"/>
-          </a:xfrm>
-          <a:prstGeom prst="rect">
-            <a:avLst/>
-          </a:prstGeom>
-          <a:noFill/>
-          <a:ln/>
-        </p:spPr>
-        <p:txBody>
-          <a:bodyPr wrap="square" lIns="0" tIns="0" rIns="0" bIns="0" rtlCol="0" anchor="ctr"/>
-          <a:lstStyle/>
-          <a:p>
-            <a:pPr indent="0" marL="0">
-              <a:buNone/>
-            </a:pPr>
-            <a:r>
-              <a:rPr lang="en-US" sz="1200" spc="150" kern="0" dirty="0">
-                <a:solidFill>
-                  <a:srgbClr val="B85C1E"/>
-                </a:solidFill>
-                <a:latin typeface="Courier New" pitchFamily="34" charset="0"/>
-                <a:ea typeface="Courier New" pitchFamily="34" charset="-122"/>
-                <a:cs typeface="Courier New" pitchFamily="34" charset="-120"/>
-              </a:rPr>
-              <a:t>06 · WHAT THE MODEL SAID</a:t>
-            </a:r>
-            <a:endParaRPr lang="en-US" sz="1200" dirty="0"/>
-          </a:p>
-        </p:txBody>
-      </p:sp>
-      <p:sp>
-        <p:nvSpPr>
-          <p:cNvPr id="3" name="status"/>
-          <p:cNvSpPr/>
-          <p:nvPr/>
-        </p:nvSpPr>
-        <p:spPr>
-          <a:xfrm>
-            <a:off x="5669280" y="329184"/>
-            <a:ext cx="2926080" cy="329184"/>
-          </a:xfrm>
-          <a:prstGeom prst="roundRect">
-            <a:avLst>
-              <a:gd name="adj" fmla="val 138889"/>
-            </a:avLst>
-          </a:prstGeom>
-          <a:solidFill>
-            <a:srgbClr val="2F5D8C"/>
-          </a:solidFill>
-          <a:ln/>
-        </p:spPr>
-        <p:txBody>
-          <a:bodyPr wrap="square" lIns="0" tIns="0" rIns="0" bIns="0" rtlCol="0" anchor="ctr"/>
-          <a:lstStyle/>
-          <a:p>
-            <a:pPr algn="ctr" indent="0" marL="0">
-              <a:buNone/>
-            </a:pPr>
-            <a:r>
-              <a:rPr lang="en-US" sz="1100" b="1" dirty="0">
-                <a:solidFill>
-                  <a:srgbClr val="F7F5EF"/>
-                </a:solidFill>
-              </a:rPr>
-              <a:t>Dev resume P02 · 9 jobs</a:t>
-            </a:r>
-            <a:endParaRPr lang="en-US" sz="1100" dirty="0"/>
-          </a:p>
-        </p:txBody>
-      </p:sp>
-      <p:sp>
-        <p:nvSpPr>
-          <p:cNvPr id="4" name="Text 0"/>
-          <p:cNvSpPr/>
-          <p:nvPr>
-            <p:ph idx="100" type="title" hasCustomPrompt="1"/>
-          </p:nvPr>
-        </p:nvSpPr>
-        <p:spPr>
-          <a:xfrm>
-            <a:off x="548640" y="777240"/>
-            <a:ext cx="8046720" cy="548640"/>
-          </a:xfrm>
-          <a:prstGeom prst="rect">
-            <a:avLst/>
-          </a:prstGeom>
-          <a:noFill/>
-          <a:ln/>
-        </p:spPr>
-        <p:txBody>
-          <a:bodyPr wrap="square" lIns="0" tIns="0" rIns="0" bIns="0" rtlCol="0" anchor="t"/>
-          <a:lstStyle/>
-          <a:p>
-            <a:pPr algn="l" indent="0" marL="0">
-              <a:buNone/>
-            </a:pPr>
-            <a:r>
-              <a:rPr lang="en-US" sz="2800" b="1" dirty="0">
-                <a:solidFill>
-                  <a:srgbClr val="14213D"/>
-                </a:solidFill>
-              </a:rPr>
-              <a:t>Both found the 2 relevant jobs, then padded the list</a:t>
-            </a:r>
-            <a:endParaRPr lang="en-US" sz="2800" dirty="0"/>
-          </a:p>
-        </p:txBody>
-      </p:sp>
-      <p:sp>
-        <p:nvSpPr>
-          <p:cNvPr id="5" name="Text 3"/>
-          <p:cNvSpPr txBox="1"/>
-          <p:nvPr/>
-        </p:nvSpPr>
-        <p:spPr>
-          <a:xfrm>
-            <a:off x="548640" y="1325880"/>
-            <a:ext cx="8046720" cy="274320"/>
-          </a:xfrm>
-          <a:prstGeom prst="rect">
-            <a:avLst/>
-          </a:prstGeom>
-          <a:noFill/>
-          <a:ln/>
-        </p:spPr>
-        <p:txBody>
-          <a:bodyPr wrap="square" lIns="0" tIns="0" rIns="0" bIns="0" rtlCol="0" anchor="ctr"/>
-          <a:lstStyle/>
-          <a:p>
-            <a:pPr indent="0" marL="0">
-              <a:buNone/>
-            </a:pPr>
-            <a:r>
-              <a:rPr lang="en-US" sz="1300" dirty="0">
-                <a:solidFill>
-                  <a:srgbClr val="4A5568"/>
-                </a:solidFill>
-              </a:rPr>
-              <a:t>Only 2 of 9 jobs are relevant (D028 potential fit, D024 good fit) · ✓ relevant, ✗ no fit in the dataset labels</a:t>
-            </a:r>
-            <a:endParaRPr lang="en-US" sz="1300" dirty="0"/>
-          </a:p>
-        </p:txBody>
-      </p:sp>
-      <p:sp>
-        <p:nvSpPr>
-          <p:cNvPr id="6" name="Shape 4"/>
-          <p:cNvSpPr/>
-          <p:nvPr/>
-        </p:nvSpPr>
-        <p:spPr>
-          <a:xfrm>
-            <a:off x="548640" y="1737360"/>
-            <a:ext cx="3931920" cy="2880360"/>
-          </a:xfrm>
-          <a:prstGeom prst="roundRect">
-            <a:avLst>
-              <a:gd name="adj" fmla="val 2540"/>
-            </a:avLst>
-          </a:prstGeom>
-          <a:solidFill>
-            <a:srgbClr val="FFFFFF"/>
-          </a:solidFill>
-          <a:ln w="9525">
-            <a:solidFill>
-              <a:srgbClr val="E2DED3"/>
-            </a:solidFill>
-            <a:prstDash val="solid"/>
-          </a:ln>
-        </p:spPr>
-      </p:sp>
-      <p:sp>
-        <p:nvSpPr>
-          <p:cNvPr id="7" name="Shape 5"/>
-          <p:cNvSpPr/>
-          <p:nvPr/>
-        </p:nvSpPr>
-        <p:spPr>
-          <a:xfrm>
-            <a:off x="4663440" y="1737360"/>
-            <a:ext cx="3931920" cy="2880360"/>
-          </a:xfrm>
-          <a:prstGeom prst="roundRect">
-            <a:avLst>
-              <a:gd name="adj" fmla="val 2540"/>
-            </a:avLst>
-          </a:prstGeom>
-          <a:solidFill>
-            <a:srgbClr val="FFFFFF"/>
-          </a:solidFill>
-          <a:ln w="9525">
-            <a:solidFill>
-              <a:srgbClr val="E2DED3"/>
-            </a:solidFill>
-            <a:prstDash val="solid"/>
-          </a:ln>
-        </p:spPr>
-      </p:sp>
-      <p:sp>
-        <p:nvSpPr>
-          <p:cNvPr id="10" name="Text 6"/>
-          <p:cNvSpPr txBox="1"/>
-          <p:nvPr/>
-        </p:nvSpPr>
-        <p:spPr>
-          <a:xfrm>
-            <a:off x="1097280" y="4754880"/>
-            <a:ext cx="7498080" cy="228600"/>
-          </a:xfrm>
-          <a:prstGeom prst="rect">
-            <a:avLst/>
-          </a:prstGeom>
-          <a:noFill/>
-          <a:ln/>
-        </p:spPr>
-        <p:txBody>
-          <a:bodyPr wrap="square" lIns="0" tIns="0" rIns="0" bIns="0" rtlCol="0" anchor="ctr"/>
-          <a:lstStyle/>
-          <a:p>
-            <a:pPr indent="0" marL="0">
-              <a:buNone/>
-            </a:pPr>
-            <a:r>
-              <a:rPr lang="en-US" sz="1000" dirty="0">
-                <a:solidFill>
-                  <a:srgbClr val="718096"/>
-                </a:solidFill>
-              </a:rPr>
-              <a:t>Qwen3 4B · dev resume P02 (HR / admin background) · must return 5 picks · job names shortened</a:t>
-            </a:r>
-            <a:endParaRPr lang="en-US" sz="1000" dirty="0"/>
-          </a:p>
-        </p:txBody>
-      </p:sp>
-      <p:sp>
-        <p:nvSpPr>
-          <p:cNvPr id="25" name="Slide Number Placeholder 0"/>
-          <p:cNvSpPr>
-            <a:spLocks noGrp="1"/>
-          </p:cNvSpPr>
-          <p:nvPr>
-            <p:ph type="sldNum" sz="quarter" idx="4294967295"/>
-          </p:nvPr>
-        </p:nvSpPr>
-        <p:spPr>
-          <a:xfrm>
-            <a:off x="548640" y="4800600"/>
-            <a:ext cx="914400" cy="228600"/>
-          </a:xfrm>
-          <a:prstGeom prst="rect">
-            <a:avLst/>
-          </a:prstGeom>
-          <a:extLst>
-            <a:ext uri="{C572A759-6A51-4108-AA02-DFA0A04FC94B}">
-              <ma14:wrappingTextBoxFlag xmlns:ma14="http://schemas.microsoft.com/office/mac/drawingml/2011/main" val="0"/>
-            </a:ext>
-          </a:extLst>
-        </p:spPr>
-        <p:txBody>
-          <a:bodyPr/>
-          <a:lstStyle>
-            <a:lvl1pPr>
-              <a:defRPr sz="1000">
-                <a:solidFill>
-                  <a:srgbClr val="718096"/>
-                </a:solidFill>
-                <a:latin typeface="Calibri"/>
-                <a:ea typeface="Calibri"/>
-                <a:cs typeface="Calibri"/>
-              </a:defRPr>
-            </a:lvl1pPr>
-          </a:lstStyle>
-          <a:p>
-            <a:r>
-              <a:t>7</a:t>
-            </a:r>
-          </a:p>
-        </p:txBody>
-      </p:sp>
-      <p:sp>
-        <p:nvSpPr>
-          <p:cNvPr id="26" name="TextBox 25"/>
-          <p:cNvSpPr txBox="1"/>
-          <p:nvPr/>
-        </p:nvSpPr>
-        <p:spPr>
-          <a:xfrm>
-            <a:off x="685800" y="1847088"/>
-            <a:ext cx="3657600" cy="274320"/>
-          </a:xfrm>
-          <a:prstGeom prst="rect">
-            <a:avLst/>
-          </a:prstGeom>
-          <a:noFill/>
-        </p:spPr>
-        <p:txBody>
-          <a:bodyPr wrap="square" lIns="18288" rIns="18288" tIns="0" bIns="0">
-            <a:spAutoFit/>
-          </a:bodyPr>
-          <a:lstStyle/>
-          <a:p>
-            <a:r>
-              <a:rPr sz="1300" b="1">
-                <a:solidFill>
-                  <a:srgbClr val="14213D"/>
-                </a:solidFill>
-              </a:rPr>
-              <a:t>Single agent · nDCG@5 0.69</a:t>
-            </a:r>
-          </a:p>
-        </p:txBody>
-      </p:sp>
-      <p:sp>
-        <p:nvSpPr>
-          <p:cNvPr id="27" name="TextBox 26"/>
-          <p:cNvSpPr txBox="1"/>
-          <p:nvPr/>
-        </p:nvSpPr>
-        <p:spPr>
-          <a:xfrm>
-            <a:off x="685800" y="2231136"/>
-            <a:ext cx="3657600" cy="2286000"/>
-          </a:xfrm>
-          <a:prstGeom prst="rect">
-            <a:avLst/>
-          </a:prstGeom>
-          <a:noFill/>
-        </p:spPr>
-        <p:txBody>
-          <a:bodyPr wrap="square" lIns="18288" rIns="18288" tIns="0" bIns="0">
-            <a:spAutoFit/>
-          </a:bodyPr>
-          <a:lstStyle/>
-          <a:p>
-            <a:r>
-              <a:rPr sz="1200" b="1">
-                <a:solidFill>
-                  <a:srgbClr val="2F5D8C"/>
-                </a:solidFill>
-              </a:rPr>
-              <a:t>Top 5 (2/5 relevant)</a:t>
-            </a:r>
-          </a:p>
-          <a:p>
-            <a:pPr>
-              <a:spcBef>
-                <a:spcPts val="500"/>
-              </a:spcBef>
-            </a:pPr>
-            <a:r>
-              <a:rPr sz="1100" b="1">
-                <a:solidFill>
-                  <a:srgbClr val="2F5D8C"/>
-                </a:solidFill>
-              </a:rPr>
-              <a:t>✓ Data Engineer, SaaS firm</a:t>
-            </a:r>
-          </a:p>
-          <a:p>
-            <a:pPr>
-              <a:spcBef>
-                <a:spcPts val="500"/>
-              </a:spcBef>
-            </a:pPr>
-            <a:r>
-              <a:rPr sz="1100" b="1">
-                <a:solidFill>
-                  <a:srgbClr val="2F5D8C"/>
-                </a:solidFill>
-              </a:rPr>
-              <a:t>✗ Sr Business Systems DB Engineer</a:t>
-            </a:r>
-          </a:p>
-          <a:p>
-            <a:pPr>
-              <a:spcBef>
-                <a:spcPts val="500"/>
-              </a:spcBef>
-            </a:pPr>
-            <a:r>
-              <a:rPr sz="1100" b="1">
-                <a:solidFill>
-                  <a:srgbClr val="2F5D8C"/>
-                </a:solidFill>
-              </a:rPr>
-              <a:t>✓ ROR Partners data role</a:t>
-            </a:r>
-          </a:p>
-          <a:p>
-            <a:pPr>
-              <a:spcBef>
-                <a:spcPts val="500"/>
-              </a:spcBef>
-            </a:pPr>
-            <a:r>
-              <a:rPr sz="1100" b="1">
-                <a:solidFill>
-                  <a:srgbClr val="2F5D8C"/>
-                </a:solidFill>
-              </a:rPr>
-              <a:t>✗ Cybersecurity / embedded (SEL)</a:t>
-            </a:r>
-          </a:p>
-          <a:p>
-            <a:pPr>
-              <a:spcBef>
-                <a:spcPts val="500"/>
-              </a:spcBef>
-            </a:pPr>
-            <a:r>
-              <a:rPr sz="1100" b="1">
-                <a:solidFill>
-                  <a:srgbClr val="2F5D8C"/>
-                </a:solidFill>
-              </a:rPr>
-              <a:t>✗ Software Engineer (Brooksource)</a:t>
-            </a:r>
-          </a:p>
-          <a:p>
-            <a:pPr>
-              <a:spcBef>
-                <a:spcPts val="500"/>
-              </a:spcBef>
-            </a:pPr>
-            <a:r>
-              <a:rPr sz="1100" b="1">
-                <a:solidFill>
-                  <a:srgbClr val="2F5D8C"/>
-                </a:solidFill>
-              </a:rPr>
-              <a:t>Its own note on #4: "no alignment"</a:t>
-            </a:r>
-          </a:p>
-        </p:txBody>
-      </p:sp>
-      <p:sp>
-        <p:nvSpPr>
-          <p:cNvPr id="29" name="TextBox 28"/>
-          <p:cNvSpPr txBox="1"/>
-          <p:nvPr/>
-        </p:nvSpPr>
-        <p:spPr>
-          <a:xfrm>
-            <a:off x="4800600" y="1847088"/>
-            <a:ext cx="3657600" cy="274320"/>
-          </a:xfrm>
-          <a:prstGeom prst="rect">
-            <a:avLst/>
-          </a:prstGeom>
-          <a:noFill/>
-        </p:spPr>
-        <p:txBody>
-          <a:bodyPr wrap="square" lIns="18288" rIns="18288" tIns="0" bIns="0">
-            <a:spAutoFit/>
-          </a:bodyPr>
-          <a:lstStyle/>
-          <a:p>
-            <a:r>
-              <a:rPr sz="1300" b="1">
-                <a:solidFill>
-                  <a:srgbClr val="14213D"/>
-                </a:solidFill>
-              </a:rPr>
-              <a:t>Multi-agent · nDCG@5 0.63</a:t>
-            </a:r>
-          </a:p>
-        </p:txBody>
-      </p:sp>
-      <p:sp>
-        <p:nvSpPr>
-          <p:cNvPr id="30" name="TextBox 29"/>
-          <p:cNvSpPr txBox="1"/>
-          <p:nvPr/>
-        </p:nvSpPr>
-        <p:spPr>
-          <a:xfrm>
-            <a:off x="4800600" y="2231136"/>
-            <a:ext cx="3657600" cy="2286000"/>
-          </a:xfrm>
-          <a:prstGeom prst="rect">
-            <a:avLst/>
-          </a:prstGeom>
-          <a:noFill/>
-        </p:spPr>
-        <p:txBody>
-          <a:bodyPr wrap="square" lIns="18288" rIns="18288" tIns="0" bIns="0">
-            <a:spAutoFit/>
-          </a:bodyPr>
-          <a:lstStyle/>
-          <a:p>
-            <a:r>
-              <a:rPr sz="1200" b="1">
-                <a:solidFill>
-                  <a:srgbClr val="2F5D8C"/>
-                </a:solidFill>
-              </a:rPr>
-              <a:t>Top 5 (2/5 relevant)</a:t>
-            </a:r>
-          </a:p>
-          <a:p>
-            <a:pPr>
-              <a:spcBef>
-                <a:spcPts val="500"/>
-              </a:spcBef>
-            </a:pPr>
-            <a:r>
-              <a:rPr sz="1100" b="1">
-                <a:solidFill>
-                  <a:srgbClr val="B85C1E"/>
-                </a:solidFill>
-              </a:rPr>
-              <a:t>✓ Data Engineer, SaaS firm</a:t>
-            </a:r>
-          </a:p>
-          <a:p>
-            <a:pPr>
-              <a:spcBef>
-                <a:spcPts val="500"/>
-              </a:spcBef>
-            </a:pPr>
-            <a:r>
-              <a:rPr sz="1100" b="1">
-                <a:solidFill>
-                  <a:srgbClr val="B85C1E"/>
-                </a:solidFill>
-              </a:rPr>
-              <a:t>✗ Prop trading firm data role</a:t>
-            </a:r>
-          </a:p>
-          <a:p>
-            <a:pPr>
-              <a:spcBef>
-                <a:spcPts val="500"/>
-              </a:spcBef>
-            </a:pPr>
-            <a:r>
-              <a:rPr sz="1100" b="1">
-                <a:solidFill>
-                  <a:srgbClr val="B85C1E"/>
-                </a:solidFill>
-              </a:rPr>
-              <a:t>✗ Sr Business Systems DB Engineer</a:t>
-            </a:r>
-          </a:p>
-          <a:p>
-            <a:pPr>
-              <a:spcBef>
-                <a:spcPts val="500"/>
-              </a:spcBef>
-            </a:pPr>
-            <a:r>
-              <a:rPr sz="1100" b="1">
-                <a:solidFill>
-                  <a:srgbClr val="B85C1E"/>
-                </a:solidFill>
-              </a:rPr>
-              <a:t>✓ ROR Partners data role</a:t>
-            </a:r>
-          </a:p>
-          <a:p>
-            <a:pPr>
-              <a:spcBef>
-                <a:spcPts val="500"/>
-              </a:spcBef>
-            </a:pPr>
-            <a:r>
-              <a:rPr sz="1100" b="1">
-                <a:solidFill>
-                  <a:srgbClr val="B85C1E"/>
-                </a:solidFill>
-              </a:rPr>
-              <a:t>✗ Cost Accountant</a:t>
-            </a:r>
-          </a:p>
-          <a:p>
-            <a:pPr>
-              <a:spcBef>
-                <a:spcPts val="500"/>
-              </a:spcBef>
-            </a:pPr>
-            <a:r>
-              <a:rPr sz="1100" b="1">
-                <a:solidFill>
-                  <a:srgbClr val="B85C1E"/>
-                </a:solidFill>
-              </a:rPr>
-              <a:t>Its own note on #5: needs ERP skills, "not mentioned"</a:t>
-            </a:r>
           </a:p>
         </p:txBody>
       </p:sp>

</xml_diff>

<commit_message>
slide 4 minor edit
</commit_message>
<xml_diff>
--- a/progress_update_2026-10.pptx
+++ b/progress_update_2026-10.pptx
@@ -4,21 +4,21 @@
   <p:sldMasterIdLst>
     <p:sldMasterId id="2147483648" r:id="rId1"/>
   </p:sldMasterIdLst>
+  <p:notesMasterIdLst>
+    <p:notesMasterId r:id="rId11"/>
+  </p:notesMasterIdLst>
   <p:sldIdLst>
     <p:sldId id="256" r:id="rId2"/>
     <p:sldId id="257" r:id="rId3"/>
     <p:sldId id="258" r:id="rId4"/>
     <p:sldId id="259" r:id="rId5"/>
     <p:sldId id="260" r:id="rId6"/>
-    <p:sldId id="261" r:id="rId12"/>
-    <p:sldId id="264" r:id="rId15"/>
-    <p:sldId id="262" r:id="rId13"/>
-    <p:sldId id="263" r:id="rId14"/>
+    <p:sldId id="261" r:id="rId7"/>
+    <p:sldId id="264" r:id="rId8"/>
+    <p:sldId id="262" r:id="rId9"/>
+    <p:sldId id="263" r:id="rId10"/>
   </p:sldIdLst>
-  <p:notesMasterIdLst>
-    <p:notesMasterId r:id="rId7"/>
-  </p:notesMasterIdLst>
-  <p:sldSz cx="9144000" cy="5143500"/>
+  <p:sldSz cx="9144000" cy="5143500" type="screen16x9"/>
   <p:notesSz cx="5143500" cy="9144000"/>
   <p:defaultTextStyle>
     <a:lvl1pPr marL="0" algn="l" defTabSz="914400" rtl="0" eaLnBrk="1" latinLnBrk="0" hangingPunct="1">
@@ -115,21 +115,25 @@
   <p:extLst>
     <p:ext uri="{521415D9-36F7-43E2-AB2F-B90AF26B5E84}">
       <p14:sectionLst xmlns:p14="http://schemas.microsoft.com/office/powerpoint/2010/main">
-        <p14:section name="Title" id="{fc9c66c6-658e-dcf3-2991-d085cadbce8a}">
+        <p14:section name="Title" id="{FC9C66C6-658E-DCF3-2991-D085CADBCE8A}">
           <p14:sldIdLst>
             <p14:sldId id="256"/>
           </p14:sldIdLst>
         </p14:section>
-        <p14:section name="Progress" id="{9d883d13-2848-e685-c1ae-1f6a632c0069}">
+        <p14:section name="Progress" id="{9D883D13-2848-E685-C1AE-1F6A632C0069}">
           <p14:sldIdLst>
             <p14:sldId id="257"/>
             <p14:sldId id="258"/>
             <p14:sldId id="259"/>
           </p14:sldIdLst>
         </p14:section>
-        <p14:section name="Results" id="{a4225a8b-24fc-cca3-683c-d76ebfa2725b}">
+        <p14:section name="Results" id="{A4225A8B-24FC-CCA3-683C-D76EBFA2725B}">
           <p14:sldIdLst>
             <p14:sldId id="260"/>
+            <p14:sldId id="261"/>
+            <p14:sldId id="264"/>
+            <p14:sldId id="262"/>
+            <p14:sldId id="263"/>
           </p14:sldIdLst>
         </p14:section>
       </p14:sectionLst>
@@ -142,9 +146,11 @@
 </file>
 
 <file path=ppt/charts/chart1.xml><?xml version="1.0" encoding="utf-8"?>
-<c:chartSpace xmlns:c="http://schemas.openxmlformats.org/drawingml/2006/chart" xmlns:a="http://schemas.openxmlformats.org/drawingml/2006/main" xmlns:r="http://schemas.openxmlformats.org/officeDocument/2006/relationships">
+<c:chartSpace xmlns:c="http://schemas.openxmlformats.org/drawingml/2006/chart" xmlns:a="http://schemas.openxmlformats.org/drawingml/2006/main" xmlns:r="http://schemas.openxmlformats.org/officeDocument/2006/relationships" xmlns:c16r2="http://schemas.microsoft.com/office/drawing/2015/06/chart">
   <c:date1904 val="0"/>
+  <c:lang val="en-US"/>
   <c:roundedCorners val="1"/>
+  <c:style val="2"/>
   <c:chart>
     <c:title>
       <c:tx>
@@ -161,7 +167,7 @@
               </a:defRPr>
             </a:pPr>
             <a:r>
-              <a:rPr sz="1300" b="0" i="0" u="none" strike="noStrike">
+              <a:rPr lang="en-US" sz="1300" b="0" i="0" u="none" strike="noStrike">
                 <a:solidFill>
                   <a:srgbClr val="14213D"/>
                 </a:solidFill>
@@ -172,7 +178,6 @@
           </a:p>
         </c:rich>
       </c:tx>
-      <c:layout/>
       <c:overlay val="0"/>
     </c:title>
     <c:autoTitleDeleted val="0"/>
@@ -203,40 +208,15 @@
             <a:effectLst/>
           </c:spPr>
           <c:invertIfNegative val="0"/>
-          <c:dLbls>
-            <c:numFmt formatCode="0.0&quot;s&quot;" sourceLinked="0"/>
-            <c:txPr>
-              <a:bodyPr/>
-              <a:lstStyle/>
-              <a:p>
-                <a:pPr>
-                  <a:defRPr b="1" i="0" strike="noStrike" sz="900" u="none">
-                    <a:solidFill>
-                      <a:srgbClr val="14213D"/>
-                    </a:solidFill>
-                    <a:latin typeface="+mn-lt"/>
-                  </a:defRPr>
-                </a:pPr>
-              </a:p>
-            </c:txPr>
-            <c:showLegendKey val="0"/>
-            <c:showVal val="1"/>
-            <c:showCatName val="0"/>
-            <c:showSerName val="0"/>
-            <c:showPercent val="0"/>
-            <c:showBubbleSize val="0"/>
-            <c:showLeaderLines val="0"/>
-          </c:dLbls>
           <c:dPt>
             <c:idx val="0"/>
             <c:invertIfNegative val="0"/>
             <c:bubble3D val="0"/>
-            <c:spPr>
-              <a:solidFill>
-                <a:srgbClr val="2A64A8"/>
-              </a:solidFill>
-              <a:effectLst/>
-            </c:spPr>
+            <c:extLst>
+              <c:ext xmlns:c16="http://schemas.microsoft.com/office/drawing/2014/chart" uri="{C3380CC4-5D6E-409C-BE32-E72D297353CC}">
+                <c16:uniqueId val="{00000001-801B-4AFD-BE44-9E5A9B3850A9}"/>
+              </c:ext>
+            </c:extLst>
           </c:dPt>
           <c:dPt>
             <c:idx val="1"/>
@@ -248,17 +228,21 @@
               </a:solidFill>
               <a:effectLst/>
             </c:spPr>
+            <c:extLst>
+              <c:ext xmlns:c16="http://schemas.microsoft.com/office/drawing/2014/chart" uri="{C3380CC4-5D6E-409C-BE32-E72D297353CC}">
+                <c16:uniqueId val="{00000003-801B-4AFD-BE44-9E5A9B3850A9}"/>
+              </c:ext>
+            </c:extLst>
           </c:dPt>
           <c:dPt>
             <c:idx val="2"/>
             <c:invertIfNegative val="0"/>
             <c:bubble3D val="0"/>
-            <c:spPr>
-              <a:solidFill>
-                <a:srgbClr val="2A64A8"/>
-              </a:solidFill>
-              <a:effectLst/>
-            </c:spPr>
+            <c:extLst>
+              <c:ext xmlns:c16="http://schemas.microsoft.com/office/drawing/2014/chart" uri="{C3380CC4-5D6E-409C-BE32-E72D297353CC}">
+                <c16:uniqueId val="{00000005-801B-4AFD-BE44-9E5A9B3850A9}"/>
+              </c:ext>
+            </c:extLst>
           </c:dPt>
           <c:dPt>
             <c:idx val="3"/>
@@ -270,7 +254,49 @@
               </a:solidFill>
               <a:effectLst/>
             </c:spPr>
+            <c:extLst>
+              <c:ext xmlns:c16="http://schemas.microsoft.com/office/drawing/2014/chart" uri="{C3380CC4-5D6E-409C-BE32-E72D297353CC}">
+                <c16:uniqueId val="{00000007-801B-4AFD-BE44-9E5A9B3850A9}"/>
+              </c:ext>
+            </c:extLst>
           </c:dPt>
+          <c:dLbls>
+            <c:numFmt formatCode="0.0&quot;s&quot;" sourceLinked="0"/>
+            <c:spPr>
+              <a:noFill/>
+              <a:ln>
+                <a:noFill/>
+              </a:ln>
+              <a:effectLst/>
+            </c:spPr>
+            <c:txPr>
+              <a:bodyPr/>
+              <a:lstStyle/>
+              <a:p>
+                <a:pPr>
+                  <a:defRPr sz="900" b="1" i="0" u="none" strike="noStrike">
+                    <a:solidFill>
+                      <a:srgbClr val="14213D"/>
+                    </a:solidFill>
+                    <a:latin typeface="+mn-lt"/>
+                  </a:defRPr>
+                </a:pPr>
+                <a:endParaRPr lang="en-US"/>
+              </a:p>
+            </c:txPr>
+            <c:showLegendKey val="0"/>
+            <c:showVal val="1"/>
+            <c:showCatName val="0"/>
+            <c:showSerName val="0"/>
+            <c:showPercent val="0"/>
+            <c:showBubbleSize val="0"/>
+            <c:showLeaderLines val="0"/>
+            <c:extLst>
+              <c:ext xmlns:c15="http://schemas.microsoft.com/office/drawing/2012/chart" uri="{CE6537A1-D6FC-4f65-9D91-7224C49458BB}">
+                <c15:showLeaderLines val="0"/>
+              </c:ext>
+            </c:extLst>
+          </c:dLbls>
           <c:cat>
             <c:strRef>
               <c:f>Sheet1!$A$2:$A$5</c:f>
@@ -307,41 +333,28 @@
                   <c:v>10.6</c:v>
                 </c:pt>
                 <c:pt idx="3">
-                  <c:v>40.8</c:v>
+                  <c:v>40.799999999999997</c:v>
                 </c:pt>
               </c:numCache>
             </c:numRef>
           </c:val>
+          <c:extLst>
+            <c:ext xmlns:c16="http://schemas.microsoft.com/office/drawing/2014/chart" uri="{C3380CC4-5D6E-409C-BE32-E72D297353CC}">
+              <c16:uniqueId val="{00000008-801B-4AFD-BE44-9E5A9B3850A9}"/>
+            </c:ext>
+          </c:extLst>
         </c:ser>
         <c:dLbls>
-          <c:numFmt formatCode="0.0&quot;s&quot;" sourceLinked="0"/>
-          <c:txPr>
-            <a:bodyPr/>
-            <a:lstStyle/>
-            <a:p>
-              <a:pPr>
-                <a:defRPr b="0" i="0" strike="noStrike" sz="1100" u="none">
-                  <a:solidFill>
-                    <a:srgbClr val="14213D"/>
-                  </a:solidFill>
-                  <a:latin typeface="+mn-lt"/>
-                </a:defRPr>
-              </a:pPr>
-            </a:p>
-          </c:txPr>
           <c:showLegendKey val="0"/>
           <c:showVal val="1"/>
           <c:showCatName val="0"/>
           <c:showSerName val="0"/>
           <c:showPercent val="0"/>
           <c:showBubbleSize val="0"/>
-          <c:showLeaderLines val="0"/>
         </c:dLbls>
         <c:gapWidth val="60"/>
-        <c:overlap val="0"/>
         <c:axId val="2094734554"/>
         <c:axId val="2094734552"/>
-        <c:axId val="2094734556"/>
       </c:barChart>
       <c:catAx>
         <c:axId val="2094734554"/>
@@ -382,6 +395,7 @@
         <c:crosses val="autoZero"/>
         <c:auto val="1"/>
         <c:lblAlgn val="ctr"/>
+        <c:lblOffset val="100"/>
         <c:noMultiLvlLbl val="1"/>
       </c:catAx>
       <c:valAx>
@@ -395,30 +409,6 @@
         <c:majorTickMark val="out"/>
         <c:minorTickMark val="none"/>
         <c:tickLblPos val="nextTo"/>
-        <c:spPr>
-          <a:ln w="12700" cap="flat">
-            <a:solidFill>
-              <a:srgbClr val="888888"/>
-            </a:solidFill>
-            <a:prstDash val="solid"/>
-            <a:round/>
-          </a:ln>
-        </c:spPr>
-        <c:txPr>
-          <a:bodyPr/>
-          <a:lstStyle/>
-          <a:p>
-            <a:pPr>
-              <a:defRPr sz="1200" b="0" i="0" u="none" strike="noStrike">
-                <a:solidFill>
-                  <a:srgbClr val="000000"/>
-                </a:solidFill>
-                <a:latin typeface="Arial"/>
-              </a:defRPr>
-            </a:pPr>
-            <a:endParaRPr lang="en-US"/>
-          </a:p>
-        </c:txPr>
         <c:crossAx val="2094734554"/>
         <c:crosses val="autoZero"/>
         <c:crossBetween val="between"/>
@@ -435,6 +425,7 @@
     </c:plotArea>
     <c:plotVisOnly val="1"/>
     <c:dispBlanksAs val="span"/>
+    <c:showDLblsOverMax val="1"/>
   </c:chart>
   <c:spPr>
     <a:noFill/>
@@ -450,9 +441,11 @@
 </file>
 
 <file path=ppt/charts/chart2.xml><?xml version="1.0" encoding="utf-8"?>
-<c:chartSpace xmlns:c="http://schemas.openxmlformats.org/drawingml/2006/chart" xmlns:a="http://schemas.openxmlformats.org/drawingml/2006/main" xmlns:r="http://schemas.openxmlformats.org/officeDocument/2006/relationships">
+<c:chartSpace xmlns:c="http://schemas.openxmlformats.org/drawingml/2006/chart" xmlns:a="http://schemas.openxmlformats.org/drawingml/2006/main" xmlns:r="http://schemas.openxmlformats.org/officeDocument/2006/relationships" xmlns:c16r2="http://schemas.microsoft.com/office/drawing/2015/06/chart">
   <c:date1904 val="0"/>
+  <c:lang val="en-US"/>
   <c:roundedCorners val="1"/>
+  <c:style val="2"/>
   <c:chart>
     <c:title>
       <c:tx>
@@ -469,7 +462,7 @@
               </a:defRPr>
             </a:pPr>
             <a:r>
-              <a:rPr sz="1300" b="0" i="0" u="none" strike="noStrike">
+              <a:rPr lang="en-US" sz="1300" b="0" i="0" u="none" strike="noStrike">
                 <a:solidFill>
                   <a:srgbClr val="14213D"/>
                 </a:solidFill>
@@ -480,7 +473,6 @@
           </a:p>
         </c:rich>
       </c:tx>
-      <c:layout/>
       <c:overlay val="0"/>
     </c:title>
     <c:autoTitleDeleted val="0"/>
@@ -511,40 +503,15 @@
             <a:effectLst/>
           </c:spPr>
           <c:invertIfNegative val="0"/>
-          <c:dLbls>
-            <c:numFmt formatCode="0.0&quot;k&quot;" sourceLinked="0"/>
-            <c:txPr>
-              <a:bodyPr/>
-              <a:lstStyle/>
-              <a:p>
-                <a:pPr>
-                  <a:defRPr b="1" i="0" strike="noStrike" sz="900" u="none">
-                    <a:solidFill>
-                      <a:srgbClr val="14213D"/>
-                    </a:solidFill>
-                    <a:latin typeface="+mn-lt"/>
-                  </a:defRPr>
-                </a:pPr>
-              </a:p>
-            </c:txPr>
-            <c:showLegendKey val="0"/>
-            <c:showVal val="1"/>
-            <c:showCatName val="0"/>
-            <c:showSerName val="0"/>
-            <c:showPercent val="0"/>
-            <c:showBubbleSize val="0"/>
-            <c:showLeaderLines val="0"/>
-          </c:dLbls>
           <c:dPt>
             <c:idx val="0"/>
             <c:invertIfNegative val="0"/>
             <c:bubble3D val="0"/>
-            <c:spPr>
-              <a:solidFill>
-                <a:srgbClr val="2A64A8"/>
-              </a:solidFill>
-              <a:effectLst/>
-            </c:spPr>
+            <c:extLst>
+              <c:ext xmlns:c16="http://schemas.microsoft.com/office/drawing/2014/chart" uri="{C3380CC4-5D6E-409C-BE32-E72D297353CC}">
+                <c16:uniqueId val="{00000001-8D51-41F6-8269-5817E0B75E13}"/>
+              </c:ext>
+            </c:extLst>
           </c:dPt>
           <c:dPt>
             <c:idx val="1"/>
@@ -556,17 +523,21 @@
               </a:solidFill>
               <a:effectLst/>
             </c:spPr>
+            <c:extLst>
+              <c:ext xmlns:c16="http://schemas.microsoft.com/office/drawing/2014/chart" uri="{C3380CC4-5D6E-409C-BE32-E72D297353CC}">
+                <c16:uniqueId val="{00000003-8D51-41F6-8269-5817E0B75E13}"/>
+              </c:ext>
+            </c:extLst>
           </c:dPt>
           <c:dPt>
             <c:idx val="2"/>
             <c:invertIfNegative val="0"/>
             <c:bubble3D val="0"/>
-            <c:spPr>
-              <a:solidFill>
-                <a:srgbClr val="2A64A8"/>
-              </a:solidFill>
-              <a:effectLst/>
-            </c:spPr>
+            <c:extLst>
+              <c:ext xmlns:c16="http://schemas.microsoft.com/office/drawing/2014/chart" uri="{C3380CC4-5D6E-409C-BE32-E72D297353CC}">
+                <c16:uniqueId val="{00000005-8D51-41F6-8269-5817E0B75E13}"/>
+              </c:ext>
+            </c:extLst>
           </c:dPt>
           <c:dPt>
             <c:idx val="3"/>
@@ -578,7 +549,49 @@
               </a:solidFill>
               <a:effectLst/>
             </c:spPr>
+            <c:extLst>
+              <c:ext xmlns:c16="http://schemas.microsoft.com/office/drawing/2014/chart" uri="{C3380CC4-5D6E-409C-BE32-E72D297353CC}">
+                <c16:uniqueId val="{00000007-8D51-41F6-8269-5817E0B75E13}"/>
+              </c:ext>
+            </c:extLst>
           </c:dPt>
+          <c:dLbls>
+            <c:numFmt formatCode="0.0&quot;k&quot;" sourceLinked="0"/>
+            <c:spPr>
+              <a:noFill/>
+              <a:ln>
+                <a:noFill/>
+              </a:ln>
+              <a:effectLst/>
+            </c:spPr>
+            <c:txPr>
+              <a:bodyPr/>
+              <a:lstStyle/>
+              <a:p>
+                <a:pPr>
+                  <a:defRPr sz="900" b="1" i="0" u="none" strike="noStrike">
+                    <a:solidFill>
+                      <a:srgbClr val="14213D"/>
+                    </a:solidFill>
+                    <a:latin typeface="+mn-lt"/>
+                  </a:defRPr>
+                </a:pPr>
+                <a:endParaRPr lang="en-US"/>
+              </a:p>
+            </c:txPr>
+            <c:showLegendKey val="0"/>
+            <c:showVal val="1"/>
+            <c:showCatName val="0"/>
+            <c:showSerName val="0"/>
+            <c:showPercent val="0"/>
+            <c:showBubbleSize val="0"/>
+            <c:showLeaderLines val="0"/>
+            <c:extLst>
+              <c:ext xmlns:c15="http://schemas.microsoft.com/office/drawing/2012/chart" uri="{CE6537A1-D6FC-4f65-9D91-7224C49458BB}">
+                <c15:showLeaderLines val="0"/>
+              </c:ext>
+            </c:extLst>
+          </c:dLbls>
           <c:cat>
             <c:strRef>
               <c:f>Sheet1!$A$2:$A$5</c:f>
@@ -609,47 +622,34 @@
                   <c:v>9.9</c:v>
                 </c:pt>
                 <c:pt idx="1">
-                  <c:v>32.2</c:v>
+                  <c:v>32.200000000000003</c:v>
                 </c:pt>
                 <c:pt idx="2">
                   <c:v>9.9</c:v>
                 </c:pt>
                 <c:pt idx="3">
-                  <c:v>32.0</c:v>
+                  <c:v>32</c:v>
                 </c:pt>
               </c:numCache>
             </c:numRef>
           </c:val>
+          <c:extLst>
+            <c:ext xmlns:c16="http://schemas.microsoft.com/office/drawing/2014/chart" uri="{C3380CC4-5D6E-409C-BE32-E72D297353CC}">
+              <c16:uniqueId val="{00000008-8D51-41F6-8269-5817E0B75E13}"/>
+            </c:ext>
+          </c:extLst>
         </c:ser>
         <c:dLbls>
-          <c:numFmt formatCode="0.0&quot;k&quot;" sourceLinked="0"/>
-          <c:txPr>
-            <a:bodyPr/>
-            <a:lstStyle/>
-            <a:p>
-              <a:pPr>
-                <a:defRPr b="0" i="0" strike="noStrike" sz="1100" u="none">
-                  <a:solidFill>
-                    <a:srgbClr val="14213D"/>
-                  </a:solidFill>
-                  <a:latin typeface="+mn-lt"/>
-                </a:defRPr>
-              </a:pPr>
-            </a:p>
-          </c:txPr>
           <c:showLegendKey val="0"/>
           <c:showVal val="1"/>
           <c:showCatName val="0"/>
           <c:showSerName val="0"/>
           <c:showPercent val="0"/>
           <c:showBubbleSize val="0"/>
-          <c:showLeaderLines val="0"/>
         </c:dLbls>
         <c:gapWidth val="60"/>
-        <c:overlap val="0"/>
         <c:axId val="2094734554"/>
         <c:axId val="2094734552"/>
-        <c:axId val="2094734556"/>
       </c:barChart>
       <c:catAx>
         <c:axId val="2094734554"/>
@@ -690,6 +690,7 @@
         <c:crosses val="autoZero"/>
         <c:auto val="1"/>
         <c:lblAlgn val="ctr"/>
+        <c:lblOffset val="100"/>
         <c:noMultiLvlLbl val="1"/>
       </c:catAx>
       <c:valAx>
@@ -703,30 +704,6 @@
         <c:majorTickMark val="out"/>
         <c:minorTickMark val="none"/>
         <c:tickLblPos val="nextTo"/>
-        <c:spPr>
-          <a:ln w="12700" cap="flat">
-            <a:solidFill>
-              <a:srgbClr val="888888"/>
-            </a:solidFill>
-            <a:prstDash val="solid"/>
-            <a:round/>
-          </a:ln>
-        </c:spPr>
-        <c:txPr>
-          <a:bodyPr/>
-          <a:lstStyle/>
-          <a:p>
-            <a:pPr>
-              <a:defRPr sz="1200" b="0" i="0" u="none" strike="noStrike">
-                <a:solidFill>
-                  <a:srgbClr val="000000"/>
-                </a:solidFill>
-                <a:latin typeface="Arial"/>
-              </a:defRPr>
-            </a:pPr>
-            <a:endParaRPr lang="en-US"/>
-          </a:p>
-        </c:txPr>
         <c:crossAx val="2094734554"/>
         <c:crosses val="autoZero"/>
         <c:crossBetween val="between"/>
@@ -743,6 +720,7 @@
     </c:plotArea>
     <c:plotVisOnly val="1"/>
     <c:dispBlanksAs val="span"/>
+    <c:showDLblsOverMax val="1"/>
   </c:chart>
   <c:spPr>
     <a:noFill/>
@@ -758,8 +736,11 @@
 </file>
 
 <file path=ppt/charts/chart3.xml><?xml version="1.0" encoding="utf-8"?>
-<c:chartSpace xmlns:c="http://schemas.openxmlformats.org/drawingml/2006/chart" xmlns:a="http://schemas.openxmlformats.org/drawingml/2006/main" xmlns:r="http://schemas.openxmlformats.org/officeDocument/2006/relationships">
+<c:chartSpace xmlns:c="http://schemas.openxmlformats.org/drawingml/2006/chart" xmlns:a="http://schemas.openxmlformats.org/drawingml/2006/main" xmlns:r="http://schemas.openxmlformats.org/officeDocument/2006/relationships" xmlns:c16r2="http://schemas.microsoft.com/office/drawing/2015/06/chart">
   <c:date1904 val="0"/>
+  <c:lang val="en-US"/>
+  <c:roundedCorners val="1"/>
+  <c:style val="2"/>
   <c:chart>
     <c:title>
       <c:tx>
@@ -768,7 +749,7 @@
           <a:lstStyle/>
           <a:p>
             <a:r>
-              <a:rPr sz="1200" b="1">
+              <a:rPr lang="en-US" sz="1200" b="1">
                 <a:solidFill>
                   <a:srgbClr val="14213D"/>
                 </a:solidFill>
@@ -778,14 +759,15 @@
           </a:p>
         </c:rich>
       </c:tx>
-      <c:layout/>
       <c:overlay val="0"/>
     </c:title>
     <c:autoTitleDeleted val="0"/>
     <c:plotArea>
+      <c:layout/>
       <c:barChart>
         <c:barDir val="col"/>
         <c:grouping val="clustered"/>
+        <c:varyColors val="1"/>
         <c:ser>
           <c:idx val="0"/>
           <c:order val="0"/>
@@ -805,8 +787,16 @@
               <a:srgbClr val="2F5D8C"/>
             </a:solidFill>
           </c:spPr>
+          <c:invertIfNegative val="1"/>
           <c:dLbls>
             <c:numFmt formatCode="0.00" sourceLinked="0"/>
+            <c:spPr>
+              <a:noFill/>
+              <a:ln>
+                <a:noFill/>
+              </a:ln>
+              <a:effectLst/>
+            </c:spPr>
             <c:txPr>
               <a:bodyPr/>
               <a:lstStyle/>
@@ -814,6 +804,7 @@
                 <a:pPr>
                   <a:defRPr sz="900" b="1"/>
                 </a:pPr>
+                <a:endParaRPr lang="en-US"/>
               </a:p>
             </c:txPr>
             <c:showLegendKey val="0"/>
@@ -822,7 +813,12 @@
             <c:showSerName val="0"/>
             <c:showPercent val="0"/>
             <c:showBubbleSize val="0"/>
-            <c:showLeaderLines val="1"/>
+            <c:showLeaderLines val="0"/>
+            <c:extLst>
+              <c:ext xmlns:c15="http://schemas.microsoft.com/office/drawing/2012/chart" uri="{CE6537A1-D6FC-4f65-9D91-7224C49458BB}">
+                <c15:showLeaderLines val="0"/>
+              </c:ext>
+            </c:extLst>
           </c:dLbls>
           <c:cat>
             <c:strRef>
@@ -848,17 +844,31 @@
                 <c:formatCode>General</c:formatCode>
                 <c:ptCount val="3"/>
                 <c:pt idx="0">
-                  <c:v>0.533</c:v>
+                  <c:v>0.53300000000000003</c:v>
                 </c:pt>
                 <c:pt idx="1">
                   <c:v>0.7</c:v>
                 </c:pt>
                 <c:pt idx="2">
-                  <c:v>0.714</c:v>
+                  <c:v>0.71399999999999997</c:v>
                 </c:pt>
               </c:numCache>
             </c:numRef>
           </c:val>
+          <c:extLst>
+            <c:ext xmlns:c14="http://schemas.microsoft.com/office/drawing/2007/8/2/chart" uri="{6F2FDCE9-48DA-4B69-8628-5D25D57E5C99}">
+              <c14:invertSolidFillFmt>
+                <c14:spPr xmlns:c14="http://schemas.microsoft.com/office/drawing/2007/8/2/chart">
+                  <a:solidFill>
+                    <a:srgbClr val="FFFFFF"/>
+                  </a:solidFill>
+                </c14:spPr>
+              </c14:invertSolidFillFmt>
+            </c:ext>
+            <c:ext xmlns:c16="http://schemas.microsoft.com/office/drawing/2014/chart" uri="{C3380CC4-5D6E-409C-BE32-E72D297353CC}">
+              <c16:uniqueId val="{00000000-75B7-4BCE-B8A2-32544399603B}"/>
+            </c:ext>
+          </c:extLst>
         </c:ser>
         <c:ser>
           <c:idx val="1"/>
@@ -879,8 +889,16 @@
               <a:srgbClr val="B85C1E"/>
             </a:solidFill>
           </c:spPr>
+          <c:invertIfNegative val="1"/>
           <c:dLbls>
             <c:numFmt formatCode="0.00" sourceLinked="0"/>
+            <c:spPr>
+              <a:noFill/>
+              <a:ln>
+                <a:noFill/>
+              </a:ln>
+              <a:effectLst/>
+            </c:spPr>
             <c:txPr>
               <a:bodyPr/>
               <a:lstStyle/>
@@ -888,6 +906,7 @@
                 <a:pPr>
                   <a:defRPr sz="900" b="1"/>
                 </a:pPr>
+                <a:endParaRPr lang="en-US"/>
               </a:p>
             </c:txPr>
             <c:showLegendKey val="0"/>
@@ -896,7 +915,12 @@
             <c:showSerName val="0"/>
             <c:showPercent val="0"/>
             <c:showBubbleSize val="0"/>
-            <c:showLeaderLines val="1"/>
+            <c:showLeaderLines val="0"/>
+            <c:extLst>
+              <c:ext xmlns:c15="http://schemas.microsoft.com/office/drawing/2012/chart" uri="{CE6537A1-D6FC-4f65-9D91-7224C49458BB}">
+                <c15:showLeaderLines val="0"/>
+              </c:ext>
+            </c:extLst>
           </c:dLbls>
           <c:cat>
             <c:strRef>
@@ -922,33 +946,33 @@
                 <c:formatCode>General</c:formatCode>
                 <c:ptCount val="3"/>
                 <c:pt idx="0">
-                  <c:v>0.486</c:v>
+                  <c:v>0.48599999999999999</c:v>
                 </c:pt>
                 <c:pt idx="1">
-                  <c:v>0.664</c:v>
+                  <c:v>0.66400000000000003</c:v>
                 </c:pt>
                 <c:pt idx="2">
-                  <c:v>0.429</c:v>
+                  <c:v>0.42899999999999999</c:v>
                 </c:pt>
               </c:numCache>
             </c:numRef>
           </c:val>
+          <c:extLst>
+            <c:ext xmlns:c14="http://schemas.microsoft.com/office/drawing/2007/8/2/chart" uri="{6F2FDCE9-48DA-4B69-8628-5D25D57E5C99}">
+              <c14:invertSolidFillFmt>
+                <c14:spPr xmlns:c14="http://schemas.microsoft.com/office/drawing/2007/8/2/chart">
+                  <a:solidFill>
+                    <a:srgbClr val="FFFFFF"/>
+                  </a:solidFill>
+                </c14:spPr>
+              </c14:invertSolidFillFmt>
+            </c:ext>
+            <c:ext xmlns:c16="http://schemas.microsoft.com/office/drawing/2014/chart" uri="{C3380CC4-5D6E-409C-BE32-E72D297353CC}">
+              <c16:uniqueId val="{00000001-75B7-4BCE-B8A2-32544399603B}"/>
+            </c:ext>
+          </c:extLst>
         </c:ser>
         <c:dLbls>
-          <c:numFmt formatCode="0.00" sourceLinked="0"/>
-          <c:txPr>
-            <a:bodyPr/>
-            <a:lstStyle/>
-            <a:p>
-              <a:pPr>
-                <a:defRPr sz="1000" b="1">
-                  <a:solidFill>
-                    <a:srgbClr val="14213D"/>
-                  </a:solidFill>
-                </a:defRPr>
-              </a:pPr>
-            </a:p>
-          </c:txPr>
           <c:dLblPos val="outEnd"/>
           <c:showLegendKey val="0"/>
           <c:showVal val="1"/>
@@ -956,7 +980,6 @@
           <c:showSerName val="0"/>
           <c:showPercent val="0"/>
           <c:showBubbleSize val="0"/>
-          <c:showLeaderLines val="1"/>
         </c:dLbls>
         <c:gapWidth val="80"/>
         <c:overlap val="-10"/>
@@ -970,6 +993,7 @@
         </c:scaling>
         <c:delete val="0"/>
         <c:axPos val="b"/>
+        <c:numFmt formatCode="General" sourceLinked="0"/>
         <c:majorTickMark val="out"/>
         <c:minorTickMark val="none"/>
         <c:tickLblPos val="nextTo"/>
@@ -991,6 +1015,7 @@
                 </a:solidFill>
               </a:defRPr>
             </a:pPr>
+            <a:endParaRPr lang="en-US"/>
           </a:p>
         </c:txPr>
         <c:crossAx val="-2113994440"/>
@@ -1002,14 +1027,18 @@
       </c:catAx>
       <c:valAx>
         <c:axId val="-2113994440"/>
-        <c:scaling/>
-        <c:delete/>
+        <c:scaling>
+          <c:orientation val="minMax"/>
+        </c:scaling>
+        <c:delete val="1"/>
         <c:axPos val="l"/>
+        <c:numFmt formatCode="General" sourceLinked="1"/>
         <c:majorTickMark val="out"/>
         <c:minorTickMark val="none"/>
         <c:tickLblPos val="nextTo"/>
         <c:crossAx val="-2068027336"/>
         <c:crosses val="autoZero"/>
+        <c:crossBetween val="between"/>
       </c:valAx>
     </c:plotArea>
     <c:legend>
@@ -1026,10 +1055,13 @@
               </a:solidFill>
             </a:defRPr>
           </a:pPr>
+          <a:endParaRPr lang="en-US"/>
         </a:p>
       </c:txPr>
     </c:legend>
+    <c:plotVisOnly val="1"/>
     <c:dispBlanksAs val="gap"/>
+    <c:showDLblsOverMax val="1"/>
   </c:chart>
   <c:txPr>
     <a:bodyPr/>
@@ -1048,8 +1080,11 @@
 </file>
 
 <file path=ppt/charts/chart4.xml><?xml version="1.0" encoding="utf-8"?>
-<c:chartSpace xmlns:c="http://schemas.openxmlformats.org/drawingml/2006/chart" xmlns:a="http://schemas.openxmlformats.org/drawingml/2006/main" xmlns:r="http://schemas.openxmlformats.org/officeDocument/2006/relationships">
+<c:chartSpace xmlns:c="http://schemas.openxmlformats.org/drawingml/2006/chart" xmlns:a="http://schemas.openxmlformats.org/drawingml/2006/main" xmlns:r="http://schemas.openxmlformats.org/officeDocument/2006/relationships" xmlns:c16r2="http://schemas.microsoft.com/office/drawing/2015/06/chart">
   <c:date1904 val="0"/>
+  <c:lang val="en-US"/>
+  <c:roundedCorners val="1"/>
+  <c:style val="2"/>
   <c:chart>
     <c:title>
       <c:tx>
@@ -1058,7 +1093,7 @@
           <a:lstStyle/>
           <a:p>
             <a:r>
-              <a:rPr sz="1200" b="1">
+              <a:rPr lang="en-US" sz="1200" b="1">
                 <a:solidFill>
                   <a:srgbClr val="14213D"/>
                 </a:solidFill>
@@ -1068,14 +1103,15 @@
           </a:p>
         </c:rich>
       </c:tx>
-      <c:layout/>
       <c:overlay val="0"/>
     </c:title>
     <c:autoTitleDeleted val="0"/>
     <c:plotArea>
+      <c:layout/>
       <c:barChart>
         <c:barDir val="col"/>
         <c:grouping val="clustered"/>
+        <c:varyColors val="1"/>
         <c:ser>
           <c:idx val="0"/>
           <c:order val="0"/>
@@ -1095,8 +1131,16 @@
               <a:srgbClr val="2F5D8C"/>
             </a:solidFill>
           </c:spPr>
+          <c:invertIfNegative val="1"/>
           <c:dLbls>
             <c:numFmt formatCode="0.00" sourceLinked="0"/>
+            <c:spPr>
+              <a:noFill/>
+              <a:ln>
+                <a:noFill/>
+              </a:ln>
+              <a:effectLst/>
+            </c:spPr>
             <c:txPr>
               <a:bodyPr/>
               <a:lstStyle/>
@@ -1104,6 +1148,7 @@
                 <a:pPr>
                   <a:defRPr sz="900" b="1"/>
                 </a:pPr>
+                <a:endParaRPr lang="en-US"/>
               </a:p>
             </c:txPr>
             <c:showLegendKey val="0"/>
@@ -1112,7 +1157,12 @@
             <c:showSerName val="0"/>
             <c:showPercent val="0"/>
             <c:showBubbleSize val="0"/>
-            <c:showLeaderLines val="1"/>
+            <c:showLeaderLines val="0"/>
+            <c:extLst>
+              <c:ext xmlns:c15="http://schemas.microsoft.com/office/drawing/2012/chart" uri="{CE6537A1-D6FC-4f65-9D91-7224C49458BB}">
+                <c15:showLeaderLines val="0"/>
+              </c:ext>
+            </c:extLst>
           </c:dLbls>
           <c:cat>
             <c:strRef>
@@ -1138,17 +1188,31 @@
                 <c:formatCode>General</c:formatCode>
                 <c:ptCount val="3"/>
                 <c:pt idx="0">
-                  <c:v>0.558</c:v>
+                  <c:v>0.55800000000000005</c:v>
                 </c:pt>
                 <c:pt idx="1">
-                  <c:v>0.518</c:v>
+                  <c:v>0.51800000000000002</c:v>
                 </c:pt>
                 <c:pt idx="2">
-                  <c:v>0.524</c:v>
+                  <c:v>0.52400000000000002</c:v>
                 </c:pt>
               </c:numCache>
             </c:numRef>
           </c:val>
+          <c:extLst>
+            <c:ext xmlns:c14="http://schemas.microsoft.com/office/drawing/2007/8/2/chart" uri="{6F2FDCE9-48DA-4B69-8628-5D25D57E5C99}">
+              <c14:invertSolidFillFmt>
+                <c14:spPr xmlns:c14="http://schemas.microsoft.com/office/drawing/2007/8/2/chart">
+                  <a:solidFill>
+                    <a:srgbClr val="FFFFFF"/>
+                  </a:solidFill>
+                </c14:spPr>
+              </c14:invertSolidFillFmt>
+            </c:ext>
+            <c:ext xmlns:c16="http://schemas.microsoft.com/office/drawing/2014/chart" uri="{C3380CC4-5D6E-409C-BE32-E72D297353CC}">
+              <c16:uniqueId val="{00000000-0576-4EBE-8A0C-16FC21F23263}"/>
+            </c:ext>
+          </c:extLst>
         </c:ser>
         <c:ser>
           <c:idx val="1"/>
@@ -1169,8 +1233,16 @@
               <a:srgbClr val="B85C1E"/>
             </a:solidFill>
           </c:spPr>
+          <c:invertIfNegative val="1"/>
           <c:dLbls>
             <c:numFmt formatCode="0.00" sourceLinked="0"/>
+            <c:spPr>
+              <a:noFill/>
+              <a:ln>
+                <a:noFill/>
+              </a:ln>
+              <a:effectLst/>
+            </c:spPr>
             <c:txPr>
               <a:bodyPr/>
               <a:lstStyle/>
@@ -1178,6 +1250,7 @@
                 <a:pPr>
                   <a:defRPr sz="900" b="1"/>
                 </a:pPr>
+                <a:endParaRPr lang="en-US"/>
               </a:p>
             </c:txPr>
             <c:showLegendKey val="0"/>
@@ -1186,7 +1259,12 @@
             <c:showSerName val="0"/>
             <c:showPercent val="0"/>
             <c:showBubbleSize val="0"/>
-            <c:showLeaderLines val="1"/>
+            <c:showLeaderLines val="0"/>
+            <c:extLst>
+              <c:ext xmlns:c15="http://schemas.microsoft.com/office/drawing/2012/chart" uri="{CE6537A1-D6FC-4f65-9D91-7224C49458BB}">
+                <c15:showLeaderLines val="0"/>
+              </c:ext>
+            </c:extLst>
           </c:dLbls>
           <c:cat>
             <c:strRef>
@@ -1212,33 +1290,33 @@
                 <c:formatCode>General</c:formatCode>
                 <c:ptCount val="3"/>
                 <c:pt idx="0">
-                  <c:v>0.414</c:v>
+                  <c:v>0.41399999999999998</c:v>
                 </c:pt>
                 <c:pt idx="1">
-                  <c:v>0.537</c:v>
+                  <c:v>0.53700000000000003</c:v>
                 </c:pt>
                 <c:pt idx="2">
-                  <c:v>0.511</c:v>
+                  <c:v>0.51100000000000001</c:v>
                 </c:pt>
               </c:numCache>
             </c:numRef>
           </c:val>
+          <c:extLst>
+            <c:ext xmlns:c14="http://schemas.microsoft.com/office/drawing/2007/8/2/chart" uri="{6F2FDCE9-48DA-4B69-8628-5D25D57E5C99}">
+              <c14:invertSolidFillFmt>
+                <c14:spPr xmlns:c14="http://schemas.microsoft.com/office/drawing/2007/8/2/chart">
+                  <a:solidFill>
+                    <a:srgbClr val="FFFFFF"/>
+                  </a:solidFill>
+                </c14:spPr>
+              </c14:invertSolidFillFmt>
+            </c:ext>
+            <c:ext xmlns:c16="http://schemas.microsoft.com/office/drawing/2014/chart" uri="{C3380CC4-5D6E-409C-BE32-E72D297353CC}">
+              <c16:uniqueId val="{00000001-0576-4EBE-8A0C-16FC21F23263}"/>
+            </c:ext>
+          </c:extLst>
         </c:ser>
         <c:dLbls>
-          <c:numFmt formatCode="0.00" sourceLinked="0"/>
-          <c:txPr>
-            <a:bodyPr/>
-            <a:lstStyle/>
-            <a:p>
-              <a:pPr>
-                <a:defRPr sz="1000" b="1">
-                  <a:solidFill>
-                    <a:srgbClr val="14213D"/>
-                  </a:solidFill>
-                </a:defRPr>
-              </a:pPr>
-            </a:p>
-          </c:txPr>
           <c:dLblPos val="outEnd"/>
           <c:showLegendKey val="0"/>
           <c:showVal val="1"/>
@@ -1246,7 +1324,6 @@
           <c:showSerName val="0"/>
           <c:showPercent val="0"/>
           <c:showBubbleSize val="0"/>
-          <c:showLeaderLines val="1"/>
         </c:dLbls>
         <c:gapWidth val="80"/>
         <c:overlap val="-10"/>
@@ -1260,6 +1337,7 @@
         </c:scaling>
         <c:delete val="0"/>
         <c:axPos val="b"/>
+        <c:numFmt formatCode="General" sourceLinked="0"/>
         <c:majorTickMark val="out"/>
         <c:minorTickMark val="none"/>
         <c:tickLblPos val="nextTo"/>
@@ -1281,6 +1359,7 @@
                 </a:solidFill>
               </a:defRPr>
             </a:pPr>
+            <a:endParaRPr lang="en-US"/>
           </a:p>
         </c:txPr>
         <c:crossAx val="-2113994440"/>
@@ -1292,14 +1371,18 @@
       </c:catAx>
       <c:valAx>
         <c:axId val="-2113994440"/>
-        <c:scaling/>
-        <c:delete/>
+        <c:scaling>
+          <c:orientation val="minMax"/>
+        </c:scaling>
+        <c:delete val="1"/>
         <c:axPos val="l"/>
+        <c:numFmt formatCode="General" sourceLinked="1"/>
         <c:majorTickMark val="out"/>
         <c:minorTickMark val="none"/>
         <c:tickLblPos val="nextTo"/>
         <c:crossAx val="-2068027336"/>
         <c:crosses val="autoZero"/>
+        <c:crossBetween val="between"/>
       </c:valAx>
     </c:plotArea>
     <c:legend>
@@ -1316,10 +1399,13 @@
               </a:solidFill>
             </a:defRPr>
           </a:pPr>
+          <a:endParaRPr lang="en-US"/>
         </a:p>
       </c:txPr>
     </c:legend>
+    <c:plotVisOnly val="1"/>
     <c:dispBlanksAs val="gap"/>
+    <c:showDLblsOverMax val="1"/>
   </c:chart>
   <c:txPr>
     <a:bodyPr/>
@@ -1359,234 +1445,10 @@
           <a:chExt cx="0" cy="0"/>
         </a:xfrm>
       </p:grpSpPr>
-      <p:sp>
-        <p:nvSpPr>
-          <p:cNvPr id="2" name="Header Placeholder 1"/>
-          <p:cNvSpPr>
-            <a:spLocks noGrp="1"/>
-          </p:cNvSpPr>
-          <p:nvPr>
-            <p:ph type="hdr" sz="quarter"/>
-          </p:nvPr>
-        </p:nvSpPr>
-        <p:spPr>
-          <a:xfrm>
-            <a:off x="0" y="0"/>
-            <a:ext cx="2971800" cy="458788"/>
-          </a:xfrm>
-          <a:prstGeom prst="rect">
-            <a:avLst/>
-          </a:prstGeom>
-        </p:spPr>
-        <p:txBody>
-          <a:bodyPr vert="horz" lIns="91440" tIns="45720" rIns="91440" bIns="45720" rtlCol="0"/>
-          <a:lstStyle>
-            <a:lvl1pPr algn="l">
-              <a:defRPr sz="1200"/>
-            </a:lvl1pPr>
-          </a:lstStyle>
-          <a:p>
-            <a:endParaRPr lang="en-US"/>
-          </a:p>
-        </p:txBody>
-      </p:sp>
-      <p:sp>
-        <p:nvSpPr>
-          <p:cNvPr id="3" name="Date Placeholder 2"/>
-          <p:cNvSpPr>
-            <a:spLocks noGrp="1"/>
-          </p:cNvSpPr>
-          <p:nvPr>
-            <p:ph type="dt" idx="1"/>
-          </p:nvPr>
-        </p:nvSpPr>
-        <p:spPr>
-          <a:xfrm>
-            <a:off x="3884613" y="0"/>
-            <a:ext cx="2971800" cy="458788"/>
-          </a:xfrm>
-          <a:prstGeom prst="rect">
-            <a:avLst/>
-          </a:prstGeom>
-        </p:spPr>
-        <p:txBody>
-          <a:bodyPr vert="horz" lIns="91440" tIns="45720" rIns="91440" bIns="45720" rtlCol="0"/>
-          <a:lstStyle>
-            <a:lvl1pPr algn="r">
-              <a:defRPr sz="1200"/>
-            </a:lvl1pPr>
-          </a:lstStyle>
-          <a:p>
-            <a:fld id="{5282F153-3F37-0F45-9E97-73ACFA13230C}" type="datetimeFigureOut">
-              <a:rPr lang="en-US"/>
-              <a:t>7/23/19</a:t>
-            </a:fld>
-            <a:endParaRPr lang="en-US"/>
-          </a:p>
-        </p:txBody>
-      </p:sp>
-      <p:sp>
-        <p:nvSpPr>
-          <p:cNvPr id="4" name="Slide Image Placeholder 3"/>
-          <p:cNvSpPr>
-            <a:spLocks noGrp="1" noRot="1" noChangeAspect="1"/>
-          </p:cNvSpPr>
-          <p:nvPr>
-            <p:ph type="sldImg" idx="2"/>
-          </p:nvPr>
-        </p:nvSpPr>
-        <p:spPr>
-          <a:xfrm>
-            <a:off x="685800" y="1143000"/>
-            <a:ext cx="5486400" cy="3086100"/>
-          </a:xfrm>
-          <a:prstGeom prst="rect">
-            <a:avLst/>
-          </a:prstGeom>
-          <a:noFill/>
-          <a:ln w="12700">
-            <a:solidFill>
-              <a:prstClr val="black"/>
-            </a:solidFill>
-          </a:ln>
-        </p:spPr>
-        <p:txBody>
-          <a:bodyPr vert="horz" lIns="91440" tIns="45720" rIns="91440" bIns="45720" rtlCol="0" anchor="ctr"/>
-          <a:lstStyle/>
-          <a:p>
-            <a:endParaRPr lang="en-US"/>
-          </a:p>
-        </p:txBody>
-      </p:sp>
-      <p:sp>
-        <p:nvSpPr>
-          <p:cNvPr id="5" name="Notes Placeholder 4"/>
-          <p:cNvSpPr>
-            <a:spLocks noGrp="1"/>
-          </p:cNvSpPr>
-          <p:nvPr>
-            <p:ph type="body" sz="quarter" idx="3"/>
-          </p:nvPr>
-        </p:nvSpPr>
-        <p:spPr>
-          <a:xfrm>
-            <a:off x="685800" y="4400550"/>
-            <a:ext cx="5486400" cy="3600450"/>
-          </a:xfrm>
-          <a:prstGeom prst="rect">
-            <a:avLst/>
-          </a:prstGeom>
-        </p:spPr>
-        <p:txBody>
-          <a:bodyPr vert="horz" lIns="91440" tIns="45720" rIns="91440" bIns="45720" rtlCol="0"/>
-          <a:lstStyle/>
-          <a:p>
-            <a:pPr lvl="0"/>
-            <a:r>
-              <a:rPr lang="en-US"/>
-              <a:t>Click to edit Master text styles</a:t>
-            </a:r>
-          </a:p>
-          <a:p>
-            <a:pPr lvl="1"/>
-            <a:r>
-              <a:rPr lang="en-US"/>
-              <a:t>Second level</a:t>
-            </a:r>
-          </a:p>
-          <a:p>
-            <a:pPr lvl="2"/>
-            <a:r>
-              <a:rPr lang="en-US"/>
-              <a:t>Third level</a:t>
-            </a:r>
-          </a:p>
-          <a:p>
-            <a:pPr lvl="3"/>
-            <a:r>
-              <a:rPr lang="en-US"/>
-              <a:t>Fourth level</a:t>
-            </a:r>
-          </a:p>
-          <a:p>
-            <a:pPr lvl="4"/>
-            <a:r>
-              <a:rPr lang="en-US"/>
-              <a:t>Fifth level</a:t>
-            </a:r>
-          </a:p>
-        </p:txBody>
-      </p:sp>
-      <p:sp>
-        <p:nvSpPr>
-          <p:cNvPr id="6" name="Footer Placeholder 5"/>
-          <p:cNvSpPr>
-            <a:spLocks noGrp="1"/>
-          </p:cNvSpPr>
-          <p:nvPr>
-            <p:ph type="ftr" sz="quarter" idx="4"/>
-          </p:nvPr>
-        </p:nvSpPr>
-        <p:spPr>
-          <a:xfrm>
-            <a:off x="0" y="8685213"/>
-            <a:ext cx="2971800" cy="458787"/>
-          </a:xfrm>
-          <a:prstGeom prst="rect">
-            <a:avLst/>
-          </a:prstGeom>
-        </p:spPr>
-        <p:txBody>
-          <a:bodyPr vert="horz" lIns="91440" tIns="45720" rIns="91440" bIns="45720" rtlCol="0" anchor="b"/>
-          <a:lstStyle>
-            <a:lvl1pPr algn="l">
-              <a:defRPr sz="1200"/>
-            </a:lvl1pPr>
-          </a:lstStyle>
-          <a:p>
-            <a:endParaRPr lang="en-US"/>
-          </a:p>
-        </p:txBody>
-      </p:sp>
-      <p:sp>
-        <p:nvSpPr>
-          <p:cNvPr id="7" name="Slide Number Placeholder 6"/>
-          <p:cNvSpPr>
-            <a:spLocks noGrp="1"/>
-          </p:cNvSpPr>
-          <p:nvPr>
-            <p:ph type="sldNum" sz="quarter" idx="5"/>
-          </p:nvPr>
-        </p:nvSpPr>
-        <p:spPr>
-          <a:xfrm>
-            <a:off x="3884613" y="8685213"/>
-            <a:ext cx="2971800" cy="458787"/>
-          </a:xfrm>
-          <a:prstGeom prst="rect">
-            <a:avLst/>
-          </a:prstGeom>
-        </p:spPr>
-        <p:txBody>
-          <a:bodyPr vert="horz" lIns="91440" tIns="45720" rIns="91440" bIns="45720" rtlCol="0" anchor="b"/>
-          <a:lstStyle>
-            <a:lvl1pPr algn="r">
-              <a:defRPr sz="1200"/>
-            </a:lvl1pPr>
-          </a:lstStyle>
-          <a:p>
-            <a:fld id="{CE5E9CC1-C706-0F49-92D6-E571CC5EEA8F}" type="slidenum">
-              <a:rPr lang="en-US"/>
-              <a:t>‹#›</a:t>
-            </a:fld>
-            <a:endParaRPr lang="en-US"/>
-          </a:p>
-        </p:txBody>
-      </p:sp>
     </p:spTree>
     <p:extLst>
       <p:ext uri="{BB962C8B-B14F-4D97-AF65-F5344CB8AC3E}">
-        <p14:creationId xmlns:p14="http://schemas.microsoft.com/office/powerpoint/2010/main" val="1024086991"/>
+        <p14:creationId xmlns:p14="http://schemas.microsoft.com/office/powerpoint/2010/main" val="962057408"/>
       </p:ext>
     </p:extLst>
   </p:cSld>
@@ -2117,7 +1979,7 @@
 </file>
 
 <file path=ppt/notesSlides/notesSlide6.xml><?xml version="1.0" encoding="utf-8"?>
-<p:notes xmlns:a="http://schemas.openxmlformats.org/drawingml/2006/main" xmlns:p="http://schemas.openxmlformats.org/presentationml/2006/main" xmlns:r="http://schemas.openxmlformats.org/officeDocument/2006/relationships">
+<p:notes xmlns:a="http://schemas.openxmlformats.org/drawingml/2006/main" xmlns:r="http://schemas.openxmlformats.org/officeDocument/2006/relationships" xmlns:p="http://schemas.openxmlformats.org/presentationml/2006/main">
   <p:cSld>
     <p:spTree>
       <p:nvGrpSpPr>
@@ -2137,7 +1999,7 @@
         <p:nvSpPr>
           <p:cNvPr id="2" name="Slide Image Placeholder 1"/>
           <p:cNvSpPr>
-            <a:spLocks noGrp="1"/>
+            <a:spLocks noGrp="1" noRot="1" noChangeAspect="1"/>
           </p:cNvSpPr>
           <p:nvPr>
             <p:ph type="sldImg" idx="2"/>
@@ -2152,7 +2014,7 @@
             <a:spLocks noGrp="1"/>
           </p:cNvSpPr>
           <p:nvPr>
-            <p:ph type="body" idx="3" sz="quarter"/>
+            <p:ph type="body" sz="quarter" idx="3"/>
           </p:nvPr>
         </p:nvSpPr>
         <p:spPr/>
@@ -2173,7 +2035,7 @@
             <a:spLocks noGrp="1"/>
           </p:cNvSpPr>
           <p:nvPr>
-            <p:ph type="sldNum" idx="5" sz="quarter"/>
+            <p:ph type="sldNum" sz="quarter" idx="5"/>
           </p:nvPr>
         </p:nvSpPr>
         <p:spPr/>
@@ -2187,7 +2049,7 @@
 </file>
 
 <file path=ppt/notesSlides/notesSlide7.xml><?xml version="1.0" encoding="utf-8"?>
-<p:notes xmlns:a="http://schemas.openxmlformats.org/drawingml/2006/main" xmlns:p="http://schemas.openxmlformats.org/presentationml/2006/main" xmlns:r="http://schemas.openxmlformats.org/officeDocument/2006/relationships">
+<p:notes xmlns:a="http://schemas.openxmlformats.org/drawingml/2006/main" xmlns:r="http://schemas.openxmlformats.org/officeDocument/2006/relationships" xmlns:p="http://schemas.openxmlformats.org/presentationml/2006/main">
   <p:cSld>
     <p:spTree>
       <p:nvGrpSpPr>
@@ -2207,7 +2069,7 @@
         <p:nvSpPr>
           <p:cNvPr id="2" name="Slide Image Placeholder 1"/>
           <p:cNvSpPr>
-            <a:spLocks noGrp="1"/>
+            <a:spLocks noGrp="1" noRot="1" noChangeAspect="1"/>
           </p:cNvSpPr>
           <p:nvPr>
             <p:ph type="sldImg" idx="2"/>
@@ -2222,7 +2084,7 @@
             <a:spLocks noGrp="1"/>
           </p:cNvSpPr>
           <p:nvPr>
-            <p:ph type="body" idx="3" sz="quarter"/>
+            <p:ph type="body" sz="quarter" idx="3"/>
           </p:nvPr>
         </p:nvSpPr>
         <p:spPr/>
@@ -2231,7 +2093,7 @@
           <a:lstStyle/>
           <a:p>
             <a:r>
-              <a:t>Largest per-resume gaps on the 14B run. Single wins: P06 (0.97 vs 0.00), P11 (0.56 vs 0.37), P09 (0.79 vs 0.61), P15 (0.65 vs 0.47). Multi-agent wins: P20 (0.37 vs 0.65), P23 (0.25 vs 0.45), P13 (0.73 vs 0.89), P22 (0.85 vs 1.00). P14 tied exactly. Full table is in paired_resumes.csv.</a:t>
+              <a:t>Real model output for eval resume P05, a software test analyst background with a pool of 20 jobs where 16 are relevant (random Precision@5 is 0.80). This is a typical case: nDCG@5 is 0.515 for the single agent and 0.518 for the orchestrator, and both get 4 of 5 relevant. They pick different jobs: the single agent leans toward engineering roles, the orchestrator toward business analyst and QA automation roles, and it puts a no-fit ServiceNow BA job first. For contrast, the biggest gap of the 28 resumes is P06 (software engineer resume, 8 jobs): the orchestrator's ranker picked five accounting jobs, 0 of 5 relevant, nDCG@5 0.00, while single got 0.97. That one is on the per-resume slide; it is an outlier, not the typical case. Explanations are sometimes cut off at the 300-character limit.</a:t>
             </a:r>
           </a:p>
         </p:txBody>
@@ -2243,7 +2105,7 @@
             <a:spLocks noGrp="1"/>
           </p:cNvSpPr>
           <p:nvPr>
-            <p:ph type="sldNum" idx="5" sz="quarter"/>
+            <p:ph type="sldNum" sz="quarter" idx="5"/>
           </p:nvPr>
         </p:nvSpPr>
         <p:spPr/>
@@ -2257,7 +2119,7 @@
 </file>
 
 <file path=ppt/notesSlides/notesSlide8.xml><?xml version="1.0" encoding="utf-8"?>
-<p:notes xmlns:a="http://schemas.openxmlformats.org/drawingml/2006/main" xmlns:p="http://schemas.openxmlformats.org/presentationml/2006/main" xmlns:r="http://schemas.openxmlformats.org/officeDocument/2006/relationships">
+<p:notes xmlns:a="http://schemas.openxmlformats.org/drawingml/2006/main" xmlns:r="http://schemas.openxmlformats.org/officeDocument/2006/relationships" xmlns:p="http://schemas.openxmlformats.org/presentationml/2006/main">
   <p:cSld>
     <p:spTree>
       <p:nvGrpSpPr>
@@ -2277,7 +2139,7 @@
         <p:nvSpPr>
           <p:cNvPr id="2" name="Slide Image Placeholder 1"/>
           <p:cNvSpPr>
-            <a:spLocks noGrp="1"/>
+            <a:spLocks noGrp="1" noRot="1" noChangeAspect="1"/>
           </p:cNvSpPr>
           <p:nvPr>
             <p:ph type="sldImg" idx="2"/>
@@ -2292,7 +2154,7 @@
             <a:spLocks noGrp="1"/>
           </p:cNvSpPr>
           <p:nvPr>
-            <p:ph type="body" idx="3" sz="quarter"/>
+            <p:ph type="body" sz="quarter" idx="3"/>
           </p:nvPr>
         </p:nvSpPr>
         <p:spPr/>
@@ -2301,7 +2163,7 @@
           <a:lstStyle/>
           <a:p>
             <a:r>
-              <a:t>Real model output for eval resume P05, a software test analyst background with a pool of 20 jobs where 16 are relevant (random Precision@5 is 0.80). This is a typical case: nDCG@5 is 0.515 for the single agent and 0.518 for the orchestrator, and both get 4 of 5 relevant. They pick different jobs: the single agent leans toward engineering roles, the orchestrator toward business analyst and QA automation roles, and it puts a no-fit ServiceNow BA job first. For contrast, the biggest gap of the 28 resumes is P06 (software engineer resume, 8 jobs): the orchestrator's ranker picked five accounting jobs, 0 of 5 relevant, nDCG@5 0.00, while single got 0.97. That one is on the per-resume slide; it is an outlier, not the typical case. Explanations are sometimes cut off at the 300-character limit.</a:t>
+              <a:t>Largest per-resume gaps on the 14B run. Single wins: P06 (0.97 vs 0.00), P11 (0.56 vs 0.37), P09 (0.79 vs 0.61), P15 (0.65 vs 0.47). Multi-agent wins: P20 (0.37 vs 0.65), P23 (0.25 vs 0.45), P13 (0.73 vs 0.89), P22 (0.85 vs 1.00). P14 tied exactly. Full table is in paired_resumes.csv.</a:t>
             </a:r>
           </a:p>
         </p:txBody>
@@ -2313,7 +2175,7 @@
             <a:spLocks noGrp="1"/>
           </p:cNvSpPr>
           <p:nvPr>
-            <p:ph type="sldNum" idx="5" sz="quarter"/>
+            <p:ph type="sldNum" sz="quarter" idx="5"/>
           </p:nvPr>
         </p:nvSpPr>
         <p:spPr/>
@@ -2364,6 +2226,7 @@
         <a:solidFill>
           <a:srgbClr val="14213D"/>
         </a:solidFill>
+        <a:effectLst/>
       </p:bgPr>
     </p:bg>
     <p:spTree>
@@ -2383,9 +2246,11 @@
       <p:sp>
         <p:nvSpPr>
           <p:cNvPr id="2" name="Text 0"/>
-          <p:cNvSpPr/>
+          <p:cNvSpPr>
+            <a:spLocks noGrp="1"/>
+          </p:cNvSpPr>
           <p:nvPr>
-            <p:ph idx="100" type="title" hasCustomPrompt="1"/>
+            <p:ph type="title" idx="100" hasCustomPrompt="1"/>
           </p:nvPr>
         </p:nvSpPr>
         <p:spPr>
@@ -2402,7 +2267,7 @@
         <p:txBody>
           <a:bodyPr wrap="square" rtlCol="0"/>
           <a:lstStyle>
-            <a:lvl1pPr algn="l" indent="0" marL="0">
+            <a:lvl1pPr marL="0" indent="0" algn="l">
               <a:buNone/>
               <a:defRPr lang="en-US" sz="4800" b="1" dirty="0">
                 <a:solidFill>
@@ -2412,7 +2277,7 @@
             </a:lvl1pPr>
           </a:lstStyle>
           <a:p>
-            <a:pPr algn="l" indent="0" marL="0">
+            <a:pPr marL="0" indent="0" algn="l">
               <a:buNone/>
             </a:pPr>
             <a:endParaRPr lang="en-US" sz="4800" dirty="0"/>
@@ -2435,6 +2300,7 @@
         <a:solidFill>
           <a:srgbClr val="F7F5EF"/>
         </a:solidFill>
+        <a:effectLst/>
       </p:bgPr>
     </p:bg>
     <p:spTree>
@@ -2454,9 +2320,11 @@
       <p:sp>
         <p:nvSpPr>
           <p:cNvPr id="2" name="Text 0"/>
-          <p:cNvSpPr/>
+          <p:cNvSpPr>
+            <a:spLocks noGrp="1"/>
+          </p:cNvSpPr>
           <p:nvPr>
-            <p:ph idx="100" type="title" hasCustomPrompt="1"/>
+            <p:ph type="title" idx="100" hasCustomPrompt="1"/>
           </p:nvPr>
         </p:nvSpPr>
         <p:spPr>
@@ -2473,7 +2341,7 @@
         <p:txBody>
           <a:bodyPr wrap="square" rtlCol="0"/>
           <a:lstStyle>
-            <a:lvl1pPr algn="l" indent="0" marL="0">
+            <a:lvl1pPr marL="0" indent="0" algn="l">
               <a:buNone/>
               <a:defRPr lang="en-US" sz="2800" b="1" dirty="0">
                 <a:solidFill>
@@ -2483,7 +2351,7 @@
             </a:lvl1pPr>
           </a:lstStyle>
           <a:p>
-            <a:pPr algn="l" indent="0" marL="0">
+            <a:pPr marL="0" indent="0" algn="l">
               <a:buNone/>
             </a:pPr>
             <a:endParaRPr lang="en-US" sz="2800" dirty="0"/>
@@ -2510,7 +2378,7 @@
           </a:prstGeom>
           <a:extLst>
             <a:ext uri="{C572A759-6A51-4108-AA02-DFA0A04FC94B}">
-              <ma14:wrappingTextBoxFlag xmlns:ma14="http://schemas.microsoft.com/office/mac/drawingml/2011/main" val="0"/>
+              <ma14:wrappingTextBoxFlag xmlns:ma14="http://schemas.microsoft.com/office/mac/drawingml/2011/main" xmlns="" val="0"/>
             </a:ext>
           </a:extLst>
         </p:spPr>
@@ -2531,8 +2399,8 @@
           <a:p>
             <a:pPr algn="l"/>
             <a:fld id="{F7021451-1387-4CA6-816F-3879F97B5CBC}" type="slidenum">
-              <a:rPr b="0" lang="en-US"/>
-              <a:t>1003</a:t>
+              <a:rPr lang="en-US" b="0"/>
+              <a:t>‹#›</a:t>
             </a:fld>
             <a:endParaRPr lang="en-US"/>
           </a:p>
@@ -2549,6 +2417,11 @@
 <file path=ppt/slideMasters/slideMaster1.xml><?xml version="1.0" encoding="utf-8"?>
 <p:sldMaster xmlns:a="http://schemas.openxmlformats.org/drawingml/2006/main" xmlns:r="http://schemas.openxmlformats.org/officeDocument/2006/relationships" xmlns:p="http://schemas.openxmlformats.org/presentationml/2006/main">
   <p:cSld>
+    <p:bg>
+      <p:bgRef idx="1001">
+        <a:schemeClr val="bg1"/>
+      </p:bgRef>
+    </p:bg>
     <p:spTree>
       <p:nvGrpSpPr>
         <p:cNvPr id="1" name=""/>
@@ -2583,7 +2456,7 @@
           </a:prstGeom>
           <a:extLst>
             <a:ext uri="{C572A759-6A51-4108-AA02-DFA0A04FC94B}">
-              <ma14:wrappingTextBoxFlag xmlns:ma14="http://schemas.microsoft.com/office/mac/drawingml/2011/main" val="0"/>
+              <ma14:wrappingTextBoxFlag xmlns:ma14="http://schemas.microsoft.com/office/mac/drawingml/2011/main" xmlns="" val="0"/>
             </a:ext>
           </a:extLst>
         </p:spPr>
@@ -2604,8 +2477,8 @@
           <a:p>
             <a:pPr algn="l"/>
             <a:fld id="{F7021451-1387-4CA6-816F-3879F97B5CBC}" type="slidenum">
-              <a:rPr b="0" lang="en-US"/>
-              <a:t>null</a:t>
+              <a:rPr lang="en-US" b="0"/>
+              <a:t>‹#›</a:t>
             </a:fld>
             <a:endParaRPr lang="en-US"/>
           </a:p>
@@ -2911,11 +2784,11 @@
           <a:bodyPr wrap="square" lIns="0" tIns="0" rIns="0" bIns="0" rtlCol="0" anchor="ctr"/>
           <a:lstStyle/>
           <a:p>
-            <a:pPr indent="0" marL="0">
+            <a:pPr marL="0" indent="0">
               <a:buNone/>
             </a:pPr>
             <a:r>
-              <a:rPr lang="en-US" sz="1200" spc="200" kern="0" dirty="0">
+              <a:rPr lang="en-US" sz="1200" kern="0" spc="200" dirty="0">
                 <a:solidFill>
                   <a:srgbClr val="F2A65A"/>
                 </a:solidFill>
@@ -2932,9 +2805,11 @@
       <p:sp>
         <p:nvSpPr>
           <p:cNvPr id="3" name="Text 0"/>
-          <p:cNvSpPr/>
+          <p:cNvSpPr>
+            <a:spLocks noGrp="1"/>
+          </p:cNvSpPr>
           <p:nvPr>
-            <p:ph idx="100" type="title" hasCustomPrompt="1"/>
+            <p:ph type="title" idx="100" hasCustomPrompt="1"/>
           </p:nvPr>
         </p:nvSpPr>
         <p:spPr>
@@ -2952,7 +2827,7 @@
           <a:bodyPr wrap="square" lIns="0" tIns="0" rIns="0" bIns="0" rtlCol="0" anchor="t"/>
           <a:lstStyle/>
           <a:p>
-            <a:pPr algn="l" indent="0" marL="0">
+            <a:pPr marL="0" indent="0" algn="l">
               <a:buNone/>
             </a:pPr>
             <a:r>
@@ -2988,7 +2863,7 @@
           <a:bodyPr wrap="square" lIns="0" tIns="0" rIns="0" bIns="0" rtlCol="0" anchor="ctr"/>
           <a:lstStyle/>
           <a:p>
-            <a:pPr indent="0" marL="0">
+            <a:pPr marL="0" indent="0">
               <a:buNone/>
             </a:pPr>
             <a:r>
@@ -3024,7 +2899,7 @@
           <a:bodyPr wrap="square" lIns="0" tIns="0" rIns="0" bIns="0" rtlCol="0" anchor="ctr"/>
           <a:lstStyle/>
           <a:p>
-            <a:pPr indent="0" marL="0">
+            <a:pPr marL="0" indent="0">
               <a:buNone/>
             </a:pPr>
             <a:r>
@@ -3060,7 +2935,7 @@
           <a:bodyPr wrap="square" lIns="0" tIns="0" rIns="0" bIns="0" rtlCol="0" anchor="ctr"/>
           <a:lstStyle/>
           <a:p>
-            <a:pPr indent="0" marL="0">
+            <a:pPr marL="0" indent="0">
               <a:buNone/>
             </a:pPr>
             <a:r>
@@ -3096,7 +2971,7 @@
           <a:bodyPr wrap="square" lIns="0" tIns="0" rIns="0" bIns="0" rtlCol="0" anchor="ctr"/>
           <a:lstStyle/>
           <a:p>
-            <a:pPr indent="0" marL="0">
+            <a:pPr marL="0" indent="0">
               <a:buNone/>
             </a:pPr>
             <a:r>
@@ -3157,11 +3032,11 @@
           <a:bodyPr wrap="square" lIns="0" tIns="0" rIns="0" bIns="0" rtlCol="0" anchor="ctr"/>
           <a:lstStyle/>
           <a:p>
-            <a:pPr indent="0" marL="0">
+            <a:pPr marL="0" indent="0">
               <a:buNone/>
             </a:pPr>
             <a:r>
-              <a:rPr lang="en-US" sz="1200" spc="150" kern="0" dirty="0">
+              <a:rPr lang="en-US" sz="1200" kern="0" spc="150" dirty="0">
                 <a:solidFill>
                   <a:srgbClr val="B85C1E"/>
                 </a:solidFill>
@@ -3200,7 +3075,7 @@
           <a:bodyPr wrap="square" lIns="0" tIns="0" rIns="0" bIns="0" rtlCol="0" anchor="ctr"/>
           <a:lstStyle/>
           <a:p>
-            <a:pPr algn="ctr" indent="0" marL="0">
+            <a:pPr marL="0" indent="0" algn="ctr">
               <a:buNone/>
             </a:pPr>
             <a:r>
@@ -3218,9 +3093,11 @@
       <p:sp>
         <p:nvSpPr>
           <p:cNvPr id="4" name="Text 0"/>
-          <p:cNvSpPr/>
+          <p:cNvSpPr>
+            <a:spLocks noGrp="1"/>
+          </p:cNvSpPr>
           <p:nvPr>
-            <p:ph idx="100" type="title" hasCustomPrompt="1"/>
+            <p:ph type="title" idx="100" hasCustomPrompt="1"/>
           </p:nvPr>
         </p:nvSpPr>
         <p:spPr>
@@ -3238,7 +3115,7 @@
           <a:bodyPr wrap="square" lIns="0" tIns="0" rIns="0" bIns="0" rtlCol="0" anchor="t"/>
           <a:lstStyle/>
           <a:p>
-            <a:pPr algn="l" indent="0" marL="0">
+            <a:pPr marL="0" indent="0" algn="l">
               <a:buNone/>
             </a:pPr>
             <a:r>
@@ -3279,6 +3156,13 @@
             <a:prstDash val="solid"/>
           </a:ln>
         </p:spPr>
+        <p:txBody>
+          <a:bodyPr/>
+          <a:lstStyle/>
+          <a:p>
+            <a:endParaRPr lang="en-US"/>
+          </a:p>
+        </p:txBody>
       </p:sp>
       <p:sp>
         <p:nvSpPr>
@@ -3301,7 +3185,7 @@
           <a:bodyPr wrap="square" lIns="0" tIns="0" rIns="0" bIns="0" rtlCol="0" anchor="ctr"/>
           <a:lstStyle/>
           <a:p>
-            <a:pPr indent="0" marL="0">
+            <a:pPr marL="0" indent="0">
               <a:buNone/>
             </a:pPr>
             <a:r>
@@ -3337,7 +3221,7 @@
           <a:bodyPr wrap="square" lIns="0" tIns="0" rIns="0" bIns="0" rtlCol="0" anchor="t"/>
           <a:lstStyle/>
           <a:p>
-            <a:pPr indent="0" marL="0">
+            <a:pPr marL="0" indent="0">
               <a:buNone/>
             </a:pPr>
             <a:r>
@@ -3378,6 +3262,13 @@
             <a:prstDash val="solid"/>
           </a:ln>
         </p:spPr>
+        <p:txBody>
+          <a:bodyPr/>
+          <a:lstStyle/>
+          <a:p>
+            <a:endParaRPr lang="en-US"/>
+          </a:p>
+        </p:txBody>
       </p:sp>
       <p:sp>
         <p:nvSpPr>
@@ -3400,7 +3291,7 @@
           <a:bodyPr wrap="square" lIns="0" tIns="0" rIns="0" bIns="0" rtlCol="0" anchor="ctr"/>
           <a:lstStyle/>
           <a:p>
-            <a:pPr indent="0" marL="0">
+            <a:pPr marL="0" indent="0">
               <a:buNone/>
             </a:pPr>
             <a:r>
@@ -3436,7 +3327,7 @@
           <a:bodyPr wrap="square" lIns="0" tIns="0" rIns="0" bIns="0" rtlCol="0" anchor="t"/>
           <a:lstStyle/>
           <a:p>
-            <a:pPr indent="0" marL="0">
+            <a:pPr marL="0" indent="0">
               <a:buNone/>
             </a:pPr>
             <a:r>
@@ -3477,6 +3368,13 @@
             <a:prstDash val="solid"/>
           </a:ln>
         </p:spPr>
+        <p:txBody>
+          <a:bodyPr/>
+          <a:lstStyle/>
+          <a:p>
+            <a:endParaRPr lang="en-US"/>
+          </a:p>
+        </p:txBody>
       </p:sp>
       <p:sp>
         <p:nvSpPr>
@@ -3499,7 +3397,7 @@
           <a:bodyPr wrap="square" lIns="0" tIns="0" rIns="0" bIns="0" rtlCol="0" anchor="ctr"/>
           <a:lstStyle/>
           <a:p>
-            <a:pPr indent="0" marL="0">
+            <a:pPr marL="0" indent="0">
               <a:buNone/>
             </a:pPr>
             <a:r>
@@ -3535,7 +3433,7 @@
           <a:bodyPr wrap="square" lIns="0" tIns="0" rIns="0" bIns="0" rtlCol="0" anchor="t"/>
           <a:lstStyle/>
           <a:p>
-            <a:pPr indent="0" marL="0">
+            <a:pPr marL="0" indent="0">
               <a:buNone/>
             </a:pPr>
             <a:r>
@@ -3576,6 +3474,13 @@
             <a:prstDash val="solid"/>
           </a:ln>
         </p:spPr>
+        <p:txBody>
+          <a:bodyPr/>
+          <a:lstStyle/>
+          <a:p>
+            <a:endParaRPr lang="en-US"/>
+          </a:p>
+        </p:txBody>
       </p:sp>
       <p:sp>
         <p:nvSpPr>
@@ -3598,7 +3503,7 @@
           <a:bodyPr wrap="square" lIns="0" tIns="0" rIns="0" bIns="0" rtlCol="0" anchor="ctr"/>
           <a:lstStyle/>
           <a:p>
-            <a:pPr indent="0" marL="0">
+            <a:pPr marL="0" indent="0">
               <a:buNone/>
             </a:pPr>
             <a:r>
@@ -3634,7 +3539,7 @@
           <a:bodyPr wrap="square" lIns="0" tIns="0" rIns="0" bIns="0" rtlCol="0" anchor="t"/>
           <a:lstStyle/>
           <a:p>
-            <a:pPr indent="0" marL="0">
+            <a:pPr marL="0" indent="0">
               <a:buNone/>
             </a:pPr>
             <a:r>
@@ -3670,7 +3575,7 @@
           <a:bodyPr wrap="square" lIns="0" tIns="0" rIns="0" bIns="0" rtlCol="0" anchor="ctr"/>
           <a:lstStyle/>
           <a:p>
-            <a:pPr indent="0" marL="0">
+            <a:pPr marL="0" indent="0">
               <a:buNone/>
             </a:pPr>
             <a:r>
@@ -3782,7 +3687,7 @@
           <a:bodyPr wrap="square" lIns="0" tIns="0" rIns="0" bIns="0" rtlCol="0" anchor="ctr"/>
           <a:lstStyle/>
           <a:p>
-            <a:pPr indent="0" marL="0">
+            <a:pPr marL="0" indent="0">
               <a:buNone/>
             </a:pPr>
             <a:r>
@@ -3875,7 +3780,7 @@
           </a:prstGeom>
           <a:extLst>
             <a:ext uri="{C572A759-6A51-4108-AA02-DFA0A04FC94B}">
-              <ma14:wrappingTextBoxFlag xmlns:ma14="http://schemas.microsoft.com/office/mac/drawingml/2011/main" val="0"/>
+              <ma14:wrappingTextBoxFlag xmlns:ma14="http://schemas.microsoft.com/office/mac/drawingml/2011/main" xmlns="" val="0"/>
             </a:ext>
           </a:extLst>
         </p:spPr>
@@ -3896,7 +3801,7 @@
           <a:p>
             <a:pPr algn="l"/>
             <a:fld id="{F7021451-1387-4CA6-816F-3879F97B5CBC}" type="slidenum">
-              <a:rPr b="0" lang="en-US"/>
+              <a:rPr lang="en-US" b="0"/>
               <a:t>2</a:t>
             </a:fld>
             <a:endParaRPr lang="en-US"/>
@@ -3949,11 +3854,11 @@
           <a:bodyPr wrap="square" lIns="0" tIns="0" rIns="0" bIns="0" rtlCol="0" anchor="ctr"/>
           <a:lstStyle/>
           <a:p>
-            <a:pPr indent="0" marL="0">
+            <a:pPr marL="0" indent="0">
               <a:buNone/>
             </a:pPr>
             <a:r>
-              <a:rPr lang="en-US" sz="1200" spc="150" kern="0" dirty="0">
+              <a:rPr lang="en-US" sz="1200" kern="0" spc="150" dirty="0">
                 <a:solidFill>
                   <a:srgbClr val="B85C1E"/>
                 </a:solidFill>
@@ -3992,7 +3897,7 @@
           <a:bodyPr wrap="square" lIns="0" tIns="0" rIns="0" bIns="0" rtlCol="0" anchor="ctr"/>
           <a:lstStyle/>
           <a:p>
-            <a:pPr algn="ctr" indent="0" marL="0">
+            <a:pPr marL="0" indent="0" algn="ctr">
               <a:buNone/>
             </a:pPr>
             <a:r>
@@ -4010,9 +3915,11 @@
       <p:sp>
         <p:nvSpPr>
           <p:cNvPr id="4" name="Text 0"/>
-          <p:cNvSpPr/>
+          <p:cNvSpPr>
+            <a:spLocks noGrp="1"/>
+          </p:cNvSpPr>
           <p:nvPr>
-            <p:ph idx="100" type="title" hasCustomPrompt="1"/>
+            <p:ph type="title" idx="100" hasCustomPrompt="1"/>
           </p:nvPr>
         </p:nvSpPr>
         <p:spPr>
@@ -4030,7 +3937,7 @@
           <a:bodyPr wrap="square" lIns="0" tIns="0" rIns="0" bIns="0" rtlCol="0" anchor="t"/>
           <a:lstStyle/>
           <a:p>
-            <a:pPr algn="l" indent="0" marL="0">
+            <a:pPr marL="0" indent="0" algn="l">
               <a:buNone/>
             </a:pPr>
             <a:r>
@@ -4071,6 +3978,13 @@
             <a:prstDash val="solid"/>
           </a:ln>
         </p:spPr>
+        <p:txBody>
+          <a:bodyPr/>
+          <a:lstStyle/>
+          <a:p>
+            <a:endParaRPr lang="en-US"/>
+          </a:p>
+        </p:txBody>
       </p:sp>
       <p:sp>
         <p:nvSpPr>
@@ -4097,7 +4011,7 @@
           <a:bodyPr wrap="square" lIns="50800" tIns="50800" rIns="50800" bIns="50800" rtlCol="0" anchor="ctr"/>
           <a:lstStyle/>
           <a:p>
-            <a:pPr algn="ctr" indent="0" marL="0">
+            <a:pPr marL="0" indent="0" algn="ctr">
               <a:buNone/>
             </a:pPr>
             <a:r>
@@ -4136,6 +4050,13 @@
             <a:prstDash val="solid"/>
           </a:ln>
         </p:spPr>
+        <p:txBody>
+          <a:bodyPr/>
+          <a:lstStyle/>
+          <a:p>
+            <a:endParaRPr lang="en-US"/>
+          </a:p>
+        </p:txBody>
       </p:sp>
       <p:sp>
         <p:nvSpPr>
@@ -4162,7 +4083,7 @@
           <a:bodyPr wrap="square" lIns="50800" tIns="50800" rIns="50800" bIns="50800" rtlCol="0" anchor="ctr"/>
           <a:lstStyle/>
           <a:p>
-            <a:pPr algn="ctr" indent="0" marL="0">
+            <a:pPr marL="0" indent="0" algn="ctr">
               <a:buNone/>
             </a:pPr>
             <a:r>
@@ -4201,6 +4122,13 @@
             <a:prstDash val="solid"/>
           </a:ln>
         </p:spPr>
+        <p:txBody>
+          <a:bodyPr/>
+          <a:lstStyle/>
+          <a:p>
+            <a:endParaRPr lang="en-US"/>
+          </a:p>
+        </p:txBody>
       </p:sp>
       <p:sp>
         <p:nvSpPr>
@@ -4227,7 +4155,7 @@
           <a:bodyPr wrap="square" lIns="50800" tIns="50800" rIns="50800" bIns="50800" rtlCol="0" anchor="ctr"/>
           <a:lstStyle/>
           <a:p>
-            <a:pPr algn="ctr" indent="0" marL="0">
+            <a:pPr marL="0" indent="0" algn="ctr">
               <a:buNone/>
             </a:pPr>
             <a:r>
@@ -4266,6 +4194,13 @@
             <a:prstDash val="solid"/>
           </a:ln>
         </p:spPr>
+        <p:txBody>
+          <a:bodyPr/>
+          <a:lstStyle/>
+          <a:p>
+            <a:endParaRPr lang="en-US"/>
+          </a:p>
+        </p:txBody>
       </p:sp>
       <p:sp>
         <p:nvSpPr>
@@ -4292,7 +4227,7 @@
           <a:bodyPr wrap="square" lIns="50800" tIns="50800" rIns="50800" bIns="50800" rtlCol="0" anchor="ctr"/>
           <a:lstStyle/>
           <a:p>
-            <a:pPr algn="ctr" indent="0" marL="0">
+            <a:pPr marL="0" indent="0" algn="ctr">
               <a:buNone/>
             </a:pPr>
             <a:r>
@@ -4328,7 +4263,7 @@
           <a:bodyPr wrap="square" lIns="0" tIns="0" rIns="0" bIns="0" rtlCol="0" anchor="ctr"/>
           <a:lstStyle/>
           <a:p>
-            <a:pPr indent="0" marL="0">
+            <a:pPr marL="0" indent="0">
               <a:buNone/>
             </a:pPr>
             <a:r>
@@ -4440,7 +4375,7 @@
           <a:bodyPr wrap="square" lIns="0" tIns="0" rIns="0" bIns="0" rtlCol="0" anchor="ctr"/>
           <a:lstStyle/>
           <a:p>
-            <a:pPr indent="0" marL="0">
+            <a:pPr marL="0" indent="0">
               <a:buNone/>
             </a:pPr>
             <a:r>
@@ -4533,7 +4468,7 @@
           </a:prstGeom>
           <a:extLst>
             <a:ext uri="{C572A759-6A51-4108-AA02-DFA0A04FC94B}">
-              <ma14:wrappingTextBoxFlag xmlns:ma14="http://schemas.microsoft.com/office/mac/drawingml/2011/main" val="0"/>
+              <ma14:wrappingTextBoxFlag xmlns:ma14="http://schemas.microsoft.com/office/mac/drawingml/2011/main" xmlns="" val="0"/>
             </a:ext>
           </a:extLst>
         </p:spPr>
@@ -4554,7 +4489,7 @@
           <a:p>
             <a:pPr algn="l"/>
             <a:fld id="{F7021451-1387-4CA6-816F-3879F97B5CBC}" type="slidenum">
-              <a:rPr b="0" lang="en-US"/>
+              <a:rPr lang="en-US" b="0"/>
               <a:t>3</a:t>
             </a:fld>
             <a:endParaRPr lang="en-US"/>
@@ -4607,11 +4542,11 @@
           <a:bodyPr wrap="square" lIns="0" tIns="0" rIns="0" bIns="0" rtlCol="0" anchor="ctr"/>
           <a:lstStyle/>
           <a:p>
-            <a:pPr indent="0" marL="0">
+            <a:pPr marL="0" indent="0">
               <a:buNone/>
             </a:pPr>
             <a:r>
-              <a:rPr lang="en-US" sz="1200" spc="150" kern="0" dirty="0">
+              <a:rPr lang="en-US" sz="1200" kern="0" spc="150" dirty="0">
                 <a:solidFill>
                   <a:srgbClr val="B85C1E"/>
                 </a:solidFill>
@@ -4650,7 +4585,7 @@
           <a:bodyPr wrap="square" lIns="0" tIns="0" rIns="0" bIns="0" rtlCol="0" anchor="ctr"/>
           <a:lstStyle/>
           <a:p>
-            <a:pPr algn="ctr" indent="0" marL="0">
+            <a:pPr marL="0" indent="0" algn="ctr">
               <a:buNone/>
             </a:pPr>
             <a:r>
@@ -4668,9 +4603,11 @@
       <p:sp>
         <p:nvSpPr>
           <p:cNvPr id="4" name="Text 0"/>
-          <p:cNvSpPr/>
+          <p:cNvSpPr>
+            <a:spLocks noGrp="1"/>
+          </p:cNvSpPr>
           <p:nvPr>
-            <p:ph idx="100" type="title" hasCustomPrompt="1"/>
+            <p:ph type="title" idx="100" hasCustomPrompt="1"/>
           </p:nvPr>
         </p:nvSpPr>
         <p:spPr>
@@ -4688,7 +4625,7 @@
           <a:bodyPr wrap="square" lIns="0" tIns="0" rIns="0" bIns="0" rtlCol="0" anchor="t"/>
           <a:lstStyle/>
           <a:p>
-            <a:pPr algn="l" indent="0" marL="0">
+            <a:pPr marL="0" indent="0" algn="l">
               <a:buNone/>
             </a:pPr>
             <a:r>
@@ -4729,6 +4666,13 @@
             <a:prstDash val="solid"/>
           </a:ln>
         </p:spPr>
+        <p:txBody>
+          <a:bodyPr/>
+          <a:lstStyle/>
+          <a:p>
+            <a:endParaRPr lang="en-US"/>
+          </a:p>
+        </p:txBody>
       </p:sp>
       <p:sp>
         <p:nvSpPr>
@@ -4755,7 +4699,7 @@
           <a:bodyPr wrap="square" lIns="50800" tIns="50800" rIns="50800" bIns="50800" rtlCol="0" anchor="ctr"/>
           <a:lstStyle/>
           <a:p>
-            <a:pPr algn="ctr" indent="0" marL="0">
+            <a:pPr marL="0" indent="0" algn="ctr">
               <a:buNone/>
             </a:pPr>
             <a:r>
@@ -4794,6 +4738,13 @@
             <a:prstDash val="solid"/>
           </a:ln>
         </p:spPr>
+        <p:txBody>
+          <a:bodyPr/>
+          <a:lstStyle/>
+          <a:p>
+            <a:endParaRPr lang="en-US"/>
+          </a:p>
+        </p:txBody>
       </p:sp>
       <p:sp>
         <p:nvSpPr>
@@ -4820,7 +4771,7 @@
           <a:bodyPr wrap="square" lIns="50800" tIns="50800" rIns="50800" bIns="50800" rtlCol="0" anchor="ctr"/>
           <a:lstStyle/>
           <a:p>
-            <a:pPr algn="ctr" indent="0" marL="0">
+            <a:pPr marL="0" indent="0" algn="ctr">
               <a:buNone/>
             </a:pPr>
             <a:r>
@@ -4859,6 +4810,13 @@
             <a:prstDash val="solid"/>
           </a:ln>
         </p:spPr>
+        <p:txBody>
+          <a:bodyPr/>
+          <a:lstStyle/>
+          <a:p>
+            <a:endParaRPr lang="en-US"/>
+          </a:p>
+        </p:txBody>
       </p:sp>
       <p:sp>
         <p:nvSpPr>
@@ -4885,7 +4843,7 @@
           <a:bodyPr wrap="square" lIns="50800" tIns="50800" rIns="50800" bIns="50800" rtlCol="0" anchor="ctr"/>
           <a:lstStyle/>
           <a:p>
-            <a:pPr algn="ctr" indent="0" marL="0">
+            <a:pPr marL="0" indent="0" algn="ctr">
               <a:buNone/>
             </a:pPr>
             <a:r>
@@ -4924,6 +4882,13 @@
             <a:prstDash val="solid"/>
           </a:ln>
         </p:spPr>
+        <p:txBody>
+          <a:bodyPr/>
+          <a:lstStyle/>
+          <a:p>
+            <a:endParaRPr lang="en-US"/>
+          </a:p>
+        </p:txBody>
       </p:sp>
       <p:sp>
         <p:nvSpPr>
@@ -4950,7 +4915,7 @@
           <a:bodyPr wrap="square" lIns="50800" tIns="50800" rIns="50800" bIns="50800" rtlCol="0" anchor="ctr"/>
           <a:lstStyle/>
           <a:p>
-            <a:pPr algn="ctr" indent="0" marL="0">
+            <a:pPr marL="0" indent="0" algn="ctr">
               <a:buNone/>
             </a:pPr>
             <a:r>
@@ -4986,7 +4951,7 @@
           <a:bodyPr wrap="square" lIns="0" tIns="0" rIns="0" bIns="0" rtlCol="0" anchor="ctr"/>
           <a:lstStyle/>
           <a:p>
-            <a:pPr indent="0" marL="0">
+            <a:pPr marL="0" indent="0">
               <a:buNone/>
             </a:pPr>
             <a:r>
@@ -5098,7 +5063,7 @@
           <a:bodyPr wrap="square" lIns="0" tIns="0" rIns="0" bIns="0" rtlCol="0" anchor="ctr"/>
           <a:lstStyle/>
           <a:p>
-            <a:pPr indent="0" marL="0">
+            <a:pPr marL="0" indent="0">
               <a:buNone/>
             </a:pPr>
             <a:r>
@@ -5147,7 +5112,7 @@
                   <a:srgbClr val="2D3748"/>
                 </a:solidFill>
               </a:rPr>
-              <a:t>One resume (P06) scored 0 while the other 27 were fine; find out why</a:t>
+              <a:t>One resume (P06) scored 0 while the other 27 were fine</a:t>
             </a:r>
             <a:endParaRPr lang="en-US" sz="1300" dirty="0"/>
           </a:p>
@@ -5191,7 +5156,7 @@
           </a:prstGeom>
           <a:extLst>
             <a:ext uri="{C572A759-6A51-4108-AA02-DFA0A04FC94B}">
-              <ma14:wrappingTextBoxFlag xmlns:ma14="http://schemas.microsoft.com/office/mac/drawingml/2011/main" val="0"/>
+              <ma14:wrappingTextBoxFlag xmlns:ma14="http://schemas.microsoft.com/office/mac/drawingml/2011/main" xmlns="" val="0"/>
             </a:ext>
           </a:extLst>
         </p:spPr>
@@ -5212,7 +5177,7 @@
           <a:p>
             <a:pPr algn="l"/>
             <a:fld id="{F7021451-1387-4CA6-816F-3879F97B5CBC}" type="slidenum">
-              <a:rPr b="0" lang="en-US"/>
+              <a:rPr lang="en-US" b="0"/>
               <a:t>4</a:t>
             </a:fld>
             <a:endParaRPr lang="en-US"/>
@@ -5265,11 +5230,11 @@
           <a:bodyPr wrap="square" lIns="0" tIns="0" rIns="0" bIns="0" rtlCol="0" anchor="ctr"/>
           <a:lstStyle/>
           <a:p>
-            <a:pPr indent="0" marL="0">
+            <a:pPr marL="0" indent="0">
               <a:buNone/>
             </a:pPr>
             <a:r>
-              <a:rPr lang="en-US" sz="1200" spc="150" kern="0" dirty="0">
+              <a:rPr lang="en-US" sz="1200" kern="0" spc="150" dirty="0">
                 <a:solidFill>
                   <a:srgbClr val="B85C1E"/>
                 </a:solidFill>
@@ -5308,7 +5273,7 @@
           <a:bodyPr wrap="square" lIns="0" tIns="0" rIns="0" bIns="0" rtlCol="0" anchor="ctr"/>
           <a:lstStyle/>
           <a:p>
-            <a:pPr algn="ctr" indent="0" marL="0">
+            <a:pPr marL="0" indent="0" algn="ctr">
               <a:buNone/>
             </a:pPr>
             <a:r>
@@ -5326,9 +5291,11 @@
       <p:sp>
         <p:nvSpPr>
           <p:cNvPr id="4" name="Text 0"/>
-          <p:cNvSpPr/>
+          <p:cNvSpPr>
+            <a:spLocks noGrp="1"/>
+          </p:cNvSpPr>
           <p:nvPr>
-            <p:ph idx="100" type="title" hasCustomPrompt="1"/>
+            <p:ph type="title" idx="100" hasCustomPrompt="1"/>
           </p:nvPr>
         </p:nvSpPr>
         <p:spPr>
@@ -5346,7 +5313,7 @@
           <a:bodyPr wrap="square" lIns="0" tIns="0" rIns="0" bIns="0" rtlCol="0" anchor="t"/>
           <a:lstStyle/>
           <a:p>
-            <a:pPr algn="l" indent="0" marL="0">
+            <a:pPr marL="0" indent="0" algn="l">
               <a:buNone/>
             </a:pPr>
             <a:r>
@@ -5382,7 +5349,7 @@
           <a:bodyPr wrap="square" lIns="0" tIns="0" rIns="0" bIns="0" rtlCol="0" anchor="ctr"/>
           <a:lstStyle/>
           <a:p>
-            <a:pPr indent="0" marL="0">
+            <a:pPr marL="0" indent="0">
               <a:buNone/>
             </a:pPr>
             <a:r>
@@ -5423,6 +5390,13 @@
             <a:prstDash val="solid"/>
           </a:ln>
         </p:spPr>
+        <p:txBody>
+          <a:bodyPr/>
+          <a:lstStyle/>
+          <a:p>
+            <a:endParaRPr lang="en-US"/>
+          </a:p>
+        </p:txBody>
       </p:sp>
       <p:sp>
         <p:nvSpPr>
@@ -5450,10 +5424,17 @@
             <a:prstDash val="solid"/>
           </a:ln>
         </p:spPr>
+        <p:txBody>
+          <a:bodyPr/>
+          <a:lstStyle/>
+          <a:p>
+            <a:endParaRPr lang="en-US"/>
+          </a:p>
+        </p:txBody>
       </p:sp>
       <p:graphicFrame>
         <p:nvGraphicFramePr>
-          <p:cNvPr id="8" name="time chart" descr=""/>
+          <p:cNvPr id="8" name="time chart"/>
           <p:cNvGraphicFramePr/>
           <p:nvPr/>
         </p:nvGraphicFramePr>
@@ -5461,15 +5442,15 @@
           <a:off x="640080" y="1810512"/>
           <a:ext cx="3749040" cy="2743200"/>
         </p:xfrm>
-        <a:graphic xmlns:a="http://schemas.openxmlformats.org/drawingml/2006/main">
+        <a:graphic>
           <a:graphicData uri="http://schemas.openxmlformats.org/drawingml/2006/chart">
-            <c:chart xmlns:c="http://schemas.openxmlformats.org/drawingml/2006/chart" r:id="rId1"/>
+            <c:chart xmlns:c="http://schemas.openxmlformats.org/drawingml/2006/chart" xmlns:r="http://schemas.openxmlformats.org/officeDocument/2006/relationships" r:id="rId3"/>
           </a:graphicData>
         </a:graphic>
       </p:graphicFrame>
       <p:graphicFrame>
         <p:nvGraphicFramePr>
-          <p:cNvPr id="9" name="token chart" descr=""/>
+          <p:cNvPr id="9" name="token chart"/>
           <p:cNvGraphicFramePr/>
           <p:nvPr/>
         </p:nvGraphicFramePr>
@@ -5477,9 +5458,9 @@
           <a:off x="4754880" y="1810512"/>
           <a:ext cx="3749040" cy="2743200"/>
         </p:xfrm>
-        <a:graphic xmlns:a="http://schemas.openxmlformats.org/drawingml/2006/main">
+        <a:graphic>
           <a:graphicData uri="http://schemas.openxmlformats.org/drawingml/2006/chart">
-            <c:chart xmlns:c="http://schemas.openxmlformats.org/drawingml/2006/chart" r:id="rId2"/>
+            <c:chart xmlns:c="http://schemas.openxmlformats.org/drawingml/2006/chart" xmlns:r="http://schemas.openxmlformats.org/officeDocument/2006/relationships" r:id="rId4"/>
           </a:graphicData>
         </a:graphic>
       </p:graphicFrame>
@@ -5503,7 +5484,7 @@
           </a:prstGeom>
           <a:extLst>
             <a:ext uri="{C572A759-6A51-4108-AA02-DFA0A04FC94B}">
-              <ma14:wrappingTextBoxFlag xmlns:ma14="http://schemas.microsoft.com/office/mac/drawingml/2011/main" val="0"/>
+              <ma14:wrappingTextBoxFlag xmlns:ma14="http://schemas.microsoft.com/office/mac/drawingml/2011/main" xmlns="" val="0"/>
             </a:ext>
           </a:extLst>
         </p:spPr>
@@ -5524,7 +5505,7 @@
           <a:p>
             <a:pPr algn="l"/>
             <a:fld id="{F7021451-1387-4CA6-816F-3879F97B5CBC}" type="slidenum">
-              <a:rPr b="0" lang="en-US"/>
+              <a:rPr lang="en-US" b="0"/>
               <a:t>5</a:t>
             </a:fld>
             <a:endParaRPr lang="en-US"/>
@@ -5540,7 +5521,7 @@
 </file>
 
 <file path=ppt/slides/slide6.xml><?xml version="1.0" encoding="utf-8"?>
-<p:sld xmlns:a="http://schemas.openxmlformats.org/drawingml/2006/main" xmlns:p="http://schemas.openxmlformats.org/presentationml/2006/main" xmlns:r="http://schemas.openxmlformats.org/officeDocument/2006/relationships">
+<p:sld xmlns:a="http://schemas.openxmlformats.org/drawingml/2006/main" xmlns:r="http://schemas.openxmlformats.org/officeDocument/2006/relationships" xmlns:p="http://schemas.openxmlformats.org/presentationml/2006/main">
   <p:cSld>
     <p:spTree>
       <p:nvGrpSpPr>
@@ -5548,7 +5529,14 @@
         <p:cNvGrpSpPr/>
         <p:nvPr/>
       </p:nvGrpSpPr>
-      <p:grpSpPr/>
+      <p:grpSpPr>
+        <a:xfrm>
+          <a:off x="0" y="0"/>
+          <a:ext cx="0" cy="0"/>
+          <a:chOff x="0" y="0"/>
+          <a:chExt cx="0" cy="0"/>
+        </a:xfrm>
+      </p:grpSpPr>
       <p:sp>
         <p:nvSpPr>
           <p:cNvPr id="2" name="eyebrow"/>
@@ -5570,11 +5558,11 @@
           <a:bodyPr wrap="square" lIns="0" tIns="0" rIns="0" bIns="0" rtlCol="0" anchor="ctr"/>
           <a:lstStyle/>
           <a:p>
-            <a:pPr indent="0" marL="0">
+            <a:pPr marL="0" indent="0">
               <a:buNone/>
             </a:pPr>
             <a:r>
-              <a:rPr lang="en-US" sz="1200" spc="150" kern="0" dirty="0">
+              <a:rPr lang="en-US" sz="1200" kern="0" spc="150" dirty="0">
                 <a:solidFill>
                   <a:srgbClr val="B85C1E"/>
                 </a:solidFill>
@@ -5613,7 +5601,7 @@
           <a:bodyPr wrap="square" lIns="0" tIns="0" rIns="0" bIns="0" rtlCol="0" anchor="ctr"/>
           <a:lstStyle/>
           <a:p>
-            <a:pPr algn="ctr" indent="0" marL="0">
+            <a:pPr marL="0" indent="0" algn="ctr">
               <a:buNone/>
             </a:pPr>
             <a:r>
@@ -5631,9 +5619,11 @@
       <p:sp>
         <p:nvSpPr>
           <p:cNvPr id="4" name="Text 0"/>
-          <p:cNvSpPr/>
+          <p:cNvSpPr>
+            <a:spLocks noGrp="1"/>
+          </p:cNvSpPr>
           <p:nvPr>
-            <p:ph idx="100" type="title" hasCustomPrompt="1"/>
+            <p:ph type="title" idx="100" hasCustomPrompt="1"/>
           </p:nvPr>
         </p:nvSpPr>
         <p:spPr>
@@ -5651,7 +5641,7 @@
           <a:bodyPr wrap="square" lIns="0" tIns="0" rIns="0" bIns="0" rtlCol="0" anchor="t"/>
           <a:lstStyle/>
           <a:p>
-            <a:pPr algn="l" indent="0" marL="0">
+            <a:pPr marL="0" indent="0" algn="l">
               <a:buNone/>
             </a:pPr>
             <a:r>
@@ -5687,7 +5677,7 @@
           <a:bodyPr wrap="square" lIns="0" tIns="0" rIns="0" bIns="0" rtlCol="0" anchor="ctr"/>
           <a:lstStyle/>
           <a:p>
-            <a:pPr indent="0" marL="0">
+            <a:pPr marL="0" indent="0">
               <a:buNone/>
             </a:pPr>
             <a:r>
@@ -5728,6 +5718,13 @@
             <a:prstDash val="solid"/>
           </a:ln>
         </p:spPr>
+        <p:txBody>
+          <a:bodyPr/>
+          <a:lstStyle/>
+          <a:p>
+            <a:endParaRPr lang="en-US"/>
+          </a:p>
+        </p:txBody>
       </p:sp>
       <p:sp>
         <p:nvSpPr>
@@ -5755,6 +5752,13 @@
             <a:prstDash val="solid"/>
           </a:ln>
         </p:spPr>
+        <p:txBody>
+          <a:bodyPr/>
+          <a:lstStyle/>
+          <a:p>
+            <a:endParaRPr lang="en-US"/>
+          </a:p>
+        </p:txBody>
       </p:sp>
       <p:sp>
         <p:nvSpPr>
@@ -5776,7 +5780,7 @@
           </a:prstGeom>
           <a:extLst>
             <a:ext uri="{C572A759-6A51-4108-AA02-DFA0A04FC94B}">
-              <ma14:wrappingTextBoxFlag xmlns:ma14="http://schemas.microsoft.com/office/mac/drawingml/2011/main" val="0"/>
+              <ma14:wrappingTextBoxFlag xmlns:ma14="http://schemas.microsoft.com/office/mac/drawingml/2011/main" xmlns="" val="0"/>
             </a:ext>
           </a:extLst>
         </p:spPr>
@@ -5815,7 +5819,7 @@
         </p:xfrm>
         <a:graphic>
           <a:graphicData uri="http://schemas.openxmlformats.org/drawingml/2006/chart">
-            <c:chart xmlns:c="http://schemas.openxmlformats.org/drawingml/2006/chart" r:id="rId2"/>
+            <c:chart xmlns:c="http://schemas.openxmlformats.org/drawingml/2006/chart" xmlns:r="http://schemas.openxmlformats.org/officeDocument/2006/relationships" r:id="rId3"/>
           </a:graphicData>
         </a:graphic>
       </p:graphicFrame>
@@ -5833,7 +5837,7 @@
         </p:xfrm>
         <a:graphic>
           <a:graphicData uri="http://schemas.openxmlformats.org/drawingml/2006/chart">
-            <c:chart xmlns:c="http://schemas.openxmlformats.org/drawingml/2006/chart" r:id="rId3"/>
+            <c:chart xmlns:c="http://schemas.openxmlformats.org/drawingml/2006/chart" xmlns:r="http://schemas.openxmlformats.org/officeDocument/2006/relationships" r:id="rId4"/>
           </a:graphicData>
         </a:graphic>
       </p:graphicFrame>
@@ -5846,7 +5850,7 @@
 </file>
 
 <file path=ppt/slides/slide7.xml><?xml version="1.0" encoding="utf-8"?>
-<p:sld xmlns:a="http://schemas.openxmlformats.org/drawingml/2006/main" xmlns:p="http://schemas.openxmlformats.org/presentationml/2006/main" xmlns:r="http://schemas.openxmlformats.org/officeDocument/2006/relationships">
+<p:sld xmlns:a="http://schemas.openxmlformats.org/drawingml/2006/main" xmlns:r="http://schemas.openxmlformats.org/officeDocument/2006/relationships" xmlns:p="http://schemas.openxmlformats.org/presentationml/2006/main">
   <p:cSld>
     <p:spTree>
       <p:nvGrpSpPr>
@@ -5854,7 +5858,14 @@
         <p:cNvGrpSpPr/>
         <p:nvPr/>
       </p:nvGrpSpPr>
-      <p:grpSpPr/>
+      <p:grpSpPr>
+        <a:xfrm>
+          <a:off x="0" y="0"/>
+          <a:ext cx="0" cy="0"/>
+          <a:chOff x="0" y="0"/>
+          <a:chExt cx="0" cy="0"/>
+        </a:xfrm>
+      </p:grpSpPr>
       <p:sp>
         <p:nvSpPr>
           <p:cNvPr id="2" name="eyebrow"/>
@@ -5876,11 +5887,11 @@
           <a:bodyPr wrap="square" lIns="0" tIns="0" rIns="0" bIns="0" rtlCol="0" anchor="ctr"/>
           <a:lstStyle/>
           <a:p>
-            <a:pPr indent="0" marL="0">
+            <a:pPr marL="0" indent="0">
               <a:buNone/>
             </a:pPr>
             <a:r>
-              <a:rPr lang="en-US" sz="1200" spc="150" kern="0" dirty="0">
+              <a:rPr lang="en-US" sz="1200" kern="0" spc="150" dirty="0">
                 <a:solidFill>
                   <a:srgbClr val="B85C1E"/>
                 </a:solidFill>
@@ -5919,7 +5930,7 @@
           <a:bodyPr wrap="square" lIns="0" tIns="0" rIns="0" bIns="0" rtlCol="0" anchor="ctr"/>
           <a:lstStyle/>
           <a:p>
-            <a:pPr algn="ctr" indent="0" marL="0">
+            <a:pPr marL="0" indent="0" algn="ctr">
               <a:buNone/>
             </a:pPr>
             <a:r>
@@ -5937,9 +5948,11 @@
       <p:sp>
         <p:nvSpPr>
           <p:cNvPr id="4" name="Text 0"/>
-          <p:cNvSpPr/>
+          <p:cNvSpPr>
+            <a:spLocks noGrp="1"/>
+          </p:cNvSpPr>
           <p:nvPr>
-            <p:ph idx="100" type="title" hasCustomPrompt="1"/>
+            <p:ph type="title" idx="100" hasCustomPrompt="1"/>
           </p:nvPr>
         </p:nvSpPr>
         <p:spPr>
@@ -5957,7 +5970,7 @@
           <a:bodyPr wrap="square" lIns="0" tIns="0" rIns="0" bIns="0" rtlCol="0" anchor="t"/>
           <a:lstStyle/>
           <a:p>
-            <a:pPr algn="l" indent="0" marL="0">
+            <a:pPr marL="0" indent="0" algn="l">
               <a:buNone/>
             </a:pPr>
             <a:r>
@@ -5993,7 +6006,7 @@
           <a:bodyPr wrap="square" lIns="0" tIns="0" rIns="0" bIns="0" rtlCol="0" anchor="ctr"/>
           <a:lstStyle/>
           <a:p>
-            <a:pPr indent="0" marL="0">
+            <a:pPr marL="0" indent="0">
               <a:buNone/>
             </a:pPr>
             <a:r>
@@ -6034,6 +6047,13 @@
             <a:prstDash val="solid"/>
           </a:ln>
         </p:spPr>
+        <p:txBody>
+          <a:bodyPr/>
+          <a:lstStyle/>
+          <a:p>
+            <a:endParaRPr lang="en-US"/>
+          </a:p>
+        </p:txBody>
       </p:sp>
       <p:sp>
         <p:nvSpPr>
@@ -6061,6 +6081,13 @@
             <a:prstDash val="solid"/>
           </a:ln>
         </p:spPr>
+        <p:txBody>
+          <a:bodyPr/>
+          <a:lstStyle/>
+          <a:p>
+            <a:endParaRPr lang="en-US"/>
+          </a:p>
+        </p:txBody>
       </p:sp>
       <p:sp>
         <p:nvSpPr>
@@ -6082,7 +6109,7 @@
           </a:prstGeom>
           <a:extLst>
             <a:ext uri="{C572A759-6A51-4108-AA02-DFA0A04FC94B}">
-              <ma14:wrappingTextBoxFlag xmlns:ma14="http://schemas.microsoft.com/office/mac/drawingml/2011/main" val="0"/>
+              <ma14:wrappingTextBoxFlag xmlns:ma14="http://schemas.microsoft.com/office/mac/drawingml/2011/main" xmlns="" val="0"/>
             </a:ext>
           </a:extLst>
         </p:spPr>
@@ -6124,7 +6151,7 @@
           <a:noFill/>
         </p:spPr>
         <p:txBody>
-          <a:bodyPr wrap="square" lIns="18288" rIns="18288" tIns="0" bIns="0">
+          <a:bodyPr wrap="square" lIns="18288" tIns="0" rIns="18288" bIns="0">
             <a:spAutoFit/>
           </a:bodyPr>
           <a:lstStyle/>
@@ -6157,7 +6184,7 @@
           <a:noFill/>
         </p:spPr>
         <p:txBody>
-          <a:bodyPr wrap="square" lIns="18288" rIns="18288" tIns="0" bIns="0">
+          <a:bodyPr wrap="square" lIns="18288" tIns="0" rIns="18288" bIns="0">
             <a:spAutoFit/>
           </a:bodyPr>
           <a:lstStyle/>
@@ -6280,7 +6307,7 @@
           <a:noFill/>
         </p:spPr>
         <p:txBody>
-          <a:bodyPr wrap="square" lIns="18288" rIns="18288" tIns="0" bIns="0">
+          <a:bodyPr wrap="square" lIns="18288" tIns="0" rIns="18288" bIns="0">
             <a:spAutoFit/>
           </a:bodyPr>
           <a:lstStyle/>
@@ -6313,7 +6340,7 @@
           <a:noFill/>
         </p:spPr>
         <p:txBody>
-          <a:bodyPr wrap="square" lIns="18288" rIns="18288" tIns="0" bIns="0">
+          <a:bodyPr wrap="square" lIns="18288" tIns="0" rIns="18288" bIns="0">
             <a:spAutoFit/>
           </a:bodyPr>
           <a:lstStyle/>
@@ -6428,7 +6455,7 @@
 </file>
 
 <file path=ppt/slides/slide8.xml><?xml version="1.0" encoding="utf-8"?>
-<p:sld xmlns:a="http://schemas.openxmlformats.org/drawingml/2006/main" xmlns:p="http://schemas.openxmlformats.org/presentationml/2006/main" xmlns:r="http://schemas.openxmlformats.org/officeDocument/2006/relationships">
+<p:sld xmlns:a="http://schemas.openxmlformats.org/drawingml/2006/main" xmlns:r="http://schemas.openxmlformats.org/officeDocument/2006/relationships" xmlns:p="http://schemas.openxmlformats.org/presentationml/2006/main">
   <p:cSld>
     <p:spTree>
       <p:nvGrpSpPr>
@@ -6436,7 +6463,14 @@
         <p:cNvGrpSpPr/>
         <p:nvPr/>
       </p:nvGrpSpPr>
-      <p:grpSpPr/>
+      <p:grpSpPr>
+        <a:xfrm>
+          <a:off x="0" y="0"/>
+          <a:ext cx="0" cy="0"/>
+          <a:chOff x="0" y="0"/>
+          <a:chExt cx="0" cy="0"/>
+        </a:xfrm>
+      </p:grpSpPr>
       <p:sp>
         <p:nvSpPr>
           <p:cNvPr id="2" name="eyebrow"/>
@@ -6458,11 +6492,11 @@
           <a:bodyPr wrap="square" lIns="0" tIns="0" rIns="0" bIns="0" rtlCol="0" anchor="ctr"/>
           <a:lstStyle/>
           <a:p>
-            <a:pPr indent="0" marL="0">
+            <a:pPr marL="0" indent="0">
               <a:buNone/>
             </a:pPr>
             <a:r>
-              <a:rPr lang="en-US" sz="1200" spc="150" kern="0" dirty="0">
+              <a:rPr lang="en-US" sz="1200" kern="0" spc="150" dirty="0">
                 <a:solidFill>
                   <a:srgbClr val="B85C1E"/>
                 </a:solidFill>
@@ -6501,7 +6535,7 @@
           <a:bodyPr wrap="square" lIns="0" tIns="0" rIns="0" bIns="0" rtlCol="0" anchor="ctr"/>
           <a:lstStyle/>
           <a:p>
-            <a:pPr algn="ctr" indent="0" marL="0">
+            <a:pPr marL="0" indent="0" algn="ctr">
               <a:buNone/>
             </a:pPr>
             <a:r>
@@ -6519,9 +6553,11 @@
       <p:sp>
         <p:nvSpPr>
           <p:cNvPr id="4" name="Text 0"/>
-          <p:cNvSpPr/>
+          <p:cNvSpPr>
+            <a:spLocks noGrp="1"/>
+          </p:cNvSpPr>
           <p:nvPr>
-            <p:ph idx="100" type="title" hasCustomPrompt="1"/>
+            <p:ph type="title" idx="100" hasCustomPrompt="1"/>
           </p:nvPr>
         </p:nvSpPr>
         <p:spPr>
@@ -6539,7 +6575,7 @@
           <a:bodyPr wrap="square" lIns="0" tIns="0" rIns="0" bIns="0" rtlCol="0" anchor="t"/>
           <a:lstStyle/>
           <a:p>
-            <a:pPr algn="l" indent="0" marL="0">
+            <a:pPr marL="0" indent="0" algn="l">
               <a:buNone/>
             </a:pPr>
             <a:r>
@@ -6575,7 +6611,7 @@
           <a:bodyPr wrap="square" lIns="0" tIns="0" rIns="0" bIns="0" rtlCol="0" anchor="ctr"/>
           <a:lstStyle/>
           <a:p>
-            <a:pPr indent="0" marL="0">
+            <a:pPr marL="0" indent="0">
               <a:buNone/>
             </a:pPr>
             <a:r>
@@ -6616,6 +6652,13 @@
             <a:prstDash val="solid"/>
           </a:ln>
         </p:spPr>
+        <p:txBody>
+          <a:bodyPr/>
+          <a:lstStyle/>
+          <a:p>
+            <a:endParaRPr lang="en-US"/>
+          </a:p>
+        </p:txBody>
       </p:sp>
       <p:sp>
         <p:nvSpPr>
@@ -6643,6 +6686,13 @@
             <a:prstDash val="solid"/>
           </a:ln>
         </p:spPr>
+        <p:txBody>
+          <a:bodyPr/>
+          <a:lstStyle/>
+          <a:p>
+            <a:endParaRPr lang="en-US"/>
+          </a:p>
+        </p:txBody>
       </p:sp>
       <p:sp>
         <p:nvSpPr>
@@ -6664,7 +6714,7 @@
           </a:prstGeom>
           <a:extLst>
             <a:ext uri="{C572A759-6A51-4108-AA02-DFA0A04FC94B}">
-              <ma14:wrappingTextBoxFlag xmlns:ma14="http://schemas.microsoft.com/office/mac/drawingml/2011/main" val="0"/>
+              <ma14:wrappingTextBoxFlag xmlns:ma14="http://schemas.microsoft.com/office/mac/drawingml/2011/main" xmlns="" val="0"/>
             </a:ext>
           </a:extLst>
         </p:spPr>
@@ -6706,7 +6756,7 @@
           <a:noFill/>
         </p:spPr>
         <p:txBody>
-          <a:bodyPr wrap="square" lIns="18288" rIns="18288" tIns="0" bIns="0">
+          <a:bodyPr wrap="square" lIns="18288" tIns="0" rIns="18288" bIns="0">
             <a:spAutoFit/>
           </a:bodyPr>
           <a:lstStyle/>
@@ -6739,7 +6789,7 @@
           <a:noFill/>
         </p:spPr>
         <p:txBody>
-          <a:bodyPr wrap="square" lIns="18288" rIns="18288" tIns="0" bIns="0">
+          <a:bodyPr wrap="square" lIns="18288" tIns="0" rIns="18288" bIns="0">
             <a:spAutoFit/>
           </a:bodyPr>
           <a:lstStyle/>
@@ -6832,7 +6882,7 @@
           <a:noFill/>
         </p:spPr>
         <p:txBody>
-          <a:bodyPr wrap="square" lIns="18288" rIns="18288" tIns="0" bIns="0">
+          <a:bodyPr wrap="square" lIns="18288" tIns="0" rIns="18288" bIns="0">
             <a:spAutoFit/>
           </a:bodyPr>
           <a:lstStyle/>
@@ -6925,7 +6975,7 @@
           <a:noFill/>
         </p:spPr>
         <p:txBody>
-          <a:bodyPr wrap="square" lIns="18288" rIns="18288" tIns="0" bIns="0">
+          <a:bodyPr wrap="square" lIns="18288" tIns="0" rIns="18288" bIns="0">
             <a:spAutoFit/>
           </a:bodyPr>
           <a:lstStyle/>
@@ -6958,7 +7008,7 @@
           <a:noFill/>
         </p:spPr>
         <p:txBody>
-          <a:bodyPr wrap="square" lIns="18288" rIns="18288" tIns="0" bIns="0">
+          <a:bodyPr wrap="square" lIns="18288" tIns="0" rIns="18288" bIns="0">
             <a:spAutoFit/>
           </a:bodyPr>
           <a:lstStyle/>
@@ -7051,7 +7101,7 @@
           <a:noFill/>
         </p:spPr>
         <p:txBody>
-          <a:bodyPr wrap="square" lIns="18288" rIns="18288" tIns="0" bIns="0">
+          <a:bodyPr wrap="square" lIns="18288" tIns="0" rIns="18288" bIns="0">
             <a:spAutoFit/>
           </a:bodyPr>
           <a:lstStyle/>
@@ -7173,11 +7223,11 @@
           <a:bodyPr wrap="square" lIns="0" tIns="0" rIns="0" bIns="0" rtlCol="0" anchor="ctr"/>
           <a:lstStyle/>
           <a:p>
-            <a:pPr indent="0" marL="0">
+            <a:pPr marL="0" indent="0">
               <a:buNone/>
             </a:pPr>
             <a:r>
-              <a:rPr lang="en-US" sz="1200" spc="200" kern="0" dirty="0">
+              <a:rPr lang="en-US" sz="1200" kern="0" spc="200" dirty="0">
                 <a:solidFill>
                   <a:srgbClr val="F2A65A"/>
                 </a:solidFill>
@@ -7194,9 +7244,11 @@
       <p:sp>
         <p:nvSpPr>
           <p:cNvPr id="3" name="Text 0"/>
-          <p:cNvSpPr/>
+          <p:cNvSpPr>
+            <a:spLocks noGrp="1"/>
+          </p:cNvSpPr>
           <p:nvPr>
-            <p:ph idx="100" type="title" hasCustomPrompt="1"/>
+            <p:ph type="title" idx="100" hasCustomPrompt="1"/>
           </p:nvPr>
         </p:nvSpPr>
         <p:spPr>
@@ -7214,7 +7266,7 @@
           <a:bodyPr wrap="square" lIns="0" tIns="0" rIns="0" bIns="0" rtlCol="0" anchor="t"/>
           <a:lstStyle/>
           <a:p>
-            <a:pPr algn="l" indent="0" marL="0">
+            <a:pPr marL="0" indent="0" algn="l">
               <a:buNone/>
             </a:pPr>
             <a:r>
@@ -7530,4 +7582,319 @@
     </a:ext>
   </a:extLst>
 </a:theme>
+</file>
+
+<file path=ppt/theme/theme2.xml><?xml version="1.0" encoding="utf-8"?>
+<a:theme xmlns:a="http://schemas.openxmlformats.org/drawingml/2006/main" name="Office Theme">
+  <a:themeElements>
+    <a:clrScheme name="Office">
+      <a:dk1>
+        <a:sysClr val="windowText" lastClr="000000"/>
+      </a:dk1>
+      <a:lt1>
+        <a:sysClr val="window" lastClr="FFFFFF"/>
+      </a:lt1>
+      <a:dk2>
+        <a:srgbClr val="0E2841"/>
+      </a:dk2>
+      <a:lt2>
+        <a:srgbClr val="E8E8E8"/>
+      </a:lt2>
+      <a:accent1>
+        <a:srgbClr val="156082"/>
+      </a:accent1>
+      <a:accent2>
+        <a:srgbClr val="E97132"/>
+      </a:accent2>
+      <a:accent3>
+        <a:srgbClr val="196B24"/>
+      </a:accent3>
+      <a:accent4>
+        <a:srgbClr val="0F9ED5"/>
+      </a:accent4>
+      <a:accent5>
+        <a:srgbClr val="A02B93"/>
+      </a:accent5>
+      <a:accent6>
+        <a:srgbClr val="4EA72E"/>
+      </a:accent6>
+      <a:hlink>
+        <a:srgbClr val="467886"/>
+      </a:hlink>
+      <a:folHlink>
+        <a:srgbClr val="96607D"/>
+      </a:folHlink>
+    </a:clrScheme>
+    <a:fontScheme name="Office">
+      <a:majorFont>
+        <a:latin typeface="Aptos Display" panose="02110004020202020204"/>
+        <a:ea typeface=""/>
+        <a:cs typeface=""/>
+        <a:font script="Jpan" typeface="游ゴシック Light"/>
+        <a:font script="Hang" typeface="맑은 고딕"/>
+        <a:font script="Hans" typeface="等线 Light"/>
+        <a:font script="Hant" typeface="新細明體"/>
+        <a:font script="Arab" typeface="Times New Roman"/>
+        <a:font script="Hebr" typeface="Times New Roman"/>
+        <a:font script="Thai" typeface="Angsana New"/>
+        <a:font script="Ethi" typeface="Nyala"/>
+        <a:font script="Beng" typeface="Vrinda"/>
+        <a:font script="Gujr" typeface="Shruti"/>
+        <a:font script="Khmr" typeface="MoolBoran"/>
+        <a:font script="Knda" typeface="Tunga"/>
+        <a:font script="Guru" typeface="Raavi"/>
+        <a:font script="Cans" typeface="Euphemia"/>
+        <a:font script="Cher" typeface="Plantagenet Cherokee"/>
+        <a:font script="Yiii" typeface="Microsoft Yi Baiti"/>
+        <a:font script="Tibt" typeface="Microsoft Himalaya"/>
+        <a:font script="Thaa" typeface="MV Boli"/>
+        <a:font script="Deva" typeface="Mangal"/>
+        <a:font script="Telu" typeface="Gautami"/>
+        <a:font script="Taml" typeface="Latha"/>
+        <a:font script="Syrc" typeface="Estrangelo Edessa"/>
+        <a:font script="Orya" typeface="Kalinga"/>
+        <a:font script="Mlym" typeface="Kartika"/>
+        <a:font script="Laoo" typeface="DokChampa"/>
+        <a:font script="Sinh" typeface="Iskoola Pota"/>
+        <a:font script="Mong" typeface="Mongolian Baiti"/>
+        <a:font script="Viet" typeface="Times New Roman"/>
+        <a:font script="Uigh" typeface="Microsoft Uighur"/>
+        <a:font script="Geor" typeface="Sylfaen"/>
+        <a:font script="Armn" typeface="Arial"/>
+        <a:font script="Bugi" typeface="Leelawadee UI"/>
+        <a:font script="Bopo" typeface="Microsoft JhengHei"/>
+        <a:font script="Java" typeface="Javanese Text"/>
+        <a:font script="Lisu" typeface="Segoe UI"/>
+        <a:font script="Mymr" typeface="Myanmar Text"/>
+        <a:font script="Nkoo" typeface="Ebrima"/>
+        <a:font script="Olck" typeface="Nirmala UI"/>
+        <a:font script="Osma" typeface="Ebrima"/>
+        <a:font script="Phag" typeface="Phagspa"/>
+        <a:font script="Syrn" typeface="Estrangelo Edessa"/>
+        <a:font script="Syrj" typeface="Estrangelo Edessa"/>
+        <a:font script="Syre" typeface="Estrangelo Edessa"/>
+        <a:font script="Sora" typeface="Nirmala UI"/>
+        <a:font script="Tale" typeface="Microsoft Tai Le"/>
+        <a:font script="Talu" typeface="Microsoft New Tai Lue"/>
+        <a:font script="Tfng" typeface="Ebrima"/>
+      </a:majorFont>
+      <a:minorFont>
+        <a:latin typeface="Aptos" panose="02110004020202020204"/>
+        <a:ea typeface=""/>
+        <a:cs typeface=""/>
+        <a:font script="Jpan" typeface="游ゴシック"/>
+        <a:font script="Hang" typeface="맑은 고딕"/>
+        <a:font script="Hans" typeface="等线"/>
+        <a:font script="Hant" typeface="新細明體"/>
+        <a:font script="Arab" typeface="Arial"/>
+        <a:font script="Hebr" typeface="Arial"/>
+        <a:font script="Thai" typeface="Cordia New"/>
+        <a:font script="Ethi" typeface="Nyala"/>
+        <a:font script="Beng" typeface="Vrinda"/>
+        <a:font script="Gujr" typeface="Shruti"/>
+        <a:font script="Khmr" typeface="DaunPenh"/>
+        <a:font script="Knda" typeface="Tunga"/>
+        <a:font script="Guru" typeface="Raavi"/>
+        <a:font script="Cans" typeface="Euphemia"/>
+        <a:font script="Cher" typeface="Plantagenet Cherokee"/>
+        <a:font script="Yiii" typeface="Microsoft Yi Baiti"/>
+        <a:font script="Tibt" typeface="Microsoft Himalaya"/>
+        <a:font script="Thaa" typeface="MV Boli"/>
+        <a:font script="Deva" typeface="Mangal"/>
+        <a:font script="Telu" typeface="Gautami"/>
+        <a:font script="Taml" typeface="Latha"/>
+        <a:font script="Syrc" typeface="Estrangelo Edessa"/>
+        <a:font script="Orya" typeface="Kalinga"/>
+        <a:font script="Mlym" typeface="Kartika"/>
+        <a:font script="Laoo" typeface="DokChampa"/>
+        <a:font script="Sinh" typeface="Iskoola Pota"/>
+        <a:font script="Mong" typeface="Mongolian Baiti"/>
+        <a:font script="Viet" typeface="Arial"/>
+        <a:font script="Uigh" typeface="Microsoft Uighur"/>
+        <a:font script="Geor" typeface="Sylfaen"/>
+        <a:font script="Armn" typeface="Arial"/>
+        <a:font script="Bugi" typeface="Leelawadee UI"/>
+        <a:font script="Bopo" typeface="Microsoft JhengHei"/>
+        <a:font script="Java" typeface="Javanese Text"/>
+        <a:font script="Lisu" typeface="Segoe UI"/>
+        <a:font script="Mymr" typeface="Myanmar Text"/>
+        <a:font script="Nkoo" typeface="Ebrima"/>
+        <a:font script="Olck" typeface="Nirmala UI"/>
+        <a:font script="Osma" typeface="Ebrima"/>
+        <a:font script="Phag" typeface="Phagspa"/>
+        <a:font script="Syrn" typeface="Estrangelo Edessa"/>
+        <a:font script="Syrj" typeface="Estrangelo Edessa"/>
+        <a:font script="Syre" typeface="Estrangelo Edessa"/>
+        <a:font script="Sora" typeface="Nirmala UI"/>
+        <a:font script="Tale" typeface="Microsoft Tai Le"/>
+        <a:font script="Talu" typeface="Microsoft New Tai Lue"/>
+        <a:font script="Tfng" typeface="Ebrima"/>
+      </a:minorFont>
+    </a:fontScheme>
+    <a:fmtScheme name="Office">
+      <a:fillStyleLst>
+        <a:solidFill>
+          <a:schemeClr val="phClr"/>
+        </a:solidFill>
+        <a:gradFill rotWithShape="1">
+          <a:gsLst>
+            <a:gs pos="0">
+              <a:schemeClr val="phClr">
+                <a:lumMod val="110000"/>
+                <a:satMod val="105000"/>
+                <a:tint val="67000"/>
+              </a:schemeClr>
+            </a:gs>
+            <a:gs pos="50000">
+              <a:schemeClr val="phClr">
+                <a:lumMod val="105000"/>
+                <a:satMod val="103000"/>
+                <a:tint val="73000"/>
+              </a:schemeClr>
+            </a:gs>
+            <a:gs pos="100000">
+              <a:schemeClr val="phClr">
+                <a:lumMod val="105000"/>
+                <a:satMod val="109000"/>
+                <a:tint val="81000"/>
+              </a:schemeClr>
+            </a:gs>
+          </a:gsLst>
+          <a:lin ang="5400000" scaled="0"/>
+        </a:gradFill>
+        <a:gradFill rotWithShape="1">
+          <a:gsLst>
+            <a:gs pos="0">
+              <a:schemeClr val="phClr">
+                <a:satMod val="103000"/>
+                <a:lumMod val="102000"/>
+                <a:tint val="94000"/>
+              </a:schemeClr>
+            </a:gs>
+            <a:gs pos="50000">
+              <a:schemeClr val="phClr">
+                <a:satMod val="110000"/>
+                <a:lumMod val="100000"/>
+                <a:shade val="100000"/>
+              </a:schemeClr>
+            </a:gs>
+            <a:gs pos="100000">
+              <a:schemeClr val="phClr">
+                <a:lumMod val="99000"/>
+                <a:satMod val="120000"/>
+                <a:shade val="78000"/>
+              </a:schemeClr>
+            </a:gs>
+          </a:gsLst>
+          <a:lin ang="5400000" scaled="0"/>
+        </a:gradFill>
+      </a:fillStyleLst>
+      <a:lnStyleLst>
+        <a:ln w="12700" cap="flat" cmpd="sng" algn="ctr">
+          <a:solidFill>
+            <a:schemeClr val="phClr"/>
+          </a:solidFill>
+          <a:prstDash val="solid"/>
+          <a:miter lim="800000"/>
+        </a:ln>
+        <a:ln w="19050" cap="flat" cmpd="sng" algn="ctr">
+          <a:solidFill>
+            <a:schemeClr val="phClr"/>
+          </a:solidFill>
+          <a:prstDash val="solid"/>
+          <a:miter lim="800000"/>
+        </a:ln>
+        <a:ln w="25400" cap="flat" cmpd="sng" algn="ctr">
+          <a:solidFill>
+            <a:schemeClr val="phClr"/>
+          </a:solidFill>
+          <a:prstDash val="solid"/>
+          <a:miter lim="800000"/>
+        </a:ln>
+      </a:lnStyleLst>
+      <a:effectStyleLst>
+        <a:effectStyle>
+          <a:effectLst/>
+        </a:effectStyle>
+        <a:effectStyle>
+          <a:effectLst/>
+        </a:effectStyle>
+        <a:effectStyle>
+          <a:effectLst>
+            <a:outerShdw blurRad="57150" dist="19050" dir="5400000" algn="ctr" rotWithShape="0">
+              <a:srgbClr val="000000">
+                <a:alpha val="63000"/>
+              </a:srgbClr>
+            </a:outerShdw>
+          </a:effectLst>
+        </a:effectStyle>
+      </a:effectStyleLst>
+      <a:bgFillStyleLst>
+        <a:solidFill>
+          <a:schemeClr val="phClr"/>
+        </a:solidFill>
+        <a:solidFill>
+          <a:schemeClr val="phClr">
+            <a:tint val="95000"/>
+            <a:satMod val="170000"/>
+          </a:schemeClr>
+        </a:solidFill>
+        <a:gradFill rotWithShape="1">
+          <a:gsLst>
+            <a:gs pos="0">
+              <a:schemeClr val="phClr">
+                <a:tint val="93000"/>
+                <a:satMod val="150000"/>
+                <a:shade val="98000"/>
+                <a:lumMod val="102000"/>
+              </a:schemeClr>
+            </a:gs>
+            <a:gs pos="50000">
+              <a:schemeClr val="phClr">
+                <a:tint val="98000"/>
+                <a:satMod val="130000"/>
+                <a:shade val="90000"/>
+                <a:lumMod val="103000"/>
+              </a:schemeClr>
+            </a:gs>
+            <a:gs pos="100000">
+              <a:schemeClr val="phClr">
+                <a:shade val="63000"/>
+                <a:satMod val="120000"/>
+              </a:schemeClr>
+            </a:gs>
+          </a:gsLst>
+          <a:lin ang="5400000" scaled="0"/>
+        </a:gradFill>
+      </a:bgFillStyleLst>
+    </a:fmtScheme>
+  </a:themeElements>
+  <a:objectDefaults>
+    <a:lnDef>
+      <a:spPr/>
+      <a:bodyPr/>
+      <a:lstStyle/>
+      <a:style>
+        <a:lnRef idx="2">
+          <a:schemeClr val="accent1"/>
+        </a:lnRef>
+        <a:fillRef idx="0">
+          <a:schemeClr val="accent1"/>
+        </a:fillRef>
+        <a:effectRef idx="1">
+          <a:schemeClr val="accent1"/>
+        </a:effectRef>
+        <a:fontRef idx="minor">
+          <a:schemeClr val="tx1"/>
+        </a:fontRef>
+      </a:style>
+    </a:lnDef>
+  </a:objectDefaults>
+  <a:extraClrSchemeLst/>
+  <a:extLst>
+    <a:ext uri="{05A4C25C-085E-4340-85A3-A5531E510DB2}">
+      <thm15:themeFamily xmlns:thm15="http://schemas.microsoft.com/office/thememl/2012/main" name="Office Theme" id="{2E142A2C-CD16-42D6-873A-C26D2A0506FA}" vid="{1BDDFF52-6CD6-40A5-AB3C-68EB2F1E4D0A}"/>
+    </a:ext>
+  </a:extLst>
+</a:theme>
 </file>
</xml_diff>